<commit_message>
Explain every step with simple analogies in the study guide and mention the m3 tag
</commit_message>
<xml_diff>
--- a/docs/museum_guide_presentation.pptx
+++ b/docs/museum_guide_presentation.pptx
@@ -121,34 +121,34 @@
   <p:extLst>
     <p:ext uri="{521415D9-36F7-43E2-AB2F-B90AF26B5E84}">
       <p14:sectionLst xmlns:p14="http://schemas.microsoft.com/office/powerpoint/2010/main">
-        <p14:section name="The question" id="{faf8f787-289d-ae75-eee1-6a401637fd96}">
+        <p14:section name="The question" id="{3fe8a66a-c6a4-6afe-c86b-0f24ec58d8a4}">
           <p14:sldIdLst>
             <p14:sldId id="256"/>
             <p14:sldId id="257"/>
             <p14:sldId id="258"/>
           </p14:sldIdLst>
         </p14:section>
-        <p14:section name="Our MLP" id="{e57fc2af-f9c6-4474-24e8-bcf431fe81c6}">
+        <p14:section name="Our MLP" id="{529e7474-1e56-1f2b-5c20-38169e60fdea}">
           <p14:sldIdLst>
             <p14:sldId id="259"/>
             <p14:sldId id="260"/>
             <p14:sldId id="261"/>
           </p14:sldIdLst>
         </p14:section>
-        <p14:section name="Pretrained ResNet" id="{13f3a775-050f-8897-97f1-4185670fabd1}">
+        <p14:section name="Pretrained ResNet" id="{d7c1cdb2-ffc1-1aed-2e56-421e1b9a7b39}">
           <p14:sldIdLst>
             <p14:sldId id="262"/>
             <p14:sldId id="263"/>
           </p14:sldIdLst>
         </p14:section>
-        <p14:section name="The answer" id="{14725e58-3a78-b739-43bd-2a21ce60ea15}">
+        <p14:section name="The answer" id="{962b1100-8f57-4d6a-bbb1-067db2b8dbc9}">
           <p14:sldIdLst>
             <p14:sldId id="264"/>
             <p14:sldId id="265"/>
             <p14:sldId id="266"/>
           </p14:sldIdLst>
         </p14:section>
-        <p14:section name="Backup" id="{f7c9bfa2-86ca-b205-c24a-f89a2e7228bc}">
+        <p14:section name="Backup" id="{84dc86e4-3d5a-6340-33b2-371fbc044581}">
           <p14:sldIdLst>
             <p14:sldId id="267"/>
             <p14:sldId id="268"/>
@@ -7515,7 +7515,7 @@
                   <a:schemeClr val="tx1"/>
                 </a:solidFill>
               </a:rPr>
-              <a:t>15 commits in 6 steps on GitHub, milestone tags m1, m2 and v1.0. Every number is saved in reports/results/*.json.</a:t>
+              <a:t>Small commits, one step at a time, on GitHub; milestone tags m1, m2, m3 and v1.0. Every number is saved in reports/results/*.json.</a:t>
             </a:r>
             <a:endParaRPr lang="en-US" sz="1500" dirty="0"/>
           </a:p>

</xml_diff>

<commit_message>
Add a transformers backup slide and a simple-words bonus chapter to the study guide
</commit_message>
<xml_diff>
--- a/docs/museum_guide_presentation.pptx
+++ b/docs/museum_guide_presentation.pptx
@@ -20,9 +20,10 @@
     <p:sldId id="268" r:id="rId14"/>
     <p:sldId id="269" r:id="rId15"/>
     <p:sldId id="270" r:id="rId16"/>
+    <p:sldId id="271" r:id="rId17"/>
   </p:sldIdLst>
   <p:notesMasterIdLst>
-    <p:notesMasterId r:id="rId17"/>
+    <p:notesMasterId r:id="rId18"/>
   </p:notesMasterIdLst>
   <p:sldSz cx="9144000" cy="5143500"/>
   <p:notesSz cx="5143500" cy="9144000"/>
@@ -121,39 +122,40 @@
   <p:extLst>
     <p:ext uri="{521415D9-36F7-43E2-AB2F-B90AF26B5E84}">
       <p14:sectionLst xmlns:p14="http://schemas.microsoft.com/office/powerpoint/2010/main">
-        <p14:section name="The question" id="{3fe8a66a-c6a4-6afe-c86b-0f24ec58d8a4}">
+        <p14:section name="The question" id="{b5153d7f-de66-c0dd-f51d-50bfe7c49577}">
           <p14:sldIdLst>
             <p14:sldId id="256"/>
             <p14:sldId id="257"/>
             <p14:sldId id="258"/>
           </p14:sldIdLst>
         </p14:section>
-        <p14:section name="Our MLP" id="{529e7474-1e56-1f2b-5c20-38169e60fdea}">
+        <p14:section name="Our MLP" id="{f412b7f4-db50-4e82-fb80-ace0e5049c2d}">
           <p14:sldIdLst>
             <p14:sldId id="259"/>
             <p14:sldId id="260"/>
             <p14:sldId id="261"/>
           </p14:sldIdLst>
         </p14:section>
-        <p14:section name="Pretrained ResNet" id="{d7c1cdb2-ffc1-1aed-2e56-421e1b9a7b39}">
+        <p14:section name="Pretrained ResNet" id="{cb7485ac-c1e9-97df-6b2f-7d05d4f2cedd}">
           <p14:sldIdLst>
             <p14:sldId id="262"/>
             <p14:sldId id="263"/>
           </p14:sldIdLst>
         </p14:section>
-        <p14:section name="The answer" id="{962b1100-8f57-4d6a-bbb1-067db2b8dbc9}">
+        <p14:section name="The answer" id="{8a88959c-610a-9931-d11b-434e0d73433c}">
           <p14:sldIdLst>
             <p14:sldId id="264"/>
             <p14:sldId id="265"/>
             <p14:sldId id="266"/>
           </p14:sldIdLst>
         </p14:section>
-        <p14:section name="Backup" id="{84dc86e4-3d5a-6340-33b2-371fbc044581}">
+        <p14:section name="Backup" id="{670931b6-0e94-28f6-7bdc-03a40ae2c03f}">
           <p14:sldIdLst>
             <p14:sldId id="267"/>
             <p14:sldId id="268"/>
             <p14:sldId id="269"/>
             <p14:sldId id="270"/>
+            <p14:sldId id="271"/>
           </p14:sldIdLst>
         </p14:section>
       </p14:sectionLst>
@@ -2544,7 +2546,7 @@
           <a:p>
             <a:r>
               <a:rPr lang="en-US" dirty="0"/>
-              <a:t>Hello. Our museum wants a guide on visitors' phones and on kiosks in the galleries. A visitor points the camera at a painting, and the guide tells them its style and the story of that movement. Here are the five styles we chose: Baroque, Cubism, Impressionism, Pop Art and Ukiyo-e. The kiosks have small CPUs, the team is small and the budget is limited. So the director asks one question: is a neural network worth it, or would a simpler classical model do the job? In the next ten minutes we answer with measured numbers.</a:t>
+              <a:t>Good morning. Imagine you are in a museum. You point your phone at a painting, and a guide tells you its style and the story of that movement. Our museum wants exactly this, on visitors' phones and on kiosks in the galleries. We worked on five styles: Baroque, Cubism, Impressionism, Pop Art and Ukiyo-e. The kiosks have small CPUs, the team is small and the budget is limited. So the director asks one question: is a neural network worth it in production, or would a simpler classical model do the job?</a:t>
             </a:r>
             <a:endParaRPr lang="en-US" dirty="0"/>
           </a:p>
@@ -2632,7 +2634,7 @@
           <a:p>
             <a:r>
               <a:rPr lang="en-US" dirty="0"/>
-              <a:t>Is it affordable on a kiosk? We timed one photo at a time, from the image to the answer. The ResNet takes 53 milliseconds on one CPU thread and 26 with four threads. Even on a kiosk four times slower, that is a fifth of a second. The model file is 45 megabytes, and training takes 17 seconds on a laptop, without a GPU. When the collection changes, we only compute the new features and retrain the last layer, in seconds.</a:t>
+              <a:t>Is it affordable on a kiosk? We timed one photo at a time, from the image to the answer. The ResNet needs 53 milliseconds on one CPU thread, 26 with four threads: faster than a blink. Even on a kiosk four times slower, it answers in a fifth of a second. The model file is 45 megabytes. And when the collection changes, we only recompute the features and retrain one layer, in seconds.</a:t>
             </a:r>
             <a:endParaRPr lang="en-US" dirty="0"/>
           </a:p>
@@ -2720,7 +2722,7 @@
           <a:p>
             <a:r>
               <a:rPr lang="en-US" dirty="0"/>
-              <a:t>So our recommendation: deploy a frozen ResNet18 with a linear head. It is the accurate choice: one visitor in six gets a wrong style, against one in three with the best classical model. It is fast enough, and cheap to maintain for a small team. We do not recommend our MLP on pixels, a classical model alone, or fine-tuning for now. Before the launch, we must test real photos taken at the kiosks, add more styles, and measure the real hardware. Everything is reproducible in our Git repository. Thank you, we are happy to take your questions.</a:t>
+              <a:t>So, our recommendation to the director: deploy a frozen ResNet18 with a linear head. Why? It is accurate: one visitor in six gets a wrong style, against one in three with the best classical model. It is fast enough for a modest CPU. And it is cheap for a small team: no GPU, no big training, one small layer retrained in seconds. We do not recommend our MLP on pixels, a classical model alone, or fine-tuning for now: it is slower and not proven better. Before the launch, we must test a few hundred real photos taken at the kiosks, add more styles, and measure the real hardware. Everything is reproducible in our Git repository. Thank you. We are happy to take your questions.</a:t>
             </a:r>
             <a:endParaRPr lang="en-US" dirty="0"/>
           </a:p>
@@ -3114,6 +3116,94 @@
 </p:notes>
 </file>
 
+<file path=ppt/notesSlides/notesSlide16.xml><?xml version="1.0" encoding="utf-8"?>
+<p:notes xmlns:a="http://schemas.openxmlformats.org/drawingml/2006/main" xmlns:r="http://schemas.openxmlformats.org/officeDocument/2006/relationships" xmlns:p="http://schemas.openxmlformats.org/presentationml/2006/main">
+  <p:cSld>
+    <p:spTree>
+      <p:nvGrpSpPr>
+        <p:cNvPr id="1" name=""/>
+        <p:cNvGrpSpPr/>
+        <p:nvPr/>
+      </p:nvGrpSpPr>
+      <p:grpSpPr>
+        <a:xfrm>
+          <a:off x="0" y="0"/>
+          <a:ext cx="0" cy="0"/>
+          <a:chOff x="0" y="0"/>
+          <a:chExt cx="0" cy="0"/>
+        </a:xfrm>
+      </p:grpSpPr>
+      <p:sp>
+        <p:nvSpPr>
+          <p:cNvPr id="2" name="Slide Image Placeholder 1"/>
+          <p:cNvSpPr>
+            <a:spLocks noGrp="1" noRot="1" noChangeAspect="1"/>
+          </p:cNvSpPr>
+          <p:nvPr>
+            <p:ph type="sldImg"/>
+          </p:nvPr>
+        </p:nvSpPr>
+        <p:spPr/>
+      </p:sp>
+      <p:sp>
+        <p:nvSpPr>
+          <p:cNvPr id="3" name="Notes Placeholder 2"/>
+          <p:cNvSpPr>
+            <a:spLocks noGrp="1"/>
+          </p:cNvSpPr>
+          <p:nvPr>
+            <p:ph type="body" idx="1"/>
+          </p:nvPr>
+        </p:nvSpPr>
+        <p:spPr/>
+        <p:txBody>
+          <a:bodyPr/>
+          <a:lstStyle/>
+          <a:p>
+            <a:r>
+              <a:rPr lang="en-US" dirty="0"/>
+              <a:t>If asked about BERT or transformers: BERT reads text, so it cannot classify paintings alone. Its image cousin ViT gives the same accuracy as ResNet18 but is about 9 times slower. CLIP, trained on images with captions, reaches about 89 percent with no training at all and about 95 percent with our linear head, on validation. Two cautions: it probably saw WikiArt during its training, and we did not reopen the test set. It is our first next step, and it would also answer visitors' questions in words.</a:t>
+            </a:r>
+            <a:endParaRPr lang="en-US" dirty="0"/>
+          </a:p>
+        </p:txBody>
+      </p:sp>
+      <p:sp>
+        <p:nvSpPr>
+          <p:cNvPr id="4" name="Slide Number Placeholder 3"/>
+          <p:cNvSpPr>
+            <a:spLocks noGrp="1"/>
+          </p:cNvSpPr>
+          <p:nvPr>
+            <p:ph type="sldNum" sz="quarter" idx="10"/>
+          </p:nvPr>
+        </p:nvSpPr>
+        <p:spPr/>
+        <p:txBody>
+          <a:bodyPr/>
+          <a:lstStyle/>
+          <a:p>
+            <a:fld id="{F7021451-1387-4CA6-816F-3879F97B5CBC}" type="slidenum">
+              <a:rPr lang="en-US"/>
+              <a:t>16</a:t>
+            </a:fld>
+            <a:endParaRPr lang="en-US"/>
+          </a:p>
+        </p:txBody>
+      </p:sp>
+    </p:spTree>
+    <p:extLst>
+      <p:ext uri="{BB962C8B-B14F-4D97-AF65-F5344CB8AC3E}">
+        <p14:creationId xmlns:p14="http://schemas.microsoft.com/office/powerpoint/2010/main" val="1024086991"/>
+      </p:ext>
+    </p:extLst>
+  </p:cSld>
+  <p:clrMapOvr>
+    <a:masterClrMapping/>
+  </p:clrMapOvr>
+</p:notes>
+</file>
+
 <file path=ppt/notesSlides/notesSlide2.xml><?xml version="1.0" encoding="utf-8"?>
 <p:notes xmlns:a="http://schemas.openxmlformats.org/drawingml/2006/main" xmlns:r="http://schemas.openxmlformats.org/officeDocument/2006/relationships" xmlns:p="http://schemas.openxmlformats.org/presentationml/2006/main">
   <p:cSld>
@@ -3160,7 +3250,7 @@
           <a:p>
             <a:r>
               <a:rPr lang="en-US" dirty="0"/>
-              <a:t>Here is our answer first. On 220 paintings that no model saw before, a pretrained ResNet18, frozen, with only one trained linear layer, reaches 83 percent. The best classical model, a random forest on hand-made colour and texture features, reaches 67 percent. Our own MLP, trained from zero on pixels, reaches 41 percent. And the ResNet costs 53 milliseconds per photo on one CPU thread, 45 megabytes, and 17 seconds of training on a laptop, with no GPU. So yes, a neural network is worth it, but a pretrained one that we reuse. Now let me show how we got these numbers, and why you can trust them.</a:t>
+              <a:t>Here is our answer first. We tested every model on 220 paintings that no model had seen before. A pretrained ResNet18, frozen, with only one linear layer trained on top, recognises the style 83 percent of the time. The best classical model, a random forest on colour and texture features made by hand, reaches 67 percent. Our own network, an MLP trained from zero on the pixels, reaches 41 percent. And the ResNet is affordable: 53 milliseconds per photo on one CPU thread, a 45 megabyte file, 17 seconds of training on a laptop, and no GPU. So yes, a neural network is worth it, but a pretrained one that we reuse. In the next minutes, I will show how we got these numbers, and why you can trust them.</a:t>
             </a:r>
             <a:endParaRPr lang="en-US" dirty="0"/>
           </a:p>
@@ -3248,7 +3338,7 @@
           <a:p>
             <a:r>
               <a:rPr lang="en-US" dirty="0"/>
-              <a:t>We used 1 500 WikiArt paintings, 300 per style. We split them into 1 061 to train, 219 to validate and 220 to test, with the same share of each style. One more rule: all the paintings of a known painter go to the same part. With a random split, 23 of our 32 known painters would be in two parts, and a model could recognise the painter instead of the style. With our split, zero. The test set stayed locked until the very end: we used it once. Later I will show that this rule changes the score by 11 points.</a:t>
+              <a:t>First, the data. We took 1 500 paintings from WikiArt, 300 per style. We used the course script with a fixed seed, so anyone can download exactly the same images. We cut them into three piles: 1 061 to train, 219 to validate, that is, to choose our settings, and 220 to test, used only once, at the very end. One rule matters a lot: all the paintings of a known painter go to the same pile. With a random split, 23 of our 32 known painters would be in two piles, and a model could learn to recognise Monet instead of Impressionism. With our split: zero. I will come back to this, because we measured its effect.</a:t>
             </a:r>
             <a:endParaRPr lang="en-US" dirty="0"/>
           </a:p>
@@ -3336,7 +3426,7 @@
           <a:p>
             <a:r>
               <a:rPr lang="en-US" dirty="0"/>
-              <a:t>Our first model is the network of the course: a multi-layer perceptron built from nn.Linear layers, 12 288 pixel inputs, two hidden layers, 6.4 million parameters. Before trusting it, we ran two checks. The first loss must be close to ln 5, the loss of a model that knows nothing: we had to shrink the last layer to get 1.59. And the model must learn one small batch by heart: it does, 100 percent. Then the real training: 99.7 percent on the training images, but only 40.6 percent on validation, and the validation loss rises after epoch 3. This is overfitting: 6 000 parameters per training image.</a:t>
+              <a:t>Our first model is the network of the course: a multi-layer perceptron built from nn.Linear layers and ReLU, with our own training loop. It reads the pixels of a 64 by 64 image: 12 288 inputs and 6.4 million parameters. Before trusting it, we ran two checks. First, a model that knows nothing should have a loss of ln 5, about 1.61. Ours started at 1.99, too confident, so we made its last layer smaller and got 1.59. Second, it must be able to learn one small batch by heart: it does, 100 percent. Then the real training. The training accuracy goes to 99.7 percent, but the validation accuracy stays around 40 percent, and the validation loss goes up after epoch 3. This is overfitting: the network learns the paintings by heart.</a:t>
             </a:r>
             <a:endParaRPr lang="en-US" dirty="0"/>
           </a:p>
@@ -3424,7 +3514,7 @@
           <a:p>
             <a:r>
               <a:rPr lang="en-US" dirty="0"/>
-              <a:t>We then looked inside the network during training: the gradient of each layer and the share of dead neurons. The gradient reaches every layer and only 4 percent of neurons are dead, so the training is healthy: the problem is overfitting. A learning-rate sweep chose 0.0001. Then we tested the tools of session 6, each with 3 seeds. Alone, each one helps a little. All together, they take the MLP from 38.8 to 45.5 percent, and the gap between train and validation from 0.61 to 0.12. But the MLP finds only 7 percent of the Cubist paintings: it sees colours, not shapes.</a:t>
+              <a:t>So we looked inside the network during training, not only at the loss. The gradient reaches every layer and only 4 percent of the neurons are dead: the training is healthy, the problem is overfitting. We also tried 8 learning rates and kept 0.0001. Then we tested the tools of session 6, each with 3 seeds, because one run on 219 images is noisy. Alone, each tool helps a little. All together, weight decay, dropout, batch norm, flips, early stopping and a cosine schedule take the MLP from 38.8 to 45.5 percent, and the gap between train and validation from 0.61 to 0.12. But one number shows the real limit: the MLP finds only 7 percent of the Cubist paintings. It sees colours, not shapes.</a:t>
             </a:r>
             <a:endParaRPr lang="en-US" dirty="0"/>
           </a:p>
@@ -3512,7 +3602,7 @@
           <a:p>
             <a:r>
               <a:rPr lang="en-US" dirty="0"/>
-              <a:t>To be ready for real problems, we broke the training four times on purpose. A learning rate too big killed 99.6 percent of the neurons of layer 2. A forgotten zero_grad made the gradients pile up, 26 times bigger after two epochs. Raw pixels gave a first loss of 16 instead of 1.6. And eight sigmoid layers gave a vanishing gradient: the first layer gets a millionth of the gradient of the last one. The key lesson: two of these bugs show the same symptom, a loss stuck at ln 5. Only the monitoring, dead neurons or gradient per layer, tells them apart.</a:t>
+              <a:t>To be ready for problems in production, we broke the training four times on purpose, and diagnosed each run. A learning rate 100 times too big killed 99.6 percent of the neurons of layer 2. A forgotten zero_grad made the gradients pile up: 26 times bigger after two epochs. Raw pixels, without standardisation, gave a first loss of 16 instead of 1.6. And eight sigmoid layers gave a vanishing gradient: the first layer received less than a millionth of the gradient of the last one. The lesson: two of these bugs show the same symptom, a loss stuck at ln 5. Only the monitoring, dead neurons or the gradient per layer, can tell them apart.</a:t>
             </a:r>
             <a:endParaRPr lang="en-US" dirty="0"/>
           </a:p>
@@ -3600,7 +3690,7 @@
           <a:p>
             <a:r>
               <a:rPr lang="en-US" dirty="0"/>
-              <a:t>A network that can see shapes is a convolutional network. With 1 061 images we cannot train one from zero, so we reuse ResNet18, trained on 1.2 million ImageNet photos. We freeze it: each painting becomes 512 numbers, and we train only one linear layer, 2 565 weights, in 0.4 seconds. Result: 88.1 percent on validation, almost twice our best MLP. Fine-tuning the last block, 8.4 million weights, does not help here: it overfits. We also measured two silent bugs: forgetting model.eval() drops the score to 12.8 percent, and forgetting the ImageNet normalisation costs 6 points.</a:t>
+              <a:t>To see shapes, we need a convolutional network. With only 1 061 images we cannot train one from zero, so we reuse ResNet18, already trained on 1.2 million ImageNet photos. We freeze it: each painting becomes 512 numbers, and we train only one linear layer, 2 565 weights, in less than a second. Result: 88.1 percent on validation, almost twice our best MLP. We also fine-tuned the last block: 8.4 million weights for 1 061 images. It overfits: 85.4 percent. And we measured two silent bugs: forgetting model.eval() drops the score to 12.8 percent, and forgetting the ImageNet normalisation costs 6 points. Nothing crashes: only measuring shows them.</a:t>
             </a:r>
             <a:endParaRPr lang="en-US" dirty="0"/>
           </a:p>
@@ -3688,7 +3778,7 @@
           <a:p>
             <a:r>
               <a:rPr lang="en-US" dirty="0"/>
-              <a:t>Now the painter rule from the beginning. To measure it fairly, we scored the same images twice with cross-validation, changing only one thing: whether the model saw other paintings by the same painter. On images by known painters, seeing the painter gives 83.7 percent instead of 72.3: 11 points of pure flattery. On the control group, unknown painters, nothing changes. So the model partly recognises painters, and a random split would have given the director a score that is too optimistic. Our split by painter avoids it.</a:t>
+              <a:t>Now, the painter rule from the beginning. To measure it fairly, we scored the same images twice with cross-validation, and changed only one thing: whether the model had seen other paintings by the same painter. On images by known painters: 83.7 percent when the painter was seen, 72.3 when not. 11 points of flattery. On the control group, the unknown painters, nothing changes. So the model partly recognises painters, and a random split would have given the director a score that is too good. Our split protects the result.</a:t>
             </a:r>
             <a:endParaRPr lang="en-US" dirty="0"/>
           </a:p>
@@ -3776,7 +3866,7 @@
           <a:p>
             <a:r>
               <a:rPr lang="en-US" dirty="0"/>
-              <a:t>Finally, the test, measured once on 220 new paintings. The pretrained models are at the top, from 83 to 88 percent. The best classical model reaches 67 percent, and our MLP 41 percent. The gap between our chosen model and the random forest is 16 points, and a paired bootstrap on the same paintings gives an interval from 9 to 24 points: it is not luck. One honest note: the fine-tuned model is first on test, but it was second on validation. With 220 images a score moves by about 5 points, so we keep the model we chose before the test.</a:t>
+              <a:t>Finally, the test, measured once, on 220 new paintings. The pretrained models are at the top, from 83 to 88 percent. The best classical model reaches 67, our MLP 41. Is the gap real? A paired bootstrap, 5 000 redraws of the same test paintings, gives our model a lead of 16.4 points over the random forest, between 9 and 24 points: it is not luck. One honest note: the fine-tuned model is first on the test, but it was second on validation. With about 220 images, a score moves by about 5 points by chance, so we keep the model we chose before the test. Choosing a model on the test would make the test useless.</a:t>
             </a:r>
             <a:endParaRPr lang="en-US" dirty="0"/>
           </a:p>
@@ -7432,7 +7522,7 @@
                   <a:schemeClr val="tx1"/>
                 </a:solidFill>
               </a:rPr>
-              <a:t>31 automatic tests: split without painter leakage, parameter counts, training loop, metrics, benchmark helpers.</a:t>
+              <a:t>33 automatic tests: split without painter leakage, parameter counts, training loop, metrics, benchmark helpers.</a:t>
             </a:r>
             <a:endParaRPr lang="en-US" sz="1500" dirty="0"/>
           </a:p>
@@ -9166,6 +9256,1404 @@
             <a:fld id="{F7021451-1387-4CA6-816F-3879F97B5CBC}" type="slidenum">
               <a:rPr b="0" lang="en-US"/>
               <a:t>15</a:t>
+            </a:fld>
+            <a:endParaRPr lang="en-US"/>
+          </a:p>
+        </p:txBody>
+      </p:sp>
+    </p:spTree>
+  </p:cSld>
+  <p:clrMapOvr>
+    <a:masterClrMapping/>
+  </p:clrMapOvr>
+</p:sld>
+</file>
+
+<file path=ppt/slides/slide16.xml><?xml version="1.0" encoding="utf-8"?>
+<p:sld xmlns:a="http://schemas.openxmlformats.org/drawingml/2006/main" xmlns:r="http://schemas.openxmlformats.org/officeDocument/2006/relationships" xmlns:p="http://schemas.openxmlformats.org/presentationml/2006/main">
+  <p:cSld name="Slide 16">
+    <p:spTree>
+      <p:nvGrpSpPr>
+        <p:cNvPr id="1" name=""/>
+        <p:cNvGrpSpPr/>
+        <p:nvPr/>
+      </p:nvGrpSpPr>
+      <p:grpSpPr>
+        <a:xfrm>
+          <a:off x="0" y="0"/>
+          <a:ext cx="0" cy="0"/>
+          <a:chOff x="0" y="0"/>
+          <a:chExt cx="0" cy="0"/>
+        </a:xfrm>
+      </p:grpSpPr>
+      <p:sp>
+        <p:nvSpPr>
+          <p:cNvPr id="2" name="Text 0"/>
+          <p:cNvSpPr/>
+          <p:nvPr>
+            <p:ph idx="100" type="title" hasCustomPrompt="1"/>
+          </p:nvPr>
+        </p:nvSpPr>
+        <p:spPr>
+          <a:xfrm>
+            <a:off x="457200" y="274320"/>
+            <a:ext cx="8229600" cy="640080"/>
+          </a:xfrm>
+          <a:prstGeom prst="rect">
+            <a:avLst/>
+          </a:prstGeom>
+          <a:noFill/>
+          <a:ln/>
+        </p:spPr>
+        <p:txBody>
+          <a:bodyPr wrap="square" lIns="0" tIns="0" rIns="0" bIns="0" rtlCol="0" anchor="ctr"/>
+          <a:lstStyle/>
+          <a:p>
+            <a:pPr indent="0" marL="0">
+              <a:buNone/>
+            </a:pPr>
+            <a:r>
+              <a:rPr lang="en-US" sz="3000" b="1" dirty="0">
+                <a:solidFill>
+                  <a:schemeClr val="tx2"/>
+                </a:solidFill>
+              </a:rPr>
+              <a:t>Backup: what about transformers (BERT)?</a:t>
+            </a:r>
+            <a:endParaRPr lang="en-US" sz="3000" dirty="0"/>
+          </a:p>
+        </p:txBody>
+      </p:sp>
+      <p:graphicFrame>
+        <p:nvGraphicFramePr>
+          <p:cNvPr id="17" name="transformers table"/>
+          <p:cNvGraphicFramePr>
+            <a:graphicFrameLocks noGrp="1"/>
+          </p:cNvGraphicFramePr>
+          <p:nvPr>
+            <p:extLst>
+              <p:ext uri="{D42A27DB-BD31-4B8C-83A1-F6EECF244321}">
+                <p14:modId xmlns:p14="http://schemas.microsoft.com/office/powerpoint/2010/main" val="1579011935"/>
+              </p:ext>
+            </p:extLst>
+          </p:nvPr>
+        </p:nvGraphicFramePr>
+        <p:xfrm>
+          <a:off x="457200" y="1051560"/>
+          <a:ext cx="8229600" cy="914400"/>
+        </p:xfrm>
+        <a:graphic>
+          <a:graphicData uri="http://schemas.openxmlformats.org/drawingml/2006/table">
+            <a:tbl>
+              <a:tblPr/>
+              <a:tblGrid>
+                <a:gridCol w="3931920"/>
+                <a:gridCol w="1280160"/>
+                <a:gridCol w="1828800"/>
+                <a:gridCol w="1188720"/>
+              </a:tblGrid>
+              <a:tr h="0">
+                <a:tc>
+                  <a:txBody>
+                    <a:bodyPr/>
+                    <a:lstStyle/>
+                    <a:p>
+                      <a:pPr indent="0" marL="0">
+                        <a:buNone/>
+                      </a:pPr>
+                      <a:r>
+                        <a:rPr lang="en-US" sz="1300" b="1" dirty="0">
+                          <a:solidFill>
+                            <a:schemeClr val="bg1"/>
+                          </a:solidFill>
+                        </a:rPr>
+                        <a:t>Frozen network (validation, 219)</a:t>
+                      </a:r>
+                      <a:endParaRPr lang="en-US" sz="1300" dirty="0"/>
+                    </a:p>
+                  </a:txBody>
+                  <a:tcPr marL="64008" marR="64008" marT="64008" marB="64008" anchor="ctr">
+                    <a:lnL w="9525" cap="flat" cmpd="sng" algn="ctr">
+                      <a:solidFill>
+                        <a:srgbClr val="D9DCE2"/>
+                      </a:solidFill>
+                      <a:prstDash val="solid"/>
+                      <a:round/>
+                      <a:headEnd type="none" w="med" len="med"/>
+                      <a:tailEnd type="none" w="med" len="med"/>
+                    </a:lnL>
+                    <a:lnR w="9525" cap="flat" cmpd="sng" algn="ctr">
+                      <a:solidFill>
+                        <a:srgbClr val="D9DCE2"/>
+                      </a:solidFill>
+                      <a:prstDash val="solid"/>
+                      <a:round/>
+                      <a:headEnd type="none" w="med" len="med"/>
+                      <a:tailEnd type="none" w="med" len="med"/>
+                    </a:lnR>
+                    <a:lnT w="9525" cap="flat" cmpd="sng" algn="ctr">
+                      <a:solidFill>
+                        <a:srgbClr val="D9DCE2"/>
+                      </a:solidFill>
+                      <a:prstDash val="solid"/>
+                      <a:round/>
+                      <a:headEnd type="none" w="med" len="med"/>
+                      <a:tailEnd type="none" w="med" len="med"/>
+                    </a:lnT>
+                    <a:lnB w="9525" cap="flat" cmpd="sng" algn="ctr">
+                      <a:solidFill>
+                        <a:srgbClr val="D9DCE2"/>
+                      </a:solidFill>
+                      <a:prstDash val="solid"/>
+                      <a:round/>
+                      <a:headEnd type="none" w="med" len="med"/>
+                      <a:tailEnd type="none" w="med" len="med"/>
+                    </a:lnB>
+                    <a:solidFill>
+                      <a:schemeClr val="tx2"/>
+                    </a:solidFill>
+                  </a:tcPr>
+                </a:tc>
+                <a:tc>
+                  <a:txBody>
+                    <a:bodyPr/>
+                    <a:lstStyle/>
+                    <a:p>
+                      <a:pPr indent="0" marL="0">
+                        <a:buNone/>
+                      </a:pPr>
+                      <a:r>
+                        <a:rPr lang="en-US" sz="1300" b="1" dirty="0">
+                          <a:solidFill>
+                            <a:schemeClr val="bg1"/>
+                          </a:solidFill>
+                        </a:rPr>
+                        <a:t>Validation</a:t>
+                      </a:r>
+                      <a:endParaRPr lang="en-US" sz="1300" dirty="0"/>
+                    </a:p>
+                  </a:txBody>
+                  <a:tcPr marL="64008" marR="64008" marT="64008" marB="64008" anchor="ctr">
+                    <a:lnL w="9525" cap="flat" cmpd="sng" algn="ctr">
+                      <a:solidFill>
+                        <a:srgbClr val="D9DCE2"/>
+                      </a:solidFill>
+                      <a:prstDash val="solid"/>
+                      <a:round/>
+                      <a:headEnd type="none" w="med" len="med"/>
+                      <a:tailEnd type="none" w="med" len="med"/>
+                    </a:lnL>
+                    <a:lnR w="9525" cap="flat" cmpd="sng" algn="ctr">
+                      <a:solidFill>
+                        <a:srgbClr val="D9DCE2"/>
+                      </a:solidFill>
+                      <a:prstDash val="solid"/>
+                      <a:round/>
+                      <a:headEnd type="none" w="med" len="med"/>
+                      <a:tailEnd type="none" w="med" len="med"/>
+                    </a:lnR>
+                    <a:lnT w="9525" cap="flat" cmpd="sng" algn="ctr">
+                      <a:solidFill>
+                        <a:srgbClr val="D9DCE2"/>
+                      </a:solidFill>
+                      <a:prstDash val="solid"/>
+                      <a:round/>
+                      <a:headEnd type="none" w="med" len="med"/>
+                      <a:tailEnd type="none" w="med" len="med"/>
+                    </a:lnT>
+                    <a:lnB w="9525" cap="flat" cmpd="sng" algn="ctr">
+                      <a:solidFill>
+                        <a:srgbClr val="D9DCE2"/>
+                      </a:solidFill>
+                      <a:prstDash val="solid"/>
+                      <a:round/>
+                      <a:headEnd type="none" w="med" len="med"/>
+                      <a:tailEnd type="none" w="med" len="med"/>
+                    </a:lnB>
+                    <a:solidFill>
+                      <a:schemeClr val="tx2"/>
+                    </a:solidFill>
+                  </a:tcPr>
+                </a:tc>
+                <a:tc>
+                  <a:txBody>
+                    <a:bodyPr/>
+                    <a:lstStyle/>
+                    <a:p>
+                      <a:pPr indent="0" marL="0">
+                        <a:buNone/>
+                      </a:pPr>
+                      <a:r>
+                        <a:rPr lang="en-US" sz="1300" b="1" dirty="0">
+                          <a:solidFill>
+                            <a:schemeClr val="bg1"/>
+                          </a:solidFill>
+                        </a:rPr>
+                        <a:t>Time per photo vs ResNet18</a:t>
+                      </a:r>
+                      <a:endParaRPr lang="en-US" sz="1300" dirty="0"/>
+                    </a:p>
+                  </a:txBody>
+                  <a:tcPr marL="64008" marR="64008" marT="64008" marB="64008" anchor="ctr">
+                    <a:lnL w="9525" cap="flat" cmpd="sng" algn="ctr">
+                      <a:solidFill>
+                        <a:srgbClr val="D9DCE2"/>
+                      </a:solidFill>
+                      <a:prstDash val="solid"/>
+                      <a:round/>
+                      <a:headEnd type="none" w="med" len="med"/>
+                      <a:tailEnd type="none" w="med" len="med"/>
+                    </a:lnL>
+                    <a:lnR w="9525" cap="flat" cmpd="sng" algn="ctr">
+                      <a:solidFill>
+                        <a:srgbClr val="D9DCE2"/>
+                      </a:solidFill>
+                      <a:prstDash val="solid"/>
+                      <a:round/>
+                      <a:headEnd type="none" w="med" len="med"/>
+                      <a:tailEnd type="none" w="med" len="med"/>
+                    </a:lnR>
+                    <a:lnT w="9525" cap="flat" cmpd="sng" algn="ctr">
+                      <a:solidFill>
+                        <a:srgbClr val="D9DCE2"/>
+                      </a:solidFill>
+                      <a:prstDash val="solid"/>
+                      <a:round/>
+                      <a:headEnd type="none" w="med" len="med"/>
+                      <a:tailEnd type="none" w="med" len="med"/>
+                    </a:lnT>
+                    <a:lnB w="9525" cap="flat" cmpd="sng" algn="ctr">
+                      <a:solidFill>
+                        <a:srgbClr val="D9DCE2"/>
+                      </a:solidFill>
+                      <a:prstDash val="solid"/>
+                      <a:round/>
+                      <a:headEnd type="none" w="med" len="med"/>
+                      <a:tailEnd type="none" w="med" len="med"/>
+                    </a:lnB>
+                    <a:solidFill>
+                      <a:schemeClr val="tx2"/>
+                    </a:solidFill>
+                  </a:tcPr>
+                </a:tc>
+                <a:tc>
+                  <a:txBody>
+                    <a:bodyPr/>
+                    <a:lstStyle/>
+                    <a:p>
+                      <a:pPr indent="0" marL="0">
+                        <a:buNone/>
+                      </a:pPr>
+                      <a:r>
+                        <a:rPr lang="en-US" sz="1300" b="1" dirty="0">
+                          <a:solidFill>
+                            <a:schemeClr val="bg1"/>
+                          </a:solidFill>
+                        </a:rPr>
+                        <a:t>Parameters</a:t>
+                      </a:r>
+                      <a:endParaRPr lang="en-US" sz="1300" dirty="0"/>
+                    </a:p>
+                  </a:txBody>
+                  <a:tcPr marL="64008" marR="64008" marT="64008" marB="64008" anchor="ctr">
+                    <a:lnL w="9525" cap="flat" cmpd="sng" algn="ctr">
+                      <a:solidFill>
+                        <a:srgbClr val="D9DCE2"/>
+                      </a:solidFill>
+                      <a:prstDash val="solid"/>
+                      <a:round/>
+                      <a:headEnd type="none" w="med" len="med"/>
+                      <a:tailEnd type="none" w="med" len="med"/>
+                    </a:lnL>
+                    <a:lnR w="9525" cap="flat" cmpd="sng" algn="ctr">
+                      <a:solidFill>
+                        <a:srgbClr val="D9DCE2"/>
+                      </a:solidFill>
+                      <a:prstDash val="solid"/>
+                      <a:round/>
+                      <a:headEnd type="none" w="med" len="med"/>
+                      <a:tailEnd type="none" w="med" len="med"/>
+                    </a:lnR>
+                    <a:lnT w="9525" cap="flat" cmpd="sng" algn="ctr">
+                      <a:solidFill>
+                        <a:srgbClr val="D9DCE2"/>
+                      </a:solidFill>
+                      <a:prstDash val="solid"/>
+                      <a:round/>
+                      <a:headEnd type="none" w="med" len="med"/>
+                      <a:tailEnd type="none" w="med" len="med"/>
+                    </a:lnT>
+                    <a:lnB w="9525" cap="flat" cmpd="sng" algn="ctr">
+                      <a:solidFill>
+                        <a:srgbClr val="D9DCE2"/>
+                      </a:solidFill>
+                      <a:prstDash val="solid"/>
+                      <a:round/>
+                      <a:headEnd type="none" w="med" len="med"/>
+                      <a:tailEnd type="none" w="med" len="med"/>
+                    </a:lnB>
+                    <a:solidFill>
+                      <a:schemeClr val="tx2"/>
+                    </a:solidFill>
+                  </a:tcPr>
+                </a:tc>
+              </a:tr>
+              <a:tr h="0">
+                <a:tc>
+                  <a:txBody>
+                    <a:bodyPr/>
+                    <a:lstStyle/>
+                    <a:p>
+                      <a:pPr indent="0" marL="0">
+                        <a:buNone/>
+                      </a:pPr>
+                      <a:r>
+                        <a:rPr lang="en-US" sz="1300" dirty="0">
+                          <a:solidFill>
+                            <a:schemeClr val="tx1"/>
+                          </a:solidFill>
+                        </a:rPr>
+                        <a:t>ResNet18 + linear head (our choice)</a:t>
+                      </a:r>
+                      <a:endParaRPr lang="en-US" sz="1300" dirty="0"/>
+                    </a:p>
+                  </a:txBody>
+                  <a:tcPr marL="64008" marR="64008" marT="64008" marB="64008" anchor="ctr">
+                    <a:lnL w="9525" cap="flat" cmpd="sng" algn="ctr">
+                      <a:solidFill>
+                        <a:srgbClr val="D9DCE2"/>
+                      </a:solidFill>
+                      <a:prstDash val="solid"/>
+                      <a:round/>
+                      <a:headEnd type="none" w="med" len="med"/>
+                      <a:tailEnd type="none" w="med" len="med"/>
+                    </a:lnL>
+                    <a:lnR w="9525" cap="flat" cmpd="sng" algn="ctr">
+                      <a:solidFill>
+                        <a:srgbClr val="D9DCE2"/>
+                      </a:solidFill>
+                      <a:prstDash val="solid"/>
+                      <a:round/>
+                      <a:headEnd type="none" w="med" len="med"/>
+                      <a:tailEnd type="none" w="med" len="med"/>
+                    </a:lnR>
+                    <a:lnT w="9525" cap="flat" cmpd="sng" algn="ctr">
+                      <a:solidFill>
+                        <a:srgbClr val="D9DCE2"/>
+                      </a:solidFill>
+                      <a:prstDash val="solid"/>
+                      <a:round/>
+                      <a:headEnd type="none" w="med" len="med"/>
+                      <a:tailEnd type="none" w="med" len="med"/>
+                    </a:lnT>
+                    <a:lnB w="9525" cap="flat" cmpd="sng" algn="ctr">
+                      <a:solidFill>
+                        <a:srgbClr val="D9DCE2"/>
+                      </a:solidFill>
+                      <a:prstDash val="solid"/>
+                      <a:round/>
+                      <a:headEnd type="none" w="med" len="med"/>
+                      <a:tailEnd type="none" w="med" len="med"/>
+                    </a:lnB>
+                  </a:tcPr>
+                </a:tc>
+                <a:tc>
+                  <a:txBody>
+                    <a:bodyPr/>
+                    <a:lstStyle/>
+                    <a:p>
+                      <a:pPr indent="0" marL="0">
+                        <a:buNone/>
+                      </a:pPr>
+                      <a:r>
+                        <a:rPr lang="en-US" sz="1300" dirty="0">
+                          <a:solidFill>
+                            <a:schemeClr val="tx1"/>
+                          </a:solidFill>
+                        </a:rPr>
+                        <a:t>88.1 %</a:t>
+                      </a:r>
+                      <a:endParaRPr lang="en-US" sz="1300" dirty="0"/>
+                    </a:p>
+                  </a:txBody>
+                  <a:tcPr marL="64008" marR="64008" marT="64008" marB="64008" anchor="ctr">
+                    <a:lnL w="9525" cap="flat" cmpd="sng" algn="ctr">
+                      <a:solidFill>
+                        <a:srgbClr val="D9DCE2"/>
+                      </a:solidFill>
+                      <a:prstDash val="solid"/>
+                      <a:round/>
+                      <a:headEnd type="none" w="med" len="med"/>
+                      <a:tailEnd type="none" w="med" len="med"/>
+                    </a:lnL>
+                    <a:lnR w="9525" cap="flat" cmpd="sng" algn="ctr">
+                      <a:solidFill>
+                        <a:srgbClr val="D9DCE2"/>
+                      </a:solidFill>
+                      <a:prstDash val="solid"/>
+                      <a:round/>
+                      <a:headEnd type="none" w="med" len="med"/>
+                      <a:tailEnd type="none" w="med" len="med"/>
+                    </a:lnR>
+                    <a:lnT w="9525" cap="flat" cmpd="sng" algn="ctr">
+                      <a:solidFill>
+                        <a:srgbClr val="D9DCE2"/>
+                      </a:solidFill>
+                      <a:prstDash val="solid"/>
+                      <a:round/>
+                      <a:headEnd type="none" w="med" len="med"/>
+                      <a:tailEnd type="none" w="med" len="med"/>
+                    </a:lnT>
+                    <a:lnB w="9525" cap="flat" cmpd="sng" algn="ctr">
+                      <a:solidFill>
+                        <a:srgbClr val="D9DCE2"/>
+                      </a:solidFill>
+                      <a:prstDash val="solid"/>
+                      <a:round/>
+                      <a:headEnd type="none" w="med" len="med"/>
+                      <a:tailEnd type="none" w="med" len="med"/>
+                    </a:lnB>
+                  </a:tcPr>
+                </a:tc>
+                <a:tc>
+                  <a:txBody>
+                    <a:bodyPr/>
+                    <a:lstStyle/>
+                    <a:p>
+                      <a:pPr indent="0" marL="0">
+                        <a:buNone/>
+                      </a:pPr>
+                      <a:r>
+                        <a:rPr lang="en-US" sz="1300" dirty="0">
+                          <a:solidFill>
+                            <a:schemeClr val="tx1"/>
+                          </a:solidFill>
+                        </a:rPr>
+                        <a:t>x 1.0</a:t>
+                      </a:r>
+                      <a:endParaRPr lang="en-US" sz="1300" dirty="0"/>
+                    </a:p>
+                  </a:txBody>
+                  <a:tcPr marL="64008" marR="64008" marT="64008" marB="64008" anchor="ctr">
+                    <a:lnL w="9525" cap="flat" cmpd="sng" algn="ctr">
+                      <a:solidFill>
+                        <a:srgbClr val="D9DCE2"/>
+                      </a:solidFill>
+                      <a:prstDash val="solid"/>
+                      <a:round/>
+                      <a:headEnd type="none" w="med" len="med"/>
+                      <a:tailEnd type="none" w="med" len="med"/>
+                    </a:lnL>
+                    <a:lnR w="9525" cap="flat" cmpd="sng" algn="ctr">
+                      <a:solidFill>
+                        <a:srgbClr val="D9DCE2"/>
+                      </a:solidFill>
+                      <a:prstDash val="solid"/>
+                      <a:round/>
+                      <a:headEnd type="none" w="med" len="med"/>
+                      <a:tailEnd type="none" w="med" len="med"/>
+                    </a:lnR>
+                    <a:lnT w="9525" cap="flat" cmpd="sng" algn="ctr">
+                      <a:solidFill>
+                        <a:srgbClr val="D9DCE2"/>
+                      </a:solidFill>
+                      <a:prstDash val="solid"/>
+                      <a:round/>
+                      <a:headEnd type="none" w="med" len="med"/>
+                      <a:tailEnd type="none" w="med" len="med"/>
+                    </a:lnT>
+                    <a:lnB w="9525" cap="flat" cmpd="sng" algn="ctr">
+                      <a:solidFill>
+                        <a:srgbClr val="D9DCE2"/>
+                      </a:solidFill>
+                      <a:prstDash val="solid"/>
+                      <a:round/>
+                      <a:headEnd type="none" w="med" len="med"/>
+                      <a:tailEnd type="none" w="med" len="med"/>
+                    </a:lnB>
+                  </a:tcPr>
+                </a:tc>
+                <a:tc>
+                  <a:txBody>
+                    <a:bodyPr/>
+                    <a:lstStyle/>
+                    <a:p>
+                      <a:pPr indent="0" marL="0">
+                        <a:buNone/>
+                      </a:pPr>
+                      <a:r>
+                        <a:rPr lang="en-US" sz="1300" dirty="0">
+                          <a:solidFill>
+                            <a:schemeClr val="tx1"/>
+                          </a:solidFill>
+                        </a:rPr>
+                        <a:t>11 M</a:t>
+                      </a:r>
+                      <a:endParaRPr lang="en-US" sz="1300" dirty="0"/>
+                    </a:p>
+                  </a:txBody>
+                  <a:tcPr marL="64008" marR="64008" marT="64008" marB="64008" anchor="ctr">
+                    <a:lnL w="9525" cap="flat" cmpd="sng" algn="ctr">
+                      <a:solidFill>
+                        <a:srgbClr val="D9DCE2"/>
+                      </a:solidFill>
+                      <a:prstDash val="solid"/>
+                      <a:round/>
+                      <a:headEnd type="none" w="med" len="med"/>
+                      <a:tailEnd type="none" w="med" len="med"/>
+                    </a:lnL>
+                    <a:lnR w="9525" cap="flat" cmpd="sng" algn="ctr">
+                      <a:solidFill>
+                        <a:srgbClr val="D9DCE2"/>
+                      </a:solidFill>
+                      <a:prstDash val="solid"/>
+                      <a:round/>
+                      <a:headEnd type="none" w="med" len="med"/>
+                      <a:tailEnd type="none" w="med" len="med"/>
+                    </a:lnR>
+                    <a:lnT w="9525" cap="flat" cmpd="sng" algn="ctr">
+                      <a:solidFill>
+                        <a:srgbClr val="D9DCE2"/>
+                      </a:solidFill>
+                      <a:prstDash val="solid"/>
+                      <a:round/>
+                      <a:headEnd type="none" w="med" len="med"/>
+                      <a:tailEnd type="none" w="med" len="med"/>
+                    </a:lnT>
+                    <a:lnB w="9525" cap="flat" cmpd="sng" algn="ctr">
+                      <a:solidFill>
+                        <a:srgbClr val="D9DCE2"/>
+                      </a:solidFill>
+                      <a:prstDash val="solid"/>
+                      <a:round/>
+                      <a:headEnd type="none" w="med" len="med"/>
+                      <a:tailEnd type="none" w="med" len="med"/>
+                    </a:lnB>
+                  </a:tcPr>
+                </a:tc>
+              </a:tr>
+              <a:tr h="0">
+                <a:tc>
+                  <a:txBody>
+                    <a:bodyPr/>
+                    <a:lstStyle/>
+                    <a:p>
+                      <a:pPr indent="0" marL="0">
+                        <a:buNone/>
+                      </a:pPr>
+                      <a:r>
+                        <a:rPr lang="en-US" sz="1300" dirty="0">
+                          <a:solidFill>
+                            <a:schemeClr val="tx1"/>
+                          </a:solidFill>
+                        </a:rPr>
+                        <a:t>ViT-B/16 (BERT on image patches) + linear head</a:t>
+                      </a:r>
+                      <a:endParaRPr lang="en-US" sz="1300" dirty="0"/>
+                    </a:p>
+                  </a:txBody>
+                  <a:tcPr marL="64008" marR="64008" marT="64008" marB="64008" anchor="ctr">
+                    <a:lnL w="9525" cap="flat" cmpd="sng" algn="ctr">
+                      <a:solidFill>
+                        <a:srgbClr val="D9DCE2"/>
+                      </a:solidFill>
+                      <a:prstDash val="solid"/>
+                      <a:round/>
+                      <a:headEnd type="none" w="med" len="med"/>
+                      <a:tailEnd type="none" w="med" len="med"/>
+                    </a:lnL>
+                    <a:lnR w="9525" cap="flat" cmpd="sng" algn="ctr">
+                      <a:solidFill>
+                        <a:srgbClr val="D9DCE2"/>
+                      </a:solidFill>
+                      <a:prstDash val="solid"/>
+                      <a:round/>
+                      <a:headEnd type="none" w="med" len="med"/>
+                      <a:tailEnd type="none" w="med" len="med"/>
+                    </a:lnR>
+                    <a:lnT w="9525" cap="flat" cmpd="sng" algn="ctr">
+                      <a:solidFill>
+                        <a:srgbClr val="D9DCE2"/>
+                      </a:solidFill>
+                      <a:prstDash val="solid"/>
+                      <a:round/>
+                      <a:headEnd type="none" w="med" len="med"/>
+                      <a:tailEnd type="none" w="med" len="med"/>
+                    </a:lnT>
+                    <a:lnB w="9525" cap="flat" cmpd="sng" algn="ctr">
+                      <a:solidFill>
+                        <a:srgbClr val="D9DCE2"/>
+                      </a:solidFill>
+                      <a:prstDash val="solid"/>
+                      <a:round/>
+                      <a:headEnd type="none" w="med" len="med"/>
+                      <a:tailEnd type="none" w="med" len="med"/>
+                    </a:lnB>
+                  </a:tcPr>
+                </a:tc>
+                <a:tc>
+                  <a:txBody>
+                    <a:bodyPr/>
+                    <a:lstStyle/>
+                    <a:p>
+                      <a:pPr indent="0" marL="0">
+                        <a:buNone/>
+                      </a:pPr>
+                      <a:r>
+                        <a:rPr lang="en-US" sz="1300" dirty="0">
+                          <a:solidFill>
+                            <a:schemeClr val="tx1"/>
+                          </a:solidFill>
+                        </a:rPr>
+                        <a:t>88.1 %</a:t>
+                      </a:r>
+                      <a:endParaRPr lang="en-US" sz="1300" dirty="0"/>
+                    </a:p>
+                  </a:txBody>
+                  <a:tcPr marL="64008" marR="64008" marT="64008" marB="64008" anchor="ctr">
+                    <a:lnL w="9525" cap="flat" cmpd="sng" algn="ctr">
+                      <a:solidFill>
+                        <a:srgbClr val="D9DCE2"/>
+                      </a:solidFill>
+                      <a:prstDash val="solid"/>
+                      <a:round/>
+                      <a:headEnd type="none" w="med" len="med"/>
+                      <a:tailEnd type="none" w="med" len="med"/>
+                    </a:lnL>
+                    <a:lnR w="9525" cap="flat" cmpd="sng" algn="ctr">
+                      <a:solidFill>
+                        <a:srgbClr val="D9DCE2"/>
+                      </a:solidFill>
+                      <a:prstDash val="solid"/>
+                      <a:round/>
+                      <a:headEnd type="none" w="med" len="med"/>
+                      <a:tailEnd type="none" w="med" len="med"/>
+                    </a:lnR>
+                    <a:lnT w="9525" cap="flat" cmpd="sng" algn="ctr">
+                      <a:solidFill>
+                        <a:srgbClr val="D9DCE2"/>
+                      </a:solidFill>
+                      <a:prstDash val="solid"/>
+                      <a:round/>
+                      <a:headEnd type="none" w="med" len="med"/>
+                      <a:tailEnd type="none" w="med" len="med"/>
+                    </a:lnT>
+                    <a:lnB w="9525" cap="flat" cmpd="sng" algn="ctr">
+                      <a:solidFill>
+                        <a:srgbClr val="D9DCE2"/>
+                      </a:solidFill>
+                      <a:prstDash val="solid"/>
+                      <a:round/>
+                      <a:headEnd type="none" w="med" len="med"/>
+                      <a:tailEnd type="none" w="med" len="med"/>
+                    </a:lnB>
+                  </a:tcPr>
+                </a:tc>
+                <a:tc>
+                  <a:txBody>
+                    <a:bodyPr/>
+                    <a:lstStyle/>
+                    <a:p>
+                      <a:pPr indent="0" marL="0">
+                        <a:buNone/>
+                      </a:pPr>
+                      <a:r>
+                        <a:rPr lang="en-US" sz="1300" dirty="0">
+                          <a:solidFill>
+                            <a:schemeClr val="tx1"/>
+                          </a:solidFill>
+                        </a:rPr>
+                        <a:t>x 9.1</a:t>
+                      </a:r>
+                      <a:endParaRPr lang="en-US" sz="1300" dirty="0"/>
+                    </a:p>
+                  </a:txBody>
+                  <a:tcPr marL="64008" marR="64008" marT="64008" marB="64008" anchor="ctr">
+                    <a:lnL w="9525" cap="flat" cmpd="sng" algn="ctr">
+                      <a:solidFill>
+                        <a:srgbClr val="D9DCE2"/>
+                      </a:solidFill>
+                      <a:prstDash val="solid"/>
+                      <a:round/>
+                      <a:headEnd type="none" w="med" len="med"/>
+                      <a:tailEnd type="none" w="med" len="med"/>
+                    </a:lnL>
+                    <a:lnR w="9525" cap="flat" cmpd="sng" algn="ctr">
+                      <a:solidFill>
+                        <a:srgbClr val="D9DCE2"/>
+                      </a:solidFill>
+                      <a:prstDash val="solid"/>
+                      <a:round/>
+                      <a:headEnd type="none" w="med" len="med"/>
+                      <a:tailEnd type="none" w="med" len="med"/>
+                    </a:lnR>
+                    <a:lnT w="9525" cap="flat" cmpd="sng" algn="ctr">
+                      <a:solidFill>
+                        <a:srgbClr val="D9DCE2"/>
+                      </a:solidFill>
+                      <a:prstDash val="solid"/>
+                      <a:round/>
+                      <a:headEnd type="none" w="med" len="med"/>
+                      <a:tailEnd type="none" w="med" len="med"/>
+                    </a:lnT>
+                    <a:lnB w="9525" cap="flat" cmpd="sng" algn="ctr">
+                      <a:solidFill>
+                        <a:srgbClr val="D9DCE2"/>
+                      </a:solidFill>
+                      <a:prstDash val="solid"/>
+                      <a:round/>
+                      <a:headEnd type="none" w="med" len="med"/>
+                      <a:tailEnd type="none" w="med" len="med"/>
+                    </a:lnB>
+                  </a:tcPr>
+                </a:tc>
+                <a:tc>
+                  <a:txBody>
+                    <a:bodyPr/>
+                    <a:lstStyle/>
+                    <a:p>
+                      <a:pPr indent="0" marL="0">
+                        <a:buNone/>
+                      </a:pPr>
+                      <a:r>
+                        <a:rPr lang="en-US" sz="1300" dirty="0">
+                          <a:solidFill>
+                            <a:schemeClr val="tx1"/>
+                          </a:solidFill>
+                        </a:rPr>
+                        <a:t>86 M</a:t>
+                      </a:r>
+                      <a:endParaRPr lang="en-US" sz="1300" dirty="0"/>
+                    </a:p>
+                  </a:txBody>
+                  <a:tcPr marL="64008" marR="64008" marT="64008" marB="64008" anchor="ctr">
+                    <a:lnL w="9525" cap="flat" cmpd="sng" algn="ctr">
+                      <a:solidFill>
+                        <a:srgbClr val="D9DCE2"/>
+                      </a:solidFill>
+                      <a:prstDash val="solid"/>
+                      <a:round/>
+                      <a:headEnd type="none" w="med" len="med"/>
+                      <a:tailEnd type="none" w="med" len="med"/>
+                    </a:lnL>
+                    <a:lnR w="9525" cap="flat" cmpd="sng" algn="ctr">
+                      <a:solidFill>
+                        <a:srgbClr val="D9DCE2"/>
+                      </a:solidFill>
+                      <a:prstDash val="solid"/>
+                      <a:round/>
+                      <a:headEnd type="none" w="med" len="med"/>
+                      <a:tailEnd type="none" w="med" len="med"/>
+                    </a:lnR>
+                    <a:lnT w="9525" cap="flat" cmpd="sng" algn="ctr">
+                      <a:solidFill>
+                        <a:srgbClr val="D9DCE2"/>
+                      </a:solidFill>
+                      <a:prstDash val="solid"/>
+                      <a:round/>
+                      <a:headEnd type="none" w="med" len="med"/>
+                      <a:tailEnd type="none" w="med" len="med"/>
+                    </a:lnT>
+                    <a:lnB w="9525" cap="flat" cmpd="sng" algn="ctr">
+                      <a:solidFill>
+                        <a:srgbClr val="D9DCE2"/>
+                      </a:solidFill>
+                      <a:prstDash val="solid"/>
+                      <a:round/>
+                      <a:headEnd type="none" w="med" len="med"/>
+                      <a:tailEnd type="none" w="med" len="med"/>
+                    </a:lnB>
+                  </a:tcPr>
+                </a:tc>
+              </a:tr>
+              <a:tr h="0">
+                <a:tc>
+                  <a:txBody>
+                    <a:bodyPr/>
+                    <a:lstStyle/>
+                    <a:p>
+                      <a:pPr indent="0" marL="0">
+                        <a:buNone/>
+                      </a:pPr>
+                      <a:r>
+                        <a:rPr lang="en-US" sz="1300" dirty="0">
+                          <a:solidFill>
+                            <a:schemeClr val="tx1"/>
+                          </a:solidFill>
+                        </a:rPr>
+                        <a:t>CLIP ViT-B/32, zero-shot (no training at all)</a:t>
+                      </a:r>
+                      <a:endParaRPr lang="en-US" sz="1300" dirty="0"/>
+                    </a:p>
+                  </a:txBody>
+                  <a:tcPr marL="64008" marR="64008" marT="64008" marB="64008" anchor="ctr">
+                    <a:lnL w="9525" cap="flat" cmpd="sng" algn="ctr">
+                      <a:solidFill>
+                        <a:srgbClr val="D9DCE2"/>
+                      </a:solidFill>
+                      <a:prstDash val="solid"/>
+                      <a:round/>
+                      <a:headEnd type="none" w="med" len="med"/>
+                      <a:tailEnd type="none" w="med" len="med"/>
+                    </a:lnL>
+                    <a:lnR w="9525" cap="flat" cmpd="sng" algn="ctr">
+                      <a:solidFill>
+                        <a:srgbClr val="D9DCE2"/>
+                      </a:solidFill>
+                      <a:prstDash val="solid"/>
+                      <a:round/>
+                      <a:headEnd type="none" w="med" len="med"/>
+                      <a:tailEnd type="none" w="med" len="med"/>
+                    </a:lnR>
+                    <a:lnT w="9525" cap="flat" cmpd="sng" algn="ctr">
+                      <a:solidFill>
+                        <a:srgbClr val="D9DCE2"/>
+                      </a:solidFill>
+                      <a:prstDash val="solid"/>
+                      <a:round/>
+                      <a:headEnd type="none" w="med" len="med"/>
+                      <a:tailEnd type="none" w="med" len="med"/>
+                    </a:lnT>
+                    <a:lnB w="9525" cap="flat" cmpd="sng" algn="ctr">
+                      <a:solidFill>
+                        <a:srgbClr val="D9DCE2"/>
+                      </a:solidFill>
+                      <a:prstDash val="solid"/>
+                      <a:round/>
+                      <a:headEnd type="none" w="med" len="med"/>
+                      <a:tailEnd type="none" w="med" len="med"/>
+                    </a:lnB>
+                  </a:tcPr>
+                </a:tc>
+                <a:tc>
+                  <a:txBody>
+                    <a:bodyPr/>
+                    <a:lstStyle/>
+                    <a:p>
+                      <a:pPr indent="0" marL="0">
+                        <a:buNone/>
+                      </a:pPr>
+                      <a:r>
+                        <a:rPr lang="en-US" sz="1300" dirty="0">
+                          <a:solidFill>
+                            <a:schemeClr val="tx1"/>
+                          </a:solidFill>
+                        </a:rPr>
+                        <a:t>89.0 %</a:t>
+                      </a:r>
+                      <a:endParaRPr lang="en-US" sz="1300" dirty="0"/>
+                    </a:p>
+                  </a:txBody>
+                  <a:tcPr marL="64008" marR="64008" marT="64008" marB="64008" anchor="ctr">
+                    <a:lnL w="9525" cap="flat" cmpd="sng" algn="ctr">
+                      <a:solidFill>
+                        <a:srgbClr val="D9DCE2"/>
+                      </a:solidFill>
+                      <a:prstDash val="solid"/>
+                      <a:round/>
+                      <a:headEnd type="none" w="med" len="med"/>
+                      <a:tailEnd type="none" w="med" len="med"/>
+                    </a:lnL>
+                    <a:lnR w="9525" cap="flat" cmpd="sng" algn="ctr">
+                      <a:solidFill>
+                        <a:srgbClr val="D9DCE2"/>
+                      </a:solidFill>
+                      <a:prstDash val="solid"/>
+                      <a:round/>
+                      <a:headEnd type="none" w="med" len="med"/>
+                      <a:tailEnd type="none" w="med" len="med"/>
+                    </a:lnR>
+                    <a:lnT w="9525" cap="flat" cmpd="sng" algn="ctr">
+                      <a:solidFill>
+                        <a:srgbClr val="D9DCE2"/>
+                      </a:solidFill>
+                      <a:prstDash val="solid"/>
+                      <a:round/>
+                      <a:headEnd type="none" w="med" len="med"/>
+                      <a:tailEnd type="none" w="med" len="med"/>
+                    </a:lnT>
+                    <a:lnB w="9525" cap="flat" cmpd="sng" algn="ctr">
+                      <a:solidFill>
+                        <a:srgbClr val="D9DCE2"/>
+                      </a:solidFill>
+                      <a:prstDash val="solid"/>
+                      <a:round/>
+                      <a:headEnd type="none" w="med" len="med"/>
+                      <a:tailEnd type="none" w="med" len="med"/>
+                    </a:lnB>
+                  </a:tcPr>
+                </a:tc>
+                <a:tc>
+                  <a:txBody>
+                    <a:bodyPr/>
+                    <a:lstStyle/>
+                    <a:p>
+                      <a:pPr indent="0" marL="0">
+                        <a:buNone/>
+                      </a:pPr>
+                      <a:r>
+                        <a:rPr lang="en-US" sz="1300" dirty="0">
+                          <a:solidFill>
+                            <a:schemeClr val="tx1"/>
+                          </a:solidFill>
+                        </a:rPr>
+                        <a:t>x 2.7</a:t>
+                      </a:r>
+                      <a:endParaRPr lang="en-US" sz="1300" dirty="0"/>
+                    </a:p>
+                  </a:txBody>
+                  <a:tcPr marL="64008" marR="64008" marT="64008" marB="64008" anchor="ctr">
+                    <a:lnL w="9525" cap="flat" cmpd="sng" algn="ctr">
+                      <a:solidFill>
+                        <a:srgbClr val="D9DCE2"/>
+                      </a:solidFill>
+                      <a:prstDash val="solid"/>
+                      <a:round/>
+                      <a:headEnd type="none" w="med" len="med"/>
+                      <a:tailEnd type="none" w="med" len="med"/>
+                    </a:lnL>
+                    <a:lnR w="9525" cap="flat" cmpd="sng" algn="ctr">
+                      <a:solidFill>
+                        <a:srgbClr val="D9DCE2"/>
+                      </a:solidFill>
+                      <a:prstDash val="solid"/>
+                      <a:round/>
+                      <a:headEnd type="none" w="med" len="med"/>
+                      <a:tailEnd type="none" w="med" len="med"/>
+                    </a:lnR>
+                    <a:lnT w="9525" cap="flat" cmpd="sng" algn="ctr">
+                      <a:solidFill>
+                        <a:srgbClr val="D9DCE2"/>
+                      </a:solidFill>
+                      <a:prstDash val="solid"/>
+                      <a:round/>
+                      <a:headEnd type="none" w="med" len="med"/>
+                      <a:tailEnd type="none" w="med" len="med"/>
+                    </a:lnT>
+                    <a:lnB w="9525" cap="flat" cmpd="sng" algn="ctr">
+                      <a:solidFill>
+                        <a:srgbClr val="D9DCE2"/>
+                      </a:solidFill>
+                      <a:prstDash val="solid"/>
+                      <a:round/>
+                      <a:headEnd type="none" w="med" len="med"/>
+                      <a:tailEnd type="none" w="med" len="med"/>
+                    </a:lnB>
+                  </a:tcPr>
+                </a:tc>
+                <a:tc>
+                  <a:txBody>
+                    <a:bodyPr/>
+                    <a:lstStyle/>
+                    <a:p>
+                      <a:pPr indent="0" marL="0">
+                        <a:buNone/>
+                      </a:pPr>
+                      <a:r>
+                        <a:rPr lang="en-US" sz="1300" dirty="0">
+                          <a:solidFill>
+                            <a:schemeClr val="tx1"/>
+                          </a:solidFill>
+                        </a:rPr>
+                        <a:t>151 M</a:t>
+                      </a:r>
+                      <a:endParaRPr lang="en-US" sz="1300" dirty="0"/>
+                    </a:p>
+                  </a:txBody>
+                  <a:tcPr marL="64008" marR="64008" marT="64008" marB="64008" anchor="ctr">
+                    <a:lnL w="9525" cap="flat" cmpd="sng" algn="ctr">
+                      <a:solidFill>
+                        <a:srgbClr val="D9DCE2"/>
+                      </a:solidFill>
+                      <a:prstDash val="solid"/>
+                      <a:round/>
+                      <a:headEnd type="none" w="med" len="med"/>
+                      <a:tailEnd type="none" w="med" len="med"/>
+                    </a:lnL>
+                    <a:lnR w="9525" cap="flat" cmpd="sng" algn="ctr">
+                      <a:solidFill>
+                        <a:srgbClr val="D9DCE2"/>
+                      </a:solidFill>
+                      <a:prstDash val="solid"/>
+                      <a:round/>
+                      <a:headEnd type="none" w="med" len="med"/>
+                      <a:tailEnd type="none" w="med" len="med"/>
+                    </a:lnR>
+                    <a:lnT w="9525" cap="flat" cmpd="sng" algn="ctr">
+                      <a:solidFill>
+                        <a:srgbClr val="D9DCE2"/>
+                      </a:solidFill>
+                      <a:prstDash val="solid"/>
+                      <a:round/>
+                      <a:headEnd type="none" w="med" len="med"/>
+                      <a:tailEnd type="none" w="med" len="med"/>
+                    </a:lnT>
+                    <a:lnB w="9525" cap="flat" cmpd="sng" algn="ctr">
+                      <a:solidFill>
+                        <a:srgbClr val="D9DCE2"/>
+                      </a:solidFill>
+                      <a:prstDash val="solid"/>
+                      <a:round/>
+                      <a:headEnd type="none" w="med" len="med"/>
+                      <a:tailEnd type="none" w="med" len="med"/>
+                    </a:lnB>
+                  </a:tcPr>
+                </a:tc>
+              </a:tr>
+              <a:tr h="0">
+                <a:tc>
+                  <a:txBody>
+                    <a:bodyPr/>
+                    <a:lstStyle/>
+                    <a:p>
+                      <a:pPr indent="0" marL="0">
+                        <a:buNone/>
+                      </a:pPr>
+                      <a:r>
+                        <a:rPr lang="en-US" sz="1300" dirty="0">
+                          <a:solidFill>
+                            <a:schemeClr val="tx1"/>
+                          </a:solidFill>
+                        </a:rPr>
+                        <a:t>CLIP ViT-B/32 + linear head</a:t>
+                      </a:r>
+                      <a:endParaRPr lang="en-US" sz="1300" dirty="0"/>
+                    </a:p>
+                  </a:txBody>
+                  <a:tcPr marL="64008" marR="64008" marT="64008" marB="64008" anchor="ctr">
+                    <a:lnL w="9525" cap="flat" cmpd="sng" algn="ctr">
+                      <a:solidFill>
+                        <a:srgbClr val="D9DCE2"/>
+                      </a:solidFill>
+                      <a:prstDash val="solid"/>
+                      <a:round/>
+                      <a:headEnd type="none" w="med" len="med"/>
+                      <a:tailEnd type="none" w="med" len="med"/>
+                    </a:lnL>
+                    <a:lnR w="9525" cap="flat" cmpd="sng" algn="ctr">
+                      <a:solidFill>
+                        <a:srgbClr val="D9DCE2"/>
+                      </a:solidFill>
+                      <a:prstDash val="solid"/>
+                      <a:round/>
+                      <a:headEnd type="none" w="med" len="med"/>
+                      <a:tailEnd type="none" w="med" len="med"/>
+                    </a:lnR>
+                    <a:lnT w="9525" cap="flat" cmpd="sng" algn="ctr">
+                      <a:solidFill>
+                        <a:srgbClr val="D9DCE2"/>
+                      </a:solidFill>
+                      <a:prstDash val="solid"/>
+                      <a:round/>
+                      <a:headEnd type="none" w="med" len="med"/>
+                      <a:tailEnd type="none" w="med" len="med"/>
+                    </a:lnT>
+                    <a:lnB w="9525" cap="flat" cmpd="sng" algn="ctr">
+                      <a:solidFill>
+                        <a:srgbClr val="D9DCE2"/>
+                      </a:solidFill>
+                      <a:prstDash val="solid"/>
+                      <a:round/>
+                      <a:headEnd type="none" w="med" len="med"/>
+                      <a:tailEnd type="none" w="med" len="med"/>
+                    </a:lnB>
+                  </a:tcPr>
+                </a:tc>
+                <a:tc>
+                  <a:txBody>
+                    <a:bodyPr/>
+                    <a:lstStyle/>
+                    <a:p>
+                      <a:pPr indent="0" marL="0">
+                        <a:buNone/>
+                      </a:pPr>
+                      <a:r>
+                        <a:rPr lang="en-US" sz="1300" dirty="0">
+                          <a:solidFill>
+                            <a:schemeClr val="tx1"/>
+                          </a:solidFill>
+                        </a:rPr>
+                        <a:t>94.7 %</a:t>
+                      </a:r>
+                      <a:endParaRPr lang="en-US" sz="1300" dirty="0"/>
+                    </a:p>
+                  </a:txBody>
+                  <a:tcPr marL="64008" marR="64008" marT="64008" marB="64008" anchor="ctr">
+                    <a:lnL w="9525" cap="flat" cmpd="sng" algn="ctr">
+                      <a:solidFill>
+                        <a:srgbClr val="D9DCE2"/>
+                      </a:solidFill>
+                      <a:prstDash val="solid"/>
+                      <a:round/>
+                      <a:headEnd type="none" w="med" len="med"/>
+                      <a:tailEnd type="none" w="med" len="med"/>
+                    </a:lnL>
+                    <a:lnR w="9525" cap="flat" cmpd="sng" algn="ctr">
+                      <a:solidFill>
+                        <a:srgbClr val="D9DCE2"/>
+                      </a:solidFill>
+                      <a:prstDash val="solid"/>
+                      <a:round/>
+                      <a:headEnd type="none" w="med" len="med"/>
+                      <a:tailEnd type="none" w="med" len="med"/>
+                    </a:lnR>
+                    <a:lnT w="9525" cap="flat" cmpd="sng" algn="ctr">
+                      <a:solidFill>
+                        <a:srgbClr val="D9DCE2"/>
+                      </a:solidFill>
+                      <a:prstDash val="solid"/>
+                      <a:round/>
+                      <a:headEnd type="none" w="med" len="med"/>
+                      <a:tailEnd type="none" w="med" len="med"/>
+                    </a:lnT>
+                    <a:lnB w="9525" cap="flat" cmpd="sng" algn="ctr">
+                      <a:solidFill>
+                        <a:srgbClr val="D9DCE2"/>
+                      </a:solidFill>
+                      <a:prstDash val="solid"/>
+                      <a:round/>
+                      <a:headEnd type="none" w="med" len="med"/>
+                      <a:tailEnd type="none" w="med" len="med"/>
+                    </a:lnB>
+                  </a:tcPr>
+                </a:tc>
+                <a:tc>
+                  <a:txBody>
+                    <a:bodyPr/>
+                    <a:lstStyle/>
+                    <a:p>
+                      <a:pPr indent="0" marL="0">
+                        <a:buNone/>
+                      </a:pPr>
+                      <a:r>
+                        <a:rPr lang="en-US" sz="1300" dirty="0">
+                          <a:solidFill>
+                            <a:schemeClr val="tx1"/>
+                          </a:solidFill>
+                        </a:rPr>
+                        <a:t>x 2.7</a:t>
+                      </a:r>
+                      <a:endParaRPr lang="en-US" sz="1300" dirty="0"/>
+                    </a:p>
+                  </a:txBody>
+                  <a:tcPr marL="64008" marR="64008" marT="64008" marB="64008" anchor="ctr">
+                    <a:lnL w="9525" cap="flat" cmpd="sng" algn="ctr">
+                      <a:solidFill>
+                        <a:srgbClr val="D9DCE2"/>
+                      </a:solidFill>
+                      <a:prstDash val="solid"/>
+                      <a:round/>
+                      <a:headEnd type="none" w="med" len="med"/>
+                      <a:tailEnd type="none" w="med" len="med"/>
+                    </a:lnL>
+                    <a:lnR w="9525" cap="flat" cmpd="sng" algn="ctr">
+                      <a:solidFill>
+                        <a:srgbClr val="D9DCE2"/>
+                      </a:solidFill>
+                      <a:prstDash val="solid"/>
+                      <a:round/>
+                      <a:headEnd type="none" w="med" len="med"/>
+                      <a:tailEnd type="none" w="med" len="med"/>
+                    </a:lnR>
+                    <a:lnT w="9525" cap="flat" cmpd="sng" algn="ctr">
+                      <a:solidFill>
+                        <a:srgbClr val="D9DCE2"/>
+                      </a:solidFill>
+                      <a:prstDash val="solid"/>
+                      <a:round/>
+                      <a:headEnd type="none" w="med" len="med"/>
+                      <a:tailEnd type="none" w="med" len="med"/>
+                    </a:lnT>
+                    <a:lnB w="9525" cap="flat" cmpd="sng" algn="ctr">
+                      <a:solidFill>
+                        <a:srgbClr val="D9DCE2"/>
+                      </a:solidFill>
+                      <a:prstDash val="solid"/>
+                      <a:round/>
+                      <a:headEnd type="none" w="med" len="med"/>
+                      <a:tailEnd type="none" w="med" len="med"/>
+                    </a:lnB>
+                  </a:tcPr>
+                </a:tc>
+                <a:tc>
+                  <a:txBody>
+                    <a:bodyPr/>
+                    <a:lstStyle/>
+                    <a:p>
+                      <a:pPr indent="0" marL="0">
+                        <a:buNone/>
+                      </a:pPr>
+                      <a:r>
+                        <a:rPr lang="en-US" sz="1300" dirty="0">
+                          <a:solidFill>
+                            <a:schemeClr val="tx1"/>
+                          </a:solidFill>
+                        </a:rPr>
+                        <a:t>151 M</a:t>
+                      </a:r>
+                      <a:endParaRPr lang="en-US" sz="1300" dirty="0"/>
+                    </a:p>
+                  </a:txBody>
+                  <a:tcPr marL="64008" marR="64008" marT="64008" marB="64008" anchor="ctr">
+                    <a:lnL w="9525" cap="flat" cmpd="sng" algn="ctr">
+                      <a:solidFill>
+                        <a:srgbClr val="D9DCE2"/>
+                      </a:solidFill>
+                      <a:prstDash val="solid"/>
+                      <a:round/>
+                      <a:headEnd type="none" w="med" len="med"/>
+                      <a:tailEnd type="none" w="med" len="med"/>
+                    </a:lnL>
+                    <a:lnR w="9525" cap="flat" cmpd="sng" algn="ctr">
+                      <a:solidFill>
+                        <a:srgbClr val="D9DCE2"/>
+                      </a:solidFill>
+                      <a:prstDash val="solid"/>
+                      <a:round/>
+                      <a:headEnd type="none" w="med" len="med"/>
+                      <a:tailEnd type="none" w="med" len="med"/>
+                    </a:lnR>
+                    <a:lnT w="9525" cap="flat" cmpd="sng" algn="ctr">
+                      <a:solidFill>
+                        <a:srgbClr val="D9DCE2"/>
+                      </a:solidFill>
+                      <a:prstDash val="solid"/>
+                      <a:round/>
+                      <a:headEnd type="none" w="med" len="med"/>
+                      <a:tailEnd type="none" w="med" len="med"/>
+                    </a:lnT>
+                    <a:lnB w="9525" cap="flat" cmpd="sng" algn="ctr">
+                      <a:solidFill>
+                        <a:srgbClr val="D9DCE2"/>
+                      </a:solidFill>
+                      <a:prstDash val="solid"/>
+                      <a:round/>
+                      <a:headEnd type="none" w="med" len="med"/>
+                      <a:tailEnd type="none" w="med" len="med"/>
+                    </a:lnB>
+                  </a:tcPr>
+                </a:tc>
+              </a:tr>
+            </a:tbl>
+          </a:graphicData>
+        </a:graphic>
+      </p:graphicFrame>
+      <p:sp>
+        <p:nvSpPr>
+          <p:cNvPr id="4" name="transformers bullets"/>
+          <p:cNvSpPr txBox="1"/>
+          <p:nvPr/>
+        </p:nvSpPr>
+        <p:spPr>
+          <a:xfrm>
+            <a:off x="457200" y="3246120"/>
+            <a:ext cx="8229600" cy="1417320"/>
+          </a:xfrm>
+          <a:prstGeom prst="rect">
+            <a:avLst/>
+          </a:prstGeom>
+          <a:noFill/>
+          <a:ln/>
+        </p:spPr>
+        <p:txBody>
+          <a:bodyPr wrap="square" lIns="0" tIns="0" rIns="0" bIns="0" rtlCol="0" anchor="t"/>
+          <a:lstStyle/>
+          <a:p>
+            <a:pPr marL="342900" indent="-342900">
+              <a:spcAft>
+                <a:spcPts val="800"/>
+              </a:spcAft>
+              <a:buSzPct val="100000"/>
+              <a:buChar char="•"/>
+            </a:pPr>
+            <a:r>
+              <a:rPr lang="en-US" sz="1400" dirty="0">
+                <a:solidFill>
+                  <a:schemeClr val="tx1"/>
+                </a:solidFill>
+              </a:rPr>
+              <a:t>BERT itself reads words, not pixels; its image cousins are ViT and CLIP</a:t>
+            </a:r>
+            <a:endParaRPr lang="en-US" sz="1400" dirty="0"/>
+          </a:p>
+          <a:p>
+            <a:pPr marL="342900" indent="-342900">
+              <a:spcAft>
+                <a:spcPts val="800"/>
+              </a:spcAft>
+              <a:buSzPct val="100000"/>
+              <a:buChar char="•"/>
+            </a:pPr>
+            <a:r>
+              <a:rPr lang="en-US" sz="1400" dirty="0">
+                <a:solidFill>
+                  <a:schemeClr val="tx1"/>
+                </a:solidFill>
+              </a:rPr>
+              <a:t>CLIP is the most accurate (+6.8 points over ResNet18, paired interval 2.3 to 11.4) but 2.7 times slower; trained on Internet images, it has probably seen WikiArt</a:t>
+            </a:r>
+            <a:endParaRPr lang="en-US" sz="1400" dirty="0"/>
+          </a:p>
+          <a:p>
+            <a:pPr marL="342900" indent="-342900">
+              <a:spcAft>
+                <a:spcPts val="800"/>
+              </a:spcAft>
+              <a:buSzPct val="100000"/>
+              <a:buChar char="•"/>
+            </a:pPr>
+            <a:r>
+              <a:rPr lang="en-US" sz="1400" dirty="0">
+                <a:solidFill>
+                  <a:schemeClr val="tx1"/>
+                </a:solidFill>
+              </a:rPr>
+              <a:t>Validation only, the test stays closed; CLIP is our first next step, and it can also answer questions in words</a:t>
+            </a:r>
+            <a:endParaRPr lang="en-US" sz="1400" dirty="0"/>
+          </a:p>
+        </p:txBody>
+      </p:sp>
+      <p:sp>
+        <p:nvSpPr>
+          <p:cNvPr id="25" name="Slide Number Placeholder 0"/>
+          <p:cNvSpPr>
+            <a:spLocks noGrp="1"/>
+          </p:cNvSpPr>
+          <p:nvPr>
+            <p:ph type="sldNum" sz="quarter" idx="4294967295"/>
+          </p:nvPr>
+        </p:nvSpPr>
+        <p:spPr>
+          <a:xfrm>
+            <a:off x="8229600" y="4754880"/>
+            <a:ext cx="457200" cy="274320"/>
+          </a:xfrm>
+          <a:prstGeom prst="rect">
+            <a:avLst/>
+          </a:prstGeom>
+          <a:extLst>
+            <a:ext uri="{C572A759-6A51-4108-AA02-DFA0A04FC94B}">
+              <ma14:wrappingTextBoxFlag xmlns:ma14="http://schemas.microsoft.com/office/mac/drawingml/2011/main" val="0"/>
+            </a:ext>
+          </a:extLst>
+        </p:spPr>
+        <p:txBody>
+          <a:bodyPr/>
+          <a:lstStyle>
+            <a:lvl1pPr>
+              <a:defRPr sz="1000">
+                <a:solidFill>
+                  <a:srgbClr val="5F6473"/>
+                </a:solidFill>
+              </a:defRPr>
+            </a:lvl1pPr>
+          </a:lstStyle>
+          <a:p>
+            <a:pPr algn="r"/>
+            <a:fld id="{F7021451-1387-4CA6-816F-3879F97B5CBC}" type="slidenum">
+              <a:rPr b="0" lang="en-US"/>
+              <a:t>16</a:t>
             </a:fld>
             <a:endParaRPr lang="en-US"/>
           </a:p>

</xml_diff>

<commit_message>
changes in the oral script to make it more fluid and comprehensive
</commit_message>
<xml_diff>
--- a/docs/museum_guide_presentation.pptx
+++ b/docs/museum_guide_presentation.pptx
@@ -122,34 +122,34 @@
   <p:extLst>
     <p:ext uri="{521415D9-36F7-43E2-AB2F-B90AF26B5E84}">
       <p14:sectionLst xmlns:p14="http://schemas.microsoft.com/office/powerpoint/2010/main">
-        <p14:section name="The question" id="{b5153d7f-de66-c0dd-f51d-50bfe7c49577}">
+        <p14:section name="The question" id="{e5c8e1d7-ddc3-fa8f-1f2b-9dad2dc8ed23}">
           <p14:sldIdLst>
             <p14:sldId id="256"/>
             <p14:sldId id="257"/>
             <p14:sldId id="258"/>
           </p14:sldIdLst>
         </p14:section>
-        <p14:section name="Our MLP" id="{f412b7f4-db50-4e82-fb80-ace0e5049c2d}">
+        <p14:section name="Our MLP" id="{b6e8bc5f-7058-8fa3-511c-5599d51b4cbf}">
           <p14:sldIdLst>
             <p14:sldId id="259"/>
             <p14:sldId id="260"/>
             <p14:sldId id="261"/>
           </p14:sldIdLst>
         </p14:section>
-        <p14:section name="Pretrained ResNet" id="{cb7485ac-c1e9-97df-6b2f-7d05d4f2cedd}">
+        <p14:section name="Pretrained ResNet" id="{ecb0ff74-0ac2-1075-e72e-170620d96556}">
           <p14:sldIdLst>
             <p14:sldId id="262"/>
             <p14:sldId id="263"/>
           </p14:sldIdLst>
         </p14:section>
-        <p14:section name="The answer" id="{8a88959c-610a-9931-d11b-434e0d73433c}">
+        <p14:section name="The answer" id="{5e1b2434-38f2-e127-0e9c-8c363d828960}">
           <p14:sldIdLst>
             <p14:sldId id="264"/>
             <p14:sldId id="265"/>
             <p14:sldId id="266"/>
           </p14:sldIdLst>
         </p14:section>
-        <p14:section name="Backup" id="{670931b6-0e94-28f6-7bdc-03a40ae2c03f}">
+        <p14:section name="Backup" id="{23a47c87-4be2-5586-f441-6963f24fc69c}">
           <p14:sldIdLst>
             <p14:sldId id="267"/>
             <p14:sldId id="268"/>
@@ -2634,7 +2634,7 @@
           <a:p>
             <a:r>
               <a:rPr lang="en-US" dirty="0"/>
-              <a:t>Is it affordable on a kiosk? We timed one photo at a time, from the image to the answer. The ResNet needs 53 milliseconds on one CPU thread, 26 with four threads: faster than a blink. Even on a kiosk four times slower, it answers in a fifth of a second. The model file is 45 megabytes. And when the collection changes, we only recompute the features and retrain one layer, in seconds.</a:t>
+              <a:t>Step six: is it affordable on a kiosk? We timed one photo at a time, from the image to the answer. The ResNet needs 53 milliseconds on one CPU thread, 26 with four threads: faster than a blink. Even on a kiosk four times slower, it answers in a fifth of a second. The model file is 45 megabytes. And when the collection changes, we only recompute the features and retrain one layer, in seconds.</a:t>
             </a:r>
             <a:endParaRPr lang="en-US" dirty="0"/>
           </a:p>
@@ -2722,7 +2722,7 @@
           <a:p>
             <a:r>
               <a:rPr lang="en-US" dirty="0"/>
-              <a:t>So, our recommendation to the director: deploy a frozen ResNet18 with a linear head. Why? It is accurate: one visitor in six gets a wrong style, against one in three with the best classical model. It is fast enough for a modest CPU. And it is cheap for a small team: no GPU, no big training, one small layer retrained in seconds. We do not recommend our MLP on pixels, a classical model alone, or fine-tuning for now: it is slower and not proven better. Before the launch, we must test a few hundred real photos taken at the kiosks, add more styles, and measure the real hardware. Everything is reproducible in our Git repository. Thank you. We are happy to take your questions.</a:t>
+              <a:t>Let's put the six steps together. On the test, our own MLP reached 41 percent, the best classical model 67, and the frozen ResNet18 83, at a cost a kiosk can afford. So, our answer to the director: yes, a neural network is worth it, but a pretrained one that we reuse. We recommend a frozen ResNet18 with a linear head. Why? It is accurate: one visitor in six gets a wrong style, against one in three. It is fast enough for a modest CPU, and cheap for a small team: one small layer, retrained in seconds. We do not recommend our MLP, a classical model alone, or fine-tuning for now. Before the launch, we must test real photos taken at the kiosks, add more styles, and measure the real hardware. Thank you. We are happy to take your questions.</a:t>
             </a:r>
             <a:endParaRPr lang="en-US" dirty="0"/>
           </a:p>
@@ -3250,7 +3250,7 @@
           <a:p>
             <a:r>
               <a:rPr lang="en-US" dirty="0"/>
-              <a:t>Here is our answer first. We tested every model on 220 paintings that no model had seen before. A pretrained ResNet18, frozen, with only one linear layer trained on top, recognises the style 83 percent of the time. The best classical model, a random forest on colour and texture features made by hand, reaches 67 percent. Our own network, an MLP trained from zero on the pixels, reaches 41 percent. And the ResNet is affordable: 53 milliseconds per photo on one CPU thread, a 45 megabyte file, 17 seconds of training on a laptop, and no GPU. So yes, a neural network is worth it, but a pretrained one that we reuse. In the next minutes, I will show how we got these numbers, and why you can trust them.</a:t>
+              <a:t>To answer, we went step by step, and each step told us what to try next. Step one: the data, and a fair test. Step two: our own network, a multi-layer perceptron built from PyTorch primitives. Step three: we watched its training from the inside and learned to diagnose failures. Step four: a pretrained convolutional network, ResNet18. Step five: a final test of every model, classical models included. Step six: the cost on a kiosk CPU. At the end of these six steps, we will have our answer. Let's start with the data.</a:t>
             </a:r>
             <a:endParaRPr lang="en-US" dirty="0"/>
           </a:p>
@@ -3338,7 +3338,7 @@
           <a:p>
             <a:r>
               <a:rPr lang="en-US" dirty="0"/>
-              <a:t>First, the data. We took 1 500 paintings from WikiArt, 300 per style. We used the course script with a fixed seed, so anyone can download exactly the same images. We cut them into three piles: 1 061 to train, 219 to validate, that is, to choose our settings, and 220 to test, used only once, at the very end. One rule matters a lot: all the paintings of a known painter go to the same pile. With a random split, 23 of our 32 known painters would be in two piles, and a model could learn to recognise Monet instead of Impressionism. With our split: zero. I will come back to this, because we measured its effect.</a:t>
+              <a:t>Step one: the data. We took 1 500 paintings from WikiArt, 300 per style. We used the course script with a fixed seed, so anyone can download exactly the same images. We cut them into three piles: 1 061 to train, 219 to validate, that is, to choose our settings, and 220 to test, used only once, at the very end. One rule matters a lot: all the paintings of a known painter go to the same pile. With a random split, 23 of our 32 known painters would be in two piles, and a model could learn to recognise Monet instead of Impressionism. With our split: zero. I will come back to this, because we measured its effect.</a:t>
             </a:r>
             <a:endParaRPr lang="en-US" dirty="0"/>
           </a:p>
@@ -3426,7 +3426,7 @@
           <a:p>
             <a:r>
               <a:rPr lang="en-US" dirty="0"/>
-              <a:t>Our first model is the network of the course: a multi-layer perceptron built from nn.Linear layers and ReLU, with our own training loop. It reads the pixels of a 64 by 64 image: 12 288 inputs and 6.4 million parameters. Before trusting it, we ran two checks. First, a model that knows nothing should have a loss of ln 5, about 1.61. Ours started at 1.99, too confident, so we made its last layer smaller and got 1.59. Second, it must be able to learn one small batch by heart: it does, 100 percent. Then the real training. The training accuracy goes to 99.7 percent, but the validation accuracy stays around 40 percent, and the validation loss goes up after epoch 3. This is overfitting: the network learns the paintings by heart.</a:t>
+              <a:t>Step two: our own network. Our first model is the network of the course: a multi-layer perceptron built from nn.Linear layers and ReLU, with our own training loop. It reads the pixels of a 64 by 64 image: 12 288 inputs and 6.4 million parameters. Before trusting it, we ran two checks. First, a model that knows nothing should have a loss of ln 5, about 1.61. Ours started at 1.99, too confident, so we made its last layer smaller and got 1.59. Second, it must be able to learn one small batch by heart: it does, 100 percent. Then the real training. The training accuracy goes to 99.7 percent, but the validation accuracy stays around 40 percent, and the validation loss goes up after epoch 3. This is overfitting: the network learns the paintings by heart.</a:t>
             </a:r>
             <a:endParaRPr lang="en-US" dirty="0"/>
           </a:p>
@@ -3514,7 +3514,7 @@
           <a:p>
             <a:r>
               <a:rPr lang="en-US" dirty="0"/>
-              <a:t>So we looked inside the network during training, not only at the loss. The gradient reaches every layer and only 4 percent of the neurons are dead: the training is healthy, the problem is overfitting. We also tried 8 learning rates and kept 0.0001. Then we tested the tools of session 6, each with 3 seeds, because one run on 219 images is noisy. Alone, each tool helps a little. All together, weight decay, dropout, batch norm, flips, early stopping and a cosine schedule take the MLP from 38.8 to 45.5 percent, and the gap between train and validation from 0.61 to 0.12. But one number shows the real limit: the MLP finds only 7 percent of the Cubist paintings. It sees colours, not shapes.</a:t>
+              <a:t>Step three: monitoring. We looked inside the network during training, not only at the loss. The gradient reaches every layer and only 4 percent of the neurons are dead: the training is healthy, the problem is overfitting. We also tried 8 learning rates and kept 0.0001. Then we tested the tools of session 6, each with 3 seeds, because one run on 219 images is noisy. Alone, each tool helps a little. All together, weight decay, dropout, batch norm, flips, early stopping and a cosine schedule take the MLP from 38.8 to 45.5 percent, and the gap between train and validation from 0.61 to 0.12. But one number shows the real limit: the MLP finds only 7 percent of the Cubist paintings. It sees colours, not shapes.</a:t>
             </a:r>
             <a:endParaRPr lang="en-US" dirty="0"/>
           </a:p>
@@ -3602,7 +3602,7 @@
           <a:p>
             <a:r>
               <a:rPr lang="en-US" dirty="0"/>
-              <a:t>To be ready for problems in production, we broke the training four times on purpose, and diagnosed each run. A learning rate 100 times too big killed 99.6 percent of the neurons of layer 2. A forgotten zero_grad made the gradients pile up: 26 times bigger after two epochs. Raw pixels, without standardisation, gave a first loss of 16 instead of 1.6. And eight sigmoid layers gave a vanishing gradient: the first layer received less than a millionth of the gradient of the last one. The lesson: two of these bugs show the same symptom, a loss stuck at ln 5. Only the monitoring, dead neurons or the gradient per layer, can tell them apart.</a:t>
+              <a:t>Still in step three, we wanted to be ready for problems in production, so we broke the training four times on purpose, and diagnosed each run. A learning rate 100 times too big killed 99.6 percent of the neurons of layer 2. A forgotten zero_grad made the gradients pile up: 26 times bigger after two epochs. Raw pixels, without standardisation, gave a first loss of 16 instead of 1.6. And eight sigmoid layers gave a vanishing gradient: the first layer received less than a millionth of the gradient of the last one. The lesson: two of these bugs show the same symptom, a loss stuck at ln 5. Only the monitoring, dead neurons or the gradient per layer, can tell them apart.</a:t>
             </a:r>
             <a:endParaRPr lang="en-US" dirty="0"/>
           </a:p>
@@ -3690,7 +3690,7 @@
           <a:p>
             <a:r>
               <a:rPr lang="en-US" dirty="0"/>
-              <a:t>To see shapes, we need a convolutional network. With only 1 061 images we cannot train one from zero, so we reuse ResNet18, already trained on 1.2 million ImageNet photos. We freeze it: each painting becomes 512 numbers, and we train only one linear layer, 2 565 weights, in less than a second. Result: 88.1 percent on validation, almost twice our best MLP. We also fine-tuned the last block: 8.4 million weights for 1 061 images. It overfits: 85.4 percent. And we measured two silent bugs: forgetting model.eval() drops the score to 12.8 percent, and forgetting the ImageNet normalisation costs 6 points. Nothing crashes: only measuring shows them.</a:t>
+              <a:t>Step four. Our MLP sees colours but not shapes, and to see shapes, we need a convolutional network. With only 1 061 images we cannot train one from zero, so we reuse ResNet18, already trained on 1.2 million ImageNet photos. We freeze it: each painting becomes 512 numbers, and we train only one linear layer, 2 565 weights, in less than a second. Result: 88.1 percent on validation, almost twice our best MLP. We also fine-tuned the last block: 8.4 million weights for 1 061 images. It overfits: 85.4 percent. And we measured two silent bugs: forgetting model.eval() drops the score to 12.8 percent, and forgetting the ImageNet normalisation costs 6 points. Nothing crashes: only measuring shows them.</a:t>
             </a:r>
             <a:endParaRPr lang="en-US" dirty="0"/>
           </a:p>
@@ -3778,7 +3778,7 @@
           <a:p>
             <a:r>
               <a:rPr lang="en-US" dirty="0"/>
-              <a:t>Now, the painter rule from the beginning. To measure it fairly, we scored the same images twice with cross-validation, and changed only one thing: whether the model had seen other paintings by the same painter. On images by known painters: 83.7 percent when the painter was seen, 72.3 when not. 11 points of flattery. On the control group, the unknown painters, nothing changes. So the model partly recognises painters, and a random split would have given the director a score that is too good. Our split protects the result.</a:t>
+              <a:t>With this stronger model, we could finally test the painter rule of step one. To measure it fairly, we scored the same images twice with cross-validation, and changed only one thing: whether the model had seen other paintings by the same painter. On images by known painters: 83.7 percent when the painter was seen, 72.3 when not. 11 points of flattery. On the control group, the unknown painters, nothing changes. So the model partly recognises painters, and a random split would have given the director a score that is too good. Our split protects the result.</a:t>
             </a:r>
             <a:endParaRPr lang="en-US" dirty="0"/>
           </a:p>
@@ -3866,7 +3866,7 @@
           <a:p>
             <a:r>
               <a:rPr lang="en-US" dirty="0"/>
-              <a:t>Finally, the test, measured once, on 220 new paintings. The pretrained models are at the top, from 83 to 88 percent. The best classical model reaches 67, our MLP 41. Is the gap real? A paired bootstrap, 5 000 redraws of the same test paintings, gives our model a lead of 16.4 points over the random forest, between 9 and 24 points: it is not luck. One honest note: the fine-tuned model is first on the test, but it was second on validation. With about 220 images, a score moves by about 5 points by chance, so we keep the model we chose before the test. Choosing a model on the test would make the test useless.</a:t>
+              <a:t>Step five: the final test. We opened the 220 test paintings once, for every model, including classical models with no neural network, such as a random forest on hand-made colour and texture features. The pretrained models are at the top, from 83 to 88 percent. The random forest reaches 67, our MLP 41. Is the gap real? A paired bootstrap, 5 000 redraws of the same test paintings, gives our model a lead of 16.4 points over the random forest, between 9 and 24 points: it is not luck. One honest note: the fine-tuned model is first on the test, but it was second on validation. With about 220 images, a score moves by about 5 points by chance, so we keep the model we chose before the test.</a:t>
             </a:r>
             <a:endParaRPr lang="en-US" dirty="0"/>
           </a:p>
@@ -5301,7 +5301,43 @@
       </p:sp>
       <p:sp>
         <p:nvSpPr>
-          <p:cNvPr id="3" name="card 53 ms"/>
+          <p:cNvPr id="3" name="step tag 6"/>
+          <p:cNvSpPr txBox="1"/>
+          <p:nvPr/>
+        </p:nvSpPr>
+        <p:spPr>
+          <a:xfrm>
+            <a:off x="457200" y="54864"/>
+            <a:ext cx="8229600" cy="237744"/>
+          </a:xfrm>
+          <a:prstGeom prst="rect">
+            <a:avLst/>
+          </a:prstGeom>
+          <a:noFill/>
+          <a:ln/>
+        </p:spPr>
+        <p:txBody>
+          <a:bodyPr wrap="square" lIns="0" tIns="0" rIns="0" bIns="0" rtlCol="0" anchor="ctr"/>
+          <a:lstStyle/>
+          <a:p>
+            <a:pPr algn="ctr" indent="0" marL="0">
+              <a:buNone/>
+            </a:pPr>
+            <a:r>
+              <a:rPr lang="en-US" sz="1100" b="1" spc="200" kern="0" dirty="0">
+                <a:solidFill>
+                  <a:schemeClr val="accent1"/>
+                </a:solidFill>
+              </a:rPr>
+              <a:t>STEP 6 OF 6 · KIOSK COST</a:t>
+            </a:r>
+            <a:endParaRPr lang="en-US" sz="1100" dirty="0"/>
+          </a:p>
+        </p:txBody>
+      </p:sp>
+      <p:sp>
+        <p:nvSpPr>
+          <p:cNvPr id="4" name="card 53 ms"/>
           <p:cNvSpPr/>
           <p:nvPr/>
         </p:nvSpPr>
@@ -5328,7 +5364,7 @@
       </p:sp>
       <p:sp>
         <p:nvSpPr>
-          <p:cNvPr id="4" name="value 53 ms"/>
+          <p:cNvPr id="5" name="value 53 ms"/>
           <p:cNvSpPr txBox="1"/>
           <p:nvPr/>
         </p:nvSpPr>
@@ -5367,7 +5403,7 @@
       </p:sp>
       <p:sp>
         <p:nvSpPr>
-          <p:cNvPr id="5" name="caption 53 ms"/>
+          <p:cNvPr id="6" name="caption 53 ms"/>
           <p:cNvSpPr txBox="1"/>
           <p:nvPr/>
         </p:nvSpPr>
@@ -5403,7 +5439,7 @@
       </p:sp>
       <p:sp>
         <p:nvSpPr>
-          <p:cNvPr id="6" name="card 26 ms"/>
+          <p:cNvPr id="7" name="card 26 ms"/>
           <p:cNvSpPr/>
           <p:nvPr/>
         </p:nvSpPr>
@@ -5430,7 +5466,7 @@
       </p:sp>
       <p:sp>
         <p:nvSpPr>
-          <p:cNvPr id="7" name="value 26 ms"/>
+          <p:cNvPr id="8" name="value 26 ms"/>
           <p:cNvSpPr txBox="1"/>
           <p:nvPr/>
         </p:nvSpPr>
@@ -5469,7 +5505,7 @@
       </p:sp>
       <p:sp>
         <p:nvSpPr>
-          <p:cNvPr id="8" name="caption 26 ms"/>
+          <p:cNvPr id="9" name="caption 26 ms"/>
           <p:cNvSpPr txBox="1"/>
           <p:nvPr/>
         </p:nvSpPr>
@@ -5505,7 +5541,7 @@
       </p:sp>
       <p:sp>
         <p:nvSpPr>
-          <p:cNvPr id="9" name="card 45 MB"/>
+          <p:cNvPr id="10" name="card 45 MB"/>
           <p:cNvSpPr/>
           <p:nvPr/>
         </p:nvSpPr>
@@ -5532,7 +5568,7 @@
       </p:sp>
       <p:sp>
         <p:nvSpPr>
-          <p:cNvPr id="10" name="value 45 MB"/>
+          <p:cNvPr id="11" name="value 45 MB"/>
           <p:cNvSpPr txBox="1"/>
           <p:nvPr/>
         </p:nvSpPr>
@@ -5571,7 +5607,7 @@
       </p:sp>
       <p:sp>
         <p:nvSpPr>
-          <p:cNvPr id="11" name="caption 45 MB"/>
+          <p:cNvPr id="12" name="caption 45 MB"/>
           <p:cNvSpPr txBox="1"/>
           <p:nvPr/>
         </p:nvSpPr>
@@ -5607,7 +5643,7 @@
       </p:sp>
       <p:sp>
         <p:nvSpPr>
-          <p:cNvPr id="12" name="card 17 s"/>
+          <p:cNvPr id="13" name="card 17 s"/>
           <p:cNvSpPr/>
           <p:nvPr/>
         </p:nvSpPr>
@@ -5634,7 +5670,7 @@
       </p:sp>
       <p:sp>
         <p:nvSpPr>
-          <p:cNvPr id="13" name="value 17 s"/>
+          <p:cNvPr id="14" name="value 17 s"/>
           <p:cNvSpPr txBox="1"/>
           <p:nvPr/>
         </p:nvSpPr>
@@ -5673,7 +5709,7 @@
       </p:sp>
       <p:sp>
         <p:nvSpPr>
-          <p:cNvPr id="14" name="caption 17 s"/>
+          <p:cNvPr id="15" name="caption 17 s"/>
           <p:cNvSpPr txBox="1"/>
           <p:nvPr/>
         </p:nvSpPr>
@@ -5709,7 +5745,7 @@
       </p:sp>
       <p:sp>
         <p:nvSpPr>
-          <p:cNvPr id="15" name="note In practice"/>
+          <p:cNvPr id="16" name="note In practice"/>
           <p:cNvSpPr/>
           <p:nvPr/>
         </p:nvSpPr>
@@ -5736,7 +5772,7 @@
       </p:sp>
       <p:sp>
         <p:nvSpPr>
-          <p:cNvPr id="16" name="text In practice"/>
+          <p:cNvPr id="17" name="text In practice"/>
           <p:cNvSpPr txBox="1"/>
           <p:nvPr/>
         </p:nvSpPr>
@@ -5892,7 +5928,7 @@
                   <a:schemeClr val="bg1"/>
                 </a:solidFill>
               </a:rPr>
-              <a:t>Deploy a frozen ResNet18 + linear head</a:t>
+              <a:t>Our choice: frozen ResNet18 + linear head</a:t>
             </a:r>
             <a:endParaRPr lang="en-US" sz="3000" dirty="0"/>
           </a:p>
@@ -5900,14 +5936,50 @@
       </p:sp>
       <p:sp>
         <p:nvSpPr>
-          <p:cNvPr id="3" name="column Why"/>
+          <p:cNvPr id="3" name="journey"/>
+          <p:cNvSpPr txBox="1"/>
+          <p:nvPr/>
+        </p:nvSpPr>
+        <p:spPr>
+          <a:xfrm>
+            <a:off x="457200" y="1051560"/>
+            <a:ext cx="8229600" cy="365760"/>
+          </a:xfrm>
+          <a:prstGeom prst="rect">
+            <a:avLst/>
+          </a:prstGeom>
+          <a:noFill/>
+          <a:ln/>
+        </p:spPr>
+        <p:txBody>
+          <a:bodyPr wrap="square" lIns="0" tIns="0" rIns="0" bIns="0" rtlCol="0" anchor="ctr"/>
+          <a:lstStyle/>
+          <a:p>
+            <a:pPr algn="ctr" indent="0" marL="0">
+              <a:buNone/>
+            </a:pPr>
+            <a:r>
+              <a:rPr lang="en-US" sz="1400" dirty="0">
+                <a:solidFill>
+                  <a:srgbClr val="C9CED8"/>
+                </a:solidFill>
+              </a:rPr>
+              <a:t>Test, 220 new paintings:  our MLP 41.4 %  →  best classical 67.3 %  →  frozen ResNet18 83.0 %</a:t>
+            </a:r>
+            <a:endParaRPr lang="en-US" sz="1400" dirty="0"/>
+          </a:p>
+        </p:txBody>
+      </p:sp>
+      <p:sp>
+        <p:nvSpPr>
+          <p:cNvPr id="4" name="column Why"/>
           <p:cNvSpPr/>
           <p:nvPr/>
         </p:nvSpPr>
         <p:spPr>
           <a:xfrm>
-            <a:off x="457200" y="1143000"/>
-            <a:ext cx="2560320" cy="3154680"/>
+            <a:off x="457200" y="1600200"/>
+            <a:ext cx="2560320" cy="2880360"/>
           </a:xfrm>
           <a:prstGeom prst="roundRect">
             <a:avLst>
@@ -5927,13 +5999,13 @@
       </p:sp>
       <p:sp>
         <p:nvSpPr>
-          <p:cNvPr id="4" name="head Why"/>
+          <p:cNvPr id="5" name="head Why"/>
           <p:cNvSpPr txBox="1"/>
           <p:nvPr/>
         </p:nvSpPr>
         <p:spPr>
           <a:xfrm>
-            <a:off x="640080" y="1280160"/>
+            <a:off x="640080" y="1719072"/>
             <a:ext cx="2194560" cy="411480"/>
           </a:xfrm>
           <a:prstGeom prst="rect">
@@ -5966,14 +6038,14 @@
       </p:sp>
       <p:sp>
         <p:nvSpPr>
-          <p:cNvPr id="5" name="items Why"/>
+          <p:cNvPr id="6" name="items Why"/>
           <p:cNvSpPr txBox="1"/>
           <p:nvPr/>
         </p:nvSpPr>
         <p:spPr>
           <a:xfrm>
-            <a:off x="640080" y="1783080"/>
-            <a:ext cx="2240280" cy="2651760"/>
+            <a:off x="640080" y="2212848"/>
+            <a:ext cx="2240280" cy="2194560"/>
           </a:xfrm>
           <a:prstGeom prst="rect">
             <a:avLst/>
@@ -6042,14 +6114,14 @@
       </p:sp>
       <p:sp>
         <p:nvSpPr>
-          <p:cNvPr id="6" name="column Not now"/>
+          <p:cNvPr id="7" name="column Not now"/>
           <p:cNvSpPr/>
           <p:nvPr/>
         </p:nvSpPr>
         <p:spPr>
           <a:xfrm>
-            <a:off x="3291840" y="1143000"/>
-            <a:ext cx="2560320" cy="3154680"/>
+            <a:off x="3291840" y="1600200"/>
+            <a:ext cx="2560320" cy="2880360"/>
           </a:xfrm>
           <a:prstGeom prst="roundRect">
             <a:avLst>
@@ -6069,13 +6141,13 @@
       </p:sp>
       <p:sp>
         <p:nvSpPr>
-          <p:cNvPr id="7" name="head Not now"/>
+          <p:cNvPr id="8" name="head Not now"/>
           <p:cNvSpPr txBox="1"/>
           <p:nvPr/>
         </p:nvSpPr>
         <p:spPr>
           <a:xfrm>
-            <a:off x="3474720" y="1280160"/>
+            <a:off x="3474720" y="1719072"/>
             <a:ext cx="2194560" cy="411480"/>
           </a:xfrm>
           <a:prstGeom prst="rect">
@@ -6108,14 +6180,14 @@
       </p:sp>
       <p:sp>
         <p:nvSpPr>
-          <p:cNvPr id="8" name="items Not now"/>
+          <p:cNvPr id="9" name="items Not now"/>
           <p:cNvSpPr txBox="1"/>
           <p:nvPr/>
         </p:nvSpPr>
         <p:spPr>
           <a:xfrm>
-            <a:off x="3474720" y="1783080"/>
-            <a:ext cx="2240280" cy="2651760"/>
+            <a:off x="3474720" y="2212848"/>
+            <a:ext cx="2240280" cy="2194560"/>
           </a:xfrm>
           <a:prstGeom prst="rect">
             <a:avLst/>
@@ -6184,14 +6256,14 @@
       </p:sp>
       <p:sp>
         <p:nvSpPr>
-          <p:cNvPr id="9" name="column Before launch"/>
+          <p:cNvPr id="10" name="column Before launch"/>
           <p:cNvSpPr/>
           <p:nvPr/>
         </p:nvSpPr>
         <p:spPr>
           <a:xfrm>
-            <a:off x="6126480" y="1143000"/>
-            <a:ext cx="2560320" cy="3154680"/>
+            <a:off x="6126480" y="1600200"/>
+            <a:ext cx="2560320" cy="2880360"/>
           </a:xfrm>
           <a:prstGeom prst="roundRect">
             <a:avLst>
@@ -6211,13 +6283,13 @@
       </p:sp>
       <p:sp>
         <p:nvSpPr>
-          <p:cNvPr id="10" name="head Before launch"/>
+          <p:cNvPr id="11" name="head Before launch"/>
           <p:cNvSpPr txBox="1"/>
           <p:nvPr/>
         </p:nvSpPr>
         <p:spPr>
           <a:xfrm>
-            <a:off x="6309360" y="1280160"/>
+            <a:off x="6309360" y="1719072"/>
             <a:ext cx="2194560" cy="411480"/>
           </a:xfrm>
           <a:prstGeom prst="rect">
@@ -6250,14 +6322,14 @@
       </p:sp>
       <p:sp>
         <p:nvSpPr>
-          <p:cNvPr id="11" name="items Before launch"/>
+          <p:cNvPr id="12" name="items Before launch"/>
           <p:cNvSpPr txBox="1"/>
           <p:nvPr/>
         </p:nvSpPr>
         <p:spPr>
           <a:xfrm>
-            <a:off x="6309360" y="1783080"/>
-            <a:ext cx="2240280" cy="2651760"/>
+            <a:off x="6309360" y="2212848"/>
+            <a:ext cx="2240280" cy="2194560"/>
           </a:xfrm>
           <a:prstGeom prst="rect">
             <a:avLst/>
@@ -10716,7 +10788,7 @@
                   <a:schemeClr val="tx2"/>
                 </a:solidFill>
               </a:rPr>
-              <a:t>Our answer: yes, a pretrained network</a:t>
+              <a:t>Six steps to answer the director</a:t>
             </a:r>
             <a:endParaRPr lang="en-US" sz="3000" dirty="0"/>
           </a:p>
@@ -10724,14 +10796,41 @@
       </p:sp>
       <p:sp>
         <p:nvSpPr>
-          <p:cNvPr id="3" name="subtitle answer"/>
+          <p:cNvPr id="3" name="note The question"/>
+          <p:cNvSpPr/>
+          <p:nvPr/>
+        </p:nvSpPr>
+        <p:spPr>
+          <a:xfrm>
+            <a:off x="457200" y="960120"/>
+            <a:ext cx="8229600" cy="914400"/>
+          </a:xfrm>
+          <a:prstGeom prst="roundRect">
+            <a:avLst>
+              <a:gd name="adj" fmla="val 8000"/>
+            </a:avLst>
+          </a:prstGeom>
+          <a:solidFill>
+            <a:schemeClr val="bg2"/>
+          </a:solidFill>
+          <a:ln w="12700">
+            <a:solidFill>
+              <a:schemeClr val="bg2"/>
+            </a:solidFill>
+            <a:prstDash val="solid"/>
+          </a:ln>
+        </p:spPr>
+      </p:sp>
+      <p:sp>
+        <p:nvSpPr>
+          <p:cNvPr id="4" name="text The question"/>
           <p:cNvSpPr txBox="1"/>
           <p:nvPr/>
         </p:nvSpPr>
         <p:spPr>
           <a:xfrm>
-            <a:off x="457200" y="960120"/>
-            <a:ext cx="8229600" cy="320040"/>
+            <a:off x="621792" y="1069848"/>
+            <a:ext cx="7900416" cy="694944"/>
           </a:xfrm>
           <a:prstGeom prst="rect">
             <a:avLst/>
@@ -10740,19 +10839,39 @@
           <a:ln/>
         </p:spPr>
         <p:txBody>
-          <a:bodyPr wrap="square" lIns="0" tIns="0" rIns="0" bIns="0" rtlCol="0" anchor="ctr"/>
+          <a:bodyPr wrap="square" lIns="0" tIns="0" rIns="0" bIns="0" rtlCol="0" anchor="t"/>
           <a:lstStyle/>
           <a:p>
             <a:pPr indent="0" marL="0">
+              <a:spcAft>
+                <a:spcPts val="400"/>
+              </a:spcAft>
+              <a:buNone/>
+            </a:pPr>
+            <a:r>
+              <a:rPr lang="en-US" sz="1400" b="1" dirty="0">
+                <a:solidFill>
+                  <a:schemeClr val="tx2"/>
+                </a:solidFill>
+              </a:rPr>
+              <a:t>The question</a:t>
+            </a:r>
+            <a:endParaRPr lang="en-US" sz="1400" dirty="0"/>
+          </a:p>
+          <a:p>
+            <a:pPr indent="0" marL="0">
+              <a:spcAft>
+                <a:spcPts val="400"/>
+              </a:spcAft>
               <a:buNone/>
             </a:pPr>
             <a:r>
               <a:rPr lang="en-US" sz="1400" dirty="0">
                 <a:solidFill>
-                  <a:srgbClr val="5F6473"/>
+                  <a:schemeClr val="tx1"/>
                 </a:solidFill>
               </a:rPr>
-              <a:t>Accuracy on 220 paintings that no model saw before (test set, measured once)</a:t>
+              <a:t>Is a neural network worth it on a kiosk with a small CPU and a small team, or would a simpler classical model do the job?</a:t>
             </a:r>
             <a:endParaRPr lang="en-US" sz="1400" dirty="0"/>
           </a:p>
@@ -10760,19 +10879,44 @@
       </p:sp>
       <p:sp>
         <p:nvSpPr>
-          <p:cNvPr id="4" name="card 83.0 %"/>
+          <p:cNvPr id="5" name="step 1"/>
           <p:cNvSpPr/>
           <p:nvPr/>
         </p:nvSpPr>
         <p:spPr>
           <a:xfrm>
-            <a:off x="457200" y="1417320"/>
-            <a:ext cx="2606040" cy="2011680"/>
+            <a:off x="457200" y="2011680"/>
+            <a:ext cx="2560320" cy="1188720"/>
           </a:xfrm>
           <a:prstGeom prst="roundRect">
             <a:avLst>
-              <a:gd name="adj" fmla="val 3636"/>
+              <a:gd name="adj" fmla="val 6154"/>
             </a:avLst>
+          </a:prstGeom>
+          <a:solidFill>
+            <a:schemeClr val="bg2"/>
+          </a:solidFill>
+          <a:ln w="12700">
+            <a:solidFill>
+              <a:schemeClr val="bg2"/>
+            </a:solidFill>
+            <a:prstDash val="solid"/>
+          </a:ln>
+        </p:spPr>
+      </p:sp>
+      <p:sp>
+        <p:nvSpPr>
+          <p:cNvPr id="6" name="step circle 1"/>
+          <p:cNvSpPr/>
+          <p:nvPr/>
+        </p:nvSpPr>
+        <p:spPr>
+          <a:xfrm>
+            <a:off x="621792" y="2194560"/>
+            <a:ext cx="457200" cy="457200"/>
+          </a:xfrm>
+          <a:prstGeom prst="ellipse">
+            <a:avLst/>
           </a:prstGeom>
           <a:solidFill>
             <a:schemeClr val="accent1"/>
@@ -10787,14 +10931,14 @@
       </p:sp>
       <p:sp>
         <p:nvSpPr>
-          <p:cNvPr id="5" name="value 83.0 %"/>
+          <p:cNvPr id="7" name="step number 1"/>
           <p:cNvSpPr txBox="1"/>
           <p:nvPr/>
         </p:nvSpPr>
         <p:spPr>
           <a:xfrm>
-            <a:off x="640080" y="1554480"/>
-            <a:ext cx="2240280" cy="731520"/>
+            <a:off x="621792" y="2194560"/>
+            <a:ext cx="457200" cy="457200"/>
           </a:xfrm>
           <a:prstGeom prst="rect">
             <a:avLst/>
@@ -10804,57 +10948,68 @@
         </p:spPr>
         <p:txBody>
           <a:bodyPr wrap="square" lIns="0" tIns="0" rIns="0" bIns="0" rtlCol="0" anchor="ctr"/>
+          <a:lstStyle/>
+          <a:p>
+            <a:pPr algn="ctr" indent="0" marL="0">
+              <a:buNone/>
+            </a:pPr>
+            <a:r>
+              <a:rPr lang="en-US" sz="1800" b="1" dirty="0">
+                <a:solidFill>
+                  <a:schemeClr val="bg1"/>
+                </a:solidFill>
+              </a:rPr>
+              <a:t>1</a:t>
+            </a:r>
+            <a:endParaRPr lang="en-US" sz="1800" dirty="0"/>
+          </a:p>
+        </p:txBody>
+      </p:sp>
+      <p:sp>
+        <p:nvSpPr>
+          <p:cNvPr id="8" name="step text 1"/>
+          <p:cNvSpPr txBox="1"/>
+          <p:nvPr/>
+        </p:nvSpPr>
+        <p:spPr>
+          <a:xfrm>
+            <a:off x="1207008" y="2148840"/>
+            <a:ext cx="1691640" cy="1024128"/>
+          </a:xfrm>
+          <a:prstGeom prst="rect">
+            <a:avLst/>
+          </a:prstGeom>
+          <a:noFill/>
+          <a:ln/>
+        </p:spPr>
+        <p:txBody>
+          <a:bodyPr wrap="square" lIns="0" tIns="0" rIns="0" bIns="0" rtlCol="0" anchor="t"/>
           <a:lstStyle/>
           <a:p>
             <a:pPr indent="0" marL="0">
               <a:buNone/>
             </a:pPr>
             <a:r>
-              <a:rPr lang="en-US" sz="4400" b="1" dirty="0">
-                <a:solidFill>
-                  <a:schemeClr val="bg1"/>
-                </a:solidFill>
-                <a:latin typeface="Cambria" pitchFamily="34" charset="0"/>
-                <a:ea typeface="Cambria" pitchFamily="34" charset="-122"/>
-                <a:cs typeface="Cambria" pitchFamily="34" charset="-120"/>
+              <a:rPr lang="en-US" sz="1400" b="1" dirty="0">
+                <a:solidFill>
+                  <a:schemeClr val="tx2"/>
+                </a:solidFill>
               </a:rPr>
-              <a:t>83.0 %</a:t>
+              <a:t>Data and a fair split</a:t>
             </a:r>
-            <a:endParaRPr lang="en-US" sz="4400" dirty="0"/>
-          </a:p>
-        </p:txBody>
-      </p:sp>
-      <p:sp>
-        <p:nvSpPr>
-          <p:cNvPr id="6" name="caption 83.0 %"/>
-          <p:cNvSpPr txBox="1"/>
-          <p:nvPr/>
-        </p:nvSpPr>
-        <p:spPr>
-          <a:xfrm>
-            <a:off x="640080" y="2331720"/>
-            <a:ext cx="2240280" cy="960120"/>
-          </a:xfrm>
-          <a:prstGeom prst="rect">
-            <a:avLst/>
-          </a:prstGeom>
-          <a:noFill/>
-          <a:ln/>
-        </p:spPr>
-        <p:txBody>
-          <a:bodyPr wrap="square" lIns="0" tIns="0" rIns="0" bIns="0" rtlCol="0" anchor="t"/>
-          <a:lstStyle/>
+            <a:endParaRPr lang="en-US" sz="1400" dirty="0"/>
+          </a:p>
           <a:p>
             <a:pPr indent="0" marL="0">
               <a:buNone/>
             </a:pPr>
             <a:r>
-              <a:rPr lang="en-US" sz="1400" dirty="0">
-                <a:solidFill>
-                  <a:schemeClr val="bg1"/>
+              <a:rPr lang="en-US" sz="1200" dirty="0">
+                <a:solidFill>
+                  <a:schemeClr val="tx1"/>
                 </a:solidFill>
               </a:rPr>
-              <a:t>Pretrained ResNet18, frozen, one trained linear layer</a:t>
+              <a:t>1 500 WikiArt paintings, 5 styles, split by painter</a:t>
             </a:r>
             <a:endParaRPr lang="en-US" sz="1400" dirty="0"/>
           </a:p>
@@ -10862,18 +11017,18 @@
       </p:sp>
       <p:sp>
         <p:nvSpPr>
-          <p:cNvPr id="7" name="card 67.3 %"/>
+          <p:cNvPr id="9" name="step 2"/>
           <p:cNvSpPr/>
           <p:nvPr/>
         </p:nvSpPr>
         <p:spPr>
           <a:xfrm>
-            <a:off x="3268980" y="1417320"/>
-            <a:ext cx="2606040" cy="2011680"/>
+            <a:off x="3291840" y="2011680"/>
+            <a:ext cx="2560320" cy="1188720"/>
           </a:xfrm>
           <a:prstGeom prst="roundRect">
             <a:avLst>
-              <a:gd name="adj" fmla="val 3636"/>
+              <a:gd name="adj" fmla="val 6154"/>
             </a:avLst>
           </a:prstGeom>
           <a:solidFill>
@@ -10889,14 +11044,39 @@
       </p:sp>
       <p:sp>
         <p:nvSpPr>
-          <p:cNvPr id="8" name="value 67.3 %"/>
+          <p:cNvPr id="10" name="step circle 2"/>
+          <p:cNvSpPr/>
+          <p:nvPr/>
+        </p:nvSpPr>
+        <p:spPr>
+          <a:xfrm>
+            <a:off x="3456432" y="2194560"/>
+            <a:ext cx="457200" cy="457200"/>
+          </a:xfrm>
+          <a:prstGeom prst="ellipse">
+            <a:avLst/>
+          </a:prstGeom>
+          <a:solidFill>
+            <a:schemeClr val="accent1"/>
+          </a:solidFill>
+          <a:ln w="12700">
+            <a:solidFill>
+              <a:schemeClr val="accent1"/>
+            </a:solidFill>
+            <a:prstDash val="solid"/>
+          </a:ln>
+        </p:spPr>
+      </p:sp>
+      <p:sp>
+        <p:nvSpPr>
+          <p:cNvPr id="11" name="step number 2"/>
           <p:cNvSpPr txBox="1"/>
           <p:nvPr/>
         </p:nvSpPr>
         <p:spPr>
           <a:xfrm>
-            <a:off x="3451860" y="1554480"/>
-            <a:ext cx="2240280" cy="731520"/>
+            <a:off x="3456432" y="2194560"/>
+            <a:ext cx="457200" cy="457200"/>
           </a:xfrm>
           <a:prstGeom prst="rect">
             <a:avLst/>
@@ -10906,57 +11086,68 @@
         </p:spPr>
         <p:txBody>
           <a:bodyPr wrap="square" lIns="0" tIns="0" rIns="0" bIns="0" rtlCol="0" anchor="ctr"/>
+          <a:lstStyle/>
+          <a:p>
+            <a:pPr algn="ctr" indent="0" marL="0">
+              <a:buNone/>
+            </a:pPr>
+            <a:r>
+              <a:rPr lang="en-US" sz="1800" b="1" dirty="0">
+                <a:solidFill>
+                  <a:schemeClr val="bg1"/>
+                </a:solidFill>
+              </a:rPr>
+              <a:t>2</a:t>
+            </a:r>
+            <a:endParaRPr lang="en-US" sz="1800" dirty="0"/>
+          </a:p>
+        </p:txBody>
+      </p:sp>
+      <p:sp>
+        <p:nvSpPr>
+          <p:cNvPr id="12" name="step text 2"/>
+          <p:cNvSpPr txBox="1"/>
+          <p:nvPr/>
+        </p:nvSpPr>
+        <p:spPr>
+          <a:xfrm>
+            <a:off x="4041648" y="2148840"/>
+            <a:ext cx="1691640" cy="1024128"/>
+          </a:xfrm>
+          <a:prstGeom prst="rect">
+            <a:avLst/>
+          </a:prstGeom>
+          <a:noFill/>
+          <a:ln/>
+        </p:spPr>
+        <p:txBody>
+          <a:bodyPr wrap="square" lIns="0" tIns="0" rIns="0" bIns="0" rtlCol="0" anchor="t"/>
           <a:lstStyle/>
           <a:p>
             <a:pPr indent="0" marL="0">
               <a:buNone/>
             </a:pPr>
             <a:r>
-              <a:rPr lang="en-US" sz="4400" b="1" dirty="0">
+              <a:rPr lang="en-US" sz="1400" b="1" dirty="0">
                 <a:solidFill>
                   <a:schemeClr val="tx2"/>
                 </a:solidFill>
-                <a:latin typeface="Cambria" pitchFamily="34" charset="0"/>
-                <a:ea typeface="Cambria" pitchFamily="34" charset="-122"/>
-                <a:cs typeface="Cambria" pitchFamily="34" charset="-120"/>
               </a:rPr>
-              <a:t>67.3 %</a:t>
+              <a:t>Our own network (MLP)</a:t>
             </a:r>
-            <a:endParaRPr lang="en-US" sz="4400" dirty="0"/>
-          </a:p>
-        </p:txBody>
-      </p:sp>
-      <p:sp>
-        <p:nvSpPr>
-          <p:cNvPr id="9" name="caption 67.3 %"/>
-          <p:cNvSpPr txBox="1"/>
-          <p:nvPr/>
-        </p:nvSpPr>
-        <p:spPr>
-          <a:xfrm>
-            <a:off x="3451860" y="2331720"/>
-            <a:ext cx="2240280" cy="960120"/>
-          </a:xfrm>
-          <a:prstGeom prst="rect">
-            <a:avLst/>
-          </a:prstGeom>
-          <a:noFill/>
-          <a:ln/>
-        </p:spPr>
-        <p:txBody>
-          <a:bodyPr wrap="square" lIns="0" tIns="0" rIns="0" bIns="0" rtlCol="0" anchor="t"/>
-          <a:lstStyle/>
+            <a:endParaRPr lang="en-US" sz="1400" dirty="0"/>
+          </a:p>
           <a:p>
             <a:pPr indent="0" marL="0">
               <a:buNone/>
             </a:pPr>
             <a:r>
-              <a:rPr lang="en-US" sz="1400" dirty="0">
+              <a:rPr lang="en-US" sz="1200" dirty="0">
                 <a:solidFill>
                   <a:schemeClr val="tx1"/>
                 </a:solidFill>
               </a:rPr>
-              <a:t>Best classical model: random forest on colour and texture features</a:t>
+              <a:t>built from nn.Linear, trained on the pixels</a:t>
             </a:r>
             <a:endParaRPr lang="en-US" sz="1400" dirty="0"/>
           </a:p>
@@ -10964,18 +11155,18 @@
       </p:sp>
       <p:sp>
         <p:nvSpPr>
-          <p:cNvPr id="10" name="card 41.4 %"/>
+          <p:cNvPr id="13" name="step 3"/>
           <p:cNvSpPr/>
           <p:nvPr/>
         </p:nvSpPr>
         <p:spPr>
           <a:xfrm>
-            <a:off x="6080760" y="1417320"/>
-            <a:ext cx="2606040" cy="2011680"/>
+            <a:off x="6126480" y="2011680"/>
+            <a:ext cx="2560320" cy="1188720"/>
           </a:xfrm>
           <a:prstGeom prst="roundRect">
             <a:avLst>
-              <a:gd name="adj" fmla="val 3636"/>
+              <a:gd name="adj" fmla="val 6154"/>
             </a:avLst>
           </a:prstGeom>
           <a:solidFill>
@@ -10991,14 +11182,39 @@
       </p:sp>
       <p:sp>
         <p:nvSpPr>
-          <p:cNvPr id="11" name="value 41.4 %"/>
+          <p:cNvPr id="14" name="step circle 3"/>
+          <p:cNvSpPr/>
+          <p:nvPr/>
+        </p:nvSpPr>
+        <p:spPr>
+          <a:xfrm>
+            <a:off x="6291072" y="2194560"/>
+            <a:ext cx="457200" cy="457200"/>
+          </a:xfrm>
+          <a:prstGeom prst="ellipse">
+            <a:avLst/>
+          </a:prstGeom>
+          <a:solidFill>
+            <a:schemeClr val="accent1"/>
+          </a:solidFill>
+          <a:ln w="12700">
+            <a:solidFill>
+              <a:schemeClr val="accent1"/>
+            </a:solidFill>
+            <a:prstDash val="solid"/>
+          </a:ln>
+        </p:spPr>
+      </p:sp>
+      <p:sp>
+        <p:nvSpPr>
+          <p:cNvPr id="15" name="step number 3"/>
           <p:cNvSpPr txBox="1"/>
           <p:nvPr/>
         </p:nvSpPr>
         <p:spPr>
           <a:xfrm>
-            <a:off x="6263640" y="1554480"/>
-            <a:ext cx="2240280" cy="731520"/>
+            <a:off x="6291072" y="2194560"/>
+            <a:ext cx="457200" cy="457200"/>
           </a:xfrm>
           <a:prstGeom prst="rect">
             <a:avLst/>
@@ -11008,57 +11224,68 @@
         </p:spPr>
         <p:txBody>
           <a:bodyPr wrap="square" lIns="0" tIns="0" rIns="0" bIns="0" rtlCol="0" anchor="ctr"/>
+          <a:lstStyle/>
+          <a:p>
+            <a:pPr algn="ctr" indent="0" marL="0">
+              <a:buNone/>
+            </a:pPr>
+            <a:r>
+              <a:rPr lang="en-US" sz="1800" b="1" dirty="0">
+                <a:solidFill>
+                  <a:schemeClr val="bg1"/>
+                </a:solidFill>
+              </a:rPr>
+              <a:t>3</a:t>
+            </a:r>
+            <a:endParaRPr lang="en-US" sz="1800" dirty="0"/>
+          </a:p>
+        </p:txBody>
+      </p:sp>
+      <p:sp>
+        <p:nvSpPr>
+          <p:cNvPr id="16" name="step text 3"/>
+          <p:cNvSpPr txBox="1"/>
+          <p:nvPr/>
+        </p:nvSpPr>
+        <p:spPr>
+          <a:xfrm>
+            <a:off x="6876288" y="2148840"/>
+            <a:ext cx="1691640" cy="1024128"/>
+          </a:xfrm>
+          <a:prstGeom prst="rect">
+            <a:avLst/>
+          </a:prstGeom>
+          <a:noFill/>
+          <a:ln/>
+        </p:spPr>
+        <p:txBody>
+          <a:bodyPr wrap="square" lIns="0" tIns="0" rIns="0" bIns="0" rtlCol="0" anchor="t"/>
           <a:lstStyle/>
           <a:p>
             <a:pPr indent="0" marL="0">
               <a:buNone/>
             </a:pPr>
             <a:r>
-              <a:rPr lang="en-US" sz="4400" b="1" dirty="0">
+              <a:rPr lang="en-US" sz="1400" b="1" dirty="0">
                 <a:solidFill>
                   <a:schemeClr val="tx2"/>
                 </a:solidFill>
-                <a:latin typeface="Cambria" pitchFamily="34" charset="0"/>
-                <a:ea typeface="Cambria" pitchFamily="34" charset="-122"/>
-                <a:cs typeface="Cambria" pitchFamily="34" charset="-120"/>
               </a:rPr>
-              <a:t>41.4 %</a:t>
+              <a:t>Monitoring and diagnosis</a:t>
             </a:r>
-            <a:endParaRPr lang="en-US" sz="4400" dirty="0"/>
-          </a:p>
-        </p:txBody>
-      </p:sp>
-      <p:sp>
-        <p:nvSpPr>
-          <p:cNvPr id="12" name="caption 41.4 %"/>
-          <p:cNvSpPr txBox="1"/>
-          <p:nvPr/>
-        </p:nvSpPr>
-        <p:spPr>
-          <a:xfrm>
-            <a:off x="6263640" y="2331720"/>
-            <a:ext cx="2240280" cy="960120"/>
-          </a:xfrm>
-          <a:prstGeom prst="rect">
-            <a:avLst/>
-          </a:prstGeom>
-          <a:noFill/>
-          <a:ln/>
-        </p:spPr>
-        <p:txBody>
-          <a:bodyPr wrap="square" lIns="0" tIns="0" rIns="0" bIns="0" rtlCol="0" anchor="t"/>
-          <a:lstStyle/>
+            <a:endParaRPr lang="en-US" sz="1400" dirty="0"/>
+          </a:p>
           <a:p>
             <a:pPr indent="0" marL="0">
               <a:buNone/>
             </a:pPr>
             <a:r>
-              <a:rPr lang="en-US" sz="1400" dirty="0">
+              <a:rPr lang="en-US" sz="1200" dirty="0">
                 <a:solidFill>
                   <a:schemeClr val="tx1"/>
                 </a:solidFill>
               </a:rPr>
-              <a:t>Our MLP, trained from zero on the pixels</a:t>
+              <a:t>look inside the training, fix it, break it on purpose</a:t>
             </a:r>
             <a:endParaRPr lang="en-US" sz="1400" dirty="0"/>
           </a:p>
@@ -11066,18 +11293,18 @@
       </p:sp>
       <p:sp>
         <p:nvSpPr>
-          <p:cNvPr id="13" name="note And it is affordable"/>
+          <p:cNvPr id="17" name="step 4"/>
           <p:cNvSpPr/>
           <p:nvPr/>
         </p:nvSpPr>
         <p:spPr>
           <a:xfrm>
-            <a:off x="457200" y="3611880"/>
-            <a:ext cx="8229600" cy="960120"/>
+            <a:off x="457200" y="3355848"/>
+            <a:ext cx="2560320" cy="1188720"/>
           </a:xfrm>
           <a:prstGeom prst="roundRect">
             <a:avLst>
-              <a:gd name="adj" fmla="val 7619"/>
+              <a:gd name="adj" fmla="val 6154"/>
             </a:avLst>
           </a:prstGeom>
           <a:solidFill>
@@ -11093,14 +11320,75 @@
       </p:sp>
       <p:sp>
         <p:nvSpPr>
-          <p:cNvPr id="14" name="text And it is affordable"/>
+          <p:cNvPr id="18" name="step circle 4"/>
+          <p:cNvSpPr/>
+          <p:nvPr/>
+        </p:nvSpPr>
+        <p:spPr>
+          <a:xfrm>
+            <a:off x="621792" y="3538728"/>
+            <a:ext cx="457200" cy="457200"/>
+          </a:xfrm>
+          <a:prstGeom prst="ellipse">
+            <a:avLst/>
+          </a:prstGeom>
+          <a:solidFill>
+            <a:schemeClr val="accent1"/>
+          </a:solidFill>
+          <a:ln w="12700">
+            <a:solidFill>
+              <a:schemeClr val="accent1"/>
+            </a:solidFill>
+            <a:prstDash val="solid"/>
+          </a:ln>
+        </p:spPr>
+      </p:sp>
+      <p:sp>
+        <p:nvSpPr>
+          <p:cNvPr id="19" name="step number 4"/>
           <p:cNvSpPr txBox="1"/>
           <p:nvPr/>
         </p:nvSpPr>
         <p:spPr>
           <a:xfrm>
-            <a:off x="621792" y="3721608"/>
-            <a:ext cx="7900416" cy="740664"/>
+            <a:off x="621792" y="3538728"/>
+            <a:ext cx="457200" cy="457200"/>
+          </a:xfrm>
+          <a:prstGeom prst="rect">
+            <a:avLst/>
+          </a:prstGeom>
+          <a:noFill/>
+          <a:ln/>
+        </p:spPr>
+        <p:txBody>
+          <a:bodyPr wrap="square" lIns="0" tIns="0" rIns="0" bIns="0" rtlCol="0" anchor="ctr"/>
+          <a:lstStyle/>
+          <a:p>
+            <a:pPr algn="ctr" indent="0" marL="0">
+              <a:buNone/>
+            </a:pPr>
+            <a:r>
+              <a:rPr lang="en-US" sz="1800" b="1" dirty="0">
+                <a:solidFill>
+                  <a:schemeClr val="bg1"/>
+                </a:solidFill>
+              </a:rPr>
+              <a:t>4</a:t>
+            </a:r>
+            <a:endParaRPr lang="en-US" sz="1800" dirty="0"/>
+          </a:p>
+        </p:txBody>
+      </p:sp>
+      <p:sp>
+        <p:nvSpPr>
+          <p:cNvPr id="20" name="step text 4"/>
+          <p:cNvSpPr txBox="1"/>
+          <p:nvPr/>
+        </p:nvSpPr>
+        <p:spPr>
+          <a:xfrm>
+            <a:off x="1207008" y="3493008"/>
+            <a:ext cx="1691640" cy="1024128"/>
           </a:xfrm>
           <a:prstGeom prst="rect">
             <a:avLst/>
@@ -11113,37 +11401,307 @@
           <a:lstStyle/>
           <a:p>
             <a:pPr indent="0" marL="0">
-              <a:spcAft>
-                <a:spcPts val="400"/>
-              </a:spcAft>
               <a:buNone/>
             </a:pPr>
             <a:r>
-              <a:rPr lang="en-US" sz="1500" b="1" dirty="0">
+              <a:rPr lang="en-US" sz="1400" b="1" dirty="0">
                 <a:solidFill>
                   <a:schemeClr val="tx2"/>
                 </a:solidFill>
               </a:rPr>
-              <a:t>And it is affordable</a:t>
+              <a:t>A pretrained ResNet18</a:t>
             </a:r>
-            <a:endParaRPr lang="en-US" sz="1500" dirty="0"/>
+            <a:endParaRPr lang="en-US" sz="1400" dirty="0"/>
           </a:p>
           <a:p>
             <a:pPr indent="0" marL="0">
-              <a:spcAft>
-                <a:spcPts val="400"/>
-              </a:spcAft>
               <a:buNone/>
             </a:pPr>
             <a:r>
-              <a:rPr lang="en-US" sz="1400" dirty="0">
+              <a:rPr lang="en-US" sz="1200" dirty="0">
                 <a:solidFill>
                   <a:schemeClr val="tx1"/>
                 </a:solidFill>
               </a:rPr>
-              <a:t>53 ms per photo on one CPU thread · 45 MB · 17 s of training on a laptop · no GPU</a:t>
+              <a:t>reuse a network trained on 1.2 million photos</a:t>
             </a:r>
-            <a:endParaRPr lang="en-US" sz="1500" dirty="0"/>
+            <a:endParaRPr lang="en-US" sz="1400" dirty="0"/>
+          </a:p>
+        </p:txBody>
+      </p:sp>
+      <p:sp>
+        <p:nvSpPr>
+          <p:cNvPr id="21" name="step 5"/>
+          <p:cNvSpPr/>
+          <p:nvPr/>
+        </p:nvSpPr>
+        <p:spPr>
+          <a:xfrm>
+            <a:off x="3291840" y="3355848"/>
+            <a:ext cx="2560320" cy="1188720"/>
+          </a:xfrm>
+          <a:prstGeom prst="roundRect">
+            <a:avLst>
+              <a:gd name="adj" fmla="val 6154"/>
+            </a:avLst>
+          </a:prstGeom>
+          <a:solidFill>
+            <a:schemeClr val="bg2"/>
+          </a:solidFill>
+          <a:ln w="12700">
+            <a:solidFill>
+              <a:schemeClr val="bg2"/>
+            </a:solidFill>
+            <a:prstDash val="solid"/>
+          </a:ln>
+        </p:spPr>
+      </p:sp>
+      <p:sp>
+        <p:nvSpPr>
+          <p:cNvPr id="22" name="step circle 5"/>
+          <p:cNvSpPr/>
+          <p:nvPr/>
+        </p:nvSpPr>
+        <p:spPr>
+          <a:xfrm>
+            <a:off x="3456432" y="3538728"/>
+            <a:ext cx="457200" cy="457200"/>
+          </a:xfrm>
+          <a:prstGeom prst="ellipse">
+            <a:avLst/>
+          </a:prstGeom>
+          <a:solidFill>
+            <a:schemeClr val="accent1"/>
+          </a:solidFill>
+          <a:ln w="12700">
+            <a:solidFill>
+              <a:schemeClr val="accent1"/>
+            </a:solidFill>
+            <a:prstDash val="solid"/>
+          </a:ln>
+        </p:spPr>
+      </p:sp>
+      <p:sp>
+        <p:nvSpPr>
+          <p:cNvPr id="23" name="step number 5"/>
+          <p:cNvSpPr txBox="1"/>
+          <p:nvPr/>
+        </p:nvSpPr>
+        <p:spPr>
+          <a:xfrm>
+            <a:off x="3456432" y="3538728"/>
+            <a:ext cx="457200" cy="457200"/>
+          </a:xfrm>
+          <a:prstGeom prst="rect">
+            <a:avLst/>
+          </a:prstGeom>
+          <a:noFill/>
+          <a:ln/>
+        </p:spPr>
+        <p:txBody>
+          <a:bodyPr wrap="square" lIns="0" tIns="0" rIns="0" bIns="0" rtlCol="0" anchor="ctr"/>
+          <a:lstStyle/>
+          <a:p>
+            <a:pPr algn="ctr" indent="0" marL="0">
+              <a:buNone/>
+            </a:pPr>
+            <a:r>
+              <a:rPr lang="en-US" sz="1800" b="1" dirty="0">
+                <a:solidFill>
+                  <a:schemeClr val="bg1"/>
+                </a:solidFill>
+              </a:rPr>
+              <a:t>5</a:t>
+            </a:r>
+            <a:endParaRPr lang="en-US" sz="1800" dirty="0"/>
+          </a:p>
+        </p:txBody>
+      </p:sp>
+      <p:sp>
+        <p:nvSpPr>
+          <p:cNvPr id="24" name="step text 5"/>
+          <p:cNvSpPr txBox="1"/>
+          <p:nvPr/>
+        </p:nvSpPr>
+        <p:spPr>
+          <a:xfrm>
+            <a:off x="4041648" y="3493008"/>
+            <a:ext cx="1691640" cy="1024128"/>
+          </a:xfrm>
+          <a:prstGeom prst="rect">
+            <a:avLst/>
+          </a:prstGeom>
+          <a:noFill/>
+          <a:ln/>
+        </p:spPr>
+        <p:txBody>
+          <a:bodyPr wrap="square" lIns="0" tIns="0" rIns="0" bIns="0" rtlCol="0" anchor="t"/>
+          <a:lstStyle/>
+          <a:p>
+            <a:pPr indent="0" marL="0">
+              <a:buNone/>
+            </a:pPr>
+            <a:r>
+              <a:rPr lang="en-US" sz="1400" b="1" dirty="0">
+                <a:solidFill>
+                  <a:schemeClr val="tx2"/>
+                </a:solidFill>
+              </a:rPr>
+              <a:t>The final test</a:t>
+            </a:r>
+            <a:endParaRPr lang="en-US" sz="1400" dirty="0"/>
+          </a:p>
+          <a:p>
+            <a:pPr indent="0" marL="0">
+              <a:buNone/>
+            </a:pPr>
+            <a:r>
+              <a:rPr lang="en-US" sz="1200" dirty="0">
+                <a:solidFill>
+                  <a:schemeClr val="tx1"/>
+                </a:solidFill>
+              </a:rPr>
+              <a:t>every model once on 220 new paintings, classical models too</a:t>
+            </a:r>
+            <a:endParaRPr lang="en-US" sz="1400" dirty="0"/>
+          </a:p>
+        </p:txBody>
+      </p:sp>
+      <p:sp>
+        <p:nvSpPr>
+          <p:cNvPr id="25" name="step 6"/>
+          <p:cNvSpPr/>
+          <p:nvPr/>
+        </p:nvSpPr>
+        <p:spPr>
+          <a:xfrm>
+            <a:off x="6126480" y="3355848"/>
+            <a:ext cx="2560320" cy="1188720"/>
+          </a:xfrm>
+          <a:prstGeom prst="roundRect">
+            <a:avLst>
+              <a:gd name="adj" fmla="val 6154"/>
+            </a:avLst>
+          </a:prstGeom>
+          <a:solidFill>
+            <a:schemeClr val="bg2"/>
+          </a:solidFill>
+          <a:ln w="12700">
+            <a:solidFill>
+              <a:schemeClr val="bg2"/>
+            </a:solidFill>
+            <a:prstDash val="solid"/>
+          </a:ln>
+        </p:spPr>
+      </p:sp>
+      <p:sp>
+        <p:nvSpPr>
+          <p:cNvPr id="26" name="step circle 6"/>
+          <p:cNvSpPr/>
+          <p:nvPr/>
+        </p:nvSpPr>
+        <p:spPr>
+          <a:xfrm>
+            <a:off x="6291072" y="3538728"/>
+            <a:ext cx="457200" cy="457200"/>
+          </a:xfrm>
+          <a:prstGeom prst="ellipse">
+            <a:avLst/>
+          </a:prstGeom>
+          <a:solidFill>
+            <a:schemeClr val="accent1"/>
+          </a:solidFill>
+          <a:ln w="12700">
+            <a:solidFill>
+              <a:schemeClr val="accent1"/>
+            </a:solidFill>
+            <a:prstDash val="solid"/>
+          </a:ln>
+        </p:spPr>
+      </p:sp>
+      <p:sp>
+        <p:nvSpPr>
+          <p:cNvPr id="27" name="step number 6"/>
+          <p:cNvSpPr txBox="1"/>
+          <p:nvPr/>
+        </p:nvSpPr>
+        <p:spPr>
+          <a:xfrm>
+            <a:off x="6291072" y="3538728"/>
+            <a:ext cx="457200" cy="457200"/>
+          </a:xfrm>
+          <a:prstGeom prst="rect">
+            <a:avLst/>
+          </a:prstGeom>
+          <a:noFill/>
+          <a:ln/>
+        </p:spPr>
+        <p:txBody>
+          <a:bodyPr wrap="square" lIns="0" tIns="0" rIns="0" bIns="0" rtlCol="0" anchor="ctr"/>
+          <a:lstStyle/>
+          <a:p>
+            <a:pPr algn="ctr" indent="0" marL="0">
+              <a:buNone/>
+            </a:pPr>
+            <a:r>
+              <a:rPr lang="en-US" sz="1800" b="1" dirty="0">
+                <a:solidFill>
+                  <a:schemeClr val="bg1"/>
+                </a:solidFill>
+              </a:rPr>
+              <a:t>6</a:t>
+            </a:r>
+            <a:endParaRPr lang="en-US" sz="1800" dirty="0"/>
+          </a:p>
+        </p:txBody>
+      </p:sp>
+      <p:sp>
+        <p:nvSpPr>
+          <p:cNvPr id="28" name="step text 6"/>
+          <p:cNvSpPr txBox="1"/>
+          <p:nvPr/>
+        </p:nvSpPr>
+        <p:spPr>
+          <a:xfrm>
+            <a:off x="6876288" y="3493008"/>
+            <a:ext cx="1691640" cy="1024128"/>
+          </a:xfrm>
+          <a:prstGeom prst="rect">
+            <a:avLst/>
+          </a:prstGeom>
+          <a:noFill/>
+          <a:ln/>
+        </p:spPr>
+        <p:txBody>
+          <a:bodyPr wrap="square" lIns="0" tIns="0" rIns="0" bIns="0" rtlCol="0" anchor="t"/>
+          <a:lstStyle/>
+          <a:p>
+            <a:pPr indent="0" marL="0">
+              <a:buNone/>
+            </a:pPr>
+            <a:r>
+              <a:rPr lang="en-US" sz="1400" b="1" dirty="0">
+                <a:solidFill>
+                  <a:schemeClr val="tx2"/>
+                </a:solidFill>
+              </a:rPr>
+              <a:t>The cost on a kiosk</a:t>
+            </a:r>
+            <a:endParaRPr lang="en-US" sz="1400" dirty="0"/>
+          </a:p>
+          <a:p>
+            <a:pPr indent="0" marL="0">
+              <a:buNone/>
+            </a:pPr>
+            <a:r>
+              <a:rPr lang="en-US" sz="1200" dirty="0">
+                <a:solidFill>
+                  <a:schemeClr val="tx1"/>
+                </a:solidFill>
+              </a:rPr>
+              <a:t>time per photo, size, training time</a:t>
+            </a:r>
+            <a:endParaRPr lang="en-US" sz="1400" dirty="0"/>
           </a:p>
         </p:txBody>
       </p:sp>
@@ -11257,7 +11815,43 @@
       </p:sp>
       <p:sp>
         <p:nvSpPr>
-          <p:cNvPr id="3" name="split bullets"/>
+          <p:cNvPr id="3" name="step tag 1"/>
+          <p:cNvSpPr txBox="1"/>
+          <p:nvPr/>
+        </p:nvSpPr>
+        <p:spPr>
+          <a:xfrm>
+            <a:off x="457200" y="54864"/>
+            <a:ext cx="8229600" cy="237744"/>
+          </a:xfrm>
+          <a:prstGeom prst="rect">
+            <a:avLst/>
+          </a:prstGeom>
+          <a:noFill/>
+          <a:ln/>
+        </p:spPr>
+        <p:txBody>
+          <a:bodyPr wrap="square" lIns="0" tIns="0" rIns="0" bIns="0" rtlCol="0" anchor="ctr"/>
+          <a:lstStyle/>
+          <a:p>
+            <a:pPr algn="ctr" indent="0" marL="0">
+              <a:buNone/>
+            </a:pPr>
+            <a:r>
+              <a:rPr lang="en-US" sz="1100" b="1" spc="200" kern="0" dirty="0">
+                <a:solidFill>
+                  <a:schemeClr val="accent1"/>
+                </a:solidFill>
+              </a:rPr>
+              <a:t>STEP 1 OF 6 · DATA</a:t>
+            </a:r>
+            <a:endParaRPr lang="en-US" sz="1100" dirty="0"/>
+          </a:p>
+        </p:txBody>
+      </p:sp>
+      <p:sp>
+        <p:nvSpPr>
+          <p:cNvPr id="4" name="split bullets"/>
           <p:cNvSpPr txBox="1"/>
           <p:nvPr/>
         </p:nvSpPr>
@@ -11351,7 +11945,7 @@
       </p:sp>
       <p:sp>
         <p:nvSpPr>
-          <p:cNvPr id="4" name="split panel"/>
+          <p:cNvPr id="5" name="split panel"/>
           <p:cNvSpPr/>
           <p:nvPr/>
         </p:nvSpPr>
@@ -11378,7 +11972,7 @@
       </p:sp>
       <p:sp>
         <p:nvSpPr>
-          <p:cNvPr id="5" name="split caption"/>
+          <p:cNvPr id="6" name="split caption"/>
           <p:cNvSpPr txBox="1"/>
           <p:nvPr/>
         </p:nvSpPr>
@@ -11414,7 +12008,7 @@
       </p:sp>
       <p:sp>
         <p:nvSpPr>
-          <p:cNvPr id="6" name="bar train"/>
+          <p:cNvPr id="7" name="bar train"/>
           <p:cNvSpPr/>
           <p:nvPr/>
         </p:nvSpPr>
@@ -11439,7 +12033,7 @@
       </p:sp>
       <p:sp>
         <p:nvSpPr>
-          <p:cNvPr id="7" name="label train"/>
+          <p:cNvPr id="8" name="label train"/>
           <p:cNvSpPr txBox="1"/>
           <p:nvPr/>
         </p:nvSpPr>
@@ -11489,7 +12083,7 @@
       </p:sp>
       <p:sp>
         <p:nvSpPr>
-          <p:cNvPr id="8" name="bar validation"/>
+          <p:cNvPr id="9" name="bar validation"/>
           <p:cNvSpPr/>
           <p:nvPr/>
         </p:nvSpPr>
@@ -11514,7 +12108,7 @@
       </p:sp>
       <p:sp>
         <p:nvSpPr>
-          <p:cNvPr id="9" name="label validation"/>
+          <p:cNvPr id="10" name="label validation"/>
           <p:cNvSpPr txBox="1"/>
           <p:nvPr/>
         </p:nvSpPr>
@@ -11564,7 +12158,7 @@
       </p:sp>
       <p:sp>
         <p:nvSpPr>
-          <p:cNvPr id="10" name="bar test"/>
+          <p:cNvPr id="11" name="bar test"/>
           <p:cNvSpPr/>
           <p:nvPr/>
         </p:nvSpPr>
@@ -11589,7 +12183,7 @@
       </p:sp>
       <p:sp>
         <p:nvSpPr>
-          <p:cNvPr id="11" name="label test"/>
+          <p:cNvPr id="12" name="label test"/>
           <p:cNvSpPr txBox="1"/>
           <p:nvPr/>
         </p:nvSpPr>
@@ -11639,7 +12233,7 @@
       </p:sp>
       <p:sp>
         <p:nvSpPr>
-          <p:cNvPr id="12" name="zero shared"/>
+          <p:cNvPr id="13" name="zero shared"/>
           <p:cNvSpPr txBox="1"/>
           <p:nvPr/>
         </p:nvSpPr>
@@ -11678,7 +12272,7 @@
       </p:sp>
       <p:sp>
         <p:nvSpPr>
-          <p:cNvPr id="13" name="zero caption"/>
+          <p:cNvPr id="14" name="zero caption"/>
           <p:cNvSpPr txBox="1"/>
           <p:nvPr/>
         </p:nvSpPr>
@@ -11728,7 +12322,7 @@
       </p:sp>
       <p:sp>
         <p:nvSpPr>
-          <p:cNvPr id="14" name="split note"/>
+          <p:cNvPr id="15" name="split note"/>
           <p:cNvSpPr txBox="1"/>
           <p:nvPr/>
         </p:nvSpPr>
@@ -11870,9 +12464,45 @@
           </a:p>
         </p:txBody>
       </p:sp>
+      <p:sp>
+        <p:nvSpPr>
+          <p:cNvPr id="3" name="step tag 2"/>
+          <p:cNvSpPr txBox="1"/>
+          <p:nvPr/>
+        </p:nvSpPr>
+        <p:spPr>
+          <a:xfrm>
+            <a:off x="457200" y="54864"/>
+            <a:ext cx="8229600" cy="237744"/>
+          </a:xfrm>
+          <a:prstGeom prst="rect">
+            <a:avLst/>
+          </a:prstGeom>
+          <a:noFill/>
+          <a:ln/>
+        </p:spPr>
+        <p:txBody>
+          <a:bodyPr wrap="square" lIns="0" tIns="0" rIns="0" bIns="0" rtlCol="0" anchor="ctr"/>
+          <a:lstStyle/>
+          <a:p>
+            <a:pPr algn="ctr" indent="0" marL="0">
+              <a:buNone/>
+            </a:pPr>
+            <a:r>
+              <a:rPr lang="en-US" sz="1100" b="1" spc="200" kern="0" dirty="0">
+                <a:solidFill>
+                  <a:schemeClr val="accent1"/>
+                </a:solidFill>
+              </a:rPr>
+              <a:t>STEP 2 OF 6 · OUR MLP</a:t>
+            </a:r>
+            <a:endParaRPr lang="en-US" sz="1100" dirty="0"/>
+          </a:p>
+        </p:txBody>
+      </p:sp>
       <p:pic>
         <p:nvPicPr>
-          <p:cNvPr id="3" name="baseline curves" descr="Training and validation loss and accuracy of the MLP baseline: training accuracy reaches 99.7 % while validation stays near 40 %">    </p:cNvPr>
+          <p:cNvPr id="4" name="baseline curves" descr="Training and validation loss and accuracy of the MLP baseline: training accuracy reaches 99.7 % while validation stays near 40 %">    </p:cNvPr>
           <p:cNvPicPr>
             <a:picLocks noChangeAspect="1"/>
           </p:cNvPicPr>
@@ -11896,7 +12526,7 @@
       </p:pic>
       <p:sp>
         <p:nvSpPr>
-          <p:cNvPr id="4" name="note The network"/>
+          <p:cNvPr id="5" name="note The network"/>
           <p:cNvSpPr/>
           <p:nvPr/>
         </p:nvSpPr>
@@ -11923,7 +12553,7 @@
       </p:sp>
       <p:sp>
         <p:nvSpPr>
-          <p:cNvPr id="5" name="text The network"/>
+          <p:cNvPr id="6" name="text The network"/>
           <p:cNvSpPr txBox="1"/>
           <p:nvPr/>
         </p:nvSpPr>
@@ -11979,7 +12609,7 @@
       </p:sp>
       <p:sp>
         <p:nvSpPr>
-          <p:cNvPr id="6" name="note Two checks first"/>
+          <p:cNvPr id="7" name="note Two checks first"/>
           <p:cNvSpPr/>
           <p:nvPr/>
         </p:nvSpPr>
@@ -12006,7 +12636,7 @@
       </p:sp>
       <p:sp>
         <p:nvSpPr>
-          <p:cNvPr id="7" name="text Two checks first"/>
+          <p:cNvPr id="8" name="text Two checks first"/>
           <p:cNvSpPr txBox="1"/>
           <p:nvPr/>
         </p:nvSpPr>
@@ -12062,7 +12692,7 @@
       </p:sp>
       <p:sp>
         <p:nvSpPr>
-          <p:cNvPr id="8" name="note The problem"/>
+          <p:cNvPr id="9" name="note The problem"/>
           <p:cNvSpPr/>
           <p:nvPr/>
         </p:nvSpPr>
@@ -12089,7 +12719,7 @@
       </p:sp>
       <p:sp>
         <p:nvSpPr>
-          <p:cNvPr id="9" name="text The problem"/>
+          <p:cNvPr id="10" name="text The problem"/>
           <p:cNvSpPr txBox="1"/>
           <p:nvPr/>
         </p:nvSpPr>
@@ -12251,9 +12881,45 @@
           </a:p>
         </p:txBody>
       </p:sp>
+      <p:sp>
+        <p:nvSpPr>
+          <p:cNvPr id="3" name="step tag 3"/>
+          <p:cNvSpPr txBox="1"/>
+          <p:nvPr/>
+        </p:nvSpPr>
+        <p:spPr>
+          <a:xfrm>
+            <a:off x="457200" y="54864"/>
+            <a:ext cx="8229600" cy="237744"/>
+          </a:xfrm>
+          <a:prstGeom prst="rect">
+            <a:avLst/>
+          </a:prstGeom>
+          <a:noFill/>
+          <a:ln/>
+        </p:spPr>
+        <p:txBody>
+          <a:bodyPr wrap="square" lIns="0" tIns="0" rIns="0" bIns="0" rtlCol="0" anchor="ctr"/>
+          <a:lstStyle/>
+          <a:p>
+            <a:pPr algn="ctr" indent="0" marL="0">
+              <a:buNone/>
+            </a:pPr>
+            <a:r>
+              <a:rPr lang="en-US" sz="1100" b="1" spc="200" kern="0" dirty="0">
+                <a:solidFill>
+                  <a:schemeClr val="accent1"/>
+                </a:solidFill>
+              </a:rPr>
+              <a:t>STEP 3 OF 6 · MONITORING</a:t>
+            </a:r>
+            <a:endParaRPr lang="en-US" sz="1100" dirty="0"/>
+          </a:p>
+        </p:txBody>
+      </p:sp>
       <p:graphicFrame>
         <p:nvGraphicFramePr>
-          <p:cNvPr id="3" name="chart regularisation" descr=""/>
+          <p:cNvPr id="4" name="chart regularisation" descr=""/>
           <p:cNvGraphicFramePr/>
           <p:nvPr/>
         </p:nvGraphicFramePr>
@@ -12269,7 +12935,7 @@
       </p:graphicFrame>
       <p:sp>
         <p:nvSpPr>
-          <p:cNvPr id="4" name="monitoring bullets"/>
+          <p:cNvPr id="5" name="monitoring bullets"/>
           <p:cNvSpPr txBox="1"/>
           <p:nvPr/>
         </p:nvSpPr>
@@ -12466,6 +13132,42 @@
               <a:t>Four broken runs, four signatures</a:t>
             </a:r>
             <a:endParaRPr lang="en-US" sz="3000" dirty="0"/>
+          </a:p>
+        </p:txBody>
+      </p:sp>
+      <p:sp>
+        <p:nvSpPr>
+          <p:cNvPr id="3" name="step tag 3"/>
+          <p:cNvSpPr txBox="1"/>
+          <p:nvPr/>
+        </p:nvSpPr>
+        <p:spPr>
+          <a:xfrm>
+            <a:off x="457200" y="54864"/>
+            <a:ext cx="8229600" cy="237744"/>
+          </a:xfrm>
+          <a:prstGeom prst="rect">
+            <a:avLst/>
+          </a:prstGeom>
+          <a:noFill/>
+          <a:ln/>
+        </p:spPr>
+        <p:txBody>
+          <a:bodyPr wrap="square" lIns="0" tIns="0" rIns="0" bIns="0" rtlCol="0" anchor="ctr"/>
+          <a:lstStyle/>
+          <a:p>
+            <a:pPr algn="ctr" indent="0" marL="0">
+              <a:buNone/>
+            </a:pPr>
+            <a:r>
+              <a:rPr lang="en-US" sz="1100" b="1" spc="200" kern="0" dirty="0">
+                <a:solidFill>
+                  <a:schemeClr val="accent1"/>
+                </a:solidFill>
+              </a:rPr>
+              <a:t>STEP 3 OF 6 · MONITORING</a:t>
+            </a:r>
+            <a:endParaRPr lang="en-US" sz="1100" dirty="0"/>
           </a:p>
         </p:txBody>
       </p:sp>
@@ -13685,7 +14387,7 @@
       </p:graphicFrame>
       <p:sp>
         <p:nvSpPr>
-          <p:cNvPr id="4" name="note Lesson"/>
+          <p:cNvPr id="5" name="note Lesson"/>
           <p:cNvSpPr/>
           <p:nvPr/>
         </p:nvSpPr>
@@ -13712,7 +14414,7 @@
       </p:sp>
       <p:sp>
         <p:nvSpPr>
-          <p:cNvPr id="5" name="text Lesson"/>
+          <p:cNvPr id="6" name="text Lesson"/>
           <p:cNvSpPr txBox="1"/>
           <p:nvPr/>
         </p:nvSpPr>
@@ -13874,9 +14576,45 @@
           </a:p>
         </p:txBody>
       </p:sp>
+      <p:sp>
+        <p:nvSpPr>
+          <p:cNvPr id="3" name="step tag 4"/>
+          <p:cNvSpPr txBox="1"/>
+          <p:nvPr/>
+        </p:nvSpPr>
+        <p:spPr>
+          <a:xfrm>
+            <a:off x="457200" y="54864"/>
+            <a:ext cx="8229600" cy="237744"/>
+          </a:xfrm>
+          <a:prstGeom prst="rect">
+            <a:avLst/>
+          </a:prstGeom>
+          <a:noFill/>
+          <a:ln/>
+        </p:spPr>
+        <p:txBody>
+          <a:bodyPr wrap="square" lIns="0" tIns="0" rIns="0" bIns="0" rtlCol="0" anchor="ctr"/>
+          <a:lstStyle/>
+          <a:p>
+            <a:pPr algn="ctr" indent="0" marL="0">
+              <a:buNone/>
+            </a:pPr>
+            <a:r>
+              <a:rPr lang="en-US" sz="1100" b="1" spc="200" kern="0" dirty="0">
+                <a:solidFill>
+                  <a:schemeClr val="accent1"/>
+                </a:solidFill>
+              </a:rPr>
+              <a:t>STEP 4 OF 6 · RESNET18</a:t>
+            </a:r>
+            <a:endParaRPr lang="en-US" sz="1100" dirty="0"/>
+          </a:p>
+        </p:txBody>
+      </p:sp>
       <p:graphicFrame>
         <p:nvGraphicFramePr>
-          <p:cNvPr id="3" name="chart resnet" descr=""/>
+          <p:cNvPr id="4" name="chart resnet" descr=""/>
           <p:cNvGraphicFramePr/>
           <p:nvPr/>
         </p:nvGraphicFramePr>
@@ -13892,7 +14630,7 @@
       </p:graphicFrame>
       <p:sp>
         <p:nvSpPr>
-          <p:cNvPr id="4" name="note Frozen features"/>
+          <p:cNvPr id="5" name="note Frozen features"/>
           <p:cNvSpPr/>
           <p:nvPr/>
         </p:nvSpPr>
@@ -13919,7 +14657,7 @@
       </p:sp>
       <p:sp>
         <p:nvSpPr>
-          <p:cNvPr id="5" name="text Frozen features"/>
+          <p:cNvPr id="6" name="text Frozen features"/>
           <p:cNvSpPr txBox="1"/>
           <p:nvPr/>
         </p:nvSpPr>
@@ -13975,7 +14713,7 @@
       </p:sp>
       <p:sp>
         <p:nvSpPr>
-          <p:cNvPr id="6" name="note Fine-tuning layer4"/>
+          <p:cNvPr id="7" name="note Fine-tuning layer4"/>
           <p:cNvSpPr/>
           <p:nvPr/>
         </p:nvSpPr>
@@ -14002,7 +14740,7 @@
       </p:sp>
       <p:sp>
         <p:nvSpPr>
-          <p:cNvPr id="7" name="text Fine-tuning layer4"/>
+          <p:cNvPr id="8" name="text Fine-tuning layer4"/>
           <p:cNvSpPr txBox="1"/>
           <p:nvPr/>
         </p:nvSpPr>
@@ -14058,7 +14796,7 @@
       </p:sp>
       <p:sp>
         <p:nvSpPr>
-          <p:cNvPr id="8" name="note Two silent bugs"/>
+          <p:cNvPr id="9" name="note Two silent bugs"/>
           <p:cNvSpPr/>
           <p:nvPr/>
         </p:nvSpPr>
@@ -14085,7 +14823,7 @@
       </p:sp>
       <p:sp>
         <p:nvSpPr>
-          <p:cNvPr id="9" name="text Two silent bugs"/>
+          <p:cNvPr id="10" name="text Two silent bugs"/>
           <p:cNvSpPr txBox="1"/>
           <p:nvPr/>
         </p:nvSpPr>
@@ -14247,9 +14985,45 @@
           </a:p>
         </p:txBody>
       </p:sp>
+      <p:sp>
+        <p:nvSpPr>
+          <p:cNvPr id="3" name="step tag 4"/>
+          <p:cNvSpPr txBox="1"/>
+          <p:nvPr/>
+        </p:nvSpPr>
+        <p:spPr>
+          <a:xfrm>
+            <a:off x="457200" y="54864"/>
+            <a:ext cx="8229600" cy="237744"/>
+          </a:xfrm>
+          <a:prstGeom prst="rect">
+            <a:avLst/>
+          </a:prstGeom>
+          <a:noFill/>
+          <a:ln/>
+        </p:spPr>
+        <p:txBody>
+          <a:bodyPr wrap="square" lIns="0" tIns="0" rIns="0" bIns="0" rtlCol="0" anchor="ctr"/>
+          <a:lstStyle/>
+          <a:p>
+            <a:pPr algn="ctr" indent="0" marL="0">
+              <a:buNone/>
+            </a:pPr>
+            <a:r>
+              <a:rPr lang="en-US" sz="1100" b="1" spc="200" kern="0" dirty="0">
+                <a:solidFill>
+                  <a:schemeClr val="accent1"/>
+                </a:solidFill>
+              </a:rPr>
+              <a:t>STEP 4 OF 6 · RESNET18</a:t>
+            </a:r>
+            <a:endParaRPr lang="en-US" sz="1100" dirty="0"/>
+          </a:p>
+        </p:txBody>
+      </p:sp>
       <p:graphicFrame>
         <p:nvGraphicFramePr>
-          <p:cNvPr id="3" name="chart leakage" descr=""/>
+          <p:cNvPr id="4" name="chart leakage" descr=""/>
           <p:cNvGraphicFramePr/>
           <p:nvPr/>
         </p:nvGraphicFramePr>
@@ -14265,7 +15039,7 @@
       </p:graphicFrame>
       <p:sp>
         <p:nvSpPr>
-          <p:cNvPr id="4" name="card +11.4"/>
+          <p:cNvPr id="5" name="card +11.4"/>
           <p:cNvSpPr/>
           <p:nvPr/>
         </p:nvSpPr>
@@ -14292,7 +15066,7 @@
       </p:sp>
       <p:sp>
         <p:nvSpPr>
-          <p:cNvPr id="5" name="value +11.4"/>
+          <p:cNvPr id="6" name="value +11.4"/>
           <p:cNvSpPr txBox="1"/>
           <p:nvPr/>
         </p:nvSpPr>
@@ -14331,7 +15105,7 @@
       </p:sp>
       <p:sp>
         <p:nvSpPr>
-          <p:cNvPr id="6" name="caption +11.4"/>
+          <p:cNvPr id="7" name="caption +11.4"/>
           <p:cNvSpPr txBox="1"/>
           <p:nvPr/>
         </p:nvSpPr>
@@ -14367,7 +15141,7 @@
       </p:sp>
       <p:sp>
         <p:nvSpPr>
-          <p:cNvPr id="7" name="leakage bullets"/>
+          <p:cNvPr id="8" name="leakage bullets"/>
           <p:cNvSpPr txBox="1"/>
           <p:nvPr/>
         </p:nvSpPr>
@@ -14549,9 +15323,45 @@
           </a:p>
         </p:txBody>
       </p:sp>
+      <p:sp>
+        <p:nvSpPr>
+          <p:cNvPr id="3" name="step tag 5"/>
+          <p:cNvSpPr txBox="1"/>
+          <p:nvPr/>
+        </p:nvSpPr>
+        <p:spPr>
+          <a:xfrm>
+            <a:off x="457200" y="54864"/>
+            <a:ext cx="8229600" cy="237744"/>
+          </a:xfrm>
+          <a:prstGeom prst="rect">
+            <a:avLst/>
+          </a:prstGeom>
+          <a:noFill/>
+          <a:ln/>
+        </p:spPr>
+        <p:txBody>
+          <a:bodyPr wrap="square" lIns="0" tIns="0" rIns="0" bIns="0" rtlCol="0" anchor="ctr"/>
+          <a:lstStyle/>
+          <a:p>
+            <a:pPr algn="ctr" indent="0" marL="0">
+              <a:buNone/>
+            </a:pPr>
+            <a:r>
+              <a:rPr lang="en-US" sz="1100" b="1" spc="200" kern="0" dirty="0">
+                <a:solidFill>
+                  <a:schemeClr val="accent1"/>
+                </a:solidFill>
+              </a:rPr>
+              <a:t>STEP 5 OF 6 · FINAL TEST</a:t>
+            </a:r>
+            <a:endParaRPr lang="en-US" sz="1100" dirty="0"/>
+          </a:p>
+        </p:txBody>
+      </p:sp>
       <p:graphicFrame>
         <p:nvGraphicFramePr>
-          <p:cNvPr id="3" name="chart final test" descr=""/>
+          <p:cNvPr id="4" name="chart final test" descr=""/>
           <p:cNvGraphicFramePr/>
           <p:nvPr/>
         </p:nvGraphicFramePr>
@@ -14567,7 +15377,7 @@
       </p:graphicFrame>
       <p:sp>
         <p:nvSpPr>
-          <p:cNvPr id="4" name="card +16.4"/>
+          <p:cNvPr id="5" name="card +16.4"/>
           <p:cNvSpPr/>
           <p:nvPr/>
         </p:nvSpPr>
@@ -14594,7 +15404,7 @@
       </p:sp>
       <p:sp>
         <p:nvSpPr>
-          <p:cNvPr id="5" name="value +16.4"/>
+          <p:cNvPr id="6" name="value +16.4"/>
           <p:cNvSpPr txBox="1"/>
           <p:nvPr/>
         </p:nvSpPr>
@@ -14633,7 +15443,7 @@
       </p:sp>
       <p:sp>
         <p:nvSpPr>
-          <p:cNvPr id="6" name="caption +16.4"/>
+          <p:cNvPr id="7" name="caption +16.4"/>
           <p:cNvSpPr txBox="1"/>
           <p:nvPr/>
         </p:nvSpPr>
@@ -14669,7 +15479,7 @@
       </p:sp>
       <p:sp>
         <p:nvSpPr>
-          <p:cNvPr id="7" name="note Honest note"/>
+          <p:cNvPr id="8" name="note Honest note"/>
           <p:cNvSpPr/>
           <p:nvPr/>
         </p:nvSpPr>
@@ -14696,7 +15506,7 @@
       </p:sp>
       <p:sp>
         <p:nvSpPr>
-          <p:cNvPr id="8" name="text Honest note"/>
+          <p:cNvPr id="9" name="text Honest note"/>
           <p:cNvSpPr txBox="1"/>
           <p:nvPr/>
         </p:nvSpPr>

</xml_diff>

<commit_message>
Add transitions between slides in the oral script and speaker notes
</commit_message>
<xml_diff>
--- a/docs/museum_guide_presentation.pptx
+++ b/docs/museum_guide_presentation.pptx
@@ -122,34 +122,34 @@
   <p:extLst>
     <p:ext uri="{521415D9-36F7-43E2-AB2F-B90AF26B5E84}">
       <p14:sectionLst xmlns:p14="http://schemas.microsoft.com/office/powerpoint/2010/main">
-        <p14:section name="The question" id="{e5c8e1d7-ddc3-fa8f-1f2b-9dad2dc8ed23}">
+        <p14:section name="The question" id="{27597ed3-da94-7c63-51d2-fa2f68b3bcf0}">
           <p14:sldIdLst>
             <p14:sldId id="256"/>
             <p14:sldId id="257"/>
             <p14:sldId id="258"/>
           </p14:sldIdLst>
         </p14:section>
-        <p14:section name="Our MLP" id="{b6e8bc5f-7058-8fa3-511c-5599d51b4cbf}">
+        <p14:section name="Our MLP" id="{1c9d8897-c720-cbce-e13a-25f6e5739eea}">
           <p14:sldIdLst>
             <p14:sldId id="259"/>
             <p14:sldId id="260"/>
             <p14:sldId id="261"/>
           </p14:sldIdLst>
         </p14:section>
-        <p14:section name="Pretrained ResNet" id="{ecb0ff74-0ac2-1075-e72e-170620d96556}">
+        <p14:section name="Pretrained ResNet" id="{d72ac846-d1f1-7b05-2571-28e258c1d731}">
           <p14:sldIdLst>
             <p14:sldId id="262"/>
             <p14:sldId id="263"/>
           </p14:sldIdLst>
         </p14:section>
-        <p14:section name="The answer" id="{5e1b2434-38f2-e127-0e9c-8c363d828960}">
+        <p14:section name="The answer" id="{1037b800-ea6f-10d0-53ae-0527c3e2970a}">
           <p14:sldIdLst>
             <p14:sldId id="264"/>
             <p14:sldId id="265"/>
             <p14:sldId id="266"/>
           </p14:sldIdLst>
         </p14:section>
-        <p14:section name="Backup" id="{23a47c87-4be2-5586-f441-6963f24fc69c}">
+        <p14:section name="Backup" id="{7cedb8db-afe4-31a0-fd7d-7bf38694390b}">
           <p14:sldIdLst>
             <p14:sldId id="267"/>
             <p14:sldId id="268"/>
@@ -2634,7 +2634,7 @@
           <a:p>
             <a:r>
               <a:rPr lang="en-US" dirty="0"/>
-              <a:t>Step six: is it affordable on a kiosk? We timed one photo at a time, from the image to the answer. The ResNet needs 53 milliseconds on one CPU thread, 26 with four threads: faster than a blink. Even on a kiosk four times slower, it answers in a fifth of a second. The model file is 45 megabytes. And when the collection changes, we only recompute the features and retrain one layer, in seconds.</a:t>
+              <a:t>Accuracy is only half of the director's question; the other half is the cost. So step six: is it affordable on a kiosk? We timed one photo at a time, from the image to the answer. The ResNet needs 53 milliseconds on one CPU thread, 26 with four threads: faster than a blink. Even on a kiosk four times slower, it answers in a fifth of a second. The model file is 45 megabytes. And when the collection changes, we only recompute the features and retrain one layer, in seconds.</a:t>
             </a:r>
             <a:endParaRPr lang="en-US" dirty="0"/>
           </a:p>
@@ -2722,7 +2722,7 @@
           <a:p>
             <a:r>
               <a:rPr lang="en-US" dirty="0"/>
-              <a:t>Let's put the six steps together. On the test, our own MLP reached 41 percent, the best classical model 67, and the frozen ResNet18 83, at a cost a kiosk can afford. So, our answer to the director: yes, a neural network is worth it, but a pretrained one that we reuse. We recommend a frozen ResNet18 with a linear head. Why? It is accurate: one visitor in six gets a wrong style, against one in three. It is fast enough for a modest CPU, and cheap for a small team: one small layer, retrained in seconds. We do not recommend our MLP, a classical model alone, or fine-tuning for now. Before the launch, we must test real photos taken at the kiosks, add more styles, and measure the real hardware. Thank you. We are happy to take your questions.</a:t>
+              <a:t>We can now answer the director. On the test, our own MLP reached 41 percent, the best classical model 67, and the frozen ResNet18 83, at a cost a kiosk can afford. So, our answer to the director: yes, a neural network is worth it, but a pretrained one that we reuse. We recommend a frozen ResNet18 with a linear head. Why? It is accurate: one visitor in six gets a wrong style, against one in three. It is fast enough for a modest CPU, and cheap for a small team: one small layer, retrained in seconds. We do not recommend our MLP, a classical model alone, or fine-tuning for now. Before the launch, we must test real photos taken at the kiosks, add more styles, and measure the real hardware. Thank you. We are happy to take your questions.</a:t>
             </a:r>
             <a:endParaRPr lang="en-US" dirty="0"/>
           </a:p>
@@ -3338,7 +3338,7 @@
           <a:p>
             <a:r>
               <a:rPr lang="en-US" dirty="0"/>
-              <a:t>Step one: the data. We took 1 500 paintings from WikiArt, 300 per style. We used the course script with a fixed seed, so anyone can download exactly the same images. We cut them into three piles: 1 061 to train, 219 to validate, that is, to choose our settings, and 220 to test, used only once, at the very end. One rule matters a lot: all the paintings of a known painter go to the same pile. With a random split, 23 of our 32 known painters would be in two piles, and a model could learn to recognise Monet instead of Impressionism. With our split: zero. I will come back to this, because we measured its effect.</a:t>
+              <a:t>Step one: the data. We took 1 500 paintings from WikiArt, 300 per style. We used the course script with a fixed seed, so anyone can download exactly the same images. We cut them into three piles: 1 061 to train, 219 to validate, that is, to choose our settings, and 220 to test, used only once, at the very end. One rule matters a lot: all the paintings of a known painter go to the same pile. With a random split, 23 of our 32 known painters would be in two piles, and a model could learn to recognise Monet instead of Impressionism. With our split: zero. With fair data in place, we could build our first model.</a:t>
             </a:r>
             <a:endParaRPr lang="en-US" dirty="0"/>
           </a:p>
@@ -3426,7 +3426,7 @@
           <a:p>
             <a:r>
               <a:rPr lang="en-US" dirty="0"/>
-              <a:t>Step two: our own network. Our first model is the network of the course: a multi-layer perceptron built from nn.Linear layers and ReLU, with our own training loop. It reads the pixels of a 64 by 64 image: 12 288 inputs and 6.4 million parameters. Before trusting it, we ran two checks. First, a model that knows nothing should have a loss of ln 5, about 1.61. Ours started at 1.99, too confident, so we made its last layer smaller and got 1.59. Second, it must be able to learn one small batch by heart: it does, 100 percent. Then the real training. The training accuracy goes to 99.7 percent, but the validation accuracy stays around 40 percent, and the validation loss goes up after epoch 3. This is overfitting: the network learns the paintings by heart.</a:t>
+              <a:t>Step two. We started with the simplest neural network of the course: a multi-layer perceptron built from nn.Linear layers and ReLU, with our own training loop. It reads the pixels of a 64 by 64 image: 12 288 inputs and 6.4 million parameters. Before trusting it, we ran two checks. First, a model that knows nothing should have a loss of ln 5, about 1.61. Ours started at 1.99, too confident, so we made its last layer smaller and got 1.59. Second, it must be able to learn one small batch by heart: it does, 100 percent. Then the real training. The training accuracy goes to 99.7 percent, but the validation accuracy stays around 40 percent. And the validation loss goes up after epoch 3. This is overfitting: the network learns the paintings by heart.</a:t>
             </a:r>
             <a:endParaRPr lang="en-US" dirty="0"/>
           </a:p>
@@ -3514,7 +3514,7 @@
           <a:p>
             <a:r>
               <a:rPr lang="en-US" dirty="0"/>
-              <a:t>Step three: monitoring. We looked inside the network during training, not only at the loss. The gradient reaches every layer and only 4 percent of the neurons are dead: the training is healthy, the problem is overfitting. We also tried 8 learning rates and kept 0.0001. Then we tested the tools of session 6, each with 3 seeds, because one run on 219 images is noisy. Alone, each tool helps a little. All together, weight decay, dropout, batch norm, flips, early stopping and a cosine schedule take the MLP from 38.8 to 45.5 percent, and the gap between train and validation from 0.61 to 0.12. But one number shows the real limit: the MLP finds only 7 percent of the Cubist paintings. It sees colours, not shapes.</a:t>
+              <a:t>Step three. Our MLP overfits, so we wanted to fix it. But first, we looked inside the network to check that the training itself was healthy: the gradient reaches every layer and only 4 percent of the neurons are dead. So the problem really is overfitting. We also tried 8 learning rates and kept 0.0001. So we attacked it with the tools of session 6, 3 seeds each. Alone, each tool helps a little. All together, weight decay, dropout, batch norm, flips and early stopping take the MLP from 38.8 to 45.5 percent, and the gap between train and validation from 0.61 to 0.12. Overfitting is under control. But one number shows a deeper limit: the MLP finds only 7 percent of the Cubist paintings. It sees colours, not shapes. This will decide our next model.</a:t>
             </a:r>
             <a:endParaRPr lang="en-US" dirty="0"/>
           </a:p>
@@ -3602,7 +3602,7 @@
           <a:p>
             <a:r>
               <a:rPr lang="en-US" dirty="0"/>
-              <a:t>Still in step three, we wanted to be ready for problems in production, so we broke the training four times on purpose, and diagnosed each run. A learning rate 100 times too big killed 99.6 percent of the neurons of layer 2. A forgotten zero_grad made the gradients pile up: 26 times bigger after two epochs. Raw pixels, without standardisation, gave a first loss of 16 instead of 1.6. And eight sigmoid layers gave a vanishing gradient: the first layer received less than a millionth of the gradient of the last one. The lesson: two of these bugs show the same symptom, a loss stuck at ln 5. Only the monitoring, dead neurons or the gradient per layer, can tell them apart.</a:t>
+              <a:t>But overfitting is not the only way a training can go wrong. To be ready for other failures, we broke the training four times on purpose, and diagnosed each run. A learning rate 100 times too big killed 99.6 percent of the neurons of layer 2. A forgotten zero_grad made the gradients pile up: 26 times bigger after two epochs. Raw pixels, without standardisation, gave a first loss of 16 instead of 1.6. And eight sigmoid layers gave a vanishing gradient: the first layer got a millionth of the gradient of the last. The lesson: two of these bugs show the same symptom, a loss stuck at ln 5. Only the monitoring, dead neurons or the gradient per layer, can tell them apart.</a:t>
             </a:r>
             <a:endParaRPr lang="en-US" dirty="0"/>
           </a:p>
@@ -3690,7 +3690,7 @@
           <a:p>
             <a:r>
               <a:rPr lang="en-US" dirty="0"/>
-              <a:t>Step four. Our MLP sees colours but not shapes, and to see shapes, we need a convolutional network. With only 1 061 images we cannot train one from zero, so we reuse ResNet18, already trained on 1.2 million ImageNet photos. We freeze it: each painting becomes 512 numbers, and we train only one linear layer, 2 565 weights, in less than a second. Result: 88.1 percent on validation, almost twice our best MLP. We also fine-tuned the last block: 8.4 million weights for 1 061 images. It overfits: 85.4 percent. And we measured two silent bugs: forgetting model.eval() drops the score to 12.8 percent, and forgetting the ImageNet normalisation costs 6 points. Nothing crashes: only measuring shows them.</a:t>
+              <a:t>With a training we can now trust, step four goes back to the deeper limit: our MLP sees colours, not shapes. To see shapes, we need a convolutional network. With only 1 061 images we cannot train one from zero, so we reuse ResNet18, already trained on 1.2 million ImageNet photos. We freeze it: each painting becomes 512 numbers, and we train only one linear layer, 2 565 weights, in less than a second. Result: 88.1 percent on validation, almost twice our best MLP. We also fine-tuned the last block: 8.4 million weights for 1 061 images. It overfits: 85.4 percent. And we measured two silent bugs: forgetting model.eval() drops the score to 12.8 percent, and forgetting the ImageNet normalisation costs 6 points. Nothing crashes: only measuring shows them.</a:t>
             </a:r>
             <a:endParaRPr lang="en-US" dirty="0"/>
           </a:p>
@@ -3778,7 +3778,7 @@
           <a:p>
             <a:r>
               <a:rPr lang="en-US" dirty="0"/>
-              <a:t>With this stronger model, we could finally test the painter rule of step one. To measure it fairly, we scored the same images twice with cross-validation, and changed only one thing: whether the model had seen other paintings by the same painter. On images by known painters: 83.7 percent when the painter was seen, 72.3 when not. 11 points of flattery. On the control group, the unknown painters, nothing changes. So the model partly recognises painters, and a random split would have given the director a score that is too good. Our split protects the result.</a:t>
+              <a:t>But a model this strong can also learn shortcuts, like recognising a painter's hand instead of a style. So we finally tested the painter rule of step one. To measure it fairly, we scored the same images twice with cross-validation, and changed only one thing: whether the model had seen other paintings by the same painter. On images by known painters: 83.7 percent when the painter was seen, 72.3 when not. 11 points of flattery. On the control group, the unknown painters, nothing changes. So the model partly recognises painters, and a random split would have given the director a score that is too good. Our split protects the result: we can trust the final test.</a:t>
             </a:r>
             <a:endParaRPr lang="en-US" dirty="0"/>
           </a:p>
@@ -3866,7 +3866,7 @@
           <a:p>
             <a:r>
               <a:rPr lang="en-US" dirty="0"/>
-              <a:t>Step five: the final test. We opened the 220 test paintings once, for every model, including classical models with no neural network, such as a random forest on hand-made colour and texture features. The pretrained models are at the top, from 83 to 88 percent. The random forest reaches 67, our MLP 41. Is the gap real? A paired bootstrap, 5 000 redraws of the same test paintings, gives our model a lead of 16.4 points over the random forest, between 9 and 24 points: it is not luck. One honest note: the fine-tuned model is first on the test, but it was second on validation. With about 220 images, a score moves by about 5 points by chance, so we keep the model we chose before the test.</a:t>
+              <a:t>Step five, the final test: the only time we opened the 220 test paintings, once, for every model, including classical models without any neural network. The pretrained models are at the top, from 83 to 88 percent. The best classical model, a random forest on hand-made colour and texture features, reaches 67; our MLP 41. Is the gap real? A paired bootstrap, 5 000 redraws of the same test paintings, gives our model a lead of 16.4 points over the random forest, between 9 and 24 points: it is not luck. One honest note: the fine-tuned model is first on the test, but it was second on validation. With about 220 images, a score moves by about 5 points by chance, so we keep the model we chose before the test.</a:t>
             </a:r>
             <a:endParaRPr lang="en-US" dirty="0"/>
           </a:p>

</xml_diff>

<commit_message>
Move the training doctor slide to the backups, show the ResNet monitoring and introduce the random forest in the talk
</commit_message>
<xml_diff>
--- a/docs/museum_guide_presentation.pptx
+++ b/docs/museum_guide_presentation.pptx
@@ -21,9 +21,10 @@
     <p:sldId id="269" r:id="rId15"/>
     <p:sldId id="270" r:id="rId16"/>
     <p:sldId id="271" r:id="rId17"/>
+    <p:sldId id="272" r:id="rId18"/>
   </p:sldIdLst>
   <p:notesMasterIdLst>
-    <p:notesMasterId r:id="rId18"/>
+    <p:notesMasterId r:id="rId19"/>
   </p:notesMasterIdLst>
   <p:sldSz cx="9144000" cy="5143500"/>
   <p:notesSz cx="5143500" cy="9144000"/>
@@ -122,33 +123,33 @@
   <p:extLst>
     <p:ext uri="{521415D9-36F7-43E2-AB2F-B90AF26B5E84}">
       <p14:sectionLst xmlns:p14="http://schemas.microsoft.com/office/powerpoint/2010/main">
-        <p14:section name="The question" id="{abc2e601-cdd7-73e2-30d3-4f1e9fc485f7}">
+        <p14:section name="The question" id="{b20822bd-4b7e-9d54-2d45-a42ce1e38732}">
           <p14:sldIdLst>
             <p14:sldId id="256"/>
             <p14:sldId id="257"/>
             <p14:sldId id="258"/>
           </p14:sldIdLst>
         </p14:section>
-        <p14:section name="Our MLP" id="{7700f104-19a8-0b88-afbb-964ed62fd467}">
+        <p14:section name="Our MLP" id="{a2e5074f-e075-7bc0-2528-d7e0499ab86e}">
           <p14:sldIdLst>
             <p14:sldId id="259"/>
             <p14:sldId id="260"/>
           </p14:sldIdLst>
         </p14:section>
-        <p14:section name="Pretrained ResNet" id="{ed918ee3-c848-9aa6-d324-5f8ca3711a36}">
+        <p14:section name="Pretrained ResNet" id="{cd4b0ac8-4f52-37cf-4f52-a7f54e7947c7}">
           <p14:sldIdLst>
             <p14:sldId id="261"/>
             <p14:sldId id="262"/>
           </p14:sldIdLst>
         </p14:section>
-        <p14:section name="The answer" id="{cd6c5b77-f55c-3ab6-1c17-c52a5d5db440}">
+        <p14:section name="The answer" id="{e1ba8499-c6b5-648f-2f8c-e6dc12754a4a}">
           <p14:sldIdLst>
             <p14:sldId id="263"/>
             <p14:sldId id="264"/>
             <p14:sldId id="265"/>
           </p14:sldIdLst>
         </p14:section>
-        <p14:section name="Backup" id="{c049815e-c09a-19bb-1ece-642a49b8084f}">
+        <p14:section name="Backup" id="{522e5cd0-c90c-c9e6-d84c-35587b3aa145}">
           <p14:sldIdLst>
             <p14:sldId id="266"/>
             <p14:sldId id="267"/>
@@ -156,6 +157,7 @@
             <p14:sldId id="269"/>
             <p14:sldId id="270"/>
             <p14:sldId id="271"/>
+            <p14:sldId id="272"/>
           </p14:sldIdLst>
         </p14:section>
       </p14:sectionLst>
@@ -2733,7 +2735,7 @@
           <a:p>
             <a:r>
               <a:rPr lang="en-US" dirty="0"/>
-              <a:t>If asked why we did not pick the fine-tuned model: the test set is used once to report, not to choose. Validation and test point in opposite directions, and their intervals overlap, so our data cannot separate the two variants.</a:t>
+              <a:t>If asked about the random forest: it is our best model without any neural network, the "classical model" of the director's question. A classical model cannot read raw pixels well, so we describe each painting with 102 hand-made numbers: its colours and the directions of its brush strokes. A random forest is 500 decision trees: each one learns from a random draw of the paintings and sees a random part of the numbers at each question, and they vote. Settings chosen on validation. On the test: 67.3 %, 16.4 points below the frozen ResNet18. The same logistic regression goes from 61.4 % on our numbers to 84.5 % on the ResNet features: the features matter more than the model on top.</a:t>
             </a:r>
             <a:endParaRPr lang="en-US" dirty="0"/>
           </a:p>
@@ -2821,7 +2823,7 @@
           <a:p>
             <a:r>
               <a:rPr lang="en-US" dirty="0"/>
-              <a:t>If asked how the work can be checked: everything runs again from the repository with two commands, and the final notebook re-trains every neural model and finds exactly the same validation scores.</a:t>
+              <a:t>If asked why we did not pick the fine-tuned model: the test set is used once to report, not to choose. Validation and test point in opposite directions, and their intervals overlap, so our data cannot separate the two variants.</a:t>
             </a:r>
             <a:endParaRPr lang="en-US" dirty="0"/>
           </a:p>
@@ -2909,7 +2911,7 @@
           <a:p>
             <a:r>
               <a:rPr lang="en-US" dirty="0"/>
-              <a:t>If asked about hyperparameters: all of them were chosen on the validation set (learning-rate sweep, 3 seeds per setting), and they are written once in src/museum_guide/recipes.py.</a:t>
+              <a:t>If asked how the work can be checked: everything runs again from the repository with two commands, and the final notebook re-trains every neural model and finds exactly the same validation scores.</a:t>
             </a:r>
             <a:endParaRPr lang="en-US" dirty="0"/>
           </a:p>
@@ -2997,7 +2999,7 @@
           <a:p>
             <a:r>
               <a:rPr lang="en-US" dirty="0"/>
-              <a:t>If asked whether our monitoring tools really detect problems: in notebook 04 we broke the MLP training four times on purpose, and each bug left its own signature. Two of them give the same loss stuck at ln 5; only the dead neurons or the gradient per layer tell them apart. For the ResNet, two silent bugs: forgetting model.eval() gives 12.8 %, forgetting the ImageNet normalisation 81.7 %.</a:t>
+              <a:t>If asked about hyperparameters: all of them were chosen on the validation set (learning-rate sweep, 3 seeds per setting), and they are written once in src/museum_guide/recipes.py.</a:t>
             </a:r>
             <a:endParaRPr lang="en-US" dirty="0"/>
           </a:p>
@@ -3085,7 +3087,7 @@
           <a:p>
             <a:r>
               <a:rPr lang="en-US" dirty="0"/>
-              <a:t>If asked about errors: the ResNet's main confusion is Cubism versus Pop Art, which share flat areas of strong colour and hard edges.</a:t>
+              <a:t>If asked whether our monitoring tools really detect problems: in notebook 04 we broke the MLP training four times on purpose, and each bug left its own signature. Two of them give the same loss stuck at ln 5; only the dead neurons or the gradient per layer tell them apart. For the ResNet, two silent bugs: forgetting model.eval() gives 12.8 %, forgetting the ImageNet normalisation 81.7 %.</a:t>
             </a:r>
             <a:endParaRPr lang="en-US" dirty="0"/>
           </a:p>
@@ -3173,7 +3175,7 @@
           <a:p>
             <a:r>
               <a:rPr lang="en-US" dirty="0"/>
-              <a:t>If asked about BERT or transformers: BERT reads text, so it cannot classify paintings alone. Its image cousin ViT gives the same accuracy as ResNet18 but is about 9 times slower. CLIP, trained on images with captions, reaches about 89 percent with no training at all and about 95 percent with our linear head, on validation. Two cautions: it probably saw WikiArt during its training, and we did not reopen the test set. It is our first next step, and it would also answer visitors' questions in words.</a:t>
+              <a:t>If asked about errors: the ResNet's main confusion is Cubism versus Pop Art, which share flat areas of strong colour and hard edges.</a:t>
             </a:r>
             <a:endParaRPr lang="en-US" dirty="0"/>
           </a:p>
@@ -3197,6 +3199,94 @@
             <a:fld id="{F7021451-1387-4CA6-816F-3879F97B5CBC}" type="slidenum">
               <a:rPr lang="en-US"/>
               <a:t>16</a:t>
+            </a:fld>
+            <a:endParaRPr lang="en-US"/>
+          </a:p>
+        </p:txBody>
+      </p:sp>
+    </p:spTree>
+    <p:extLst>
+      <p:ext uri="{BB962C8B-B14F-4D97-AF65-F5344CB8AC3E}">
+        <p14:creationId xmlns:p14="http://schemas.microsoft.com/office/powerpoint/2010/main" val="1024086991"/>
+      </p:ext>
+    </p:extLst>
+  </p:cSld>
+  <p:clrMapOvr>
+    <a:masterClrMapping/>
+  </p:clrMapOvr>
+</p:notes>
+</file>
+
+<file path=ppt/notesSlides/notesSlide17.xml><?xml version="1.0" encoding="utf-8"?>
+<p:notes xmlns:a="http://schemas.openxmlformats.org/drawingml/2006/main" xmlns:r="http://schemas.openxmlformats.org/officeDocument/2006/relationships" xmlns:p="http://schemas.openxmlformats.org/presentationml/2006/main">
+  <p:cSld>
+    <p:spTree>
+      <p:nvGrpSpPr>
+        <p:cNvPr id="1" name=""/>
+        <p:cNvGrpSpPr/>
+        <p:nvPr/>
+      </p:nvGrpSpPr>
+      <p:grpSpPr>
+        <a:xfrm>
+          <a:off x="0" y="0"/>
+          <a:ext cx="0" cy="0"/>
+          <a:chOff x="0" y="0"/>
+          <a:chExt cx="0" cy="0"/>
+        </a:xfrm>
+      </p:grpSpPr>
+      <p:sp>
+        <p:nvSpPr>
+          <p:cNvPr id="2" name="Slide Image Placeholder 1"/>
+          <p:cNvSpPr>
+            <a:spLocks noGrp="1" noRot="1" noChangeAspect="1"/>
+          </p:cNvSpPr>
+          <p:nvPr>
+            <p:ph type="sldImg"/>
+          </p:nvPr>
+        </p:nvSpPr>
+        <p:spPr/>
+      </p:sp>
+      <p:sp>
+        <p:nvSpPr>
+          <p:cNvPr id="3" name="Notes Placeholder 2"/>
+          <p:cNvSpPr>
+            <a:spLocks noGrp="1"/>
+          </p:cNvSpPr>
+          <p:nvPr>
+            <p:ph type="body" idx="1"/>
+          </p:nvPr>
+        </p:nvSpPr>
+        <p:spPr/>
+        <p:txBody>
+          <a:bodyPr/>
+          <a:lstStyle/>
+          <a:p>
+            <a:r>
+              <a:rPr lang="en-US" dirty="0"/>
+              <a:t>If asked about BERT or transformers: BERT reads text, so it cannot classify paintings alone. Its image cousin ViT gives the same accuracy as ResNet18 but is about 9 times slower. CLIP, trained on images with captions, reaches about 89 percent with no training at all and about 95 percent with our linear head, on validation. Two cautions: it probably saw WikiArt during its training, and we did not reopen the test set. It is our first next step, and it would also answer visitors' questions in words.</a:t>
+            </a:r>
+            <a:endParaRPr lang="en-US" dirty="0"/>
+          </a:p>
+        </p:txBody>
+      </p:sp>
+      <p:sp>
+        <p:nvSpPr>
+          <p:cNvPr id="4" name="Slide Number Placeholder 3"/>
+          <p:cNvSpPr>
+            <a:spLocks noGrp="1"/>
+          </p:cNvSpPr>
+          <p:nvPr>
+            <p:ph type="sldNum" sz="quarter" idx="10"/>
+          </p:nvPr>
+        </p:nvSpPr>
+        <p:spPr/>
+        <p:txBody>
+          <a:bodyPr/>
+          <a:lstStyle/>
+          <a:p>
+            <a:fld id="{F7021451-1387-4CA6-816F-3879F97B5CBC}" type="slidenum">
+              <a:rPr lang="en-US"/>
+              <a:t>17</a:t>
             </a:fld>
             <a:endParaRPr lang="en-US"/>
           </a:p>
@@ -3767,7 +3857,7 @@
             </a:pPr>
             <a:r>
               <a:rPr lang="en-US" b="1" dirty="0"/>
-              <a:t>TRANSITION: We saw that our split stops this cheating: we can trust our test. So now, step five: the final test of every model.</a:t>
+              <a:t>TRANSITION: We saw that our split stops this cheating: we can trust our test. But to answer the director, we also need a challenger without any neural network. So now, step five: the final test of every model.</a:t>
             </a:r>
             <a:endParaRPr lang="en-US" dirty="0"/>
           </a:p>
@@ -3855,7 +3945,7 @@
           <a:p>
             <a:r>
               <a:rPr lang="en-US" dirty="0"/>
-              <a:t>We opened the 220 test paintings only once, for every model, classical models included. The pretrained models are at the top, from 83 to 88 percent. The best classical model, a random forest on hand-made colour and texture features, reaches 67; our MLP 41. Is the gap real? A paired bootstrap on the same test paintings gives our model a lead of 16.4 points over the random forest, between 9 and 24 points: it is not luck. One honest note: the fine-tuned model is first on the test, but it was second on validation. With 220 images, a score moves by about 5 points by chance, so we keep the model chosen before the test.</a:t>
+              <a:t>Our classical challenger does not read pixels. We describe each painting with 102 hand-made numbers, its colours and the directions of its brush strokes, and train two classic models on them: a logistic regression, and a random forest, 500 small decision trees that vote. Then we opened the 220 test paintings, only once, for every model. The pretrained models are at the top, from 83 to 88 percent. The best classical model, the random forest, reaches 67; our MLP 41. Is the gap real? A paired bootstrap on the same test paintings gives our model a lead of 16.4 points over the random forest, between 9 and 24 points: it is not luck. One honest note: the fine-tuned model is first on the test, but it was second on validation. With 220 images, a score moves by about 5 points by chance, so we keep the model chosen before the test.</a:t>
             </a:r>
           </a:p>
           <a:p>
@@ -5962,6 +6052,724 @@
                   <a:schemeClr val="tx2"/>
                 </a:solidFill>
               </a:rPr>
+              <a:t>Backup: the random forest challenger</a:t>
+            </a:r>
+            <a:endParaRPr lang="en-US" sz="3000" dirty="0"/>
+          </a:p>
+        </p:txBody>
+      </p:sp>
+      <p:sp>
+        <p:nvSpPr>
+          <p:cNvPr id="3" name="note 102 hand-made numbers per painting"/>
+          <p:cNvSpPr/>
+          <p:nvPr/>
+        </p:nvSpPr>
+        <p:spPr>
+          <a:xfrm>
+            <a:off x="457200" y="1051560"/>
+            <a:ext cx="4023360" cy="1600200"/>
+          </a:xfrm>
+          <a:prstGeom prst="roundRect">
+            <a:avLst>
+              <a:gd name="adj" fmla="val 4571"/>
+            </a:avLst>
+          </a:prstGeom>
+          <a:solidFill>
+            <a:schemeClr val="bg2"/>
+          </a:solidFill>
+          <a:ln w="12700">
+            <a:solidFill>
+              <a:schemeClr val="bg2"/>
+            </a:solidFill>
+            <a:prstDash val="solid"/>
+          </a:ln>
+        </p:spPr>
+      </p:sp>
+      <p:sp>
+        <p:nvSpPr>
+          <p:cNvPr id="4" name="text 102 hand-made numbers per painting"/>
+          <p:cNvSpPr txBox="1"/>
+          <p:nvPr/>
+        </p:nvSpPr>
+        <p:spPr>
+          <a:xfrm>
+            <a:off x="621792" y="1161288"/>
+            <a:ext cx="3694176" cy="1380744"/>
+          </a:xfrm>
+          <a:prstGeom prst="rect">
+            <a:avLst/>
+          </a:prstGeom>
+          <a:noFill/>
+          <a:ln/>
+        </p:spPr>
+        <p:txBody>
+          <a:bodyPr wrap="square" lIns="0" tIns="0" rIns="0" bIns="0" rtlCol="0" anchor="t"/>
+          <a:lstStyle/>
+          <a:p>
+            <a:pPr indent="0" marL="0">
+              <a:spcAft>
+                <a:spcPts val="400"/>
+              </a:spcAft>
+              <a:buNone/>
+            </a:pPr>
+            <a:r>
+              <a:rPr lang="en-US" sz="1500" b="1" dirty="0">
+                <a:solidFill>
+                  <a:schemeClr val="tx2"/>
+                </a:solidFill>
+              </a:rPr>
+              <a:t>102 hand-made numbers per painting</a:t>
+            </a:r>
+            <a:endParaRPr lang="en-US" sz="1500" dirty="0"/>
+          </a:p>
+          <a:p>
+            <a:pPr indent="0" marL="0">
+              <a:spcAft>
+                <a:spcPts val="400"/>
+              </a:spcAft>
+              <a:buNone/>
+            </a:pPr>
+            <a:r>
+              <a:rPr lang="en-US" sz="1400" dirty="0">
+                <a:solidFill>
+                  <a:schemeClr val="tx1"/>
+                </a:solidFill>
+              </a:rPr>
+              <a:t>Colours: a histogram of hue, saturation and brightness (72) and colour statistics (10). Brush strokes: direction and strength of the edges, at two sizes (20).</a:t>
+            </a:r>
+            <a:endParaRPr lang="en-US" sz="1500" dirty="0"/>
+          </a:p>
+        </p:txBody>
+      </p:sp>
+      <p:sp>
+        <p:nvSpPr>
+          <p:cNvPr id="5" name="note 500 decision trees that vote"/>
+          <p:cNvSpPr/>
+          <p:nvPr/>
+        </p:nvSpPr>
+        <p:spPr>
+          <a:xfrm>
+            <a:off x="4663440" y="1051560"/>
+            <a:ext cx="4023360" cy="1600200"/>
+          </a:xfrm>
+          <a:prstGeom prst="roundRect">
+            <a:avLst>
+              <a:gd name="adj" fmla="val 4571"/>
+            </a:avLst>
+          </a:prstGeom>
+          <a:solidFill>
+            <a:schemeClr val="bg2"/>
+          </a:solidFill>
+          <a:ln w="12700">
+            <a:solidFill>
+              <a:schemeClr val="bg2"/>
+            </a:solidFill>
+            <a:prstDash val="solid"/>
+          </a:ln>
+        </p:spPr>
+      </p:sp>
+      <p:sp>
+        <p:nvSpPr>
+          <p:cNvPr id="6" name="text 500 decision trees that vote"/>
+          <p:cNvSpPr txBox="1"/>
+          <p:nvPr/>
+        </p:nvSpPr>
+        <p:spPr>
+          <a:xfrm>
+            <a:off x="4828032" y="1161288"/>
+            <a:ext cx="3694176" cy="1380744"/>
+          </a:xfrm>
+          <a:prstGeom prst="rect">
+            <a:avLst/>
+          </a:prstGeom>
+          <a:noFill/>
+          <a:ln/>
+        </p:spPr>
+        <p:txBody>
+          <a:bodyPr wrap="square" lIns="0" tIns="0" rIns="0" bIns="0" rtlCol="0" anchor="t"/>
+          <a:lstStyle/>
+          <a:p>
+            <a:pPr indent="0" marL="0">
+              <a:spcAft>
+                <a:spcPts val="400"/>
+              </a:spcAft>
+              <a:buNone/>
+            </a:pPr>
+            <a:r>
+              <a:rPr lang="en-US" sz="1500" b="1" dirty="0">
+                <a:solidFill>
+                  <a:schemeClr val="tx2"/>
+                </a:solidFill>
+              </a:rPr>
+              <a:t>500 decision trees that vote</a:t>
+            </a:r>
+            <a:endParaRPr lang="en-US" sz="1500" dirty="0"/>
+          </a:p>
+          <a:p>
+            <a:pPr indent="0" marL="0">
+              <a:spcAft>
+                <a:spcPts val="400"/>
+              </a:spcAft>
+              <a:buNone/>
+            </a:pPr>
+            <a:r>
+              <a:rPr lang="en-US" sz="1400" dirty="0">
+                <a:solidFill>
+                  <a:schemeClr val="tx1"/>
+                </a:solidFill>
+              </a:rPr>
+              <a:t>Each tree learns from a random draw of the training paintings and sees 10 of the 102 numbers at each question. Their mistakes differ, so the vote cancels them.</a:t>
+            </a:r>
+            <a:endParaRPr lang="en-US" sz="1500" dirty="0"/>
+          </a:p>
+        </p:txBody>
+      </p:sp>
+      <p:sp>
+        <p:nvSpPr>
+          <p:cNvPr id="7" name="card 32.7 %"/>
+          <p:cNvSpPr/>
+          <p:nvPr/>
+        </p:nvSpPr>
+        <p:spPr>
+          <a:xfrm>
+            <a:off x="457200" y="2834640"/>
+            <a:ext cx="1874520" cy="1463040"/>
+          </a:xfrm>
+          <a:prstGeom prst="roundRect">
+            <a:avLst>
+              <a:gd name="adj" fmla="val 5000"/>
+            </a:avLst>
+          </a:prstGeom>
+          <a:solidFill>
+            <a:schemeClr val="bg2"/>
+          </a:solidFill>
+          <a:ln w="12700">
+            <a:solidFill>
+              <a:schemeClr val="bg2"/>
+            </a:solidFill>
+            <a:prstDash val="solid"/>
+          </a:ln>
+        </p:spPr>
+      </p:sp>
+      <p:sp>
+        <p:nvSpPr>
+          <p:cNvPr id="8" name="value 32.7 %"/>
+          <p:cNvSpPr txBox="1"/>
+          <p:nvPr/>
+        </p:nvSpPr>
+        <p:spPr>
+          <a:xfrm>
+            <a:off x="640080" y="2971800"/>
+            <a:ext cx="1508760" cy="731520"/>
+          </a:xfrm>
+          <a:prstGeom prst="rect">
+            <a:avLst/>
+          </a:prstGeom>
+          <a:noFill/>
+          <a:ln/>
+        </p:spPr>
+        <p:txBody>
+          <a:bodyPr wrap="square" lIns="0" tIns="0" rIns="0" bIns="0" rtlCol="0" anchor="ctr"/>
+          <a:lstStyle/>
+          <a:p>
+            <a:pPr indent="0" marL="0">
+              <a:buNone/>
+            </a:pPr>
+            <a:r>
+              <a:rPr lang="en-US" sz="3000" b="1" dirty="0">
+                <a:solidFill>
+                  <a:schemeClr val="tx2"/>
+                </a:solidFill>
+                <a:latin typeface="Cambria" pitchFamily="34" charset="0"/>
+                <a:ea typeface="Cambria" pitchFamily="34" charset="-122"/>
+                <a:cs typeface="Cambria" pitchFamily="34" charset="-120"/>
+              </a:rPr>
+              <a:t>32.7 %</a:t>
+            </a:r>
+            <a:endParaRPr lang="en-US" sz="3000" dirty="0"/>
+          </a:p>
+        </p:txBody>
+      </p:sp>
+      <p:sp>
+        <p:nvSpPr>
+          <p:cNvPr id="9" name="caption 32.7 %"/>
+          <p:cNvSpPr txBox="1"/>
+          <p:nvPr/>
+        </p:nvSpPr>
+        <p:spPr>
+          <a:xfrm>
+            <a:off x="640080" y="3749040"/>
+            <a:ext cx="1508760" cy="411480"/>
+          </a:xfrm>
+          <a:prstGeom prst="rect">
+            <a:avLst/>
+          </a:prstGeom>
+          <a:noFill/>
+          <a:ln/>
+        </p:spPr>
+        <p:txBody>
+          <a:bodyPr wrap="square" lIns="0" tIns="0" rIns="0" bIns="0" rtlCol="0" anchor="t"/>
+          <a:lstStyle/>
+          <a:p>
+            <a:pPr indent="0" marL="0">
+              <a:buNone/>
+            </a:pPr>
+            <a:r>
+              <a:rPr lang="en-US" sz="1200" dirty="0">
+                <a:solidFill>
+                  <a:schemeClr val="tx1"/>
+                </a:solidFill>
+              </a:rPr>
+              <a:t>Logistic regression on pixels</a:t>
+            </a:r>
+            <a:endParaRPr lang="en-US" sz="1200" dirty="0"/>
+          </a:p>
+        </p:txBody>
+      </p:sp>
+      <p:sp>
+        <p:nvSpPr>
+          <p:cNvPr id="10" name="card 61.4 %"/>
+          <p:cNvSpPr/>
+          <p:nvPr/>
+        </p:nvSpPr>
+        <p:spPr>
+          <a:xfrm>
+            <a:off x="2575590" y="2834640"/>
+            <a:ext cx="1874520" cy="1463040"/>
+          </a:xfrm>
+          <a:prstGeom prst="roundRect">
+            <a:avLst>
+              <a:gd name="adj" fmla="val 5000"/>
+            </a:avLst>
+          </a:prstGeom>
+          <a:solidFill>
+            <a:schemeClr val="bg2"/>
+          </a:solidFill>
+          <a:ln w="12700">
+            <a:solidFill>
+              <a:schemeClr val="bg2"/>
+            </a:solidFill>
+            <a:prstDash val="solid"/>
+          </a:ln>
+        </p:spPr>
+      </p:sp>
+      <p:sp>
+        <p:nvSpPr>
+          <p:cNvPr id="11" name="value 61.4 %"/>
+          <p:cNvSpPr txBox="1"/>
+          <p:nvPr/>
+        </p:nvSpPr>
+        <p:spPr>
+          <a:xfrm>
+            <a:off x="2758470" y="2971800"/>
+            <a:ext cx="1508760" cy="731520"/>
+          </a:xfrm>
+          <a:prstGeom prst="rect">
+            <a:avLst/>
+          </a:prstGeom>
+          <a:noFill/>
+          <a:ln/>
+        </p:spPr>
+        <p:txBody>
+          <a:bodyPr wrap="square" lIns="0" tIns="0" rIns="0" bIns="0" rtlCol="0" anchor="ctr"/>
+          <a:lstStyle/>
+          <a:p>
+            <a:pPr indent="0" marL="0">
+              <a:buNone/>
+            </a:pPr>
+            <a:r>
+              <a:rPr lang="en-US" sz="3000" b="1" dirty="0">
+                <a:solidFill>
+                  <a:schemeClr val="tx2"/>
+                </a:solidFill>
+                <a:latin typeface="Cambria" pitchFamily="34" charset="0"/>
+                <a:ea typeface="Cambria" pitchFamily="34" charset="-122"/>
+                <a:cs typeface="Cambria" pitchFamily="34" charset="-120"/>
+              </a:rPr>
+              <a:t>61.4 %</a:t>
+            </a:r>
+            <a:endParaRPr lang="en-US" sz="3000" dirty="0"/>
+          </a:p>
+        </p:txBody>
+      </p:sp>
+      <p:sp>
+        <p:nvSpPr>
+          <p:cNvPr id="12" name="caption 61.4 %"/>
+          <p:cNvSpPr txBox="1"/>
+          <p:nvPr/>
+        </p:nvSpPr>
+        <p:spPr>
+          <a:xfrm>
+            <a:off x="2758470" y="3749040"/>
+            <a:ext cx="1508760" cy="411480"/>
+          </a:xfrm>
+          <a:prstGeom prst="rect">
+            <a:avLst/>
+          </a:prstGeom>
+          <a:noFill/>
+          <a:ln/>
+        </p:spPr>
+        <p:txBody>
+          <a:bodyPr wrap="square" lIns="0" tIns="0" rIns="0" bIns="0" rtlCol="0" anchor="t"/>
+          <a:lstStyle/>
+          <a:p>
+            <a:pPr indent="0" marL="0">
+              <a:buNone/>
+            </a:pPr>
+            <a:r>
+              <a:rPr lang="en-US" sz="1200" dirty="0">
+                <a:solidFill>
+                  <a:schemeClr val="tx1"/>
+                </a:solidFill>
+              </a:rPr>
+              <a:t>Logistic regression on the 102 numbers</a:t>
+            </a:r>
+            <a:endParaRPr lang="en-US" sz="1200" dirty="0"/>
+          </a:p>
+        </p:txBody>
+      </p:sp>
+      <p:sp>
+        <p:nvSpPr>
+          <p:cNvPr id="13" name="card 67.3 %"/>
+          <p:cNvSpPr/>
+          <p:nvPr/>
+        </p:nvSpPr>
+        <p:spPr>
+          <a:xfrm>
+            <a:off x="4693981" y="2834640"/>
+            <a:ext cx="1874520" cy="1463040"/>
+          </a:xfrm>
+          <a:prstGeom prst="roundRect">
+            <a:avLst>
+              <a:gd name="adj" fmla="val 5000"/>
+            </a:avLst>
+          </a:prstGeom>
+          <a:solidFill>
+            <a:schemeClr val="bg2"/>
+          </a:solidFill>
+          <a:ln w="12700">
+            <a:solidFill>
+              <a:schemeClr val="bg2"/>
+            </a:solidFill>
+            <a:prstDash val="solid"/>
+          </a:ln>
+        </p:spPr>
+      </p:sp>
+      <p:sp>
+        <p:nvSpPr>
+          <p:cNvPr id="14" name="value 67.3 %"/>
+          <p:cNvSpPr txBox="1"/>
+          <p:nvPr/>
+        </p:nvSpPr>
+        <p:spPr>
+          <a:xfrm>
+            <a:off x="4876861" y="2971800"/>
+            <a:ext cx="1508760" cy="731520"/>
+          </a:xfrm>
+          <a:prstGeom prst="rect">
+            <a:avLst/>
+          </a:prstGeom>
+          <a:noFill/>
+          <a:ln/>
+        </p:spPr>
+        <p:txBody>
+          <a:bodyPr wrap="square" lIns="0" tIns="0" rIns="0" bIns="0" rtlCol="0" anchor="ctr"/>
+          <a:lstStyle/>
+          <a:p>
+            <a:pPr indent="0" marL="0">
+              <a:buNone/>
+            </a:pPr>
+            <a:r>
+              <a:rPr lang="en-US" sz="3000" b="1" dirty="0">
+                <a:solidFill>
+                  <a:srgbClr val="EB6834"/>
+                </a:solidFill>
+                <a:latin typeface="Cambria" pitchFamily="34" charset="0"/>
+                <a:ea typeface="Cambria" pitchFamily="34" charset="-122"/>
+                <a:cs typeface="Cambria" pitchFamily="34" charset="-120"/>
+              </a:rPr>
+              <a:t>67.3 %</a:t>
+            </a:r>
+            <a:endParaRPr lang="en-US" sz="3000" dirty="0"/>
+          </a:p>
+        </p:txBody>
+      </p:sp>
+      <p:sp>
+        <p:nvSpPr>
+          <p:cNvPr id="15" name="caption 67.3 %"/>
+          <p:cNvSpPr txBox="1"/>
+          <p:nvPr/>
+        </p:nvSpPr>
+        <p:spPr>
+          <a:xfrm>
+            <a:off x="4876861" y="3749040"/>
+            <a:ext cx="1508760" cy="411480"/>
+          </a:xfrm>
+          <a:prstGeom prst="rect">
+            <a:avLst/>
+          </a:prstGeom>
+          <a:noFill/>
+          <a:ln/>
+        </p:spPr>
+        <p:txBody>
+          <a:bodyPr wrap="square" lIns="0" tIns="0" rIns="0" bIns="0" rtlCol="0" anchor="t"/>
+          <a:lstStyle/>
+          <a:p>
+            <a:pPr indent="0" marL="0">
+              <a:buNone/>
+            </a:pPr>
+            <a:r>
+              <a:rPr lang="en-US" sz="1200" dirty="0">
+                <a:solidFill>
+                  <a:schemeClr val="tx1"/>
+                </a:solidFill>
+              </a:rPr>
+              <a:t>Random forest on the 102 numbers</a:t>
+            </a:r>
+            <a:endParaRPr lang="en-US" sz="1200" dirty="0"/>
+          </a:p>
+        </p:txBody>
+      </p:sp>
+      <p:sp>
+        <p:nvSpPr>
+          <p:cNvPr id="16" name="card 83.0 %"/>
+          <p:cNvSpPr/>
+          <p:nvPr/>
+        </p:nvSpPr>
+        <p:spPr>
+          <a:xfrm>
+            <a:off x="6812371" y="2834640"/>
+            <a:ext cx="1874520" cy="1463040"/>
+          </a:xfrm>
+          <a:prstGeom prst="roundRect">
+            <a:avLst>
+              <a:gd name="adj" fmla="val 5000"/>
+            </a:avLst>
+          </a:prstGeom>
+          <a:solidFill>
+            <a:schemeClr val="accent1"/>
+          </a:solidFill>
+          <a:ln w="12700">
+            <a:solidFill>
+              <a:schemeClr val="accent1"/>
+            </a:solidFill>
+            <a:prstDash val="solid"/>
+          </a:ln>
+        </p:spPr>
+      </p:sp>
+      <p:sp>
+        <p:nvSpPr>
+          <p:cNvPr id="17" name="value 83.0 %"/>
+          <p:cNvSpPr txBox="1"/>
+          <p:nvPr/>
+        </p:nvSpPr>
+        <p:spPr>
+          <a:xfrm>
+            <a:off x="6995251" y="2971800"/>
+            <a:ext cx="1508760" cy="731520"/>
+          </a:xfrm>
+          <a:prstGeom prst="rect">
+            <a:avLst/>
+          </a:prstGeom>
+          <a:noFill/>
+          <a:ln/>
+        </p:spPr>
+        <p:txBody>
+          <a:bodyPr wrap="square" lIns="0" tIns="0" rIns="0" bIns="0" rtlCol="0" anchor="ctr"/>
+          <a:lstStyle/>
+          <a:p>
+            <a:pPr indent="0" marL="0">
+              <a:buNone/>
+            </a:pPr>
+            <a:r>
+              <a:rPr lang="en-US" sz="3000" b="1" dirty="0">
+                <a:solidFill>
+                  <a:schemeClr val="bg1"/>
+                </a:solidFill>
+                <a:latin typeface="Cambria" pitchFamily="34" charset="0"/>
+                <a:ea typeface="Cambria" pitchFamily="34" charset="-122"/>
+                <a:cs typeface="Cambria" pitchFamily="34" charset="-120"/>
+              </a:rPr>
+              <a:t>83.0 %</a:t>
+            </a:r>
+            <a:endParaRPr lang="en-US" sz="3000" dirty="0"/>
+          </a:p>
+        </p:txBody>
+      </p:sp>
+      <p:sp>
+        <p:nvSpPr>
+          <p:cNvPr id="18" name="caption 83.0 %"/>
+          <p:cNvSpPr txBox="1"/>
+          <p:nvPr/>
+        </p:nvSpPr>
+        <p:spPr>
+          <a:xfrm>
+            <a:off x="6995251" y="3749040"/>
+            <a:ext cx="1508760" cy="411480"/>
+          </a:xfrm>
+          <a:prstGeom prst="rect">
+            <a:avLst/>
+          </a:prstGeom>
+          <a:noFill/>
+          <a:ln/>
+        </p:spPr>
+        <p:txBody>
+          <a:bodyPr wrap="square" lIns="0" tIns="0" rIns="0" bIns="0" rtlCol="0" anchor="t"/>
+          <a:lstStyle/>
+          <a:p>
+            <a:pPr indent="0" marL="0">
+              <a:buNone/>
+            </a:pPr>
+            <a:r>
+              <a:rPr lang="en-US" sz="1200" dirty="0">
+                <a:solidFill>
+                  <a:schemeClr val="bg1"/>
+                </a:solidFill>
+              </a:rPr>
+              <a:t>ResNet18 frozen + linear head (ours)</a:t>
+            </a:r>
+            <a:endParaRPr lang="en-US" sz="1200" dirty="0"/>
+          </a:p>
+        </p:txBody>
+      </p:sp>
+      <p:sp>
+        <p:nvSpPr>
+          <p:cNvPr id="19" name="forest caption"/>
+          <p:cNvSpPr txBox="1"/>
+          <p:nvPr/>
+        </p:nvSpPr>
+        <p:spPr>
+          <a:xfrm>
+            <a:off x="457200" y="4370832"/>
+            <a:ext cx="8229600" cy="320040"/>
+          </a:xfrm>
+          <a:prstGeom prst="rect">
+            <a:avLst/>
+          </a:prstGeom>
+          <a:noFill/>
+          <a:ln/>
+        </p:spPr>
+        <p:txBody>
+          <a:bodyPr wrap="square" lIns="0" tIns="0" rIns="0" bIns="0" rtlCol="0" anchor="t"/>
+          <a:lstStyle/>
+          <a:p>
+            <a:pPr indent="0" marL="0">
+              <a:buNone/>
+            </a:pPr>
+            <a:r>
+              <a:rPr lang="en-US" sz="1200" dirty="0">
+                <a:solidFill>
+                  <a:srgbClr val="5F6473"/>
+                </a:solidFill>
+              </a:rPr>
+              <a:t>Test accuracy, 220 paintings. Best of 4 settings on validation: 63.5 %. Training 1 s, 24 ms per photo, 26 MB.</a:t>
+            </a:r>
+            <a:endParaRPr lang="en-US" sz="1200" dirty="0"/>
+          </a:p>
+        </p:txBody>
+      </p:sp>
+      <p:sp>
+        <p:nvSpPr>
+          <p:cNvPr id="25" name="Slide Number Placeholder 0"/>
+          <p:cNvSpPr>
+            <a:spLocks noGrp="1"/>
+          </p:cNvSpPr>
+          <p:nvPr>
+            <p:ph type="sldNum" sz="quarter" idx="4294967295"/>
+          </p:nvPr>
+        </p:nvSpPr>
+        <p:spPr>
+          <a:xfrm>
+            <a:off x="8229600" y="4754880"/>
+            <a:ext cx="457200" cy="274320"/>
+          </a:xfrm>
+          <a:prstGeom prst="rect">
+            <a:avLst/>
+          </a:prstGeom>
+          <a:extLst>
+            <a:ext uri="{C572A759-6A51-4108-AA02-DFA0A04FC94B}">
+              <ma14:wrappingTextBoxFlag xmlns:ma14="http://schemas.microsoft.com/office/mac/drawingml/2011/main" val="0"/>
+            </a:ext>
+          </a:extLst>
+        </p:spPr>
+        <p:txBody>
+          <a:bodyPr/>
+          <a:lstStyle>
+            <a:lvl1pPr>
+              <a:defRPr sz="1000">
+                <a:solidFill>
+                  <a:srgbClr val="5F6473"/>
+                </a:solidFill>
+              </a:defRPr>
+            </a:lvl1pPr>
+          </a:lstStyle>
+          <a:p>
+            <a:pPr algn="r"/>
+            <a:fld id="{F7021451-1387-4CA6-816F-3879F97B5CBC}" type="slidenum">
+              <a:rPr b="0" lang="en-US"/>
+              <a:t>11</a:t>
+            </a:fld>
+            <a:endParaRPr lang="en-US"/>
+          </a:p>
+        </p:txBody>
+      </p:sp>
+    </p:spTree>
+  </p:cSld>
+  <p:clrMapOvr>
+    <a:masterClrMapping/>
+  </p:clrMapOvr>
+</p:sld>
+</file>
+
+<file path=ppt/slides/slide12.xml><?xml version="1.0" encoding="utf-8"?>
+<p:sld xmlns:a="http://schemas.openxmlformats.org/drawingml/2006/main" xmlns:r="http://schemas.openxmlformats.org/officeDocument/2006/relationships" xmlns:p="http://schemas.openxmlformats.org/presentationml/2006/main">
+  <p:cSld name="Slide 12">
+    <p:spTree>
+      <p:nvGrpSpPr>
+        <p:cNvPr id="1" name=""/>
+        <p:cNvGrpSpPr/>
+        <p:nvPr/>
+      </p:nvGrpSpPr>
+      <p:grpSpPr>
+        <a:xfrm>
+          <a:off x="0" y="0"/>
+          <a:ext cx="0" cy="0"/>
+          <a:chOff x="0" y="0"/>
+          <a:chExt cx="0" cy="0"/>
+        </a:xfrm>
+      </p:grpSpPr>
+      <p:sp>
+        <p:nvSpPr>
+          <p:cNvPr id="2" name="Text 0"/>
+          <p:cNvSpPr/>
+          <p:nvPr>
+            <p:ph idx="100" type="title" hasCustomPrompt="1"/>
+          </p:nvPr>
+        </p:nvSpPr>
+        <p:spPr>
+          <a:xfrm>
+            <a:off x="457200" y="274320"/>
+            <a:ext cx="8229600" cy="640080"/>
+          </a:xfrm>
+          <a:prstGeom prst="rect">
+            <a:avLst/>
+          </a:prstGeom>
+          <a:noFill/>
+          <a:ln/>
+        </p:spPr>
+        <p:txBody>
+          <a:bodyPr wrap="square" lIns="0" tIns="0" rIns="0" bIns="0" rtlCol="0" anchor="ctr"/>
+          <a:lstStyle/>
+          <a:p>
+            <a:pPr indent="0" marL="0">
+              <a:buNone/>
+            </a:pPr>
+            <a:r>
+              <a:rPr lang="en-US" sz="3000" b="1" dirty="0">
+                <a:solidFill>
+                  <a:schemeClr val="tx2"/>
+                </a:solidFill>
+              </a:rPr>
               <a:t>Backup: validation and test disagree</a:t>
             </a:r>
             <a:endParaRPr lang="en-US" sz="3000" dirty="0"/>
@@ -5970,7 +6778,7 @@
       </p:sp>
       <p:graphicFrame>
         <p:nvGraphicFramePr>
-          <p:cNvPr id="12" name="disagreement table"/>
+          <p:cNvPr id="13" name="disagreement table"/>
           <p:cNvGraphicFramePr>
             <a:graphicFrameLocks noGrp="1"/>
           </p:cNvGraphicFramePr>
@@ -6829,446 +7637,6 @@
             <a:pPr algn="r"/>
             <a:fld id="{F7021451-1387-4CA6-816F-3879F97B5CBC}" type="slidenum">
               <a:rPr b="0" lang="en-US"/>
-              <a:t>11</a:t>
-            </a:fld>
-            <a:endParaRPr lang="en-US"/>
-          </a:p>
-        </p:txBody>
-      </p:sp>
-    </p:spTree>
-  </p:cSld>
-  <p:clrMapOvr>
-    <a:masterClrMapping/>
-  </p:clrMapOvr>
-</p:sld>
-</file>
-
-<file path=ppt/slides/slide12.xml><?xml version="1.0" encoding="utf-8"?>
-<p:sld xmlns:a="http://schemas.openxmlformats.org/drawingml/2006/main" xmlns:r="http://schemas.openxmlformats.org/officeDocument/2006/relationships" xmlns:p="http://schemas.openxmlformats.org/presentationml/2006/main">
-  <p:cSld name="Slide 12">
-    <p:spTree>
-      <p:nvGrpSpPr>
-        <p:cNvPr id="1" name=""/>
-        <p:cNvGrpSpPr/>
-        <p:nvPr/>
-      </p:nvGrpSpPr>
-      <p:grpSpPr>
-        <a:xfrm>
-          <a:off x="0" y="0"/>
-          <a:ext cx="0" cy="0"/>
-          <a:chOff x="0" y="0"/>
-          <a:chExt cx="0" cy="0"/>
-        </a:xfrm>
-      </p:grpSpPr>
-      <p:sp>
-        <p:nvSpPr>
-          <p:cNvPr id="2" name="Text 0"/>
-          <p:cNvSpPr/>
-          <p:nvPr>
-            <p:ph idx="100" type="title" hasCustomPrompt="1"/>
-          </p:nvPr>
-        </p:nvSpPr>
-        <p:spPr>
-          <a:xfrm>
-            <a:off x="457200" y="274320"/>
-            <a:ext cx="8229600" cy="640080"/>
-          </a:xfrm>
-          <a:prstGeom prst="rect">
-            <a:avLst/>
-          </a:prstGeom>
-          <a:noFill/>
-          <a:ln/>
-        </p:spPr>
-        <p:txBody>
-          <a:bodyPr wrap="square" lIns="0" tIns="0" rIns="0" bIns="0" rtlCol="0" anchor="ctr"/>
-          <a:lstStyle/>
-          <a:p>
-            <a:pPr indent="0" marL="0">
-              <a:buNone/>
-            </a:pPr>
-            <a:r>
-              <a:rPr lang="en-US" sz="3000" b="1" dirty="0">
-                <a:solidFill>
-                  <a:schemeClr val="tx2"/>
-                </a:solidFill>
-              </a:rPr>
-              <a:t>Backup: why you can trust the numbers</a:t>
-            </a:r>
-            <a:endParaRPr lang="en-US" sz="3000" dirty="0"/>
-          </a:p>
-        </p:txBody>
-      </p:sp>
-      <p:sp>
-        <p:nvSpPr>
-          <p:cNvPr id="3" name="note Reproducible"/>
-          <p:cNvSpPr/>
-          <p:nvPr/>
-        </p:nvSpPr>
-        <p:spPr>
-          <a:xfrm>
-            <a:off x="457200" y="1097280"/>
-            <a:ext cx="4023360" cy="1600200"/>
-          </a:xfrm>
-          <a:prstGeom prst="roundRect">
-            <a:avLst>
-              <a:gd name="adj" fmla="val 4571"/>
-            </a:avLst>
-          </a:prstGeom>
-          <a:solidFill>
-            <a:schemeClr val="bg2"/>
-          </a:solidFill>
-          <a:ln w="12700">
-            <a:solidFill>
-              <a:schemeClr val="bg2"/>
-            </a:solidFill>
-            <a:prstDash val="solid"/>
-          </a:ln>
-        </p:spPr>
-      </p:sp>
-      <p:sp>
-        <p:nvSpPr>
-          <p:cNvPr id="4" name="text Reproducible"/>
-          <p:cNvSpPr txBox="1"/>
-          <p:nvPr/>
-        </p:nvSpPr>
-        <p:spPr>
-          <a:xfrm>
-            <a:off x="621792" y="1207008"/>
-            <a:ext cx="3694176" cy="1380744"/>
-          </a:xfrm>
-          <a:prstGeom prst="rect">
-            <a:avLst/>
-          </a:prstGeom>
-          <a:noFill/>
-          <a:ln/>
-        </p:spPr>
-        <p:txBody>
-          <a:bodyPr wrap="square" lIns="0" tIns="0" rIns="0" bIns="0" rtlCol="0" anchor="t"/>
-          <a:lstStyle/>
-          <a:p>
-            <a:pPr indent="0" marL="0">
-              <a:spcAft>
-                <a:spcPts val="400"/>
-              </a:spcAft>
-              <a:buNone/>
-            </a:pPr>
-            <a:r>
-              <a:rPr lang="en-US" sz="1500" b="1" dirty="0">
-                <a:solidFill>
-                  <a:schemeClr val="tx2"/>
-                </a:solidFill>
-              </a:rPr>
-              <a:t>Reproducible</a:t>
-            </a:r>
-            <a:endParaRPr lang="en-US" sz="1500" dirty="0"/>
-          </a:p>
-          <a:p>
-            <a:pPr indent="0" marL="0">
-              <a:spcAft>
-                <a:spcPts val="400"/>
-              </a:spcAft>
-              <a:buNone/>
-            </a:pPr>
-            <a:r>
-              <a:rPr lang="en-US" sz="1400" dirty="0">
-                <a:solidFill>
-                  <a:schemeClr val="tx1"/>
-                </a:solidFill>
-              </a:rPr>
-              <a:t>Fixed seeds and a pinned dataset revision. Notebook 06 trains the 9 neural models again and gets the same validation scores, to 4 decimals.</a:t>
-            </a:r>
-            <a:endParaRPr lang="en-US" sz="1500" dirty="0"/>
-          </a:p>
-        </p:txBody>
-      </p:sp>
-      <p:sp>
-        <p:nvSpPr>
-          <p:cNvPr id="5" name="note Tested"/>
-          <p:cNvSpPr/>
-          <p:nvPr/>
-        </p:nvSpPr>
-        <p:spPr>
-          <a:xfrm>
-            <a:off x="4663440" y="1097280"/>
-            <a:ext cx="4023360" cy="1600200"/>
-          </a:xfrm>
-          <a:prstGeom prst="roundRect">
-            <a:avLst>
-              <a:gd name="adj" fmla="val 4571"/>
-            </a:avLst>
-          </a:prstGeom>
-          <a:solidFill>
-            <a:schemeClr val="bg2"/>
-          </a:solidFill>
-          <a:ln w="12700">
-            <a:solidFill>
-              <a:schemeClr val="bg2"/>
-            </a:solidFill>
-            <a:prstDash val="solid"/>
-          </a:ln>
-        </p:spPr>
-      </p:sp>
-      <p:sp>
-        <p:nvSpPr>
-          <p:cNvPr id="6" name="text Tested"/>
-          <p:cNvSpPr txBox="1"/>
-          <p:nvPr/>
-        </p:nvSpPr>
-        <p:spPr>
-          <a:xfrm>
-            <a:off x="4828032" y="1207008"/>
-            <a:ext cx="3694176" cy="1380744"/>
-          </a:xfrm>
-          <a:prstGeom prst="rect">
-            <a:avLst/>
-          </a:prstGeom>
-          <a:noFill/>
-          <a:ln/>
-        </p:spPr>
-        <p:txBody>
-          <a:bodyPr wrap="square" lIns="0" tIns="0" rIns="0" bIns="0" rtlCol="0" anchor="t"/>
-          <a:lstStyle/>
-          <a:p>
-            <a:pPr indent="0" marL="0">
-              <a:spcAft>
-                <a:spcPts val="400"/>
-              </a:spcAft>
-              <a:buNone/>
-            </a:pPr>
-            <a:r>
-              <a:rPr lang="en-US" sz="1500" b="1" dirty="0">
-                <a:solidFill>
-                  <a:schemeClr val="tx2"/>
-                </a:solidFill>
-              </a:rPr>
-              <a:t>Tested</a:t>
-            </a:r>
-            <a:endParaRPr lang="en-US" sz="1500" dirty="0"/>
-          </a:p>
-          <a:p>
-            <a:pPr indent="0" marL="0">
-              <a:spcAft>
-                <a:spcPts val="400"/>
-              </a:spcAft>
-              <a:buNone/>
-            </a:pPr>
-            <a:r>
-              <a:rPr lang="en-US" sz="1400" dirty="0">
-                <a:solidFill>
-                  <a:schemeClr val="tx1"/>
-                </a:solidFill>
-              </a:rPr>
-              <a:t>33 automatic tests: split without painter leakage, parameter counts, training loop, metrics, benchmark helpers.</a:t>
-            </a:r>
-            <a:endParaRPr lang="en-US" sz="1500" dirty="0"/>
-          </a:p>
-        </p:txBody>
-      </p:sp>
-      <p:sp>
-        <p:nvSpPr>
-          <p:cNvPr id="7" name="note Versioned"/>
-          <p:cNvSpPr/>
-          <p:nvPr/>
-        </p:nvSpPr>
-        <p:spPr>
-          <a:xfrm>
-            <a:off x="457200" y="2880360"/>
-            <a:ext cx="4023360" cy="1600200"/>
-          </a:xfrm>
-          <a:prstGeom prst="roundRect">
-            <a:avLst>
-              <a:gd name="adj" fmla="val 4571"/>
-            </a:avLst>
-          </a:prstGeom>
-          <a:solidFill>
-            <a:schemeClr val="bg2"/>
-          </a:solidFill>
-          <a:ln w="12700">
-            <a:solidFill>
-              <a:schemeClr val="bg2"/>
-            </a:solidFill>
-            <a:prstDash val="solid"/>
-          </a:ln>
-        </p:spPr>
-      </p:sp>
-      <p:sp>
-        <p:nvSpPr>
-          <p:cNvPr id="8" name="text Versioned"/>
-          <p:cNvSpPr txBox="1"/>
-          <p:nvPr/>
-        </p:nvSpPr>
-        <p:spPr>
-          <a:xfrm>
-            <a:off x="621792" y="2990088"/>
-            <a:ext cx="3694176" cy="1380744"/>
-          </a:xfrm>
-          <a:prstGeom prst="rect">
-            <a:avLst/>
-          </a:prstGeom>
-          <a:noFill/>
-          <a:ln/>
-        </p:spPr>
-        <p:txBody>
-          <a:bodyPr wrap="square" lIns="0" tIns="0" rIns="0" bIns="0" rtlCol="0" anchor="t"/>
-          <a:lstStyle/>
-          <a:p>
-            <a:pPr indent="0" marL="0">
-              <a:spcAft>
-                <a:spcPts val="400"/>
-              </a:spcAft>
-              <a:buNone/>
-            </a:pPr>
-            <a:r>
-              <a:rPr lang="en-US" sz="1500" b="1" dirty="0">
-                <a:solidFill>
-                  <a:schemeClr val="tx2"/>
-                </a:solidFill>
-              </a:rPr>
-              <a:t>Versioned</a:t>
-            </a:r>
-            <a:endParaRPr lang="en-US" sz="1500" dirty="0"/>
-          </a:p>
-          <a:p>
-            <a:pPr indent="0" marL="0">
-              <a:spcAft>
-                <a:spcPts val="400"/>
-              </a:spcAft>
-              <a:buNone/>
-            </a:pPr>
-            <a:r>
-              <a:rPr lang="en-US" sz="1400" dirty="0">
-                <a:solidFill>
-                  <a:schemeClr val="tx1"/>
-                </a:solidFill>
-              </a:rPr>
-              <a:t>Small commits, one step at a time, on GitHub; milestone tags m1, m2, m3 and v1.0. Every number is saved in reports/results/*.json.</a:t>
-            </a:r>
-            <a:endParaRPr lang="en-US" sz="1500" dirty="0"/>
-          </a:p>
-        </p:txBody>
-      </p:sp>
-      <p:sp>
-        <p:nvSpPr>
-          <p:cNvPr id="9" name="note Honest"/>
-          <p:cNvSpPr/>
-          <p:nvPr/>
-        </p:nvSpPr>
-        <p:spPr>
-          <a:xfrm>
-            <a:off x="4663440" y="2880360"/>
-            <a:ext cx="4023360" cy="1600200"/>
-          </a:xfrm>
-          <a:prstGeom prst="roundRect">
-            <a:avLst>
-              <a:gd name="adj" fmla="val 4571"/>
-            </a:avLst>
-          </a:prstGeom>
-          <a:solidFill>
-            <a:schemeClr val="bg2"/>
-          </a:solidFill>
-          <a:ln w="12700">
-            <a:solidFill>
-              <a:schemeClr val="bg2"/>
-            </a:solidFill>
-            <a:prstDash val="solid"/>
-          </a:ln>
-        </p:spPr>
-      </p:sp>
-      <p:sp>
-        <p:nvSpPr>
-          <p:cNvPr id="10" name="text Honest"/>
-          <p:cNvSpPr txBox="1"/>
-          <p:nvPr/>
-        </p:nvSpPr>
-        <p:spPr>
-          <a:xfrm>
-            <a:off x="4828032" y="2990088"/>
-            <a:ext cx="3694176" cy="1380744"/>
-          </a:xfrm>
-          <a:prstGeom prst="rect">
-            <a:avLst/>
-          </a:prstGeom>
-          <a:noFill/>
-          <a:ln/>
-        </p:spPr>
-        <p:txBody>
-          <a:bodyPr wrap="square" lIns="0" tIns="0" rIns="0" bIns="0" rtlCol="0" anchor="t"/>
-          <a:lstStyle/>
-          <a:p>
-            <a:pPr indent="0" marL="0">
-              <a:spcAft>
-                <a:spcPts val="400"/>
-              </a:spcAft>
-              <a:buNone/>
-            </a:pPr>
-            <a:r>
-              <a:rPr lang="en-US" sz="1500" b="1" dirty="0">
-                <a:solidFill>
-                  <a:schemeClr val="tx2"/>
-                </a:solidFill>
-              </a:rPr>
-              <a:t>Honest</a:t>
-            </a:r>
-            <a:endParaRPr lang="en-US" sz="1500" dirty="0"/>
-          </a:p>
-          <a:p>
-            <a:pPr indent="0" marL="0">
-              <a:spcAft>
-                <a:spcPts val="400"/>
-              </a:spcAft>
-              <a:buNone/>
-            </a:pPr>
-            <a:r>
-              <a:rPr lang="en-US" sz="1400" dirty="0">
-                <a:solidFill>
-                  <a:schemeClr val="tx1"/>
-                </a:solidFill>
-              </a:rPr>
-              <a:t>Test set used once; 3 seeds for noisy runs; 95 % bootstrap intervals; no image of the paintings in Git (licence).</a:t>
-            </a:r>
-            <a:endParaRPr lang="en-US" sz="1500" dirty="0"/>
-          </a:p>
-        </p:txBody>
-      </p:sp>
-      <p:sp>
-        <p:nvSpPr>
-          <p:cNvPr id="25" name="Slide Number Placeholder 0"/>
-          <p:cNvSpPr>
-            <a:spLocks noGrp="1"/>
-          </p:cNvSpPr>
-          <p:nvPr>
-            <p:ph type="sldNum" sz="quarter" idx="4294967295"/>
-          </p:nvPr>
-        </p:nvSpPr>
-        <p:spPr>
-          <a:xfrm>
-            <a:off x="8229600" y="4754880"/>
-            <a:ext cx="457200" cy="274320"/>
-          </a:xfrm>
-          <a:prstGeom prst="rect">
-            <a:avLst/>
-          </a:prstGeom>
-          <a:extLst>
-            <a:ext uri="{C572A759-6A51-4108-AA02-DFA0A04FC94B}">
-              <ma14:wrappingTextBoxFlag xmlns:ma14="http://schemas.microsoft.com/office/mac/drawingml/2011/main" val="0"/>
-            </a:ext>
-          </a:extLst>
-        </p:spPr>
-        <p:txBody>
-          <a:bodyPr/>
-          <a:lstStyle>
-            <a:lvl1pPr>
-              <a:defRPr sz="1000">
-                <a:solidFill>
-                  <a:srgbClr val="5F6473"/>
-                </a:solidFill>
-              </a:defRPr>
-            </a:lvl1pPr>
-          </a:lstStyle>
-          <a:p>
-            <a:pPr algn="r"/>
-            <a:fld id="{F7021451-1387-4CA6-816F-3879F97B5CBC}" type="slidenum">
-              <a:rPr b="0" lang="en-US"/>
               <a:t>12</a:t>
             </a:fld>
             <a:endParaRPr lang="en-US"/>
@@ -7332,6 +7700,446 @@
                   <a:schemeClr val="tx2"/>
                 </a:solidFill>
               </a:rPr>
+              <a:t>Backup: why you can trust the numbers</a:t>
+            </a:r>
+            <a:endParaRPr lang="en-US" sz="3000" dirty="0"/>
+          </a:p>
+        </p:txBody>
+      </p:sp>
+      <p:sp>
+        <p:nvSpPr>
+          <p:cNvPr id="3" name="note Reproducible"/>
+          <p:cNvSpPr/>
+          <p:nvPr/>
+        </p:nvSpPr>
+        <p:spPr>
+          <a:xfrm>
+            <a:off x="457200" y="1097280"/>
+            <a:ext cx="4023360" cy="1600200"/>
+          </a:xfrm>
+          <a:prstGeom prst="roundRect">
+            <a:avLst>
+              <a:gd name="adj" fmla="val 4571"/>
+            </a:avLst>
+          </a:prstGeom>
+          <a:solidFill>
+            <a:schemeClr val="bg2"/>
+          </a:solidFill>
+          <a:ln w="12700">
+            <a:solidFill>
+              <a:schemeClr val="bg2"/>
+            </a:solidFill>
+            <a:prstDash val="solid"/>
+          </a:ln>
+        </p:spPr>
+      </p:sp>
+      <p:sp>
+        <p:nvSpPr>
+          <p:cNvPr id="4" name="text Reproducible"/>
+          <p:cNvSpPr txBox="1"/>
+          <p:nvPr/>
+        </p:nvSpPr>
+        <p:spPr>
+          <a:xfrm>
+            <a:off x="621792" y="1207008"/>
+            <a:ext cx="3694176" cy="1380744"/>
+          </a:xfrm>
+          <a:prstGeom prst="rect">
+            <a:avLst/>
+          </a:prstGeom>
+          <a:noFill/>
+          <a:ln/>
+        </p:spPr>
+        <p:txBody>
+          <a:bodyPr wrap="square" lIns="0" tIns="0" rIns="0" bIns="0" rtlCol="0" anchor="t"/>
+          <a:lstStyle/>
+          <a:p>
+            <a:pPr indent="0" marL="0">
+              <a:spcAft>
+                <a:spcPts val="400"/>
+              </a:spcAft>
+              <a:buNone/>
+            </a:pPr>
+            <a:r>
+              <a:rPr lang="en-US" sz="1500" b="1" dirty="0">
+                <a:solidFill>
+                  <a:schemeClr val="tx2"/>
+                </a:solidFill>
+              </a:rPr>
+              <a:t>Reproducible</a:t>
+            </a:r>
+            <a:endParaRPr lang="en-US" sz="1500" dirty="0"/>
+          </a:p>
+          <a:p>
+            <a:pPr indent="0" marL="0">
+              <a:spcAft>
+                <a:spcPts val="400"/>
+              </a:spcAft>
+              <a:buNone/>
+            </a:pPr>
+            <a:r>
+              <a:rPr lang="en-US" sz="1400" dirty="0">
+                <a:solidFill>
+                  <a:schemeClr val="tx1"/>
+                </a:solidFill>
+              </a:rPr>
+              <a:t>Fixed seeds and a pinned dataset revision. Notebook 06 trains the 9 neural models again and gets the same validation scores, to 4 decimals.</a:t>
+            </a:r>
+            <a:endParaRPr lang="en-US" sz="1500" dirty="0"/>
+          </a:p>
+        </p:txBody>
+      </p:sp>
+      <p:sp>
+        <p:nvSpPr>
+          <p:cNvPr id="5" name="note Tested"/>
+          <p:cNvSpPr/>
+          <p:nvPr/>
+        </p:nvSpPr>
+        <p:spPr>
+          <a:xfrm>
+            <a:off x="4663440" y="1097280"/>
+            <a:ext cx="4023360" cy="1600200"/>
+          </a:xfrm>
+          <a:prstGeom prst="roundRect">
+            <a:avLst>
+              <a:gd name="adj" fmla="val 4571"/>
+            </a:avLst>
+          </a:prstGeom>
+          <a:solidFill>
+            <a:schemeClr val="bg2"/>
+          </a:solidFill>
+          <a:ln w="12700">
+            <a:solidFill>
+              <a:schemeClr val="bg2"/>
+            </a:solidFill>
+            <a:prstDash val="solid"/>
+          </a:ln>
+        </p:spPr>
+      </p:sp>
+      <p:sp>
+        <p:nvSpPr>
+          <p:cNvPr id="6" name="text Tested"/>
+          <p:cNvSpPr txBox="1"/>
+          <p:nvPr/>
+        </p:nvSpPr>
+        <p:spPr>
+          <a:xfrm>
+            <a:off x="4828032" y="1207008"/>
+            <a:ext cx="3694176" cy="1380744"/>
+          </a:xfrm>
+          <a:prstGeom prst="rect">
+            <a:avLst/>
+          </a:prstGeom>
+          <a:noFill/>
+          <a:ln/>
+        </p:spPr>
+        <p:txBody>
+          <a:bodyPr wrap="square" lIns="0" tIns="0" rIns="0" bIns="0" rtlCol="0" anchor="t"/>
+          <a:lstStyle/>
+          <a:p>
+            <a:pPr indent="0" marL="0">
+              <a:spcAft>
+                <a:spcPts val="400"/>
+              </a:spcAft>
+              <a:buNone/>
+            </a:pPr>
+            <a:r>
+              <a:rPr lang="en-US" sz="1500" b="1" dirty="0">
+                <a:solidFill>
+                  <a:schemeClr val="tx2"/>
+                </a:solidFill>
+              </a:rPr>
+              <a:t>Tested</a:t>
+            </a:r>
+            <a:endParaRPr lang="en-US" sz="1500" dirty="0"/>
+          </a:p>
+          <a:p>
+            <a:pPr indent="0" marL="0">
+              <a:spcAft>
+                <a:spcPts val="400"/>
+              </a:spcAft>
+              <a:buNone/>
+            </a:pPr>
+            <a:r>
+              <a:rPr lang="en-US" sz="1400" dirty="0">
+                <a:solidFill>
+                  <a:schemeClr val="tx1"/>
+                </a:solidFill>
+              </a:rPr>
+              <a:t>33 automatic tests: split without painter leakage, parameter counts, training loop, metrics, benchmark helpers.</a:t>
+            </a:r>
+            <a:endParaRPr lang="en-US" sz="1500" dirty="0"/>
+          </a:p>
+        </p:txBody>
+      </p:sp>
+      <p:sp>
+        <p:nvSpPr>
+          <p:cNvPr id="7" name="note Versioned"/>
+          <p:cNvSpPr/>
+          <p:nvPr/>
+        </p:nvSpPr>
+        <p:spPr>
+          <a:xfrm>
+            <a:off x="457200" y="2880360"/>
+            <a:ext cx="4023360" cy="1600200"/>
+          </a:xfrm>
+          <a:prstGeom prst="roundRect">
+            <a:avLst>
+              <a:gd name="adj" fmla="val 4571"/>
+            </a:avLst>
+          </a:prstGeom>
+          <a:solidFill>
+            <a:schemeClr val="bg2"/>
+          </a:solidFill>
+          <a:ln w="12700">
+            <a:solidFill>
+              <a:schemeClr val="bg2"/>
+            </a:solidFill>
+            <a:prstDash val="solid"/>
+          </a:ln>
+        </p:spPr>
+      </p:sp>
+      <p:sp>
+        <p:nvSpPr>
+          <p:cNvPr id="8" name="text Versioned"/>
+          <p:cNvSpPr txBox="1"/>
+          <p:nvPr/>
+        </p:nvSpPr>
+        <p:spPr>
+          <a:xfrm>
+            <a:off x="621792" y="2990088"/>
+            <a:ext cx="3694176" cy="1380744"/>
+          </a:xfrm>
+          <a:prstGeom prst="rect">
+            <a:avLst/>
+          </a:prstGeom>
+          <a:noFill/>
+          <a:ln/>
+        </p:spPr>
+        <p:txBody>
+          <a:bodyPr wrap="square" lIns="0" tIns="0" rIns="0" bIns="0" rtlCol="0" anchor="t"/>
+          <a:lstStyle/>
+          <a:p>
+            <a:pPr indent="0" marL="0">
+              <a:spcAft>
+                <a:spcPts val="400"/>
+              </a:spcAft>
+              <a:buNone/>
+            </a:pPr>
+            <a:r>
+              <a:rPr lang="en-US" sz="1500" b="1" dirty="0">
+                <a:solidFill>
+                  <a:schemeClr val="tx2"/>
+                </a:solidFill>
+              </a:rPr>
+              <a:t>Versioned</a:t>
+            </a:r>
+            <a:endParaRPr lang="en-US" sz="1500" dirty="0"/>
+          </a:p>
+          <a:p>
+            <a:pPr indent="0" marL="0">
+              <a:spcAft>
+                <a:spcPts val="400"/>
+              </a:spcAft>
+              <a:buNone/>
+            </a:pPr>
+            <a:r>
+              <a:rPr lang="en-US" sz="1400" dirty="0">
+                <a:solidFill>
+                  <a:schemeClr val="tx1"/>
+                </a:solidFill>
+              </a:rPr>
+              <a:t>Small commits, one step at a time, on GitHub; milestone tags m1, m2, m3 and v1.0. Every number is saved in reports/results/*.json.</a:t>
+            </a:r>
+            <a:endParaRPr lang="en-US" sz="1500" dirty="0"/>
+          </a:p>
+        </p:txBody>
+      </p:sp>
+      <p:sp>
+        <p:nvSpPr>
+          <p:cNvPr id="9" name="note Honest"/>
+          <p:cNvSpPr/>
+          <p:nvPr/>
+        </p:nvSpPr>
+        <p:spPr>
+          <a:xfrm>
+            <a:off x="4663440" y="2880360"/>
+            <a:ext cx="4023360" cy="1600200"/>
+          </a:xfrm>
+          <a:prstGeom prst="roundRect">
+            <a:avLst>
+              <a:gd name="adj" fmla="val 4571"/>
+            </a:avLst>
+          </a:prstGeom>
+          <a:solidFill>
+            <a:schemeClr val="bg2"/>
+          </a:solidFill>
+          <a:ln w="12700">
+            <a:solidFill>
+              <a:schemeClr val="bg2"/>
+            </a:solidFill>
+            <a:prstDash val="solid"/>
+          </a:ln>
+        </p:spPr>
+      </p:sp>
+      <p:sp>
+        <p:nvSpPr>
+          <p:cNvPr id="10" name="text Honest"/>
+          <p:cNvSpPr txBox="1"/>
+          <p:nvPr/>
+        </p:nvSpPr>
+        <p:spPr>
+          <a:xfrm>
+            <a:off x="4828032" y="2990088"/>
+            <a:ext cx="3694176" cy="1380744"/>
+          </a:xfrm>
+          <a:prstGeom prst="rect">
+            <a:avLst/>
+          </a:prstGeom>
+          <a:noFill/>
+          <a:ln/>
+        </p:spPr>
+        <p:txBody>
+          <a:bodyPr wrap="square" lIns="0" tIns="0" rIns="0" bIns="0" rtlCol="0" anchor="t"/>
+          <a:lstStyle/>
+          <a:p>
+            <a:pPr indent="0" marL="0">
+              <a:spcAft>
+                <a:spcPts val="400"/>
+              </a:spcAft>
+              <a:buNone/>
+            </a:pPr>
+            <a:r>
+              <a:rPr lang="en-US" sz="1500" b="1" dirty="0">
+                <a:solidFill>
+                  <a:schemeClr val="tx2"/>
+                </a:solidFill>
+              </a:rPr>
+              <a:t>Honest</a:t>
+            </a:r>
+            <a:endParaRPr lang="en-US" sz="1500" dirty="0"/>
+          </a:p>
+          <a:p>
+            <a:pPr indent="0" marL="0">
+              <a:spcAft>
+                <a:spcPts val="400"/>
+              </a:spcAft>
+              <a:buNone/>
+            </a:pPr>
+            <a:r>
+              <a:rPr lang="en-US" sz="1400" dirty="0">
+                <a:solidFill>
+                  <a:schemeClr val="tx1"/>
+                </a:solidFill>
+              </a:rPr>
+              <a:t>Test set used once; 3 seeds for noisy runs; 95 % bootstrap intervals; no image of the paintings in Git (licence).</a:t>
+            </a:r>
+            <a:endParaRPr lang="en-US" sz="1500" dirty="0"/>
+          </a:p>
+        </p:txBody>
+      </p:sp>
+      <p:sp>
+        <p:nvSpPr>
+          <p:cNvPr id="25" name="Slide Number Placeholder 0"/>
+          <p:cNvSpPr>
+            <a:spLocks noGrp="1"/>
+          </p:cNvSpPr>
+          <p:nvPr>
+            <p:ph type="sldNum" sz="quarter" idx="4294967295"/>
+          </p:nvPr>
+        </p:nvSpPr>
+        <p:spPr>
+          <a:xfrm>
+            <a:off x="8229600" y="4754880"/>
+            <a:ext cx="457200" cy="274320"/>
+          </a:xfrm>
+          <a:prstGeom prst="rect">
+            <a:avLst/>
+          </a:prstGeom>
+          <a:extLst>
+            <a:ext uri="{C572A759-6A51-4108-AA02-DFA0A04FC94B}">
+              <ma14:wrappingTextBoxFlag xmlns:ma14="http://schemas.microsoft.com/office/mac/drawingml/2011/main" val="0"/>
+            </a:ext>
+          </a:extLst>
+        </p:spPr>
+        <p:txBody>
+          <a:bodyPr/>
+          <a:lstStyle>
+            <a:lvl1pPr>
+              <a:defRPr sz="1000">
+                <a:solidFill>
+                  <a:srgbClr val="5F6473"/>
+                </a:solidFill>
+              </a:defRPr>
+            </a:lvl1pPr>
+          </a:lstStyle>
+          <a:p>
+            <a:pPr algn="r"/>
+            <a:fld id="{F7021451-1387-4CA6-816F-3879F97B5CBC}" type="slidenum">
+              <a:rPr b="0" lang="en-US"/>
+              <a:t>13</a:t>
+            </a:fld>
+            <a:endParaRPr lang="en-US"/>
+          </a:p>
+        </p:txBody>
+      </p:sp>
+    </p:spTree>
+  </p:cSld>
+  <p:clrMapOvr>
+    <a:masterClrMapping/>
+  </p:clrMapOvr>
+</p:sld>
+</file>
+
+<file path=ppt/slides/slide14.xml><?xml version="1.0" encoding="utf-8"?>
+<p:sld xmlns:a="http://schemas.openxmlformats.org/drawingml/2006/main" xmlns:r="http://schemas.openxmlformats.org/officeDocument/2006/relationships" xmlns:p="http://schemas.openxmlformats.org/presentationml/2006/main">
+  <p:cSld name="Slide 14">
+    <p:spTree>
+      <p:nvGrpSpPr>
+        <p:cNvPr id="1" name=""/>
+        <p:cNvGrpSpPr/>
+        <p:nvPr/>
+      </p:nvGrpSpPr>
+      <p:grpSpPr>
+        <a:xfrm>
+          <a:off x="0" y="0"/>
+          <a:ext cx="0" cy="0"/>
+          <a:chOff x="0" y="0"/>
+          <a:chExt cx="0" cy="0"/>
+        </a:xfrm>
+      </p:grpSpPr>
+      <p:sp>
+        <p:nvSpPr>
+          <p:cNvPr id="2" name="Text 0"/>
+          <p:cNvSpPr/>
+          <p:nvPr>
+            <p:ph idx="100" type="title" hasCustomPrompt="1"/>
+          </p:nvPr>
+        </p:nvSpPr>
+        <p:spPr>
+          <a:xfrm>
+            <a:off x="457200" y="274320"/>
+            <a:ext cx="8229600" cy="640080"/>
+          </a:xfrm>
+          <a:prstGeom prst="rect">
+            <a:avLst/>
+          </a:prstGeom>
+          <a:noFill/>
+          <a:ln/>
+        </p:spPr>
+        <p:txBody>
+          <a:bodyPr wrap="square" lIns="0" tIns="0" rIns="0" bIns="0" rtlCol="0" anchor="ctr"/>
+          <a:lstStyle/>
+          <a:p>
+            <a:pPr indent="0" marL="0">
+              <a:buNone/>
+            </a:pPr>
+            <a:r>
+              <a:rPr lang="en-US" sz="3000" b="1" dirty="0">
+                <a:solidFill>
+                  <a:schemeClr val="tx2"/>
+                </a:solidFill>
+              </a:rPr>
               <a:t>Backup: the training recipes</a:t>
             </a:r>
             <a:endParaRPr lang="en-US" sz="3000" dirty="0"/>
@@ -7340,7 +8148,7 @@
       </p:sp>
       <p:graphicFrame>
         <p:nvGraphicFramePr>
-          <p:cNvPr id="14" name="recipes table"/>
+          <p:cNvPr id="15" name="recipes table"/>
           <p:cNvGraphicFramePr>
             <a:graphicFrameLocks noGrp="1"/>
           </p:cNvGraphicFramePr>
@@ -8591,7 +9399,7 @@
             <a:pPr algn="r"/>
             <a:fld id="{F7021451-1387-4CA6-816F-3879F97B5CBC}" type="slidenum">
               <a:rPr b="0" lang="en-US"/>
-              <a:t>13</a:t>
+              <a:t>14</a:t>
             </a:fld>
             <a:endParaRPr lang="en-US"/>
           </a:p>
@@ -8605,9 +9413,9 @@
 </p:sld>
 </file>
 
-<file path=ppt/slides/slide14.xml><?xml version="1.0" encoding="utf-8"?>
+<file path=ppt/slides/slide15.xml><?xml version="1.0" encoding="utf-8"?>
 <p:sld xmlns:a="http://schemas.openxmlformats.org/drawingml/2006/main" xmlns:r="http://schemas.openxmlformats.org/officeDocument/2006/relationships" xmlns:p="http://schemas.openxmlformats.org/presentationml/2006/main">
-  <p:cSld name="Slide 14">
+  <p:cSld name="Slide 15">
     <p:spTree>
       <p:nvGrpSpPr>
         <p:cNvPr id="1" name=""/>
@@ -8662,7 +9470,7 @@
       </p:sp>
       <p:graphicFrame>
         <p:nvGraphicFramePr>
-          <p:cNvPr id="15" name="doctor table"/>
+          <p:cNvPr id="16" name="doctor table"/>
           <p:cNvGraphicFramePr>
             <a:graphicFrameLocks noGrp="1"/>
           </p:cNvGraphicFramePr>
@@ -9996,206 +10804,6 @@
             <a:pPr algn="r"/>
             <a:fld id="{F7021451-1387-4CA6-816F-3879F97B5CBC}" type="slidenum">
               <a:rPr b="0" lang="en-US"/>
-              <a:t>14</a:t>
-            </a:fld>
-            <a:endParaRPr lang="en-US"/>
-          </a:p>
-        </p:txBody>
-      </p:sp>
-    </p:spTree>
-  </p:cSld>
-  <p:clrMapOvr>
-    <a:masterClrMapping/>
-  </p:clrMapOvr>
-</p:sld>
-</file>
-
-<file path=ppt/slides/slide15.xml><?xml version="1.0" encoding="utf-8"?>
-<p:sld xmlns:a="http://schemas.openxmlformats.org/drawingml/2006/main" xmlns:r="http://schemas.openxmlformats.org/officeDocument/2006/relationships" xmlns:p="http://schemas.openxmlformats.org/presentationml/2006/main">
-  <p:cSld name="Slide 15">
-    <p:spTree>
-      <p:nvGrpSpPr>
-        <p:cNvPr id="1" name=""/>
-        <p:cNvGrpSpPr/>
-        <p:nvPr/>
-      </p:nvGrpSpPr>
-      <p:grpSpPr>
-        <a:xfrm>
-          <a:off x="0" y="0"/>
-          <a:ext cx="0" cy="0"/>
-          <a:chOff x="0" y="0"/>
-          <a:chExt cx="0" cy="0"/>
-        </a:xfrm>
-      </p:grpSpPr>
-      <p:sp>
-        <p:nvSpPr>
-          <p:cNvPr id="2" name="Text 0"/>
-          <p:cNvSpPr/>
-          <p:nvPr>
-            <p:ph idx="100" type="title" hasCustomPrompt="1"/>
-          </p:nvPr>
-        </p:nvSpPr>
-        <p:spPr>
-          <a:xfrm>
-            <a:off x="457200" y="274320"/>
-            <a:ext cx="8229600" cy="640080"/>
-          </a:xfrm>
-          <a:prstGeom prst="rect">
-            <a:avLst/>
-          </a:prstGeom>
-          <a:noFill/>
-          <a:ln/>
-        </p:spPr>
-        <p:txBody>
-          <a:bodyPr wrap="square" lIns="0" tIns="0" rIns="0" bIns="0" rtlCol="0" anchor="ctr"/>
-          <a:lstStyle/>
-          <a:p>
-            <a:pPr indent="0" marL="0">
-              <a:buNone/>
-            </a:pPr>
-            <a:r>
-              <a:rPr lang="en-US" sz="3000" b="1" dirty="0">
-                <a:solidFill>
-                  <a:schemeClr val="tx2"/>
-                </a:solidFill>
-              </a:rPr>
-              <a:t>Backup: where the chosen model fails</a:t>
-            </a:r>
-            <a:endParaRPr lang="en-US" sz="3000" dirty="0"/>
-          </a:p>
-        </p:txBody>
-      </p:sp>
-      <p:graphicFrame>
-        <p:nvGraphicFramePr>
-          <p:cNvPr id="3" name="chart per class" descr=""/>
-          <p:cNvGraphicFramePr/>
-          <p:nvPr/>
-        </p:nvGraphicFramePr>
-        <p:xfrm>
-          <a:off x="365760" y="1005840"/>
-          <a:ext cx="4937760" cy="3611880"/>
-        </p:xfrm>
-        <a:graphic xmlns:a="http://schemas.openxmlformats.org/drawingml/2006/main">
-          <a:graphicData uri="http://schemas.openxmlformats.org/drawingml/2006/chart">
-            <c:chart xmlns:c="http://schemas.openxmlformats.org/drawingml/2006/chart" r:id="rId1"/>
-          </a:graphicData>
-        </a:graphic>
-      </p:graphicFrame>
-      <p:sp>
-        <p:nvSpPr>
-          <p:cNvPr id="4" name="per class bullets"/>
-          <p:cNvSpPr txBox="1"/>
-          <p:nvPr/>
-        </p:nvSpPr>
-        <p:spPr>
-          <a:xfrm>
-            <a:off x="5532120" y="1097280"/>
-            <a:ext cx="3154680" cy="3520440"/>
-          </a:xfrm>
-          <a:prstGeom prst="rect">
-            <a:avLst/>
-          </a:prstGeom>
-          <a:noFill/>
-          <a:ln/>
-        </p:spPr>
-        <p:txBody>
-          <a:bodyPr wrap="square" lIns="0" tIns="0" rIns="0" bIns="0" rtlCol="0" anchor="t"/>
-          <a:lstStyle/>
-          <a:p>
-            <a:pPr marL="342900" indent="-342900">
-              <a:spcAft>
-                <a:spcPts val="800"/>
-              </a:spcAft>
-              <a:buSzPct val="100000"/>
-              <a:buChar char="•"/>
-            </a:pPr>
-            <a:r>
-              <a:rPr lang="en-US" sz="1400" dirty="0">
-                <a:solidFill>
-                  <a:schemeClr val="tx1"/>
-                </a:solidFill>
-              </a:rPr>
-              <a:t>Easiest: Ukiyo-e and Impressionism</a:t>
-            </a:r>
-            <a:endParaRPr lang="en-US" sz="1400" dirty="0"/>
-          </a:p>
-          <a:p>
-            <a:pPr marL="342900" indent="-342900">
-              <a:spcAft>
-                <a:spcPts val="800"/>
-              </a:spcAft>
-              <a:buSzPct val="100000"/>
-              <a:buChar char="•"/>
-            </a:pPr>
-            <a:r>
-              <a:rPr lang="en-US" sz="1400" dirty="0">
-                <a:solidFill>
-                  <a:schemeClr val="tx1"/>
-                </a:solidFill>
-              </a:rPr>
-              <a:t>Hardest: Pop Art and Cubism; on validation they were mostly confused with each other (flat strong colours, hard edges)</a:t>
-            </a:r>
-            <a:endParaRPr lang="en-US" sz="1400" dirty="0"/>
-          </a:p>
-          <a:p>
-            <a:pPr marL="342900" indent="-342900">
-              <a:spcAft>
-                <a:spcPts val="800"/>
-              </a:spcAft>
-              <a:buSzPct val="100000"/>
-              <a:buChar char="•"/>
-            </a:pPr>
-            <a:r>
-              <a:rPr lang="en-US" sz="1400" dirty="0">
-                <a:solidFill>
-                  <a:schemeClr val="tx1"/>
-                </a:solidFill>
-              </a:rPr>
-              <a:t>The MLP found only 7 % of Cubist paintings; the ResNet finds most of them</a:t>
-            </a:r>
-            <a:endParaRPr lang="en-US" sz="1400" dirty="0"/>
-          </a:p>
-        </p:txBody>
-      </p:sp>
-      <p:sp>
-        <p:nvSpPr>
-          <p:cNvPr id="25" name="Slide Number Placeholder 0"/>
-          <p:cNvSpPr>
-            <a:spLocks noGrp="1"/>
-          </p:cNvSpPr>
-          <p:nvPr>
-            <p:ph type="sldNum" sz="quarter" idx="4294967295"/>
-          </p:nvPr>
-        </p:nvSpPr>
-        <p:spPr>
-          <a:xfrm>
-            <a:off x="8229600" y="4754880"/>
-            <a:ext cx="457200" cy="274320"/>
-          </a:xfrm>
-          <a:prstGeom prst="rect">
-            <a:avLst/>
-          </a:prstGeom>
-          <a:extLst>
-            <a:ext uri="{C572A759-6A51-4108-AA02-DFA0A04FC94B}">
-              <ma14:wrappingTextBoxFlag xmlns:ma14="http://schemas.microsoft.com/office/mac/drawingml/2011/main" val="0"/>
-            </a:ext>
-          </a:extLst>
-        </p:spPr>
-        <p:txBody>
-          <a:bodyPr/>
-          <a:lstStyle>
-            <a:lvl1pPr>
-              <a:defRPr sz="1000">
-                <a:solidFill>
-                  <a:srgbClr val="5F6473"/>
-                </a:solidFill>
-              </a:defRPr>
-            </a:lvl1pPr>
-          </a:lstStyle>
-          <a:p>
-            <a:pPr algn="r"/>
-            <a:fld id="{F7021451-1387-4CA6-816F-3879F97B5CBC}" type="slidenum">
-              <a:rPr b="0" lang="en-US"/>
               <a:t>15</a:t>
             </a:fld>
             <a:endParaRPr lang="en-US"/>
@@ -10259,7 +10867,7 @@
                   <a:schemeClr val="tx2"/>
                 </a:solidFill>
               </a:rPr>
-              <a:t>Backup: what about transformers (BERT)?</a:t>
+              <a:t>Backup: where the chosen model fails</a:t>
             </a:r>
             <a:endParaRPr lang="en-US" sz="3000" dirty="0"/>
           </a:p>
@@ -10267,7 +10875,207 @@
       </p:sp>
       <p:graphicFrame>
         <p:nvGraphicFramePr>
-          <p:cNvPr id="17" name="transformers table"/>
+          <p:cNvPr id="3" name="chart per class" descr=""/>
+          <p:cNvGraphicFramePr/>
+          <p:nvPr/>
+        </p:nvGraphicFramePr>
+        <p:xfrm>
+          <a:off x="365760" y="1005840"/>
+          <a:ext cx="4937760" cy="3611880"/>
+        </p:xfrm>
+        <a:graphic xmlns:a="http://schemas.openxmlformats.org/drawingml/2006/main">
+          <a:graphicData uri="http://schemas.openxmlformats.org/drawingml/2006/chart">
+            <c:chart xmlns:c="http://schemas.openxmlformats.org/drawingml/2006/chart" r:id="rId1"/>
+          </a:graphicData>
+        </a:graphic>
+      </p:graphicFrame>
+      <p:sp>
+        <p:nvSpPr>
+          <p:cNvPr id="4" name="per class bullets"/>
+          <p:cNvSpPr txBox="1"/>
+          <p:nvPr/>
+        </p:nvSpPr>
+        <p:spPr>
+          <a:xfrm>
+            <a:off x="5532120" y="1097280"/>
+            <a:ext cx="3154680" cy="3520440"/>
+          </a:xfrm>
+          <a:prstGeom prst="rect">
+            <a:avLst/>
+          </a:prstGeom>
+          <a:noFill/>
+          <a:ln/>
+        </p:spPr>
+        <p:txBody>
+          <a:bodyPr wrap="square" lIns="0" tIns="0" rIns="0" bIns="0" rtlCol="0" anchor="t"/>
+          <a:lstStyle/>
+          <a:p>
+            <a:pPr marL="342900" indent="-342900">
+              <a:spcAft>
+                <a:spcPts val="800"/>
+              </a:spcAft>
+              <a:buSzPct val="100000"/>
+              <a:buChar char="•"/>
+            </a:pPr>
+            <a:r>
+              <a:rPr lang="en-US" sz="1400" dirty="0">
+                <a:solidFill>
+                  <a:schemeClr val="tx1"/>
+                </a:solidFill>
+              </a:rPr>
+              <a:t>Easiest: Ukiyo-e and Impressionism</a:t>
+            </a:r>
+            <a:endParaRPr lang="en-US" sz="1400" dirty="0"/>
+          </a:p>
+          <a:p>
+            <a:pPr marL="342900" indent="-342900">
+              <a:spcAft>
+                <a:spcPts val="800"/>
+              </a:spcAft>
+              <a:buSzPct val="100000"/>
+              <a:buChar char="•"/>
+            </a:pPr>
+            <a:r>
+              <a:rPr lang="en-US" sz="1400" dirty="0">
+                <a:solidFill>
+                  <a:schemeClr val="tx1"/>
+                </a:solidFill>
+              </a:rPr>
+              <a:t>Hardest: Pop Art and Cubism; on validation they were mostly confused with each other (flat strong colours, hard edges)</a:t>
+            </a:r>
+            <a:endParaRPr lang="en-US" sz="1400" dirty="0"/>
+          </a:p>
+          <a:p>
+            <a:pPr marL="342900" indent="-342900">
+              <a:spcAft>
+                <a:spcPts val="800"/>
+              </a:spcAft>
+              <a:buSzPct val="100000"/>
+              <a:buChar char="•"/>
+            </a:pPr>
+            <a:r>
+              <a:rPr lang="en-US" sz="1400" dirty="0">
+                <a:solidFill>
+                  <a:schemeClr val="tx1"/>
+                </a:solidFill>
+              </a:rPr>
+              <a:t>The MLP found only 7 % of Cubist paintings; the ResNet finds most of them</a:t>
+            </a:r>
+            <a:endParaRPr lang="en-US" sz="1400" dirty="0"/>
+          </a:p>
+        </p:txBody>
+      </p:sp>
+      <p:sp>
+        <p:nvSpPr>
+          <p:cNvPr id="25" name="Slide Number Placeholder 0"/>
+          <p:cNvSpPr>
+            <a:spLocks noGrp="1"/>
+          </p:cNvSpPr>
+          <p:nvPr>
+            <p:ph type="sldNum" sz="quarter" idx="4294967295"/>
+          </p:nvPr>
+        </p:nvSpPr>
+        <p:spPr>
+          <a:xfrm>
+            <a:off x="8229600" y="4754880"/>
+            <a:ext cx="457200" cy="274320"/>
+          </a:xfrm>
+          <a:prstGeom prst="rect">
+            <a:avLst/>
+          </a:prstGeom>
+          <a:extLst>
+            <a:ext uri="{C572A759-6A51-4108-AA02-DFA0A04FC94B}">
+              <ma14:wrappingTextBoxFlag xmlns:ma14="http://schemas.microsoft.com/office/mac/drawingml/2011/main" val="0"/>
+            </a:ext>
+          </a:extLst>
+        </p:spPr>
+        <p:txBody>
+          <a:bodyPr/>
+          <a:lstStyle>
+            <a:lvl1pPr>
+              <a:defRPr sz="1000">
+                <a:solidFill>
+                  <a:srgbClr val="5F6473"/>
+                </a:solidFill>
+              </a:defRPr>
+            </a:lvl1pPr>
+          </a:lstStyle>
+          <a:p>
+            <a:pPr algn="r"/>
+            <a:fld id="{F7021451-1387-4CA6-816F-3879F97B5CBC}" type="slidenum">
+              <a:rPr b="0" lang="en-US"/>
+              <a:t>16</a:t>
+            </a:fld>
+            <a:endParaRPr lang="en-US"/>
+          </a:p>
+        </p:txBody>
+      </p:sp>
+    </p:spTree>
+  </p:cSld>
+  <p:clrMapOvr>
+    <a:masterClrMapping/>
+  </p:clrMapOvr>
+</p:sld>
+</file>
+
+<file path=ppt/slides/slide17.xml><?xml version="1.0" encoding="utf-8"?>
+<p:sld xmlns:a="http://schemas.openxmlformats.org/drawingml/2006/main" xmlns:r="http://schemas.openxmlformats.org/officeDocument/2006/relationships" xmlns:p="http://schemas.openxmlformats.org/presentationml/2006/main">
+  <p:cSld name="Slide 17">
+    <p:spTree>
+      <p:nvGrpSpPr>
+        <p:cNvPr id="1" name=""/>
+        <p:cNvGrpSpPr/>
+        <p:nvPr/>
+      </p:nvGrpSpPr>
+      <p:grpSpPr>
+        <a:xfrm>
+          <a:off x="0" y="0"/>
+          <a:ext cx="0" cy="0"/>
+          <a:chOff x="0" y="0"/>
+          <a:chExt cx="0" cy="0"/>
+        </a:xfrm>
+      </p:grpSpPr>
+      <p:sp>
+        <p:nvSpPr>
+          <p:cNvPr id="2" name="Text 0"/>
+          <p:cNvSpPr/>
+          <p:nvPr>
+            <p:ph idx="100" type="title" hasCustomPrompt="1"/>
+          </p:nvPr>
+        </p:nvSpPr>
+        <p:spPr>
+          <a:xfrm>
+            <a:off x="457200" y="274320"/>
+            <a:ext cx="8229600" cy="640080"/>
+          </a:xfrm>
+          <a:prstGeom prst="rect">
+            <a:avLst/>
+          </a:prstGeom>
+          <a:noFill/>
+          <a:ln/>
+        </p:spPr>
+        <p:txBody>
+          <a:bodyPr wrap="square" lIns="0" tIns="0" rIns="0" bIns="0" rtlCol="0" anchor="ctr"/>
+          <a:lstStyle/>
+          <a:p>
+            <a:pPr indent="0" marL="0">
+              <a:buNone/>
+            </a:pPr>
+            <a:r>
+              <a:rPr lang="en-US" sz="3000" b="1" dirty="0">
+                <a:solidFill>
+                  <a:schemeClr val="tx2"/>
+                </a:solidFill>
+              </a:rPr>
+              <a:t>Backup: what about transformers (BERT)?</a:t>
+            </a:r>
+            <a:endParaRPr lang="en-US" sz="3000" dirty="0"/>
+          </a:p>
+        </p:txBody>
+      </p:sp>
+      <p:graphicFrame>
+        <p:nvGraphicFramePr>
+          <p:cNvPr id="18" name="transformers table"/>
           <p:cNvGraphicFramePr>
             <a:graphicFrameLocks noGrp="1"/>
           </p:cNvGraphicFramePr>
@@ -11594,7 +12402,7 @@
             <a:pPr algn="r"/>
             <a:fld id="{F7021451-1387-4CA6-816F-3879F97B5CBC}" type="slidenum">
               <a:rPr b="0" lang="en-US"/>
-              <a:t>16</a:t>
+              <a:t>17</a:t>
             </a:fld>
             <a:endParaRPr lang="en-US"/>
           </a:p>

</xml_diff>

<commit_message>
Keep four models on the final test slide and move the painter slide to the backups
</commit_message>
<xml_diff>
--- a/docs/museum_guide_presentation.pptx
+++ b/docs/museum_guide_presentation.pptx
@@ -123,34 +123,34 @@
   <p:extLst>
     <p:ext uri="{521415D9-36F7-43E2-AB2F-B90AF26B5E84}">
       <p14:sectionLst xmlns:p14="http://schemas.microsoft.com/office/powerpoint/2010/main">
-        <p14:section name="The question" id="{b20822bd-4b7e-9d54-2d45-a42ce1e38732}">
+        <p14:section name="The question" id="{b8a762f9-c60f-67c5-bce3-c18dd96eaed9}">
           <p14:sldIdLst>
             <p14:sldId id="256"/>
             <p14:sldId id="257"/>
             <p14:sldId id="258"/>
           </p14:sldIdLst>
         </p14:section>
-        <p14:section name="Our MLP" id="{a2e5074f-e075-7bc0-2528-d7e0499ab86e}">
+        <p14:section name="Our MLP" id="{b614dd4a-3125-e102-466c-caea8105ba13}">
           <p14:sldIdLst>
             <p14:sldId id="259"/>
             <p14:sldId id="260"/>
           </p14:sldIdLst>
         </p14:section>
-        <p14:section name="Pretrained ResNet" id="{cd4b0ac8-4f52-37cf-4f52-a7f54e7947c7}">
+        <p14:section name="Pretrained ResNet" id="{9a7877d0-65eb-eb2a-027b-f273edae7f08}">
           <p14:sldIdLst>
             <p14:sldId id="261"/>
-            <p14:sldId id="262"/>
           </p14:sldIdLst>
         </p14:section>
-        <p14:section name="The answer" id="{e1ba8499-c6b5-648f-2f8c-e6dc12754a4a}">
+        <p14:section name="The answer" id="{4b40f9d3-42ba-a7ac-0940-a6c77271bb94}">
           <p14:sldIdLst>
+            <p14:sldId id="262"/>
             <p14:sldId id="263"/>
             <p14:sldId id="264"/>
-            <p14:sldId id="265"/>
           </p14:sldIdLst>
         </p14:section>
-        <p14:section name="Backup" id="{522e5cd0-c90c-c9e6-d84c-35587b3aa145}">
+        <p14:section name="Backup" id="{ae4b2d23-a67e-3a9f-ac23-f6d6454925c5}">
           <p14:sldIdLst>
+            <p14:sldId id="265"/>
             <p14:sldId id="266"/>
             <p14:sldId id="267"/>
             <p14:sldId id="268"/>
@@ -914,6 +914,381 @@
   <c:date1904 val="0"/>
   <c:roundedCorners val="1"/>
   <c:chart>
+    <c:title>
+      <c:tx>
+        <c:rich>
+          <a:bodyPr/>
+          <a:lstStyle/>
+          <a:p>
+            <a:pPr>
+              <a:defRPr sz="1400" b="0" i="0" u="none" strike="noStrike">
+                <a:solidFill>
+                  <a:srgbClr val="3A3F4B"/>
+                </a:solidFill>
+                <a:latin typeface="+mn-lt"/>
+              </a:defRPr>
+            </a:pPr>
+            <a:r>
+              <a:rPr sz="1400" b="0" i="0" u="none" strike="noStrike">
+                <a:solidFill>
+                  <a:srgbClr val="3A3F4B"/>
+                </a:solidFill>
+                <a:latin typeface="+mn-lt"/>
+              </a:rPr>
+              <a:t>Test accuracy, 220 new paintings</a:t>
+            </a:r>
+          </a:p>
+        </c:rich>
+      </c:tx>
+      <c:layout/>
+      <c:overlay val="0"/>
+    </c:title>
+    <c:autoTitleDeleted val="0"/>
+    <c:plotArea>
+      <c:layout/>
+      <c:barChart>
+        <c:barDir val="bar"/>
+        <c:grouping val="stacked"/>
+        <c:varyColors val="0"/>
+        <c:ser>
+          <c:idx val="0"/>
+          <c:order val="0"/>
+          <c:tx>
+            <c:strRef>
+              <c:f>Sheet1!$B$1</c:f>
+              <c:strCache>
+                <c:ptCount val="1"/>
+                <c:pt idx="0">
+                  <c:v>Classical</c:v>
+                </c:pt>
+              </c:strCache>
+            </c:strRef>
+          </c:tx>
+          <c:spPr>
+            <a:solidFill>
+              <a:srgbClr val="EB6834"/>
+            </a:solidFill>
+            <a:effectLst/>
+          </c:spPr>
+          <c:invertIfNegative val="0"/>
+          <c:dLbls>
+            <c:numFmt formatCode="0&quot;.&quot;0&quot; %&quot;;;" sourceLinked="0"/>
+            <c:txPr>
+              <a:bodyPr/>
+              <a:lstStyle/>
+              <a:p>
+                <a:pPr>
+                  <a:defRPr b="0" i="0" strike="noStrike" sz="1200" u="none">
+                    <a:solidFill>
+                      <a:srgbClr val="FFFFFF"/>
+                    </a:solidFill>
+                    <a:latin typeface="+mn-lt"/>
+                  </a:defRPr>
+                </a:pPr>
+              </a:p>
+            </c:txPr>
+            <c:dLblPos val="inEnd"/>
+            <c:showLegendKey val="0"/>
+            <c:showVal val="1"/>
+            <c:showCatName val="0"/>
+            <c:showSerName val="0"/>
+            <c:showPercent val="0"/>
+            <c:showBubbleSize val="0"/>
+            <c:showLeaderLines val="0"/>
+          </c:dLbls>
+          <c:cat>
+            <c:multiLvlStrRef>
+              <c:f>Sheet1!$A$2:$A$5</c:f>
+              <c:multiLvlStrCache>
+                <c:ptCount val="4"/>
+                <c:lvl>
+                  <c:pt idx="0">
+                    <c:v>Our MLP, pixels</c:v>
+                  </c:pt>
+                  <c:pt idx="1">
+                    <c:v>Random forest, 102 hand-made numbers</c:v>
+                  </c:pt>
+                  <c:pt idx="2">
+                    <c:v>ResNet18 frozen + linear head (ours)</c:v>
+                  </c:pt>
+                  <c:pt idx="3">
+                    <c:v>ResNet18, layer4 fine-tuned</c:v>
+                  </c:pt>
+                </c:lvl>
+              </c:multiLvlStrCache>
+            </c:multiLvlStrRef>
+          </c:cat>
+          <c:val>
+            <c:numRef>
+              <c:f>Sheet1!$B$2:$B$5</c:f>
+              <c:numCache>
+                <c:formatCode>General</c:formatCode>
+                <c:ptCount val="4"/>
+                <c:pt idx="0">
+                  <c:v>0</c:v>
+                </c:pt>
+                <c:pt idx="1">
+                  <c:v>673</c:v>
+                </c:pt>
+                <c:pt idx="2">
+                  <c:v>0</c:v>
+                </c:pt>
+                <c:pt idx="3">
+                  <c:v>0</c:v>
+                </c:pt>
+              </c:numCache>
+            </c:numRef>
+          </c:val>
+        </c:ser>
+        <c:ser>
+          <c:idx val="1"/>
+          <c:order val="1"/>
+          <c:tx>
+            <c:strRef>
+              <c:f>Sheet1!$C$1</c:f>
+              <c:strCache>
+                <c:ptCount val="1"/>
+                <c:pt idx="0">
+                  <c:v>Neural</c:v>
+                </c:pt>
+              </c:strCache>
+            </c:strRef>
+          </c:tx>
+          <c:spPr>
+            <a:solidFill>
+              <a:srgbClr val="2A78D6"/>
+            </a:solidFill>
+            <a:effectLst/>
+          </c:spPr>
+          <c:invertIfNegative val="0"/>
+          <c:dLbls>
+            <c:numFmt formatCode="0&quot;.&quot;0&quot; %&quot;;;" sourceLinked="0"/>
+            <c:txPr>
+              <a:bodyPr/>
+              <a:lstStyle/>
+              <a:p>
+                <a:pPr>
+                  <a:defRPr b="0" i="0" strike="noStrike" sz="1200" u="none">
+                    <a:solidFill>
+                      <a:srgbClr val="FFFFFF"/>
+                    </a:solidFill>
+                    <a:latin typeface="+mn-lt"/>
+                  </a:defRPr>
+                </a:pPr>
+              </a:p>
+            </c:txPr>
+            <c:dLblPos val="inEnd"/>
+            <c:showLegendKey val="0"/>
+            <c:showVal val="1"/>
+            <c:showCatName val="0"/>
+            <c:showSerName val="0"/>
+            <c:showPercent val="0"/>
+            <c:showBubbleSize val="0"/>
+            <c:showLeaderLines val="0"/>
+          </c:dLbls>
+          <c:cat>
+            <c:multiLvlStrRef>
+              <c:f>Sheet1!$A$2:$A$5</c:f>
+              <c:multiLvlStrCache>
+                <c:ptCount val="4"/>
+                <c:lvl>
+                  <c:pt idx="0">
+                    <c:v>Our MLP, pixels</c:v>
+                  </c:pt>
+                  <c:pt idx="1">
+                    <c:v>Random forest, 102 hand-made numbers</c:v>
+                  </c:pt>
+                  <c:pt idx="2">
+                    <c:v>ResNet18 frozen + linear head (ours)</c:v>
+                  </c:pt>
+                  <c:pt idx="3">
+                    <c:v>ResNet18, layer4 fine-tuned</c:v>
+                  </c:pt>
+                </c:lvl>
+              </c:multiLvlStrCache>
+            </c:multiLvlStrRef>
+          </c:cat>
+          <c:val>
+            <c:numRef>
+              <c:f>Sheet1!$C$2:$C$5</c:f>
+              <c:numCache>
+                <c:formatCode>General</c:formatCode>
+                <c:ptCount val="4"/>
+                <c:pt idx="0">
+                  <c:v>414</c:v>
+                </c:pt>
+                <c:pt idx="1">
+                  <c:v>0</c:v>
+                </c:pt>
+                <c:pt idx="2">
+                  <c:v>830</c:v>
+                </c:pt>
+                <c:pt idx="3">
+                  <c:v>879</c:v>
+                </c:pt>
+              </c:numCache>
+            </c:numRef>
+          </c:val>
+        </c:ser>
+        <c:dLbls>
+          <c:numFmt formatCode="0&quot;.&quot;0&quot; %&quot;;;" sourceLinked="0"/>
+          <c:txPr>
+            <a:bodyPr/>
+            <a:lstStyle/>
+            <a:p>
+              <a:pPr>
+                <a:defRPr b="0" i="0" strike="noStrike" sz="1200" u="none">
+                  <a:solidFill>
+                    <a:srgbClr val="FFFFFF"/>
+                  </a:solidFill>
+                  <a:latin typeface="+mn-lt"/>
+                </a:defRPr>
+              </a:pPr>
+            </a:p>
+          </c:txPr>
+          <c:dLblPos val="inEnd"/>
+          <c:showLegendKey val="0"/>
+          <c:showVal val="1"/>
+          <c:showCatName val="0"/>
+          <c:showSerName val="0"/>
+          <c:showPercent val="0"/>
+          <c:showBubbleSize val="0"/>
+          <c:showLeaderLines val="0"/>
+        </c:dLbls>
+        <c:gapWidth val="60"/>
+        <c:overlap val="100"/>
+        <c:axId val="2094734554"/>
+        <c:axId val="2094734552"/>
+        <c:axId val="2094734556"/>
+      </c:barChart>
+      <c:catAx>
+        <c:axId val="2094734554"/>
+        <c:scaling>
+          <c:orientation val="minMax"/>
+        </c:scaling>
+        <c:delete val="0"/>
+        <c:axPos val="l"/>
+        <c:numFmt formatCode="General" sourceLinked="1"/>
+        <c:majorTickMark val="out"/>
+        <c:minorTickMark val="none"/>
+        <c:tickLblPos val="nextTo"/>
+        <c:spPr>
+          <a:ln w="12700" cap="flat">
+            <a:solidFill>
+              <a:srgbClr val="888888"/>
+            </a:solidFill>
+            <a:prstDash val="solid"/>
+            <a:round/>
+          </a:ln>
+        </c:spPr>
+        <c:txPr>
+          <a:bodyPr/>
+          <a:lstStyle/>
+          <a:p>
+            <a:pPr>
+              <a:defRPr sz="1200" b="0" i="0" u="none" strike="noStrike">
+                <a:solidFill>
+                  <a:srgbClr val="3A3F4B"/>
+                </a:solidFill>
+                <a:latin typeface="+mn-lt"/>
+              </a:defRPr>
+            </a:pPr>
+            <a:endParaRPr lang="en-US"/>
+          </a:p>
+        </c:txPr>
+        <c:crossAx val="2094734552"/>
+        <c:crosses val="autoZero"/>
+        <c:auto val="1"/>
+        <c:lblAlgn val="ctr"/>
+        <c:noMultiLvlLbl val="1"/>
+      </c:catAx>
+      <c:valAx>
+        <c:axId val="2094734552"/>
+        <c:scaling>
+          <c:orientation val="minMax"/>
+          <c:max val="1000"/>
+          <c:min val="0"/>
+        </c:scaling>
+        <c:delete val="1"/>
+        <c:axPos val="b"/>
+        <c:numFmt formatCode="General" sourceLinked="0"/>
+        <c:majorTickMark val="out"/>
+        <c:minorTickMark val="none"/>
+        <c:tickLblPos val="low"/>
+        <c:spPr>
+          <a:ln w="12700" cap="flat">
+            <a:solidFill>
+              <a:srgbClr val="888888"/>
+            </a:solidFill>
+            <a:prstDash val="solid"/>
+            <a:round/>
+          </a:ln>
+        </c:spPr>
+        <c:txPr>
+          <a:bodyPr/>
+          <a:lstStyle/>
+          <a:p>
+            <a:pPr>
+              <a:defRPr sz="1200" b="0" i="0" u="none" strike="noStrike">
+                <a:solidFill>
+                  <a:srgbClr val="000000"/>
+                </a:solidFill>
+                <a:latin typeface="+mn-lt"/>
+              </a:defRPr>
+            </a:pPr>
+            <a:endParaRPr lang="en-US"/>
+          </a:p>
+        </c:txPr>
+        <c:crossAx val="2094734554"/>
+        <c:crosses val="autoZero"/>
+        <c:crossBetween val="between"/>
+      </c:valAx>
+      <c:spPr>
+        <a:noFill/>
+        <a:ln>
+          <a:noFill/>
+        </a:ln>
+        <a:effectLst/>
+      </c:spPr>
+    </c:plotArea>
+    <c:legend>
+      <c:legendPos val="b"/>
+      <c:overlay val="0"/>
+      <c:txPr>
+        <a:bodyPr/>
+        <a:lstStyle/>
+        <a:p>
+          <a:pPr>
+            <a:defRPr sz="1200">
+              <a:latin typeface="+mn-lt"/>
+              <a:cs typeface="+mn-lt"/>
+            </a:defRPr>
+          </a:pPr>
+          <a:endParaRPr lang="en-US"/>
+        </a:p>
+      </c:txPr>
+    </c:legend>
+    <c:plotVisOnly val="1"/>
+    <c:dispBlanksAs val="span"/>
+  </c:chart>
+  <c:spPr>
+    <a:noFill/>
+    <a:ln>
+      <a:noFill/>
+    </a:ln>
+    <a:effectLst/>
+  </c:spPr>
+  <c:externalData r:id="rId1">
+    <c:autoUpdate val="0"/>
+  </c:externalData>
+</c:chartSpace>
+</file>
+
+<file path=ppt/charts/chart4.xml><?xml version="1.0" encoding="utf-8"?>
+<c:chartSpace xmlns:c="http://schemas.openxmlformats.org/drawingml/2006/chart" xmlns:a="http://schemas.openxmlformats.org/drawingml/2006/main" xmlns:r="http://schemas.openxmlformats.org/officeDocument/2006/relationships">
+  <c:date1904 val="0"/>
+  <c:roundedCorners val="1"/>
+  <c:chart>
     <c:autoTitleDeleted val="1"/>
     <c:plotArea>
       <c:layout/>
@@ -1228,657 +1603,6 @@
 </c:chartSpace>
 </file>
 
-<file path=ppt/charts/chart4.xml><?xml version="1.0" encoding="utf-8"?>
-<c:chartSpace xmlns:c="http://schemas.openxmlformats.org/drawingml/2006/chart" xmlns:a="http://schemas.openxmlformats.org/drawingml/2006/main" xmlns:r="http://schemas.openxmlformats.org/officeDocument/2006/relationships">
-  <c:date1904 val="0"/>
-  <c:roundedCorners val="1"/>
-  <c:chart>
-    <c:title>
-      <c:tx>
-        <c:rich>
-          <a:bodyPr/>
-          <a:lstStyle/>
-          <a:p>
-            <a:pPr>
-              <a:defRPr sz="1400" b="0" i="0" u="none" strike="noStrike">
-                <a:solidFill>
-                  <a:srgbClr val="3A3F4B"/>
-                </a:solidFill>
-                <a:latin typeface="+mn-lt"/>
-              </a:defRPr>
-            </a:pPr>
-            <a:r>
-              <a:rPr sz="1400" b="0" i="0" u="none" strike="noStrike">
-                <a:solidFill>
-                  <a:srgbClr val="3A3F4B"/>
-                </a:solidFill>
-                <a:latin typeface="+mn-lt"/>
-              </a:rPr>
-              <a:t>Test accuracy, 220 new paintings</a:t>
-            </a:r>
-          </a:p>
-        </c:rich>
-      </c:tx>
-      <c:layout/>
-      <c:overlay val="0"/>
-    </c:title>
-    <c:autoTitleDeleted val="0"/>
-    <c:plotArea>
-      <c:layout/>
-      <c:barChart>
-        <c:barDir val="bar"/>
-        <c:grouping val="stacked"/>
-        <c:varyColors val="0"/>
-        <c:ser>
-          <c:idx val="0"/>
-          <c:order val="0"/>
-          <c:tx>
-            <c:strRef>
-              <c:f>Sheet1!$B$1</c:f>
-              <c:strCache>
-                <c:ptCount val="1"/>
-                <c:pt idx="0">
-                  <c:v>Baseline</c:v>
-                </c:pt>
-              </c:strCache>
-            </c:strRef>
-          </c:tx>
-          <c:spPr>
-            <a:solidFill>
-              <a:srgbClr val="A9AEB8"/>
-            </a:solidFill>
-            <a:effectLst/>
-          </c:spPr>
-          <c:invertIfNegative val="0"/>
-          <c:dLbls>
-            <c:numFmt formatCode="0&quot;.&quot;0&quot; %&quot;;;" sourceLinked="0"/>
-            <c:txPr>
-              <a:bodyPr/>
-              <a:lstStyle/>
-              <a:p>
-                <a:pPr>
-                  <a:defRPr b="0" i="0" strike="noStrike" sz="1200" u="none">
-                    <a:solidFill>
-                      <a:srgbClr val="FFFFFF"/>
-                    </a:solidFill>
-                    <a:latin typeface="+mn-lt"/>
-                  </a:defRPr>
-                </a:pPr>
-              </a:p>
-            </c:txPr>
-            <c:dLblPos val="inEnd"/>
-            <c:showLegendKey val="0"/>
-            <c:showVal val="1"/>
-            <c:showCatName val="0"/>
-            <c:showSerName val="0"/>
-            <c:showPercent val="0"/>
-            <c:showBubbleSize val="0"/>
-            <c:showLeaderLines val="0"/>
-          </c:dLbls>
-          <c:cat>
-            <c:multiLvlStrRef>
-              <c:f>Sheet1!$A$2:$A$9</c:f>
-              <c:multiLvlStrCache>
-                <c:ptCount val="8"/>
-                <c:lvl>
-                  <c:pt idx="0">
-                    <c:v>Always the same style</c:v>
-                  </c:pt>
-                  <c:pt idx="1">
-                    <c:v>Logistic regression, pixels</c:v>
-                  </c:pt>
-                  <c:pt idx="2">
-                    <c:v>Our MLP, pixels</c:v>
-                  </c:pt>
-                  <c:pt idx="3">
-                    <c:v>Logistic regression, hand-made</c:v>
-                  </c:pt>
-                  <c:pt idx="4">
-                    <c:v>Random forest, hand-made</c:v>
-                  </c:pt>
-                  <c:pt idx="5">
-                    <c:v>ResNet18 frozen + linear head (ours)</c:v>
-                  </c:pt>
-                  <c:pt idx="6">
-                    <c:v>ResNet18 frozen + logistic regression</c:v>
-                  </c:pt>
-                  <c:pt idx="7">
-                    <c:v>ResNet18, layer4 fine-tuned</c:v>
-                  </c:pt>
-                </c:lvl>
-              </c:multiLvlStrCache>
-            </c:multiLvlStrRef>
-          </c:cat>
-          <c:val>
-            <c:numRef>
-              <c:f>Sheet1!$B$2:$B$9</c:f>
-              <c:numCache>
-                <c:formatCode>General</c:formatCode>
-                <c:ptCount val="8"/>
-                <c:pt idx="0">
-                  <c:v>191</c:v>
-                </c:pt>
-                <c:pt idx="1">
-                  <c:v>0</c:v>
-                </c:pt>
-                <c:pt idx="2">
-                  <c:v>0</c:v>
-                </c:pt>
-                <c:pt idx="3">
-                  <c:v>0</c:v>
-                </c:pt>
-                <c:pt idx="4">
-                  <c:v>0</c:v>
-                </c:pt>
-                <c:pt idx="5">
-                  <c:v>0</c:v>
-                </c:pt>
-                <c:pt idx="6">
-                  <c:v>0</c:v>
-                </c:pt>
-                <c:pt idx="7">
-                  <c:v>0</c:v>
-                </c:pt>
-              </c:numCache>
-            </c:numRef>
-          </c:val>
-        </c:ser>
-        <c:ser>
-          <c:idx val="1"/>
-          <c:order val="1"/>
-          <c:tx>
-            <c:strRef>
-              <c:f>Sheet1!$C$1</c:f>
-              <c:strCache>
-                <c:ptCount val="1"/>
-                <c:pt idx="0">
-                  <c:v>Classical</c:v>
-                </c:pt>
-              </c:strCache>
-            </c:strRef>
-          </c:tx>
-          <c:spPr>
-            <a:solidFill>
-              <a:srgbClr val="EB6834"/>
-            </a:solidFill>
-            <a:effectLst/>
-          </c:spPr>
-          <c:invertIfNegative val="0"/>
-          <c:dLbls>
-            <c:numFmt formatCode="0&quot;.&quot;0&quot; %&quot;;;" sourceLinked="0"/>
-            <c:txPr>
-              <a:bodyPr/>
-              <a:lstStyle/>
-              <a:p>
-                <a:pPr>
-                  <a:defRPr b="0" i="0" strike="noStrike" sz="1200" u="none">
-                    <a:solidFill>
-                      <a:srgbClr val="FFFFFF"/>
-                    </a:solidFill>
-                    <a:latin typeface="+mn-lt"/>
-                  </a:defRPr>
-                </a:pPr>
-              </a:p>
-            </c:txPr>
-            <c:dLblPos val="inEnd"/>
-            <c:showLegendKey val="0"/>
-            <c:showVal val="1"/>
-            <c:showCatName val="0"/>
-            <c:showSerName val="0"/>
-            <c:showPercent val="0"/>
-            <c:showBubbleSize val="0"/>
-            <c:showLeaderLines val="0"/>
-          </c:dLbls>
-          <c:cat>
-            <c:multiLvlStrRef>
-              <c:f>Sheet1!$A$2:$A$9</c:f>
-              <c:multiLvlStrCache>
-                <c:ptCount val="8"/>
-                <c:lvl>
-                  <c:pt idx="0">
-                    <c:v>Always the same style</c:v>
-                  </c:pt>
-                  <c:pt idx="1">
-                    <c:v>Logistic regression, pixels</c:v>
-                  </c:pt>
-                  <c:pt idx="2">
-                    <c:v>Our MLP, pixels</c:v>
-                  </c:pt>
-                  <c:pt idx="3">
-                    <c:v>Logistic regression, hand-made</c:v>
-                  </c:pt>
-                  <c:pt idx="4">
-                    <c:v>Random forest, hand-made</c:v>
-                  </c:pt>
-                  <c:pt idx="5">
-                    <c:v>ResNet18 frozen + linear head (ours)</c:v>
-                  </c:pt>
-                  <c:pt idx="6">
-                    <c:v>ResNet18 frozen + logistic regression</c:v>
-                  </c:pt>
-                  <c:pt idx="7">
-                    <c:v>ResNet18, layer4 fine-tuned</c:v>
-                  </c:pt>
-                </c:lvl>
-              </c:multiLvlStrCache>
-            </c:multiLvlStrRef>
-          </c:cat>
-          <c:val>
-            <c:numRef>
-              <c:f>Sheet1!$C$2:$C$9</c:f>
-              <c:numCache>
-                <c:formatCode>General</c:formatCode>
-                <c:ptCount val="8"/>
-                <c:pt idx="0">
-                  <c:v>0</c:v>
-                </c:pt>
-                <c:pt idx="1">
-                  <c:v>327</c:v>
-                </c:pt>
-                <c:pt idx="2">
-                  <c:v>0</c:v>
-                </c:pt>
-                <c:pt idx="3">
-                  <c:v>614</c:v>
-                </c:pt>
-                <c:pt idx="4">
-                  <c:v>673</c:v>
-                </c:pt>
-                <c:pt idx="5">
-                  <c:v>0</c:v>
-                </c:pt>
-                <c:pt idx="6">
-                  <c:v>0</c:v>
-                </c:pt>
-                <c:pt idx="7">
-                  <c:v>0</c:v>
-                </c:pt>
-              </c:numCache>
-            </c:numRef>
-          </c:val>
-        </c:ser>
-        <c:ser>
-          <c:idx val="2"/>
-          <c:order val="2"/>
-          <c:tx>
-            <c:strRef>
-              <c:f>Sheet1!$D$1</c:f>
-              <c:strCache>
-                <c:ptCount val="1"/>
-                <c:pt idx="0">
-                  <c:v>Hybrid</c:v>
-                </c:pt>
-              </c:strCache>
-            </c:strRef>
-          </c:tx>
-          <c:spPr>
-            <a:solidFill>
-              <a:srgbClr val="1BAF7A"/>
-            </a:solidFill>
-            <a:effectLst/>
-          </c:spPr>
-          <c:invertIfNegative val="0"/>
-          <c:dLbls>
-            <c:numFmt formatCode="0&quot;.&quot;0&quot; %&quot;;;" sourceLinked="0"/>
-            <c:txPr>
-              <a:bodyPr/>
-              <a:lstStyle/>
-              <a:p>
-                <a:pPr>
-                  <a:defRPr b="0" i="0" strike="noStrike" sz="1200" u="none">
-                    <a:solidFill>
-                      <a:srgbClr val="FFFFFF"/>
-                    </a:solidFill>
-                    <a:latin typeface="+mn-lt"/>
-                  </a:defRPr>
-                </a:pPr>
-              </a:p>
-            </c:txPr>
-            <c:dLblPos val="inEnd"/>
-            <c:showLegendKey val="0"/>
-            <c:showVal val="1"/>
-            <c:showCatName val="0"/>
-            <c:showSerName val="0"/>
-            <c:showPercent val="0"/>
-            <c:showBubbleSize val="0"/>
-            <c:showLeaderLines val="0"/>
-          </c:dLbls>
-          <c:cat>
-            <c:multiLvlStrRef>
-              <c:f>Sheet1!$A$2:$A$9</c:f>
-              <c:multiLvlStrCache>
-                <c:ptCount val="8"/>
-                <c:lvl>
-                  <c:pt idx="0">
-                    <c:v>Always the same style</c:v>
-                  </c:pt>
-                  <c:pt idx="1">
-                    <c:v>Logistic regression, pixels</c:v>
-                  </c:pt>
-                  <c:pt idx="2">
-                    <c:v>Our MLP, pixels</c:v>
-                  </c:pt>
-                  <c:pt idx="3">
-                    <c:v>Logistic regression, hand-made</c:v>
-                  </c:pt>
-                  <c:pt idx="4">
-                    <c:v>Random forest, hand-made</c:v>
-                  </c:pt>
-                  <c:pt idx="5">
-                    <c:v>ResNet18 frozen + linear head (ours)</c:v>
-                  </c:pt>
-                  <c:pt idx="6">
-                    <c:v>ResNet18 frozen + logistic regression</c:v>
-                  </c:pt>
-                  <c:pt idx="7">
-                    <c:v>ResNet18, layer4 fine-tuned</c:v>
-                  </c:pt>
-                </c:lvl>
-              </c:multiLvlStrCache>
-            </c:multiLvlStrRef>
-          </c:cat>
-          <c:val>
-            <c:numRef>
-              <c:f>Sheet1!$D$2:$D$9</c:f>
-              <c:numCache>
-                <c:formatCode>General</c:formatCode>
-                <c:ptCount val="8"/>
-                <c:pt idx="0">
-                  <c:v>0</c:v>
-                </c:pt>
-                <c:pt idx="1">
-                  <c:v>0</c:v>
-                </c:pt>
-                <c:pt idx="2">
-                  <c:v>0</c:v>
-                </c:pt>
-                <c:pt idx="3">
-                  <c:v>0</c:v>
-                </c:pt>
-                <c:pt idx="4">
-                  <c:v>0</c:v>
-                </c:pt>
-                <c:pt idx="5">
-                  <c:v>0</c:v>
-                </c:pt>
-                <c:pt idx="6">
-                  <c:v>845</c:v>
-                </c:pt>
-                <c:pt idx="7">
-                  <c:v>0</c:v>
-                </c:pt>
-              </c:numCache>
-            </c:numRef>
-          </c:val>
-        </c:ser>
-        <c:ser>
-          <c:idx val="3"/>
-          <c:order val="3"/>
-          <c:tx>
-            <c:strRef>
-              <c:f>Sheet1!$E$1</c:f>
-              <c:strCache>
-                <c:ptCount val="1"/>
-                <c:pt idx="0">
-                  <c:v>Neural</c:v>
-                </c:pt>
-              </c:strCache>
-            </c:strRef>
-          </c:tx>
-          <c:spPr>
-            <a:solidFill>
-              <a:srgbClr val="2A78D6"/>
-            </a:solidFill>
-            <a:effectLst/>
-          </c:spPr>
-          <c:invertIfNegative val="0"/>
-          <c:dLbls>
-            <c:numFmt formatCode="0&quot;.&quot;0&quot; %&quot;;;" sourceLinked="0"/>
-            <c:txPr>
-              <a:bodyPr/>
-              <a:lstStyle/>
-              <a:p>
-                <a:pPr>
-                  <a:defRPr b="0" i="0" strike="noStrike" sz="1200" u="none">
-                    <a:solidFill>
-                      <a:srgbClr val="FFFFFF"/>
-                    </a:solidFill>
-                    <a:latin typeface="+mn-lt"/>
-                  </a:defRPr>
-                </a:pPr>
-              </a:p>
-            </c:txPr>
-            <c:dLblPos val="inEnd"/>
-            <c:showLegendKey val="0"/>
-            <c:showVal val="1"/>
-            <c:showCatName val="0"/>
-            <c:showSerName val="0"/>
-            <c:showPercent val="0"/>
-            <c:showBubbleSize val="0"/>
-            <c:showLeaderLines val="0"/>
-          </c:dLbls>
-          <c:cat>
-            <c:multiLvlStrRef>
-              <c:f>Sheet1!$A$2:$A$9</c:f>
-              <c:multiLvlStrCache>
-                <c:ptCount val="8"/>
-                <c:lvl>
-                  <c:pt idx="0">
-                    <c:v>Always the same style</c:v>
-                  </c:pt>
-                  <c:pt idx="1">
-                    <c:v>Logistic regression, pixels</c:v>
-                  </c:pt>
-                  <c:pt idx="2">
-                    <c:v>Our MLP, pixels</c:v>
-                  </c:pt>
-                  <c:pt idx="3">
-                    <c:v>Logistic regression, hand-made</c:v>
-                  </c:pt>
-                  <c:pt idx="4">
-                    <c:v>Random forest, hand-made</c:v>
-                  </c:pt>
-                  <c:pt idx="5">
-                    <c:v>ResNet18 frozen + linear head (ours)</c:v>
-                  </c:pt>
-                  <c:pt idx="6">
-                    <c:v>ResNet18 frozen + logistic regression</c:v>
-                  </c:pt>
-                  <c:pt idx="7">
-                    <c:v>ResNet18, layer4 fine-tuned</c:v>
-                  </c:pt>
-                </c:lvl>
-              </c:multiLvlStrCache>
-            </c:multiLvlStrRef>
-          </c:cat>
-          <c:val>
-            <c:numRef>
-              <c:f>Sheet1!$E$2:$E$9</c:f>
-              <c:numCache>
-                <c:formatCode>General</c:formatCode>
-                <c:ptCount val="8"/>
-                <c:pt idx="0">
-                  <c:v>0</c:v>
-                </c:pt>
-                <c:pt idx="1">
-                  <c:v>0</c:v>
-                </c:pt>
-                <c:pt idx="2">
-                  <c:v>414</c:v>
-                </c:pt>
-                <c:pt idx="3">
-                  <c:v>0</c:v>
-                </c:pt>
-                <c:pt idx="4">
-                  <c:v>0</c:v>
-                </c:pt>
-                <c:pt idx="5">
-                  <c:v>830</c:v>
-                </c:pt>
-                <c:pt idx="6">
-                  <c:v>0</c:v>
-                </c:pt>
-                <c:pt idx="7">
-                  <c:v>879</c:v>
-                </c:pt>
-              </c:numCache>
-            </c:numRef>
-          </c:val>
-        </c:ser>
-        <c:dLbls>
-          <c:numFmt formatCode="0&quot;.&quot;0&quot; %&quot;;;" sourceLinked="0"/>
-          <c:txPr>
-            <a:bodyPr/>
-            <a:lstStyle/>
-            <a:p>
-              <a:pPr>
-                <a:defRPr b="0" i="0" strike="noStrike" sz="1200" u="none">
-                  <a:solidFill>
-                    <a:srgbClr val="FFFFFF"/>
-                  </a:solidFill>
-                  <a:latin typeface="+mn-lt"/>
-                </a:defRPr>
-              </a:pPr>
-            </a:p>
-          </c:txPr>
-          <c:dLblPos val="inEnd"/>
-          <c:showLegendKey val="0"/>
-          <c:showVal val="1"/>
-          <c:showCatName val="0"/>
-          <c:showSerName val="0"/>
-          <c:showPercent val="0"/>
-          <c:showBubbleSize val="0"/>
-          <c:showLeaderLines val="0"/>
-        </c:dLbls>
-        <c:gapWidth val="35"/>
-        <c:overlap val="100"/>
-        <c:axId val="2094734554"/>
-        <c:axId val="2094734552"/>
-        <c:axId val="2094734556"/>
-      </c:barChart>
-      <c:catAx>
-        <c:axId val="2094734554"/>
-        <c:scaling>
-          <c:orientation val="minMax"/>
-        </c:scaling>
-        <c:delete val="0"/>
-        <c:axPos val="l"/>
-        <c:numFmt formatCode="General" sourceLinked="1"/>
-        <c:majorTickMark val="out"/>
-        <c:minorTickMark val="none"/>
-        <c:tickLblPos val="nextTo"/>
-        <c:spPr>
-          <a:ln w="12700" cap="flat">
-            <a:solidFill>
-              <a:srgbClr val="888888"/>
-            </a:solidFill>
-            <a:prstDash val="solid"/>
-            <a:round/>
-          </a:ln>
-        </c:spPr>
-        <c:txPr>
-          <a:bodyPr/>
-          <a:lstStyle/>
-          <a:p>
-            <a:pPr>
-              <a:defRPr sz="1200" b="0" i="0" u="none" strike="noStrike">
-                <a:solidFill>
-                  <a:srgbClr val="3A3F4B"/>
-                </a:solidFill>
-                <a:latin typeface="+mn-lt"/>
-              </a:defRPr>
-            </a:pPr>
-            <a:endParaRPr lang="en-US"/>
-          </a:p>
-        </c:txPr>
-        <c:crossAx val="2094734552"/>
-        <c:crosses val="autoZero"/>
-        <c:auto val="1"/>
-        <c:lblAlgn val="ctr"/>
-        <c:noMultiLvlLbl val="1"/>
-      </c:catAx>
-      <c:valAx>
-        <c:axId val="2094734552"/>
-        <c:scaling>
-          <c:orientation val="minMax"/>
-          <c:max val="1000"/>
-          <c:min val="0"/>
-        </c:scaling>
-        <c:delete val="1"/>
-        <c:axPos val="b"/>
-        <c:numFmt formatCode="General" sourceLinked="0"/>
-        <c:majorTickMark val="out"/>
-        <c:minorTickMark val="none"/>
-        <c:tickLblPos val="low"/>
-        <c:spPr>
-          <a:ln w="12700" cap="flat">
-            <a:solidFill>
-              <a:srgbClr val="888888"/>
-            </a:solidFill>
-            <a:prstDash val="solid"/>
-            <a:round/>
-          </a:ln>
-        </c:spPr>
-        <c:txPr>
-          <a:bodyPr/>
-          <a:lstStyle/>
-          <a:p>
-            <a:pPr>
-              <a:defRPr sz="1200" b="0" i="0" u="none" strike="noStrike">
-                <a:solidFill>
-                  <a:srgbClr val="000000"/>
-                </a:solidFill>
-                <a:latin typeface="+mn-lt"/>
-              </a:defRPr>
-            </a:pPr>
-            <a:endParaRPr lang="en-US"/>
-          </a:p>
-        </c:txPr>
-        <c:crossAx val="2094734554"/>
-        <c:crosses val="autoZero"/>
-        <c:crossBetween val="between"/>
-      </c:valAx>
-      <c:spPr>
-        <a:noFill/>
-        <a:ln>
-          <a:noFill/>
-        </a:ln>
-        <a:effectLst/>
-      </c:spPr>
-    </c:plotArea>
-    <c:legend>
-      <c:legendPos val="b"/>
-      <c:overlay val="0"/>
-      <c:txPr>
-        <a:bodyPr/>
-        <a:lstStyle/>
-        <a:p>
-          <a:pPr>
-            <a:defRPr sz="1200">
-              <a:latin typeface="+mn-lt"/>
-              <a:cs typeface="+mn-lt"/>
-            </a:defRPr>
-          </a:pPr>
-          <a:endParaRPr lang="en-US"/>
-        </a:p>
-      </c:txPr>
-    </c:legend>
-    <c:plotVisOnly val="1"/>
-    <c:dispBlanksAs val="span"/>
-  </c:chart>
-  <c:spPr>
-    <a:noFill/>
-    <a:ln>
-      <a:noFill/>
-    </a:ln>
-    <a:effectLst/>
-  </c:spPr>
-  <c:externalData r:id="rId1">
-    <c:autoUpdate val="0"/>
-  </c:externalData>
-</c:chartSpace>
-</file>
-
 <file path=ppt/charts/chart5.xml><?xml version="1.0" encoding="utf-8"?>
 <c:chartSpace xmlns:c="http://schemas.openxmlformats.org/drawingml/2006/chart" xmlns:a="http://schemas.openxmlformats.org/drawingml/2006/main" xmlns:r="http://schemas.openxmlformats.org/officeDocument/2006/relationships">
   <c:date1904 val="0"/>
@@ -2647,7 +2371,7 @@
           <a:p>
             <a:r>
               <a:rPr lang="en-US" dirty="0"/>
-              <a:t>On the test, our own MLP reached 41 percent, the best classical model 67, and the frozen ResNet18 83. So, our answer to the director: yes, a neural network is worth it, but a pretrained one that we reuse. We recommend a frozen ResNet18 with a linear head. Why? It is accurate: one visitor in six gets a wrong style, against one in three. It is fast enough for a modest CPU, and cheap for a small team: one small layer, retrained in seconds. We do not recommend our MLP, a classical model alone, or fine-tuning for now. Before the launch, we must test real photos taken at the kiosks, add more styles, and measure the real hardware. Thank you. We are happy to take your questions.</a:t>
+              <a:t>If asked about the random forest: it is our best model without any neural network, the "classical model" of the director's question. A classical model cannot read raw pixels well, so we describe each painting with 102 hand-made numbers: its colours and the directions of its brush strokes. A random forest is 500 decision trees: each one learns from a random draw of the paintings and sees a random part of the numbers at each question, and they vote. Settings chosen on validation. On the test: 67.3 %, 16.4 points below the frozen ResNet18. The same logistic regression goes from 61.4 % on our numbers to 84.5 % on the ResNet features: the features matter more than the model on top.</a:t>
             </a:r>
             <a:endParaRPr lang="en-US" dirty="0"/>
           </a:p>
@@ -2735,7 +2459,7 @@
           <a:p>
             <a:r>
               <a:rPr lang="en-US" dirty="0"/>
-              <a:t>If asked about the random forest: it is our best model without any neural network, the "classical model" of the director's question. A classical model cannot read raw pixels well, so we describe each painting with 102 hand-made numbers: its colours and the directions of its brush strokes. A random forest is 500 decision trees: each one learns from a random draw of the paintings and sees a random part of the numbers at each question, and they vote. Settings chosen on validation. On the test: 67.3 %, 16.4 points below the frozen ResNet18. The same logistic regression goes from 61.4 % on our numbers to 84.5 % on the ResNet features: the features matter more than the model on top.</a:t>
+              <a:t>If asked why we split by painter: we scored the same images twice with cross-validation, changing only one thing: whether the model saw other paintings by the same painter. On images by known painters, seeing the painter gives 83.7 percent instead of 72.3: 11 points of flattery. On the control group, unknown painters, nothing changes. So a random split would have given the director a score that is too optimistic.</a:t>
             </a:r>
             <a:endParaRPr lang="en-US" dirty="0"/>
           </a:p>
@@ -3450,7 +3174,7 @@
           <a:p>
             <a:r>
               <a:rPr lang="en-US" dirty="0"/>
-              <a:t>We took 1 500 paintings from WikiArt, 300 per style. We used the course script with a fixed seed: anyone can download the same images. We cut them into three piles: 1 061 to train, 219 to validate, that is, to choose our settings, and 220 to test, used only once, at the very end. One rule matters a lot: all the paintings of a known painter go to the same pile. With a random split, 23 of our 32 known painters would be in two piles, and a model could learn to recognise Monet instead of Impressionism. With our split: zero.</a:t>
+              <a:t>We took 1 500 paintings from WikiArt, 300 per style. We used the course script with a fixed seed: anyone can download the same images. We cut them into three piles: 1 061 to train, 219 to validate, that is, to choose our settings, and 220 to test, used only once, at the very end. One rule matters a lot: all the paintings of a known painter go to the same pile. With a random split, 23 of our 32 known painters would be in two piles, and a model could learn to recognise Monet instead of Impressionism. With our split: zero. We measured it: when the model has seen the painter, it scores 11 points higher.</a:t>
             </a:r>
           </a:p>
           <a:p>
@@ -3758,7 +3482,7 @@
             </a:pPr>
             <a:r>
               <a:rPr lang="en-US" b="1" dirty="0"/>
-              <a:t>TRANSITION: We saw that ResNet18 reaches 88 percent. But a model this strong could cheat, by recognising the painter instead of the style. So now, we check if it cheats.</a:t>
+              <a:t>TRANSITION: We saw that ResNet18 reaches 88 percent on validation. But to answer the director, we also need a challenger without any neural network. So now, step five: the final test of every model.</a:t>
             </a:r>
             <a:endParaRPr lang="en-US" dirty="0"/>
           </a:p>
@@ -3846,7 +3570,7 @@
           <a:p>
             <a:r>
               <a:rPr lang="en-US" dirty="0"/>
-              <a:t>Remember the painter rule of step one. To measure its effect, we scored the same images twice with cross-validation, and changed only one thing: whether the model had seen other paintings by the same painter. On images by known painters: 83.7 percent when the painter was seen, 72.3 when not. 11 points of flattery. On the control group, the unknown painters, nothing changes. So the model partly recognises painters: a random split would have given the director a score that is too good.</a:t>
+              <a:t>Our classical challenger does not read pixels. We describe each painting with 102 hand-made numbers, its colours and the directions of its brush strokes, and train a random forest on them: 500 small decision trees that vote. Then we opened the 220 test paintings, only once, for every model. The pretrained models are at the top, from 83 to 88 percent. The random forest reaches 67; our MLP 41. Is the gap real? A paired bootstrap on the same test paintings gives our model a lead of 16.4 points over the random forest, between 9 and 24 points: it is not luck. One honest note: the fine-tuned model is first on the test, but it was second on validation. With 220 images, a score moves by about 5 points by chance, so we keep the model chosen before the test.</a:t>
             </a:r>
           </a:p>
           <a:p>
@@ -3857,7 +3581,7 @@
             </a:pPr>
             <a:r>
               <a:rPr lang="en-US" b="1" dirty="0"/>
-              <a:t>TRANSITION: We saw that our split stops this cheating: we can trust our test. But to answer the director, we also need a challenger without any neural network. So now, step five: the final test of every model.</a:t>
+              <a:t>TRANSITION: We saw that the pretrained network is the most accurate. But accuracy is only half of the director's question. So now, step six: what does it cost on a kiosk?</a:t>
             </a:r>
             <a:endParaRPr lang="en-US" dirty="0"/>
           </a:p>
@@ -3945,7 +3669,7 @@
           <a:p>
             <a:r>
               <a:rPr lang="en-US" dirty="0"/>
-              <a:t>Our classical challenger does not read pixels. We describe each painting with 102 hand-made numbers, its colours and the directions of its brush strokes, and train two classic models on them: a logistic regression, and a random forest, 500 small decision trees that vote. Then we opened the 220 test paintings, only once, for every model. The pretrained models are at the top, from 83 to 88 percent. The best classical model, the random forest, reaches 67; our MLP 41. Is the gap real? A paired bootstrap on the same test paintings gives our model a lead of 16.4 points over the random forest, between 9 and 24 points: it is not luck. One honest note: the fine-tuned model is first on the test, but it was second on validation. With 220 images, a score moves by about 5 points by chance, so we keep the model chosen before the test.</a:t>
+              <a:t>We timed one photo at a time, from the image to the answer. The ResNet needs 53 milliseconds on one CPU thread, 26 with four threads: faster than a blink. Even on a kiosk four times slower, it answers in a fifth of a second. The model file is 45 megabytes. And when the collection changes, we only recompute the features and retrain one layer, in seconds.</a:t>
             </a:r>
           </a:p>
           <a:p>
@@ -3956,7 +3680,7 @@
             </a:pPr>
             <a:r>
               <a:rPr lang="en-US" b="1" dirty="0"/>
-              <a:t>TRANSITION: We saw that the pretrained network is the most accurate. But accuracy is only half of the director's question. So now, step six: what does it cost on a kiosk?</a:t>
+              <a:t>TRANSITION: We saw that it is accurate, fast and cheap. So now, we have everything we need to answer the director.</a:t>
             </a:r>
             <a:endParaRPr lang="en-US" dirty="0"/>
           </a:p>
@@ -4044,18 +3768,7 @@
           <a:p>
             <a:r>
               <a:rPr lang="en-US" dirty="0"/>
-              <a:t>We timed one photo at a time, from the image to the answer. The ResNet needs 53 milliseconds on one CPU thread, 26 with four threads: faster than a blink. Even on a kiosk four times slower, it answers in a fifth of a second. The model file is 45 megabytes. And when the collection changes, we only recompute the features and retrain one layer, in seconds.</a:t>
-            </a:r>
-          </a:p>
-          <a:p>
-            <a:pPr>
-              <a:spcBef>
-                <a:spcPts val="900"/>
-              </a:spcBef>
-            </a:pPr>
-            <a:r>
-              <a:rPr lang="en-US" b="1" dirty="0"/>
-              <a:t>TRANSITION: We saw that it is accurate, fast and cheap. So now, we have everything we need to answer the director.</a:t>
+              <a:t>On the test, our own MLP reached 41 percent, the best classical model 67, and the frozen ResNet18 83. So, our answer to the director: yes, a neural network is worth it, but a pretrained one that we reuse. We recommend a frozen ResNet18 with a linear head. Why? It is accurate: one visitor in six gets a wrong style, against one in three. It is fast enough for a modest CPU, and cheap for a small team: one small layer, retrained in seconds. We do not recommend our MLP, a classical model alone, or fine-tuning for now. Before the launch, we must test real photos taken at the kiosks, add more styles, and measure the real hardware. Thank you. We are happy to take your questions.</a:t>
             </a:r>
             <a:endParaRPr lang="en-US" dirty="0"/>
           </a:p>
@@ -5479,10 +5192,10 @@
             <a:r>
               <a:rPr lang="en-US" sz="3000" b="1" dirty="0">
                 <a:solidFill>
-                  <a:schemeClr val="bg1"/>
+                  <a:schemeClr val="tx2"/>
                 </a:solidFill>
               </a:rPr>
-              <a:t>Our choice: frozen ResNet18 + linear head</a:t>
+              <a:t>Backup: the random forest challenger</a:t>
             </a:r>
             <a:endParaRPr lang="en-US" sz="3000" dirty="0"/>
           </a:p>
@@ -5490,14 +5203,207 @@
       </p:sp>
       <p:sp>
         <p:nvSpPr>
-          <p:cNvPr id="3" name="journey"/>
+          <p:cNvPr id="3" name="note 102 hand-made numbers per painting"/>
+          <p:cNvSpPr/>
+          <p:nvPr/>
+        </p:nvSpPr>
+        <p:spPr>
+          <a:xfrm>
+            <a:off x="457200" y="1051560"/>
+            <a:ext cx="4023360" cy="1600200"/>
+          </a:xfrm>
+          <a:prstGeom prst="roundRect">
+            <a:avLst>
+              <a:gd name="adj" fmla="val 4571"/>
+            </a:avLst>
+          </a:prstGeom>
+          <a:solidFill>
+            <a:schemeClr val="bg2"/>
+          </a:solidFill>
+          <a:ln w="12700">
+            <a:solidFill>
+              <a:schemeClr val="bg2"/>
+            </a:solidFill>
+            <a:prstDash val="solid"/>
+          </a:ln>
+        </p:spPr>
+      </p:sp>
+      <p:sp>
+        <p:nvSpPr>
+          <p:cNvPr id="4" name="text 102 hand-made numbers per painting"/>
           <p:cNvSpPr txBox="1"/>
           <p:nvPr/>
         </p:nvSpPr>
         <p:spPr>
           <a:xfrm>
-            <a:off x="457200" y="1051560"/>
-            <a:ext cx="8229600" cy="365760"/>
+            <a:off x="621792" y="1161288"/>
+            <a:ext cx="3694176" cy="1380744"/>
+          </a:xfrm>
+          <a:prstGeom prst="rect">
+            <a:avLst/>
+          </a:prstGeom>
+          <a:noFill/>
+          <a:ln/>
+        </p:spPr>
+        <p:txBody>
+          <a:bodyPr wrap="square" lIns="0" tIns="0" rIns="0" bIns="0" rtlCol="0" anchor="t"/>
+          <a:lstStyle/>
+          <a:p>
+            <a:pPr indent="0" marL="0">
+              <a:spcAft>
+                <a:spcPts val="400"/>
+              </a:spcAft>
+              <a:buNone/>
+            </a:pPr>
+            <a:r>
+              <a:rPr lang="en-US" sz="1500" b="1" dirty="0">
+                <a:solidFill>
+                  <a:schemeClr val="tx2"/>
+                </a:solidFill>
+              </a:rPr>
+              <a:t>102 hand-made numbers per painting</a:t>
+            </a:r>
+            <a:endParaRPr lang="en-US" sz="1500" dirty="0"/>
+          </a:p>
+          <a:p>
+            <a:pPr indent="0" marL="0">
+              <a:spcAft>
+                <a:spcPts val="400"/>
+              </a:spcAft>
+              <a:buNone/>
+            </a:pPr>
+            <a:r>
+              <a:rPr lang="en-US" sz="1400" dirty="0">
+                <a:solidFill>
+                  <a:schemeClr val="tx1"/>
+                </a:solidFill>
+              </a:rPr>
+              <a:t>Colours: a histogram of hue, saturation and brightness (72) and colour statistics (10). Brush strokes: direction and strength of the edges, at two sizes (20).</a:t>
+            </a:r>
+            <a:endParaRPr lang="en-US" sz="1500" dirty="0"/>
+          </a:p>
+        </p:txBody>
+      </p:sp>
+      <p:sp>
+        <p:nvSpPr>
+          <p:cNvPr id="5" name="note 500 decision trees that vote"/>
+          <p:cNvSpPr/>
+          <p:nvPr/>
+        </p:nvSpPr>
+        <p:spPr>
+          <a:xfrm>
+            <a:off x="4663440" y="1051560"/>
+            <a:ext cx="4023360" cy="1600200"/>
+          </a:xfrm>
+          <a:prstGeom prst="roundRect">
+            <a:avLst>
+              <a:gd name="adj" fmla="val 4571"/>
+            </a:avLst>
+          </a:prstGeom>
+          <a:solidFill>
+            <a:schemeClr val="bg2"/>
+          </a:solidFill>
+          <a:ln w="12700">
+            <a:solidFill>
+              <a:schemeClr val="bg2"/>
+            </a:solidFill>
+            <a:prstDash val="solid"/>
+          </a:ln>
+        </p:spPr>
+      </p:sp>
+      <p:sp>
+        <p:nvSpPr>
+          <p:cNvPr id="6" name="text 500 decision trees that vote"/>
+          <p:cNvSpPr txBox="1"/>
+          <p:nvPr/>
+        </p:nvSpPr>
+        <p:spPr>
+          <a:xfrm>
+            <a:off x="4828032" y="1161288"/>
+            <a:ext cx="3694176" cy="1380744"/>
+          </a:xfrm>
+          <a:prstGeom prst="rect">
+            <a:avLst/>
+          </a:prstGeom>
+          <a:noFill/>
+          <a:ln/>
+        </p:spPr>
+        <p:txBody>
+          <a:bodyPr wrap="square" lIns="0" tIns="0" rIns="0" bIns="0" rtlCol="0" anchor="t"/>
+          <a:lstStyle/>
+          <a:p>
+            <a:pPr indent="0" marL="0">
+              <a:spcAft>
+                <a:spcPts val="400"/>
+              </a:spcAft>
+              <a:buNone/>
+            </a:pPr>
+            <a:r>
+              <a:rPr lang="en-US" sz="1500" b="1" dirty="0">
+                <a:solidFill>
+                  <a:schemeClr val="tx2"/>
+                </a:solidFill>
+              </a:rPr>
+              <a:t>500 decision trees that vote</a:t>
+            </a:r>
+            <a:endParaRPr lang="en-US" sz="1500" dirty="0"/>
+          </a:p>
+          <a:p>
+            <a:pPr indent="0" marL="0">
+              <a:spcAft>
+                <a:spcPts val="400"/>
+              </a:spcAft>
+              <a:buNone/>
+            </a:pPr>
+            <a:r>
+              <a:rPr lang="en-US" sz="1400" dirty="0">
+                <a:solidFill>
+                  <a:schemeClr val="tx1"/>
+                </a:solidFill>
+              </a:rPr>
+              <a:t>Each tree learns from a random draw of the training paintings and sees 10 of the 102 numbers at each question. Their mistakes differ, so the vote cancels them.</a:t>
+            </a:r>
+            <a:endParaRPr lang="en-US" sz="1500" dirty="0"/>
+          </a:p>
+        </p:txBody>
+      </p:sp>
+      <p:sp>
+        <p:nvSpPr>
+          <p:cNvPr id="7" name="card 32.7 %"/>
+          <p:cNvSpPr/>
+          <p:nvPr/>
+        </p:nvSpPr>
+        <p:spPr>
+          <a:xfrm>
+            <a:off x="457200" y="2834640"/>
+            <a:ext cx="1874520" cy="1463040"/>
+          </a:xfrm>
+          <a:prstGeom prst="roundRect">
+            <a:avLst>
+              <a:gd name="adj" fmla="val 5000"/>
+            </a:avLst>
+          </a:prstGeom>
+          <a:solidFill>
+            <a:schemeClr val="bg2"/>
+          </a:solidFill>
+          <a:ln w="12700">
+            <a:solidFill>
+              <a:schemeClr val="bg2"/>
+            </a:solidFill>
+            <a:prstDash val="solid"/>
+          </a:ln>
+        </p:spPr>
+      </p:sp>
+      <p:sp>
+        <p:nvSpPr>
+          <p:cNvPr id="8" name="value 32.7 %"/>
+          <p:cNvSpPr txBox="1"/>
+          <p:nvPr/>
+        </p:nvSpPr>
+        <p:spPr>
+          <a:xfrm>
+            <a:off x="640080" y="2971800"/>
+            <a:ext cx="1508760" cy="731520"/>
           </a:xfrm>
           <a:prstGeom prst="rect">
             <a:avLst/>
@@ -5509,97 +5415,34 @@
           <a:bodyPr wrap="square" lIns="0" tIns="0" rIns="0" bIns="0" rtlCol="0" anchor="ctr"/>
           <a:lstStyle/>
           <a:p>
-            <a:pPr algn="ctr" indent="0" marL="0">
-              <a:buNone/>
-            </a:pPr>
-            <a:r>
-              <a:rPr lang="en-US" sz="1400" dirty="0">
-                <a:solidFill>
-                  <a:srgbClr val="C9CED8"/>
-                </a:solidFill>
-              </a:rPr>
-              <a:t>Test, 220 new paintings:  our MLP 41.4 %  →  best classical 67.3 %  →  frozen ResNet18 83.0 %</a:t>
-            </a:r>
-            <a:endParaRPr lang="en-US" sz="1400" dirty="0"/>
-          </a:p>
-        </p:txBody>
-      </p:sp>
-      <p:sp>
-        <p:nvSpPr>
-          <p:cNvPr id="4" name="column Why"/>
-          <p:cNvSpPr/>
-          <p:nvPr/>
-        </p:nvSpPr>
-        <p:spPr>
-          <a:xfrm>
-            <a:off x="457200" y="1600200"/>
-            <a:ext cx="2560320" cy="2880360"/>
-          </a:xfrm>
-          <a:prstGeom prst="roundRect">
-            <a:avLst>
-              <a:gd name="adj" fmla="val 2857"/>
-            </a:avLst>
-          </a:prstGeom>
-          <a:solidFill>
-            <a:srgbClr val="2A3448"/>
-          </a:solidFill>
-          <a:ln w="12700">
-            <a:solidFill>
-              <a:srgbClr val="2A3448"/>
-            </a:solidFill>
-            <a:prstDash val="solid"/>
-          </a:ln>
-        </p:spPr>
-      </p:sp>
-      <p:sp>
-        <p:nvSpPr>
-          <p:cNvPr id="5" name="head Why"/>
-          <p:cNvSpPr txBox="1"/>
-          <p:nvPr/>
-        </p:nvSpPr>
-        <p:spPr>
-          <a:xfrm>
-            <a:off x="640080" y="1719072"/>
-            <a:ext cx="2194560" cy="411480"/>
-          </a:xfrm>
-          <a:prstGeom prst="rect">
-            <a:avLst/>
-          </a:prstGeom>
-          <a:noFill/>
-          <a:ln/>
-        </p:spPr>
-        <p:txBody>
-          <a:bodyPr wrap="square" lIns="0" tIns="0" rIns="0" bIns="0" rtlCol="0" anchor="ctr"/>
-          <a:lstStyle/>
-          <a:p>
             <a:pPr indent="0" marL="0">
               <a:buNone/>
             </a:pPr>
             <a:r>
-              <a:rPr lang="en-US" sz="2000" b="1" dirty="0">
-                <a:solidFill>
-                  <a:schemeClr val="accent3"/>
+              <a:rPr lang="en-US" sz="3000" b="1" dirty="0">
+                <a:solidFill>
+                  <a:schemeClr val="tx2"/>
                 </a:solidFill>
                 <a:latin typeface="Cambria" pitchFamily="34" charset="0"/>
                 <a:ea typeface="Cambria" pitchFamily="34" charset="-122"/>
                 <a:cs typeface="Cambria" pitchFamily="34" charset="-120"/>
               </a:rPr>
-              <a:t>Why</a:t>
-            </a:r>
-            <a:endParaRPr lang="en-US" sz="2000" dirty="0"/>
+              <a:t>32.7 %</a:t>
+            </a:r>
+            <a:endParaRPr lang="en-US" sz="3000" dirty="0"/>
           </a:p>
         </p:txBody>
       </p:sp>
       <p:sp>
         <p:nvSpPr>
-          <p:cNvPr id="6" name="items Why"/>
+          <p:cNvPr id="9" name="caption 32.7 %"/>
           <p:cNvSpPr txBox="1"/>
           <p:nvPr/>
         </p:nvSpPr>
         <p:spPr>
           <a:xfrm>
-            <a:off x="640080" y="2212848"/>
-            <a:ext cx="2240280" cy="2194560"/>
+            <a:off x="640080" y="3749040"/>
+            <a:ext cx="1508760" cy="411480"/>
           </a:xfrm>
           <a:prstGeom prst="rect">
             <a:avLst/>
@@ -5611,83 +5454,43 @@
           <a:bodyPr wrap="square" lIns="0" tIns="0" rIns="0" bIns="0" rtlCol="0" anchor="t"/>
           <a:lstStyle/>
           <a:p>
-            <a:pPr marL="342900" indent="-342900">
-              <a:spcAft>
-                <a:spcPts val="800"/>
-              </a:spcAft>
-              <a:buSzPct val="100000"/>
-              <a:buChar char="•"/>
-            </a:pPr>
-            <a:r>
-              <a:rPr lang="en-US" sz="1400" dirty="0">
-                <a:solidFill>
-                  <a:schemeClr val="bg1"/>
+            <a:pPr indent="0" marL="0">
+              <a:buNone/>
+            </a:pPr>
+            <a:r>
+              <a:rPr lang="en-US" sz="1200" dirty="0">
+                <a:solidFill>
+                  <a:schemeClr val="tx1"/>
                 </a:solidFill>
               </a:rPr>
-              <a:t>1 visitor in 6 gets a wrong style, against 1 in 3 with the best classical model</a:t>
-            </a:r>
-            <a:endParaRPr lang="en-US" sz="1400" dirty="0"/>
-          </a:p>
-          <a:p>
-            <a:pPr marL="342900" indent="-342900">
-              <a:spcAft>
-                <a:spcPts val="800"/>
-              </a:spcAft>
-              <a:buSzPct val="100000"/>
-              <a:buChar char="•"/>
-            </a:pPr>
-            <a:r>
-              <a:rPr lang="en-US" sz="1400" dirty="0">
-                <a:solidFill>
-                  <a:schemeClr val="bg1"/>
-                </a:solidFill>
-              </a:rPr>
-              <a:t>53 ms per photo on a modest CPU</a:t>
-            </a:r>
-            <a:endParaRPr lang="en-US" sz="1400" dirty="0"/>
-          </a:p>
-          <a:p>
-            <a:pPr marL="342900" indent="-342900">
-              <a:spcAft>
-                <a:spcPts val="800"/>
-              </a:spcAft>
-              <a:buSzPct val="100000"/>
-              <a:buChar char="•"/>
-            </a:pPr>
-            <a:r>
-              <a:rPr lang="en-US" sz="1400" dirty="0">
-                <a:solidFill>
-                  <a:schemeClr val="bg1"/>
-                </a:solidFill>
-              </a:rPr>
-              <a:t>Retrained in seconds when the collection changes</a:t>
-            </a:r>
-            <a:endParaRPr lang="en-US" sz="1400" dirty="0"/>
+              <a:t>Logistic regression on pixels</a:t>
+            </a:r>
+            <a:endParaRPr lang="en-US" sz="1200" dirty="0"/>
           </a:p>
         </p:txBody>
       </p:sp>
       <p:sp>
         <p:nvSpPr>
-          <p:cNvPr id="7" name="column Not now"/>
+          <p:cNvPr id="10" name="card 61.4 %"/>
           <p:cNvSpPr/>
           <p:nvPr/>
         </p:nvSpPr>
         <p:spPr>
           <a:xfrm>
-            <a:off x="3291840" y="1600200"/>
-            <a:ext cx="2560320" cy="2880360"/>
+            <a:off x="2575590" y="2834640"/>
+            <a:ext cx="1874520" cy="1463040"/>
           </a:xfrm>
           <a:prstGeom prst="roundRect">
             <a:avLst>
-              <a:gd name="adj" fmla="val 2857"/>
+              <a:gd name="adj" fmla="val 5000"/>
             </a:avLst>
           </a:prstGeom>
           <a:solidFill>
-            <a:srgbClr val="2A3448"/>
+            <a:schemeClr val="bg2"/>
           </a:solidFill>
           <a:ln w="12700">
             <a:solidFill>
-              <a:srgbClr val="2A3448"/>
+              <a:schemeClr val="bg2"/>
             </a:solidFill>
             <a:prstDash val="solid"/>
           </a:ln>
@@ -5695,14 +5498,14 @@
       </p:sp>
       <p:sp>
         <p:nvSpPr>
-          <p:cNvPr id="8" name="head Not now"/>
+          <p:cNvPr id="11" name="value 61.4 %"/>
           <p:cNvSpPr txBox="1"/>
           <p:nvPr/>
         </p:nvSpPr>
         <p:spPr>
           <a:xfrm>
-            <a:off x="3474720" y="1719072"/>
-            <a:ext cx="2194560" cy="411480"/>
+            <a:off x="2758470" y="2971800"/>
+            <a:ext cx="1508760" cy="731520"/>
           </a:xfrm>
           <a:prstGeom prst="rect">
             <a:avLst/>
@@ -5718,30 +5521,30 @@
               <a:buNone/>
             </a:pPr>
             <a:r>
-              <a:rPr lang="en-US" sz="2000" b="1" dirty="0">
-                <a:solidFill>
-                  <a:schemeClr val="accent2"/>
+              <a:rPr lang="en-US" sz="3000" b="1" dirty="0">
+                <a:solidFill>
+                  <a:schemeClr val="tx2"/>
                 </a:solidFill>
                 <a:latin typeface="Cambria" pitchFamily="34" charset="0"/>
                 <a:ea typeface="Cambria" pitchFamily="34" charset="-122"/>
                 <a:cs typeface="Cambria" pitchFamily="34" charset="-120"/>
               </a:rPr>
-              <a:t>Not now</a:t>
-            </a:r>
-            <a:endParaRPr lang="en-US" sz="2000" dirty="0"/>
+              <a:t>61.4 %</a:t>
+            </a:r>
+            <a:endParaRPr lang="en-US" sz="3000" dirty="0"/>
           </a:p>
         </p:txBody>
       </p:sp>
       <p:sp>
         <p:nvSpPr>
-          <p:cNvPr id="9" name="items Not now"/>
+          <p:cNvPr id="12" name="caption 61.4 %"/>
           <p:cNvSpPr txBox="1"/>
           <p:nvPr/>
         </p:nvSpPr>
         <p:spPr>
           <a:xfrm>
-            <a:off x="3474720" y="2212848"/>
-            <a:ext cx="2240280" cy="2194560"/>
+            <a:off x="2758470" y="3749040"/>
+            <a:ext cx="1508760" cy="411480"/>
           </a:xfrm>
           <a:prstGeom prst="rect">
             <a:avLst/>
@@ -5753,83 +5556,43 @@
           <a:bodyPr wrap="square" lIns="0" tIns="0" rIns="0" bIns="0" rtlCol="0" anchor="t"/>
           <a:lstStyle/>
           <a:p>
-            <a:pPr marL="342900" indent="-342900">
-              <a:spcAft>
-                <a:spcPts val="800"/>
-              </a:spcAft>
-              <a:buSzPct val="100000"/>
-              <a:buChar char="•"/>
-            </a:pPr>
-            <a:r>
-              <a:rPr lang="en-US" sz="1400" dirty="0">
-                <a:solidFill>
-                  <a:schemeClr val="bg1"/>
+            <a:pPr indent="0" marL="0">
+              <a:buNone/>
+            </a:pPr>
+            <a:r>
+              <a:rPr lang="en-US" sz="1200" dirty="0">
+                <a:solidFill>
+                  <a:schemeClr val="tx1"/>
                 </a:solidFill>
               </a:rPr>
-              <a:t>Our MLP on pixels: 41 %</a:t>
-            </a:r>
-            <a:endParaRPr lang="en-US" sz="1400" dirty="0"/>
-          </a:p>
-          <a:p>
-            <a:pPr marL="342900" indent="-342900">
-              <a:spcAft>
-                <a:spcPts val="800"/>
-              </a:spcAft>
-              <a:buSzPct val="100000"/>
-              <a:buChar char="•"/>
-            </a:pPr>
-            <a:r>
-              <a:rPr lang="en-US" sz="1400" dirty="0">
-                <a:solidFill>
-                  <a:schemeClr val="bg1"/>
-                </a:solidFill>
-              </a:rPr>
-              <a:t>A classical model alone: 61 to 67 %</a:t>
-            </a:r>
-            <a:endParaRPr lang="en-US" sz="1400" dirty="0"/>
-          </a:p>
-          <a:p>
-            <a:pPr marL="342900" indent="-342900">
-              <a:spcAft>
-                <a:spcPts val="800"/>
-              </a:spcAft>
-              <a:buSzPct val="100000"/>
-              <a:buChar char="•"/>
-            </a:pPr>
-            <a:r>
-              <a:rPr lang="en-US" sz="1400" dirty="0">
-                <a:solidFill>
-                  <a:schemeClr val="bg1"/>
-                </a:solidFill>
-              </a:rPr>
-              <a:t>Fine-tuning: slower, not proven better</a:t>
-            </a:r>
-            <a:endParaRPr lang="en-US" sz="1400" dirty="0"/>
+              <a:t>Logistic regression on the 102 numbers</a:t>
+            </a:r>
+            <a:endParaRPr lang="en-US" sz="1200" dirty="0"/>
           </a:p>
         </p:txBody>
       </p:sp>
       <p:sp>
         <p:nvSpPr>
-          <p:cNvPr id="10" name="column Before launch"/>
+          <p:cNvPr id="13" name="card 67.3 %"/>
           <p:cNvSpPr/>
           <p:nvPr/>
         </p:nvSpPr>
         <p:spPr>
           <a:xfrm>
-            <a:off x="6126480" y="1600200"/>
-            <a:ext cx="2560320" cy="2880360"/>
+            <a:off x="4693981" y="2834640"/>
+            <a:ext cx="1874520" cy="1463040"/>
           </a:xfrm>
           <a:prstGeom prst="roundRect">
             <a:avLst>
-              <a:gd name="adj" fmla="val 2857"/>
+              <a:gd name="adj" fmla="val 5000"/>
             </a:avLst>
           </a:prstGeom>
           <a:solidFill>
-            <a:srgbClr val="2A3448"/>
+            <a:schemeClr val="bg2"/>
           </a:solidFill>
           <a:ln w="12700">
             <a:solidFill>
-              <a:srgbClr val="2A3448"/>
+              <a:schemeClr val="bg2"/>
             </a:solidFill>
             <a:prstDash val="solid"/>
           </a:ln>
@@ -5837,14 +5600,14 @@
       </p:sp>
       <p:sp>
         <p:nvSpPr>
-          <p:cNvPr id="11" name="head Before launch"/>
+          <p:cNvPr id="14" name="value 67.3 %"/>
           <p:cNvSpPr txBox="1"/>
           <p:nvPr/>
         </p:nvSpPr>
         <p:spPr>
           <a:xfrm>
-            <a:off x="6309360" y="1719072"/>
-            <a:ext cx="2194560" cy="411480"/>
+            <a:off x="4876861" y="2971800"/>
+            <a:ext cx="1508760" cy="731520"/>
           </a:xfrm>
           <a:prstGeom prst="rect">
             <a:avLst/>
@@ -5860,30 +5623,30 @@
               <a:buNone/>
             </a:pPr>
             <a:r>
-              <a:rPr lang="en-US" sz="2000" b="1" dirty="0">
-                <a:solidFill>
-                  <a:schemeClr val="accent4"/>
+              <a:rPr lang="en-US" sz="3000" b="1" dirty="0">
+                <a:solidFill>
+                  <a:srgbClr val="EB6834"/>
                 </a:solidFill>
                 <a:latin typeface="Cambria" pitchFamily="34" charset="0"/>
                 <a:ea typeface="Cambria" pitchFamily="34" charset="-122"/>
                 <a:cs typeface="Cambria" pitchFamily="34" charset="-120"/>
               </a:rPr>
-              <a:t>Before launch</a:t>
-            </a:r>
-            <a:endParaRPr lang="en-US" sz="2000" dirty="0"/>
+              <a:t>67.3 %</a:t>
+            </a:r>
+            <a:endParaRPr lang="en-US" sz="3000" dirty="0"/>
           </a:p>
         </p:txBody>
       </p:sp>
       <p:sp>
         <p:nvSpPr>
-          <p:cNvPr id="12" name="items Before launch"/>
+          <p:cNvPr id="15" name="caption 67.3 %"/>
           <p:cNvSpPr txBox="1"/>
           <p:nvPr/>
         </p:nvSpPr>
         <p:spPr>
           <a:xfrm>
-            <a:off x="6309360" y="2212848"/>
-            <a:ext cx="2240280" cy="2194560"/>
+            <a:off x="4876861" y="3749040"/>
+            <a:ext cx="1508760" cy="411480"/>
           </a:xfrm>
           <a:prstGeom prst="rect">
             <a:avLst/>
@@ -5895,58 +5658,156 @@
           <a:bodyPr wrap="square" lIns="0" tIns="0" rIns="0" bIns="0" rtlCol="0" anchor="t"/>
           <a:lstStyle/>
           <a:p>
-            <a:pPr marL="342900" indent="-342900">
-              <a:spcAft>
-                <a:spcPts val="800"/>
-              </a:spcAft>
-              <a:buSzPct val="100000"/>
-              <a:buChar char="•"/>
-            </a:pPr>
-            <a:r>
-              <a:rPr lang="en-US" sz="1400" dirty="0">
+            <a:pPr indent="0" marL="0">
+              <a:buNone/>
+            </a:pPr>
+            <a:r>
+              <a:rPr lang="en-US" sz="1200" dirty="0">
+                <a:solidFill>
+                  <a:schemeClr val="tx1"/>
+                </a:solidFill>
+              </a:rPr>
+              <a:t>Random forest on the 102 numbers</a:t>
+            </a:r>
+            <a:endParaRPr lang="en-US" sz="1200" dirty="0"/>
+          </a:p>
+        </p:txBody>
+      </p:sp>
+      <p:sp>
+        <p:nvSpPr>
+          <p:cNvPr id="16" name="card 83.0 %"/>
+          <p:cNvSpPr/>
+          <p:nvPr/>
+        </p:nvSpPr>
+        <p:spPr>
+          <a:xfrm>
+            <a:off x="6812371" y="2834640"/>
+            <a:ext cx="1874520" cy="1463040"/>
+          </a:xfrm>
+          <a:prstGeom prst="roundRect">
+            <a:avLst>
+              <a:gd name="adj" fmla="val 5000"/>
+            </a:avLst>
+          </a:prstGeom>
+          <a:solidFill>
+            <a:schemeClr val="accent1"/>
+          </a:solidFill>
+          <a:ln w="12700">
+            <a:solidFill>
+              <a:schemeClr val="accent1"/>
+            </a:solidFill>
+            <a:prstDash val="solid"/>
+          </a:ln>
+        </p:spPr>
+      </p:sp>
+      <p:sp>
+        <p:nvSpPr>
+          <p:cNvPr id="17" name="value 83.0 %"/>
+          <p:cNvSpPr txBox="1"/>
+          <p:nvPr/>
+        </p:nvSpPr>
+        <p:spPr>
+          <a:xfrm>
+            <a:off x="6995251" y="2971800"/>
+            <a:ext cx="1508760" cy="731520"/>
+          </a:xfrm>
+          <a:prstGeom prst="rect">
+            <a:avLst/>
+          </a:prstGeom>
+          <a:noFill/>
+          <a:ln/>
+        </p:spPr>
+        <p:txBody>
+          <a:bodyPr wrap="square" lIns="0" tIns="0" rIns="0" bIns="0" rtlCol="0" anchor="ctr"/>
+          <a:lstStyle/>
+          <a:p>
+            <a:pPr indent="0" marL="0">
+              <a:buNone/>
+            </a:pPr>
+            <a:r>
+              <a:rPr lang="en-US" sz="3000" b="1" dirty="0">
                 <a:solidFill>
                   <a:schemeClr val="bg1"/>
                 </a:solidFill>
+                <a:latin typeface="Cambria" pitchFamily="34" charset="0"/>
+                <a:ea typeface="Cambria" pitchFamily="34" charset="-122"/>
+                <a:cs typeface="Cambria" pitchFamily="34" charset="-120"/>
               </a:rPr>
-              <a:t>Test a few hundred real kiosk photos</a:t>
-            </a:r>
-            <a:endParaRPr lang="en-US" sz="1400" dirty="0"/>
-          </a:p>
-          <a:p>
-            <a:pPr marL="342900" indent="-342900">
-              <a:spcAft>
-                <a:spcPts val="800"/>
-              </a:spcAft>
-              <a:buSzPct val="100000"/>
-              <a:buChar char="•"/>
-            </a:pPr>
-            <a:r>
-              <a:rPr lang="en-US" sz="1400" dirty="0">
+              <a:t>83.0 %</a:t>
+            </a:r>
+            <a:endParaRPr lang="en-US" sz="3000" dirty="0"/>
+          </a:p>
+        </p:txBody>
+      </p:sp>
+      <p:sp>
+        <p:nvSpPr>
+          <p:cNvPr id="18" name="caption 83.0 %"/>
+          <p:cNvSpPr txBox="1"/>
+          <p:nvPr/>
+        </p:nvSpPr>
+        <p:spPr>
+          <a:xfrm>
+            <a:off x="6995251" y="3749040"/>
+            <a:ext cx="1508760" cy="411480"/>
+          </a:xfrm>
+          <a:prstGeom prst="rect">
+            <a:avLst/>
+          </a:prstGeom>
+          <a:noFill/>
+          <a:ln/>
+        </p:spPr>
+        <p:txBody>
+          <a:bodyPr wrap="square" lIns="0" tIns="0" rIns="0" bIns="0" rtlCol="0" anchor="t"/>
+          <a:lstStyle/>
+          <a:p>
+            <a:pPr indent="0" marL="0">
+              <a:buNone/>
+            </a:pPr>
+            <a:r>
+              <a:rPr lang="en-US" sz="1200" dirty="0">
                 <a:solidFill>
                   <a:schemeClr val="bg1"/>
                 </a:solidFill>
               </a:rPr>
-              <a:t>Add more styles and paintings</a:t>
-            </a:r>
-            <a:endParaRPr lang="en-US" sz="1400" dirty="0"/>
-          </a:p>
-          <a:p>
-            <a:pPr marL="342900" indent="-342900">
-              <a:spcAft>
-                <a:spcPts val="800"/>
-              </a:spcAft>
-              <a:buSzPct val="100000"/>
-              <a:buChar char="•"/>
-            </a:pPr>
-            <a:r>
-              <a:rPr lang="en-US" sz="1400" dirty="0">
-                <a:solidFill>
-                  <a:schemeClr val="bg1"/>
+              <a:t>ResNet18 frozen + linear head (ours)</a:t>
+            </a:r>
+            <a:endParaRPr lang="en-US" sz="1200" dirty="0"/>
+          </a:p>
+        </p:txBody>
+      </p:sp>
+      <p:sp>
+        <p:nvSpPr>
+          <p:cNvPr id="19" name="forest caption"/>
+          <p:cNvSpPr txBox="1"/>
+          <p:nvPr/>
+        </p:nvSpPr>
+        <p:spPr>
+          <a:xfrm>
+            <a:off x="457200" y="4370832"/>
+            <a:ext cx="8229600" cy="320040"/>
+          </a:xfrm>
+          <a:prstGeom prst="rect">
+            <a:avLst/>
+          </a:prstGeom>
+          <a:noFill/>
+          <a:ln/>
+        </p:spPr>
+        <p:txBody>
+          <a:bodyPr wrap="square" lIns="0" tIns="0" rIns="0" bIns="0" rtlCol="0" anchor="t"/>
+          <a:lstStyle/>
+          <a:p>
+            <a:pPr indent="0" marL="0">
+              <a:buNone/>
+            </a:pPr>
+            <a:r>
+              <a:rPr lang="en-US" sz="1200" dirty="0">
+                <a:solidFill>
+                  <a:srgbClr val="5F6473"/>
                 </a:solidFill>
               </a:rPr>
-              <a:t>Measure the real kiosk hardware</a:t>
-            </a:r>
-            <a:endParaRPr lang="en-US" sz="1400" dirty="0"/>
+              <a:t>Test accuracy, 220 paintings. Best of 4 settings on validation: 63.5 %. Training 1 s, 24 ms per photo, 26 MB.</a:t>
+            </a:r>
+            <a:endParaRPr lang="en-US" sz="1200" dirty="0"/>
           </a:p>
         </p:txBody>
       </p:sp>
@@ -5980,7 +5841,7 @@
             <a:lvl1pPr>
               <a:defRPr sz="1000">
                 <a:solidFill>
-                  <a:srgbClr val="C9CED8"/>
+                  <a:srgbClr val="5F6473"/>
                 </a:solidFill>
               </a:defRPr>
             </a:lvl1pPr>
@@ -6052,498 +5913,42 @@
                   <a:schemeClr val="tx2"/>
                 </a:solidFill>
               </a:rPr>
-              <a:t>Backup: the random forest challenger</a:t>
+              <a:t>Backup: seeing the painter inflates the score</a:t>
             </a:r>
             <a:endParaRPr lang="en-US" sz="3000" dirty="0"/>
           </a:p>
         </p:txBody>
       </p:sp>
-      <p:sp>
-        <p:nvSpPr>
-          <p:cNvPr id="3" name="note 102 hand-made numbers per painting"/>
+      <p:graphicFrame>
+        <p:nvGraphicFramePr>
+          <p:cNvPr id="3" name="chart leakage" descr=""/>
+          <p:cNvGraphicFramePr/>
+          <p:nvPr/>
+        </p:nvGraphicFramePr>
+        <p:xfrm>
+          <a:off x="365760" y="1005840"/>
+          <a:ext cx="5120640" cy="3611880"/>
+        </p:xfrm>
+        <a:graphic xmlns:a="http://schemas.openxmlformats.org/drawingml/2006/main">
+          <a:graphicData uri="http://schemas.openxmlformats.org/drawingml/2006/chart">
+            <c:chart xmlns:c="http://schemas.openxmlformats.org/drawingml/2006/chart" r:id="rId1"/>
+          </a:graphicData>
+        </a:graphic>
+      </p:graphicFrame>
+      <p:sp>
+        <p:nvSpPr>
+          <p:cNvPr id="4" name="card +11.4"/>
           <p:cNvSpPr/>
           <p:nvPr/>
         </p:nvSpPr>
         <p:spPr>
           <a:xfrm>
-            <a:off x="457200" y="1051560"/>
-            <a:ext cx="4023360" cy="1600200"/>
+            <a:off x="5760720" y="1051560"/>
+            <a:ext cx="2926080" cy="1600200"/>
           </a:xfrm>
           <a:prstGeom prst="roundRect">
             <a:avLst>
               <a:gd name="adj" fmla="val 4571"/>
-            </a:avLst>
-          </a:prstGeom>
-          <a:solidFill>
-            <a:schemeClr val="bg2"/>
-          </a:solidFill>
-          <a:ln w="12700">
-            <a:solidFill>
-              <a:schemeClr val="bg2"/>
-            </a:solidFill>
-            <a:prstDash val="solid"/>
-          </a:ln>
-        </p:spPr>
-      </p:sp>
-      <p:sp>
-        <p:nvSpPr>
-          <p:cNvPr id="4" name="text 102 hand-made numbers per painting"/>
-          <p:cNvSpPr txBox="1"/>
-          <p:nvPr/>
-        </p:nvSpPr>
-        <p:spPr>
-          <a:xfrm>
-            <a:off x="621792" y="1161288"/>
-            <a:ext cx="3694176" cy="1380744"/>
-          </a:xfrm>
-          <a:prstGeom prst="rect">
-            <a:avLst/>
-          </a:prstGeom>
-          <a:noFill/>
-          <a:ln/>
-        </p:spPr>
-        <p:txBody>
-          <a:bodyPr wrap="square" lIns="0" tIns="0" rIns="0" bIns="0" rtlCol="0" anchor="t"/>
-          <a:lstStyle/>
-          <a:p>
-            <a:pPr indent="0" marL="0">
-              <a:spcAft>
-                <a:spcPts val="400"/>
-              </a:spcAft>
-              <a:buNone/>
-            </a:pPr>
-            <a:r>
-              <a:rPr lang="en-US" sz="1500" b="1" dirty="0">
-                <a:solidFill>
-                  <a:schemeClr val="tx2"/>
-                </a:solidFill>
-              </a:rPr>
-              <a:t>102 hand-made numbers per painting</a:t>
-            </a:r>
-            <a:endParaRPr lang="en-US" sz="1500" dirty="0"/>
-          </a:p>
-          <a:p>
-            <a:pPr indent="0" marL="0">
-              <a:spcAft>
-                <a:spcPts val="400"/>
-              </a:spcAft>
-              <a:buNone/>
-            </a:pPr>
-            <a:r>
-              <a:rPr lang="en-US" sz="1400" dirty="0">
-                <a:solidFill>
-                  <a:schemeClr val="tx1"/>
-                </a:solidFill>
-              </a:rPr>
-              <a:t>Colours: a histogram of hue, saturation and brightness (72) and colour statistics (10). Brush strokes: direction and strength of the edges, at two sizes (20).</a:t>
-            </a:r>
-            <a:endParaRPr lang="en-US" sz="1500" dirty="0"/>
-          </a:p>
-        </p:txBody>
-      </p:sp>
-      <p:sp>
-        <p:nvSpPr>
-          <p:cNvPr id="5" name="note 500 decision trees that vote"/>
-          <p:cNvSpPr/>
-          <p:nvPr/>
-        </p:nvSpPr>
-        <p:spPr>
-          <a:xfrm>
-            <a:off x="4663440" y="1051560"/>
-            <a:ext cx="4023360" cy="1600200"/>
-          </a:xfrm>
-          <a:prstGeom prst="roundRect">
-            <a:avLst>
-              <a:gd name="adj" fmla="val 4571"/>
-            </a:avLst>
-          </a:prstGeom>
-          <a:solidFill>
-            <a:schemeClr val="bg2"/>
-          </a:solidFill>
-          <a:ln w="12700">
-            <a:solidFill>
-              <a:schemeClr val="bg2"/>
-            </a:solidFill>
-            <a:prstDash val="solid"/>
-          </a:ln>
-        </p:spPr>
-      </p:sp>
-      <p:sp>
-        <p:nvSpPr>
-          <p:cNvPr id="6" name="text 500 decision trees that vote"/>
-          <p:cNvSpPr txBox="1"/>
-          <p:nvPr/>
-        </p:nvSpPr>
-        <p:spPr>
-          <a:xfrm>
-            <a:off x="4828032" y="1161288"/>
-            <a:ext cx="3694176" cy="1380744"/>
-          </a:xfrm>
-          <a:prstGeom prst="rect">
-            <a:avLst/>
-          </a:prstGeom>
-          <a:noFill/>
-          <a:ln/>
-        </p:spPr>
-        <p:txBody>
-          <a:bodyPr wrap="square" lIns="0" tIns="0" rIns="0" bIns="0" rtlCol="0" anchor="t"/>
-          <a:lstStyle/>
-          <a:p>
-            <a:pPr indent="0" marL="0">
-              <a:spcAft>
-                <a:spcPts val="400"/>
-              </a:spcAft>
-              <a:buNone/>
-            </a:pPr>
-            <a:r>
-              <a:rPr lang="en-US" sz="1500" b="1" dirty="0">
-                <a:solidFill>
-                  <a:schemeClr val="tx2"/>
-                </a:solidFill>
-              </a:rPr>
-              <a:t>500 decision trees that vote</a:t>
-            </a:r>
-            <a:endParaRPr lang="en-US" sz="1500" dirty="0"/>
-          </a:p>
-          <a:p>
-            <a:pPr indent="0" marL="0">
-              <a:spcAft>
-                <a:spcPts val="400"/>
-              </a:spcAft>
-              <a:buNone/>
-            </a:pPr>
-            <a:r>
-              <a:rPr lang="en-US" sz="1400" dirty="0">
-                <a:solidFill>
-                  <a:schemeClr val="tx1"/>
-                </a:solidFill>
-              </a:rPr>
-              <a:t>Each tree learns from a random draw of the training paintings and sees 10 of the 102 numbers at each question. Their mistakes differ, so the vote cancels them.</a:t>
-            </a:r>
-            <a:endParaRPr lang="en-US" sz="1500" dirty="0"/>
-          </a:p>
-        </p:txBody>
-      </p:sp>
-      <p:sp>
-        <p:nvSpPr>
-          <p:cNvPr id="7" name="card 32.7 %"/>
-          <p:cNvSpPr/>
-          <p:nvPr/>
-        </p:nvSpPr>
-        <p:spPr>
-          <a:xfrm>
-            <a:off x="457200" y="2834640"/>
-            <a:ext cx="1874520" cy="1463040"/>
-          </a:xfrm>
-          <a:prstGeom prst="roundRect">
-            <a:avLst>
-              <a:gd name="adj" fmla="val 5000"/>
-            </a:avLst>
-          </a:prstGeom>
-          <a:solidFill>
-            <a:schemeClr val="bg2"/>
-          </a:solidFill>
-          <a:ln w="12700">
-            <a:solidFill>
-              <a:schemeClr val="bg2"/>
-            </a:solidFill>
-            <a:prstDash val="solid"/>
-          </a:ln>
-        </p:spPr>
-      </p:sp>
-      <p:sp>
-        <p:nvSpPr>
-          <p:cNvPr id="8" name="value 32.7 %"/>
-          <p:cNvSpPr txBox="1"/>
-          <p:nvPr/>
-        </p:nvSpPr>
-        <p:spPr>
-          <a:xfrm>
-            <a:off x="640080" y="2971800"/>
-            <a:ext cx="1508760" cy="731520"/>
-          </a:xfrm>
-          <a:prstGeom prst="rect">
-            <a:avLst/>
-          </a:prstGeom>
-          <a:noFill/>
-          <a:ln/>
-        </p:spPr>
-        <p:txBody>
-          <a:bodyPr wrap="square" lIns="0" tIns="0" rIns="0" bIns="0" rtlCol="0" anchor="ctr"/>
-          <a:lstStyle/>
-          <a:p>
-            <a:pPr indent="0" marL="0">
-              <a:buNone/>
-            </a:pPr>
-            <a:r>
-              <a:rPr lang="en-US" sz="3000" b="1" dirty="0">
-                <a:solidFill>
-                  <a:schemeClr val="tx2"/>
-                </a:solidFill>
-                <a:latin typeface="Cambria" pitchFamily="34" charset="0"/>
-                <a:ea typeface="Cambria" pitchFamily="34" charset="-122"/>
-                <a:cs typeface="Cambria" pitchFamily="34" charset="-120"/>
-              </a:rPr>
-              <a:t>32.7 %</a:t>
-            </a:r>
-            <a:endParaRPr lang="en-US" sz="3000" dirty="0"/>
-          </a:p>
-        </p:txBody>
-      </p:sp>
-      <p:sp>
-        <p:nvSpPr>
-          <p:cNvPr id="9" name="caption 32.7 %"/>
-          <p:cNvSpPr txBox="1"/>
-          <p:nvPr/>
-        </p:nvSpPr>
-        <p:spPr>
-          <a:xfrm>
-            <a:off x="640080" y="3749040"/>
-            <a:ext cx="1508760" cy="411480"/>
-          </a:xfrm>
-          <a:prstGeom prst="rect">
-            <a:avLst/>
-          </a:prstGeom>
-          <a:noFill/>
-          <a:ln/>
-        </p:spPr>
-        <p:txBody>
-          <a:bodyPr wrap="square" lIns="0" tIns="0" rIns="0" bIns="0" rtlCol="0" anchor="t"/>
-          <a:lstStyle/>
-          <a:p>
-            <a:pPr indent="0" marL="0">
-              <a:buNone/>
-            </a:pPr>
-            <a:r>
-              <a:rPr lang="en-US" sz="1200" dirty="0">
-                <a:solidFill>
-                  <a:schemeClr val="tx1"/>
-                </a:solidFill>
-              </a:rPr>
-              <a:t>Logistic regression on pixels</a:t>
-            </a:r>
-            <a:endParaRPr lang="en-US" sz="1200" dirty="0"/>
-          </a:p>
-        </p:txBody>
-      </p:sp>
-      <p:sp>
-        <p:nvSpPr>
-          <p:cNvPr id="10" name="card 61.4 %"/>
-          <p:cNvSpPr/>
-          <p:nvPr/>
-        </p:nvSpPr>
-        <p:spPr>
-          <a:xfrm>
-            <a:off x="2575590" y="2834640"/>
-            <a:ext cx="1874520" cy="1463040"/>
-          </a:xfrm>
-          <a:prstGeom prst="roundRect">
-            <a:avLst>
-              <a:gd name="adj" fmla="val 5000"/>
-            </a:avLst>
-          </a:prstGeom>
-          <a:solidFill>
-            <a:schemeClr val="bg2"/>
-          </a:solidFill>
-          <a:ln w="12700">
-            <a:solidFill>
-              <a:schemeClr val="bg2"/>
-            </a:solidFill>
-            <a:prstDash val="solid"/>
-          </a:ln>
-        </p:spPr>
-      </p:sp>
-      <p:sp>
-        <p:nvSpPr>
-          <p:cNvPr id="11" name="value 61.4 %"/>
-          <p:cNvSpPr txBox="1"/>
-          <p:nvPr/>
-        </p:nvSpPr>
-        <p:spPr>
-          <a:xfrm>
-            <a:off x="2758470" y="2971800"/>
-            <a:ext cx="1508760" cy="731520"/>
-          </a:xfrm>
-          <a:prstGeom prst="rect">
-            <a:avLst/>
-          </a:prstGeom>
-          <a:noFill/>
-          <a:ln/>
-        </p:spPr>
-        <p:txBody>
-          <a:bodyPr wrap="square" lIns="0" tIns="0" rIns="0" bIns="0" rtlCol="0" anchor="ctr"/>
-          <a:lstStyle/>
-          <a:p>
-            <a:pPr indent="0" marL="0">
-              <a:buNone/>
-            </a:pPr>
-            <a:r>
-              <a:rPr lang="en-US" sz="3000" b="1" dirty="0">
-                <a:solidFill>
-                  <a:schemeClr val="tx2"/>
-                </a:solidFill>
-                <a:latin typeface="Cambria" pitchFamily="34" charset="0"/>
-                <a:ea typeface="Cambria" pitchFamily="34" charset="-122"/>
-                <a:cs typeface="Cambria" pitchFamily="34" charset="-120"/>
-              </a:rPr>
-              <a:t>61.4 %</a:t>
-            </a:r>
-            <a:endParaRPr lang="en-US" sz="3000" dirty="0"/>
-          </a:p>
-        </p:txBody>
-      </p:sp>
-      <p:sp>
-        <p:nvSpPr>
-          <p:cNvPr id="12" name="caption 61.4 %"/>
-          <p:cNvSpPr txBox="1"/>
-          <p:nvPr/>
-        </p:nvSpPr>
-        <p:spPr>
-          <a:xfrm>
-            <a:off x="2758470" y="3749040"/>
-            <a:ext cx="1508760" cy="411480"/>
-          </a:xfrm>
-          <a:prstGeom prst="rect">
-            <a:avLst/>
-          </a:prstGeom>
-          <a:noFill/>
-          <a:ln/>
-        </p:spPr>
-        <p:txBody>
-          <a:bodyPr wrap="square" lIns="0" tIns="0" rIns="0" bIns="0" rtlCol="0" anchor="t"/>
-          <a:lstStyle/>
-          <a:p>
-            <a:pPr indent="0" marL="0">
-              <a:buNone/>
-            </a:pPr>
-            <a:r>
-              <a:rPr lang="en-US" sz="1200" dirty="0">
-                <a:solidFill>
-                  <a:schemeClr val="tx1"/>
-                </a:solidFill>
-              </a:rPr>
-              <a:t>Logistic regression on the 102 numbers</a:t>
-            </a:r>
-            <a:endParaRPr lang="en-US" sz="1200" dirty="0"/>
-          </a:p>
-        </p:txBody>
-      </p:sp>
-      <p:sp>
-        <p:nvSpPr>
-          <p:cNvPr id="13" name="card 67.3 %"/>
-          <p:cNvSpPr/>
-          <p:nvPr/>
-        </p:nvSpPr>
-        <p:spPr>
-          <a:xfrm>
-            <a:off x="4693981" y="2834640"/>
-            <a:ext cx="1874520" cy="1463040"/>
-          </a:xfrm>
-          <a:prstGeom prst="roundRect">
-            <a:avLst>
-              <a:gd name="adj" fmla="val 5000"/>
-            </a:avLst>
-          </a:prstGeom>
-          <a:solidFill>
-            <a:schemeClr val="bg2"/>
-          </a:solidFill>
-          <a:ln w="12700">
-            <a:solidFill>
-              <a:schemeClr val="bg2"/>
-            </a:solidFill>
-            <a:prstDash val="solid"/>
-          </a:ln>
-        </p:spPr>
-      </p:sp>
-      <p:sp>
-        <p:nvSpPr>
-          <p:cNvPr id="14" name="value 67.3 %"/>
-          <p:cNvSpPr txBox="1"/>
-          <p:nvPr/>
-        </p:nvSpPr>
-        <p:spPr>
-          <a:xfrm>
-            <a:off x="4876861" y="2971800"/>
-            <a:ext cx="1508760" cy="731520"/>
-          </a:xfrm>
-          <a:prstGeom prst="rect">
-            <a:avLst/>
-          </a:prstGeom>
-          <a:noFill/>
-          <a:ln/>
-        </p:spPr>
-        <p:txBody>
-          <a:bodyPr wrap="square" lIns="0" tIns="0" rIns="0" bIns="0" rtlCol="0" anchor="ctr"/>
-          <a:lstStyle/>
-          <a:p>
-            <a:pPr indent="0" marL="0">
-              <a:buNone/>
-            </a:pPr>
-            <a:r>
-              <a:rPr lang="en-US" sz="3000" b="1" dirty="0">
-                <a:solidFill>
-                  <a:srgbClr val="EB6834"/>
-                </a:solidFill>
-                <a:latin typeface="Cambria" pitchFamily="34" charset="0"/>
-                <a:ea typeface="Cambria" pitchFamily="34" charset="-122"/>
-                <a:cs typeface="Cambria" pitchFamily="34" charset="-120"/>
-              </a:rPr>
-              <a:t>67.3 %</a:t>
-            </a:r>
-            <a:endParaRPr lang="en-US" sz="3000" dirty="0"/>
-          </a:p>
-        </p:txBody>
-      </p:sp>
-      <p:sp>
-        <p:nvSpPr>
-          <p:cNvPr id="15" name="caption 67.3 %"/>
-          <p:cNvSpPr txBox="1"/>
-          <p:nvPr/>
-        </p:nvSpPr>
-        <p:spPr>
-          <a:xfrm>
-            <a:off x="4876861" y="3749040"/>
-            <a:ext cx="1508760" cy="411480"/>
-          </a:xfrm>
-          <a:prstGeom prst="rect">
-            <a:avLst/>
-          </a:prstGeom>
-          <a:noFill/>
-          <a:ln/>
-        </p:spPr>
-        <p:txBody>
-          <a:bodyPr wrap="square" lIns="0" tIns="0" rIns="0" bIns="0" rtlCol="0" anchor="t"/>
-          <a:lstStyle/>
-          <a:p>
-            <a:pPr indent="0" marL="0">
-              <a:buNone/>
-            </a:pPr>
-            <a:r>
-              <a:rPr lang="en-US" sz="1200" dirty="0">
-                <a:solidFill>
-                  <a:schemeClr val="tx1"/>
-                </a:solidFill>
-              </a:rPr>
-              <a:t>Random forest on the 102 numbers</a:t>
-            </a:r>
-            <a:endParaRPr lang="en-US" sz="1200" dirty="0"/>
-          </a:p>
-        </p:txBody>
-      </p:sp>
-      <p:sp>
-        <p:nvSpPr>
-          <p:cNvPr id="16" name="card 83.0 %"/>
-          <p:cNvSpPr/>
-          <p:nvPr/>
-        </p:nvSpPr>
-        <p:spPr>
-          <a:xfrm>
-            <a:off x="6812371" y="2834640"/>
-            <a:ext cx="1874520" cy="1463040"/>
-          </a:xfrm>
-          <a:prstGeom prst="roundRect">
-            <a:avLst>
-              <a:gd name="adj" fmla="val 5000"/>
             </a:avLst>
           </a:prstGeom>
           <a:solidFill>
@@ -6559,14 +5964,14 @@
       </p:sp>
       <p:sp>
         <p:nvSpPr>
-          <p:cNvPr id="17" name="value 83.0 %"/>
+          <p:cNvPr id="5" name="value +11.4"/>
           <p:cNvSpPr txBox="1"/>
           <p:nvPr/>
         </p:nvSpPr>
         <p:spPr>
           <a:xfrm>
-            <a:off x="6995251" y="2971800"/>
-            <a:ext cx="1508760" cy="731520"/>
+            <a:off x="5943600" y="1188720"/>
+            <a:ext cx="2560320" cy="731520"/>
           </a:xfrm>
           <a:prstGeom prst="rect">
             <a:avLst/>
@@ -6582,7 +5987,7 @@
               <a:buNone/>
             </a:pPr>
             <a:r>
-              <a:rPr lang="en-US" sz="3000" b="1" dirty="0">
+              <a:rPr lang="en-US" sz="4000" b="1" dirty="0">
                 <a:solidFill>
                   <a:schemeClr val="bg1"/>
                 </a:solidFill>
@@ -6590,22 +5995,22 @@
                 <a:ea typeface="Cambria" pitchFamily="34" charset="-122"/>
                 <a:cs typeface="Cambria" pitchFamily="34" charset="-120"/>
               </a:rPr>
-              <a:t>83.0 %</a:t>
-            </a:r>
-            <a:endParaRPr lang="en-US" sz="3000" dirty="0"/>
+              <a:t>+11.4</a:t>
+            </a:r>
+            <a:endParaRPr lang="en-US" sz="4000" dirty="0"/>
           </a:p>
         </p:txBody>
       </p:sp>
       <p:sp>
         <p:nvSpPr>
-          <p:cNvPr id="18" name="caption 83.0 %"/>
+          <p:cNvPr id="6" name="caption +11.4"/>
           <p:cNvSpPr txBox="1"/>
           <p:nvPr/>
         </p:nvSpPr>
         <p:spPr>
           <a:xfrm>
-            <a:off x="6995251" y="3749040"/>
-            <a:ext cx="1508760" cy="411480"/>
+            <a:off x="5943600" y="1965960"/>
+            <a:ext cx="2560320" cy="548640"/>
           </a:xfrm>
           <a:prstGeom prst="rect">
             <a:avLst/>
@@ -6621,27 +6026,27 @@
               <a:buNone/>
             </a:pPr>
             <a:r>
-              <a:rPr lang="en-US" sz="1200" dirty="0">
+              <a:rPr lang="en-US" sz="1400" dirty="0">
                 <a:solidFill>
                   <a:schemeClr val="bg1"/>
                 </a:solidFill>
               </a:rPr>
-              <a:t>ResNet18 frozen + linear head (ours)</a:t>
-            </a:r>
-            <a:endParaRPr lang="en-US" sz="1200" dirty="0"/>
+              <a:t>points when the painter was seen in training</a:t>
+            </a:r>
+            <a:endParaRPr lang="en-US" sz="1400" dirty="0"/>
           </a:p>
         </p:txBody>
       </p:sp>
       <p:sp>
         <p:nvSpPr>
-          <p:cNvPr id="19" name="forest caption"/>
+          <p:cNvPr id="7" name="leakage bullets"/>
           <p:cNvSpPr txBox="1"/>
           <p:nvPr/>
         </p:nvSpPr>
         <p:spPr>
           <a:xfrm>
-            <a:off x="457200" y="4370832"/>
-            <a:ext cx="8229600" cy="320040"/>
+            <a:off x="5760720" y="2834640"/>
+            <a:ext cx="2926080" cy="1783080"/>
           </a:xfrm>
           <a:prstGeom prst="rect">
             <a:avLst/>
@@ -6653,18 +6058,58 @@
           <a:bodyPr wrap="square" lIns="0" tIns="0" rIns="0" bIns="0" rtlCol="0" anchor="t"/>
           <a:lstStyle/>
           <a:p>
-            <a:pPr indent="0" marL="0">
-              <a:buNone/>
-            </a:pPr>
-            <a:r>
-              <a:rPr lang="en-US" sz="1200" dirty="0">
-                <a:solidFill>
-                  <a:srgbClr val="5F6473"/>
+            <a:pPr marL="342900" indent="-342900">
+              <a:spcAft>
+                <a:spcPts val="800"/>
+              </a:spcAft>
+              <a:buSzPct val="100000"/>
+              <a:buChar char="•"/>
+            </a:pPr>
+            <a:r>
+              <a:rPr lang="en-US" sz="1400" dirty="0">
+                <a:solidFill>
+                  <a:schemeClr val="tx1"/>
                 </a:solidFill>
               </a:rPr>
-              <a:t>Test accuracy, 220 paintings. Best of 4 settings on validation: 63.5 %. Training 1 s, 24 ms per photo, 26 MB.</a:t>
-            </a:r>
-            <a:endParaRPr lang="en-US" sz="1200" dirty="0"/>
+              <a:t>Same images, same model: 5-fold cross-validation on train + validation</a:t>
+            </a:r>
+            <a:endParaRPr lang="en-US" sz="1400" dirty="0"/>
+          </a:p>
+          <a:p>
+            <a:pPr marL="342900" indent="-342900">
+              <a:spcAft>
+                <a:spcPts val="800"/>
+              </a:spcAft>
+              <a:buSzPct val="100000"/>
+              <a:buChar char="•"/>
+            </a:pPr>
+            <a:r>
+              <a:rPr lang="en-US" sz="1400" dirty="0">
+                <a:solidFill>
+                  <a:schemeClr val="tx1"/>
+                </a:solidFill>
+              </a:rPr>
+              <a:t>Control group (unknown painters): no change</a:t>
+            </a:r>
+            <a:endParaRPr lang="en-US" sz="1400" dirty="0"/>
+          </a:p>
+          <a:p>
+            <a:pPr marL="342900" indent="-342900">
+              <a:spcAft>
+                <a:spcPts val="800"/>
+              </a:spcAft>
+              <a:buSzPct val="100000"/>
+              <a:buChar char="•"/>
+            </a:pPr>
+            <a:r>
+              <a:rPr lang="en-US" sz="1400" dirty="0">
+                <a:solidFill>
+                  <a:schemeClr val="tx1"/>
+                </a:solidFill>
+              </a:rPr>
+              <a:t>So we split by painter: a random split would flatter the score</a:t>
+            </a:r>
+            <a:endParaRPr lang="en-US" sz="1400" dirty="0"/>
           </a:p>
         </p:txBody>
       </p:sp>
@@ -14027,7 +13472,7 @@
                   <a:srgbClr val="5F6473"/>
                 </a:solidFill>
               </a:rPr>
-              <a:t>Otherwise a model can recognise the painter instead of the style (measured later: +11 points).</a:t>
+              <a:t>Otherwise a model can recognise the painter instead of the style (we measured it: +11 points).</a:t>
             </a:r>
             <a:endParaRPr lang="en-US" sz="1200" dirty="0"/>
           </a:p>
@@ -15215,7 +14660,7 @@
                   <a:schemeClr val="tx2"/>
                 </a:solidFill>
               </a:rPr>
-              <a:t>Seeing the painter inflates the score</a:t>
+              <a:t>Final test: the pretrained network wins</a:t>
             </a:r>
             <a:endParaRPr lang="en-US" sz="3000" dirty="0"/>
           </a:p>
@@ -15223,7 +14668,7 @@
       </p:sp>
       <p:sp>
         <p:nvSpPr>
-          <p:cNvPr id="3" name="step tag 4"/>
+          <p:cNvPr id="3" name="step tag 5"/>
           <p:cNvSpPr txBox="1"/>
           <p:nvPr/>
         </p:nvSpPr>
@@ -15251,7 +14696,7 @@
                   <a:schemeClr val="accent1"/>
                 </a:solidFill>
               </a:rPr>
-              <a:t>STEP 4 OF 6 · RESNET18</a:t>
+              <a:t>STEP 5 OF 6 · FINAL TEST</a:t>
             </a:r>
             <a:endParaRPr lang="en-US" sz="1100" dirty="0"/>
           </a:p>
@@ -15259,13 +14704,13 @@
       </p:sp>
       <p:graphicFrame>
         <p:nvGraphicFramePr>
-          <p:cNvPr id="4" name="chart leakage" descr=""/>
+          <p:cNvPr id="4" name="chart final test" descr=""/>
           <p:cNvGraphicFramePr/>
           <p:nvPr/>
         </p:nvGraphicFramePr>
         <p:xfrm>
-          <a:off x="365760" y="1005840"/>
-          <a:ext cx="5120640" cy="3611880"/>
+          <a:off x="274320" y="960120"/>
+          <a:ext cx="5806440" cy="3703320"/>
         </p:xfrm>
         <a:graphic xmlns:a="http://schemas.openxmlformats.org/drawingml/2006/main">
           <a:graphicData uri="http://schemas.openxmlformats.org/drawingml/2006/chart">
@@ -15275,18 +14720,18 @@
       </p:graphicFrame>
       <p:sp>
         <p:nvSpPr>
-          <p:cNvPr id="5" name="card +11.4"/>
+          <p:cNvPr id="5" name="card +16.4"/>
           <p:cNvSpPr/>
           <p:nvPr/>
         </p:nvSpPr>
         <p:spPr>
           <a:xfrm>
-            <a:off x="5760720" y="1051560"/>
-            <a:ext cx="2926080" cy="1600200"/>
+            <a:off x="6263640" y="1051560"/>
+            <a:ext cx="2423160" cy="1965960"/>
           </a:xfrm>
           <a:prstGeom prst="roundRect">
             <a:avLst>
-              <a:gd name="adj" fmla="val 4571"/>
+              <a:gd name="adj" fmla="val 3721"/>
             </a:avLst>
           </a:prstGeom>
           <a:solidFill>
@@ -15302,14 +14747,14 @@
       </p:sp>
       <p:sp>
         <p:nvSpPr>
-          <p:cNvPr id="6" name="value +11.4"/>
+          <p:cNvPr id="6" name="value +16.4"/>
           <p:cNvSpPr txBox="1"/>
           <p:nvPr/>
         </p:nvSpPr>
         <p:spPr>
           <a:xfrm>
-            <a:off x="5943600" y="1188720"/>
-            <a:ext cx="2560320" cy="731520"/>
+            <a:off x="6446520" y="1188720"/>
+            <a:ext cx="2057400" cy="731520"/>
           </a:xfrm>
           <a:prstGeom prst="rect">
             <a:avLst/>
@@ -15333,7 +14778,7 @@
                 <a:ea typeface="Cambria" pitchFamily="34" charset="-122"/>
                 <a:cs typeface="Cambria" pitchFamily="34" charset="-120"/>
               </a:rPr>
-              <a:t>+11.4</a:t>
+              <a:t>+16.4</a:t>
             </a:r>
             <a:endParaRPr lang="en-US" sz="4000" dirty="0"/>
           </a:p>
@@ -15341,14 +14786,14 @@
       </p:sp>
       <p:sp>
         <p:nvSpPr>
-          <p:cNvPr id="7" name="caption +11.4"/>
+          <p:cNvPr id="7" name="caption +16.4"/>
           <p:cNvSpPr txBox="1"/>
           <p:nvPr/>
         </p:nvSpPr>
         <p:spPr>
           <a:xfrm>
-            <a:off x="5943600" y="1965960"/>
-            <a:ext cx="2560320" cy="548640"/>
+            <a:off x="6446520" y="1965960"/>
+            <a:ext cx="2057400" cy="914400"/>
           </a:xfrm>
           <a:prstGeom prst="rect">
             <a:avLst/>
@@ -15364,27 +14809,54 @@
               <a:buNone/>
             </a:pPr>
             <a:r>
-              <a:rPr lang="en-US" sz="1400" dirty="0">
+              <a:rPr lang="en-US" sz="1300" dirty="0">
                 <a:solidFill>
                   <a:schemeClr val="bg1"/>
                 </a:solidFill>
               </a:rPr>
-              <a:t>points when the painter was seen in training</a:t>
-            </a:r>
-            <a:endParaRPr lang="en-US" sz="1400" dirty="0"/>
+              <a:t>points over the best classical model (95 % interval 9.1 to 24.1)</a:t>
+            </a:r>
+            <a:endParaRPr lang="en-US" sz="1300" dirty="0"/>
           </a:p>
         </p:txBody>
       </p:sp>
       <p:sp>
         <p:nvSpPr>
-          <p:cNvPr id="8" name="leakage bullets"/>
+          <p:cNvPr id="8" name="note Honest note"/>
+          <p:cNvSpPr/>
+          <p:nvPr/>
+        </p:nvSpPr>
+        <p:spPr>
+          <a:xfrm>
+            <a:off x="6263640" y="3154680"/>
+            <a:ext cx="2423160" cy="1463040"/>
+          </a:xfrm>
+          <a:prstGeom prst="roundRect">
+            <a:avLst>
+              <a:gd name="adj" fmla="val 5000"/>
+            </a:avLst>
+          </a:prstGeom>
+          <a:solidFill>
+            <a:schemeClr val="bg2"/>
+          </a:solidFill>
+          <a:ln w="12700">
+            <a:solidFill>
+              <a:schemeClr val="bg2"/>
+            </a:solidFill>
+            <a:prstDash val="solid"/>
+          </a:ln>
+        </p:spPr>
+      </p:sp>
+      <p:sp>
+        <p:nvSpPr>
+          <p:cNvPr id="9" name="text Honest note"/>
           <p:cNvSpPr txBox="1"/>
           <p:nvPr/>
         </p:nvSpPr>
         <p:spPr>
           <a:xfrm>
-            <a:off x="5760720" y="2834640"/>
-            <a:ext cx="2926080" cy="1783080"/>
+            <a:off x="6428232" y="3264408"/>
+            <a:ext cx="2093976" cy="1243584"/>
           </a:xfrm>
           <a:prstGeom prst="rect">
             <a:avLst/>
@@ -15396,56 +14868,36 @@
           <a:bodyPr wrap="square" lIns="0" tIns="0" rIns="0" bIns="0" rtlCol="0" anchor="t"/>
           <a:lstStyle/>
           <a:p>
-            <a:pPr marL="342900" indent="-342900">
+            <a:pPr indent="0" marL="0">
               <a:spcAft>
-                <a:spcPts val="800"/>
+                <a:spcPts val="400"/>
               </a:spcAft>
-              <a:buSzPct val="100000"/>
-              <a:buChar char="•"/>
-            </a:pPr>
-            <a:r>
-              <a:rPr lang="en-US" sz="1400" dirty="0">
+              <a:buNone/>
+            </a:pPr>
+            <a:r>
+              <a:rPr lang="en-US" sz="1400" b="1" dirty="0">
+                <a:solidFill>
+                  <a:schemeClr val="tx2"/>
+                </a:solidFill>
+              </a:rPr>
+              <a:t>Honest note</a:t>
+            </a:r>
+            <a:endParaRPr lang="en-US" sz="1400" dirty="0"/>
+          </a:p>
+          <a:p>
+            <a:pPr indent="0" marL="0">
+              <a:spcAft>
+                <a:spcPts val="400"/>
+              </a:spcAft>
+              <a:buNone/>
+            </a:pPr>
+            <a:r>
+              <a:rPr lang="en-US" sz="1200" dirty="0">
                 <a:solidFill>
                   <a:schemeClr val="tx1"/>
                 </a:solidFill>
               </a:rPr>
-              <a:t>Same images, same model: 5-fold cross-validation on train + validation</a:t>
-            </a:r>
-            <a:endParaRPr lang="en-US" sz="1400" dirty="0"/>
-          </a:p>
-          <a:p>
-            <a:pPr marL="342900" indent="-342900">
-              <a:spcAft>
-                <a:spcPts val="800"/>
-              </a:spcAft>
-              <a:buSzPct val="100000"/>
-              <a:buChar char="•"/>
-            </a:pPr>
-            <a:r>
-              <a:rPr lang="en-US" sz="1400" dirty="0">
-                <a:solidFill>
-                  <a:schemeClr val="tx1"/>
-                </a:solidFill>
-              </a:rPr>
-              <a:t>Control group (unknown painters): no change</a:t>
-            </a:r>
-            <a:endParaRPr lang="en-US" sz="1400" dirty="0"/>
-          </a:p>
-          <a:p>
-            <a:pPr marL="342900" indent="-342900">
-              <a:spcAft>
-                <a:spcPts val="800"/>
-              </a:spcAft>
-              <a:buSzPct val="100000"/>
-              <a:buChar char="•"/>
-            </a:pPr>
-            <a:r>
-              <a:rPr lang="en-US" sz="1400" dirty="0">
-                <a:solidFill>
-                  <a:schemeClr val="tx1"/>
-                </a:solidFill>
-              </a:rPr>
-              <a:t>So we split by painter: a random split would flatter the score</a:t>
+              <a:t>Fine-tuned: 1st on test (87.9 %), 2nd on validation (85.4 %). We keep the model chosen before the test.</a:t>
             </a:r>
             <a:endParaRPr lang="en-US" sz="1400" dirty="0"/>
           </a:p>
@@ -15553,7 +15005,7 @@
                   <a:schemeClr val="tx2"/>
                 </a:solidFill>
               </a:rPr>
-              <a:t>Final test: the pretrained network wins</a:t>
+              <a:t>Fast and cheap enough for a kiosk</a:t>
             </a:r>
             <a:endParaRPr lang="en-US" sz="3000" dirty="0"/>
           </a:p>
@@ -15561,7 +15013,7 @@
       </p:sp>
       <p:sp>
         <p:nvSpPr>
-          <p:cNvPr id="3" name="step tag 5"/>
+          <p:cNvPr id="3" name="step tag 6"/>
           <p:cNvSpPr txBox="1"/>
           <p:nvPr/>
         </p:nvSpPr>
@@ -15589,42 +15041,26 @@
                   <a:schemeClr val="accent1"/>
                 </a:solidFill>
               </a:rPr>
-              <a:t>STEP 5 OF 6 · FINAL TEST</a:t>
+              <a:t>STEP 6 OF 6 · KIOSK COST</a:t>
             </a:r>
             <a:endParaRPr lang="en-US" sz="1100" dirty="0"/>
           </a:p>
         </p:txBody>
       </p:sp>
-      <p:graphicFrame>
-        <p:nvGraphicFramePr>
-          <p:cNvPr id="4" name="chart final test" descr=""/>
-          <p:cNvGraphicFramePr/>
-          <p:nvPr/>
-        </p:nvGraphicFramePr>
-        <p:xfrm>
-          <a:off x="274320" y="960120"/>
-          <a:ext cx="5806440" cy="3703320"/>
-        </p:xfrm>
-        <a:graphic xmlns:a="http://schemas.openxmlformats.org/drawingml/2006/main">
-          <a:graphicData uri="http://schemas.openxmlformats.org/drawingml/2006/chart">
-            <c:chart xmlns:c="http://schemas.openxmlformats.org/drawingml/2006/chart" r:id="rId1"/>
-          </a:graphicData>
-        </a:graphic>
-      </p:graphicFrame>
-      <p:sp>
-        <p:nvSpPr>
-          <p:cNvPr id="5" name="card +16.4"/>
+      <p:sp>
+        <p:nvSpPr>
+          <p:cNvPr id="4" name="card 53 ms"/>
           <p:cNvSpPr/>
           <p:nvPr/>
         </p:nvSpPr>
         <p:spPr>
           <a:xfrm>
-            <a:off x="6263640" y="1051560"/>
-            <a:ext cx="2423160" cy="1965960"/>
+            <a:off x="457200" y="1097280"/>
+            <a:ext cx="1920240" cy="1828800"/>
           </a:xfrm>
           <a:prstGeom prst="roundRect">
             <a:avLst>
-              <a:gd name="adj" fmla="val 3721"/>
+              <a:gd name="adj" fmla="val 4000"/>
             </a:avLst>
           </a:prstGeom>
           <a:solidFill>
@@ -15640,14 +15076,14 @@
       </p:sp>
       <p:sp>
         <p:nvSpPr>
-          <p:cNvPr id="6" name="value +16.4"/>
+          <p:cNvPr id="5" name="value 53 ms"/>
           <p:cNvSpPr txBox="1"/>
           <p:nvPr/>
         </p:nvSpPr>
         <p:spPr>
           <a:xfrm>
-            <a:off x="6446520" y="1188720"/>
-            <a:ext cx="2057400" cy="731520"/>
+            <a:off x="640080" y="1234440"/>
+            <a:ext cx="1554480" cy="731520"/>
           </a:xfrm>
           <a:prstGeom prst="rect">
             <a:avLst/>
@@ -15663,7 +15099,7 @@
               <a:buNone/>
             </a:pPr>
             <a:r>
-              <a:rPr lang="en-US" sz="4000" b="1" dirty="0">
+              <a:rPr lang="en-US" sz="3600" b="1" dirty="0">
                 <a:solidFill>
                   <a:schemeClr val="bg1"/>
                 </a:solidFill>
@@ -15671,22 +15107,22 @@
                 <a:ea typeface="Cambria" pitchFamily="34" charset="-122"/>
                 <a:cs typeface="Cambria" pitchFamily="34" charset="-120"/>
               </a:rPr>
-              <a:t>+16.4</a:t>
-            </a:r>
-            <a:endParaRPr lang="en-US" sz="4000" dirty="0"/>
+              <a:t>53 ms</a:t>
+            </a:r>
+            <a:endParaRPr lang="en-US" sz="3600" dirty="0"/>
           </a:p>
         </p:txBody>
       </p:sp>
       <p:sp>
         <p:nvSpPr>
-          <p:cNvPr id="7" name="caption +16.4"/>
+          <p:cNvPr id="6" name="caption 53 ms"/>
           <p:cNvSpPr txBox="1"/>
           <p:nvPr/>
         </p:nvSpPr>
         <p:spPr>
           <a:xfrm>
-            <a:off x="6446520" y="1965960"/>
-            <a:ext cx="2057400" cy="914400"/>
+            <a:off x="640080" y="2011680"/>
+            <a:ext cx="1554480" cy="777240"/>
           </a:xfrm>
           <a:prstGeom prst="rect">
             <a:avLst/>
@@ -15702,31 +15138,31 @@
               <a:buNone/>
             </a:pPr>
             <a:r>
-              <a:rPr lang="en-US" sz="1300" dirty="0">
+              <a:rPr lang="en-US" sz="1400" dirty="0">
                 <a:solidFill>
                   <a:schemeClr val="bg1"/>
                 </a:solidFill>
               </a:rPr>
-              <a:t>points over the best classical model (95 % interval 9.1 to 24.1)</a:t>
-            </a:r>
-            <a:endParaRPr lang="en-US" sz="1300" dirty="0"/>
+              <a:t>per photo on one CPU thread</a:t>
+            </a:r>
+            <a:endParaRPr lang="en-US" sz="1400" dirty="0"/>
           </a:p>
         </p:txBody>
       </p:sp>
       <p:sp>
         <p:nvSpPr>
-          <p:cNvPr id="8" name="note Honest note"/>
+          <p:cNvPr id="7" name="card 26 ms"/>
           <p:cNvSpPr/>
           <p:nvPr/>
         </p:nvSpPr>
         <p:spPr>
           <a:xfrm>
-            <a:off x="6263640" y="3154680"/>
-            <a:ext cx="2423160" cy="1463040"/>
+            <a:off x="2560320" y="1097280"/>
+            <a:ext cx="1920240" cy="1828800"/>
           </a:xfrm>
           <a:prstGeom prst="roundRect">
             <a:avLst>
-              <a:gd name="adj" fmla="val 5000"/>
+              <a:gd name="adj" fmla="val 4000"/>
             </a:avLst>
           </a:prstGeom>
           <a:solidFill>
@@ -15742,14 +15178,320 @@
       </p:sp>
       <p:sp>
         <p:nvSpPr>
-          <p:cNvPr id="9" name="text Honest note"/>
+          <p:cNvPr id="8" name="value 26 ms"/>
           <p:cNvSpPr txBox="1"/>
           <p:nvPr/>
         </p:nvSpPr>
         <p:spPr>
           <a:xfrm>
-            <a:off x="6428232" y="3264408"/>
-            <a:ext cx="2093976" cy="1243584"/>
+            <a:off x="2743200" y="1234440"/>
+            <a:ext cx="1554480" cy="731520"/>
+          </a:xfrm>
+          <a:prstGeom prst="rect">
+            <a:avLst/>
+          </a:prstGeom>
+          <a:noFill/>
+          <a:ln/>
+        </p:spPr>
+        <p:txBody>
+          <a:bodyPr wrap="square" lIns="0" tIns="0" rIns="0" bIns="0" rtlCol="0" anchor="ctr"/>
+          <a:lstStyle/>
+          <a:p>
+            <a:pPr indent="0" marL="0">
+              <a:buNone/>
+            </a:pPr>
+            <a:r>
+              <a:rPr lang="en-US" sz="3600" b="1" dirty="0">
+                <a:solidFill>
+                  <a:schemeClr val="tx2"/>
+                </a:solidFill>
+                <a:latin typeface="Cambria" pitchFamily="34" charset="0"/>
+                <a:ea typeface="Cambria" pitchFamily="34" charset="-122"/>
+                <a:cs typeface="Cambria" pitchFamily="34" charset="-120"/>
+              </a:rPr>
+              <a:t>26 ms</a:t>
+            </a:r>
+            <a:endParaRPr lang="en-US" sz="3600" dirty="0"/>
+          </a:p>
+        </p:txBody>
+      </p:sp>
+      <p:sp>
+        <p:nvSpPr>
+          <p:cNvPr id="9" name="caption 26 ms"/>
+          <p:cNvSpPr txBox="1"/>
+          <p:nvPr/>
+        </p:nvSpPr>
+        <p:spPr>
+          <a:xfrm>
+            <a:off x="2743200" y="2011680"/>
+            <a:ext cx="1554480" cy="777240"/>
+          </a:xfrm>
+          <a:prstGeom prst="rect">
+            <a:avLst/>
+          </a:prstGeom>
+          <a:noFill/>
+          <a:ln/>
+        </p:spPr>
+        <p:txBody>
+          <a:bodyPr wrap="square" lIns="0" tIns="0" rIns="0" bIns="0" rtlCol="0" anchor="t"/>
+          <a:lstStyle/>
+          <a:p>
+            <a:pPr indent="0" marL="0">
+              <a:buNone/>
+            </a:pPr>
+            <a:r>
+              <a:rPr lang="en-US" sz="1400" dirty="0">
+                <a:solidFill>
+                  <a:schemeClr val="tx1"/>
+                </a:solidFill>
+              </a:rPr>
+              <a:t>per photo with 4 threads</a:t>
+            </a:r>
+            <a:endParaRPr lang="en-US" sz="1400" dirty="0"/>
+          </a:p>
+        </p:txBody>
+      </p:sp>
+      <p:sp>
+        <p:nvSpPr>
+          <p:cNvPr id="10" name="card 45 MB"/>
+          <p:cNvSpPr/>
+          <p:nvPr/>
+        </p:nvSpPr>
+        <p:spPr>
+          <a:xfrm>
+            <a:off x="4663440" y="1097280"/>
+            <a:ext cx="1920240" cy="1828800"/>
+          </a:xfrm>
+          <a:prstGeom prst="roundRect">
+            <a:avLst>
+              <a:gd name="adj" fmla="val 4000"/>
+            </a:avLst>
+          </a:prstGeom>
+          <a:solidFill>
+            <a:schemeClr val="bg2"/>
+          </a:solidFill>
+          <a:ln w="12700">
+            <a:solidFill>
+              <a:schemeClr val="bg2"/>
+            </a:solidFill>
+            <a:prstDash val="solid"/>
+          </a:ln>
+        </p:spPr>
+      </p:sp>
+      <p:sp>
+        <p:nvSpPr>
+          <p:cNvPr id="11" name="value 45 MB"/>
+          <p:cNvSpPr txBox="1"/>
+          <p:nvPr/>
+        </p:nvSpPr>
+        <p:spPr>
+          <a:xfrm>
+            <a:off x="4846320" y="1234440"/>
+            <a:ext cx="1554480" cy="731520"/>
+          </a:xfrm>
+          <a:prstGeom prst="rect">
+            <a:avLst/>
+          </a:prstGeom>
+          <a:noFill/>
+          <a:ln/>
+        </p:spPr>
+        <p:txBody>
+          <a:bodyPr wrap="square" lIns="0" tIns="0" rIns="0" bIns="0" rtlCol="0" anchor="ctr"/>
+          <a:lstStyle/>
+          <a:p>
+            <a:pPr indent="0" marL="0">
+              <a:buNone/>
+            </a:pPr>
+            <a:r>
+              <a:rPr lang="en-US" sz="3600" b="1" dirty="0">
+                <a:solidFill>
+                  <a:schemeClr val="tx2"/>
+                </a:solidFill>
+                <a:latin typeface="Cambria" pitchFamily="34" charset="0"/>
+                <a:ea typeface="Cambria" pitchFamily="34" charset="-122"/>
+                <a:cs typeface="Cambria" pitchFamily="34" charset="-120"/>
+              </a:rPr>
+              <a:t>45 MB</a:t>
+            </a:r>
+            <a:endParaRPr lang="en-US" sz="3600" dirty="0"/>
+          </a:p>
+        </p:txBody>
+      </p:sp>
+      <p:sp>
+        <p:nvSpPr>
+          <p:cNvPr id="12" name="caption 45 MB"/>
+          <p:cNvSpPr txBox="1"/>
+          <p:nvPr/>
+        </p:nvSpPr>
+        <p:spPr>
+          <a:xfrm>
+            <a:off x="4846320" y="2011680"/>
+            <a:ext cx="1554480" cy="777240"/>
+          </a:xfrm>
+          <a:prstGeom prst="rect">
+            <a:avLst/>
+          </a:prstGeom>
+          <a:noFill/>
+          <a:ln/>
+        </p:spPr>
+        <p:txBody>
+          <a:bodyPr wrap="square" lIns="0" tIns="0" rIns="0" bIns="0" rtlCol="0" anchor="t"/>
+          <a:lstStyle/>
+          <a:p>
+            <a:pPr indent="0" marL="0">
+              <a:buNone/>
+            </a:pPr>
+            <a:r>
+              <a:rPr lang="en-US" sz="1400" dirty="0">
+                <a:solidFill>
+                  <a:schemeClr val="tx1"/>
+                </a:solidFill>
+              </a:rPr>
+              <a:t>model file (11 M numbers)</a:t>
+            </a:r>
+            <a:endParaRPr lang="en-US" sz="1400" dirty="0"/>
+          </a:p>
+        </p:txBody>
+      </p:sp>
+      <p:sp>
+        <p:nvSpPr>
+          <p:cNvPr id="13" name="card 17 s"/>
+          <p:cNvSpPr/>
+          <p:nvPr/>
+        </p:nvSpPr>
+        <p:spPr>
+          <a:xfrm>
+            <a:off x="6766560" y="1097280"/>
+            <a:ext cx="1920240" cy="1828800"/>
+          </a:xfrm>
+          <a:prstGeom prst="roundRect">
+            <a:avLst>
+              <a:gd name="adj" fmla="val 4000"/>
+            </a:avLst>
+          </a:prstGeom>
+          <a:solidFill>
+            <a:schemeClr val="bg2"/>
+          </a:solidFill>
+          <a:ln w="12700">
+            <a:solidFill>
+              <a:schemeClr val="bg2"/>
+            </a:solidFill>
+            <a:prstDash val="solid"/>
+          </a:ln>
+        </p:spPr>
+      </p:sp>
+      <p:sp>
+        <p:nvSpPr>
+          <p:cNvPr id="14" name="value 17 s"/>
+          <p:cNvSpPr txBox="1"/>
+          <p:nvPr/>
+        </p:nvSpPr>
+        <p:spPr>
+          <a:xfrm>
+            <a:off x="6949440" y="1234440"/>
+            <a:ext cx="1554480" cy="731520"/>
+          </a:xfrm>
+          <a:prstGeom prst="rect">
+            <a:avLst/>
+          </a:prstGeom>
+          <a:noFill/>
+          <a:ln/>
+        </p:spPr>
+        <p:txBody>
+          <a:bodyPr wrap="square" lIns="0" tIns="0" rIns="0" bIns="0" rtlCol="0" anchor="ctr"/>
+          <a:lstStyle/>
+          <a:p>
+            <a:pPr indent="0" marL="0">
+              <a:buNone/>
+            </a:pPr>
+            <a:r>
+              <a:rPr lang="en-US" sz="3600" b="1" dirty="0">
+                <a:solidFill>
+                  <a:schemeClr val="tx2"/>
+                </a:solidFill>
+                <a:latin typeface="Cambria" pitchFamily="34" charset="0"/>
+                <a:ea typeface="Cambria" pitchFamily="34" charset="-122"/>
+                <a:cs typeface="Cambria" pitchFamily="34" charset="-120"/>
+              </a:rPr>
+              <a:t>17 s</a:t>
+            </a:r>
+            <a:endParaRPr lang="en-US" sz="3600" dirty="0"/>
+          </a:p>
+        </p:txBody>
+      </p:sp>
+      <p:sp>
+        <p:nvSpPr>
+          <p:cNvPr id="15" name="caption 17 s"/>
+          <p:cNvSpPr txBox="1"/>
+          <p:nvPr/>
+        </p:nvSpPr>
+        <p:spPr>
+          <a:xfrm>
+            <a:off x="6949440" y="2011680"/>
+            <a:ext cx="1554480" cy="777240"/>
+          </a:xfrm>
+          <a:prstGeom prst="rect">
+            <a:avLst/>
+          </a:prstGeom>
+          <a:noFill/>
+          <a:ln/>
+        </p:spPr>
+        <p:txBody>
+          <a:bodyPr wrap="square" lIns="0" tIns="0" rIns="0" bIns="0" rtlCol="0" anchor="t"/>
+          <a:lstStyle/>
+          <a:p>
+            <a:pPr indent="0" marL="0">
+              <a:buNone/>
+            </a:pPr>
+            <a:r>
+              <a:rPr lang="en-US" sz="1400" dirty="0">
+                <a:solidFill>
+                  <a:schemeClr val="tx1"/>
+                </a:solidFill>
+              </a:rPr>
+              <a:t>training on a laptop, no GPU</a:t>
+            </a:r>
+            <a:endParaRPr lang="en-US" sz="1400" dirty="0"/>
+          </a:p>
+        </p:txBody>
+      </p:sp>
+      <p:sp>
+        <p:nvSpPr>
+          <p:cNvPr id="16" name="note In practice"/>
+          <p:cNvSpPr/>
+          <p:nvPr/>
+        </p:nvSpPr>
+        <p:spPr>
+          <a:xfrm>
+            <a:off x="457200" y="3154680"/>
+            <a:ext cx="8229600" cy="1143000"/>
+          </a:xfrm>
+          <a:prstGeom prst="roundRect">
+            <a:avLst>
+              <a:gd name="adj" fmla="val 6400"/>
+            </a:avLst>
+          </a:prstGeom>
+          <a:solidFill>
+            <a:schemeClr val="bg2"/>
+          </a:solidFill>
+          <a:ln w="12700">
+            <a:solidFill>
+              <a:schemeClr val="bg2"/>
+            </a:solidFill>
+            <a:prstDash val="solid"/>
+          </a:ln>
+        </p:spPr>
+      </p:sp>
+      <p:sp>
+        <p:nvSpPr>
+          <p:cNvPr id="17" name="text In practice"/>
+          <p:cNvSpPr txBox="1"/>
+          <p:nvPr/>
+        </p:nvSpPr>
+        <p:spPr>
+          <a:xfrm>
+            <a:off x="621792" y="3264408"/>
+            <a:ext cx="7900416" cy="923544"/>
           </a:xfrm>
           <a:prstGeom prst="rect">
             <a:avLst/>
@@ -15768,14 +15510,14 @@
               <a:buNone/>
             </a:pPr>
             <a:r>
-              <a:rPr lang="en-US" sz="1400" b="1" dirty="0">
+              <a:rPr lang="en-US" sz="1500" b="1" dirty="0">
                 <a:solidFill>
                   <a:schemeClr val="tx2"/>
                 </a:solidFill>
               </a:rPr>
-              <a:t>Honest note</a:t>
-            </a:r>
-            <a:endParaRPr lang="en-US" sz="1400" dirty="0"/>
+              <a:t>In practice</a:t>
+            </a:r>
+            <a:endParaRPr lang="en-US" sz="1500" dirty="0"/>
           </a:p>
           <a:p>
             <a:pPr indent="0" marL="0">
@@ -15785,14 +15527,14 @@
               <a:buNone/>
             </a:pPr>
             <a:r>
-              <a:rPr lang="en-US" sz="1200" dirty="0">
+              <a:rPr lang="en-US" sz="1400" dirty="0">
                 <a:solidFill>
                   <a:schemeClr val="tx1"/>
                 </a:solidFill>
               </a:rPr>
-              <a:t>Fine-tuned: 1st on test (87.9 %), 2nd on validation (85.4 %). We keep the model chosen before the test.</a:t>
-            </a:r>
-            <a:endParaRPr lang="en-US" sz="1400" dirty="0"/>
+              <a:t>A kiosk 4 times slower still answers in about 0.2 s. Random forest: 24 ms and 26 MB, but 67.3 %. When the collection changes: compute the new features, retrain one layer, in seconds.</a:t>
+            </a:r>
+            <a:endParaRPr lang="en-US" sz="1500" dirty="0"/>
           </a:p>
         </p:txBody>
       </p:sp>
@@ -15895,10 +15637,10 @@
             <a:r>
               <a:rPr lang="en-US" sz="3000" b="1" dirty="0">
                 <a:solidFill>
-                  <a:schemeClr val="tx2"/>
+                  <a:schemeClr val="bg1"/>
                 </a:solidFill>
               </a:rPr>
-              <a:t>Fast and cheap enough for a kiosk</a:t>
+              <a:t>Our choice: frozen ResNet18 + linear head</a:t>
             </a:r>
             <a:endParaRPr lang="en-US" sz="3000" dirty="0"/>
           </a:p>
@@ -15906,14 +15648,14 @@
       </p:sp>
       <p:sp>
         <p:nvSpPr>
-          <p:cNvPr id="3" name="step tag 6"/>
+          <p:cNvPr id="3" name="journey"/>
           <p:cNvSpPr txBox="1"/>
           <p:nvPr/>
         </p:nvSpPr>
         <p:spPr>
           <a:xfrm>
-            <a:off x="457200" y="54864"/>
-            <a:ext cx="8229600" cy="237744"/>
+            <a:off x="457200" y="1051560"/>
+            <a:ext cx="8229600" cy="365760"/>
           </a:xfrm>
           <a:prstGeom prst="rect">
             <a:avLst/>
@@ -15929,39 +15671,39 @@
               <a:buNone/>
             </a:pPr>
             <a:r>
-              <a:rPr lang="en-US" sz="1100" b="1" spc="200" kern="0" dirty="0">
-                <a:solidFill>
-                  <a:schemeClr val="accent1"/>
+              <a:rPr lang="en-US" sz="1400" dirty="0">
+                <a:solidFill>
+                  <a:srgbClr val="C9CED8"/>
                 </a:solidFill>
               </a:rPr>
-              <a:t>STEP 6 OF 6 · KIOSK COST</a:t>
-            </a:r>
-            <a:endParaRPr lang="en-US" sz="1100" dirty="0"/>
+              <a:t>Test, 220 new paintings:  our MLP 41.4 %  →  best classical 67.3 %  →  frozen ResNet18 83.0 %</a:t>
+            </a:r>
+            <a:endParaRPr lang="en-US" sz="1400" dirty="0"/>
           </a:p>
         </p:txBody>
       </p:sp>
       <p:sp>
         <p:nvSpPr>
-          <p:cNvPr id="4" name="card 53 ms"/>
+          <p:cNvPr id="4" name="column Why"/>
           <p:cNvSpPr/>
           <p:nvPr/>
         </p:nvSpPr>
         <p:spPr>
           <a:xfrm>
-            <a:off x="457200" y="1097280"/>
-            <a:ext cx="1920240" cy="1828800"/>
+            <a:off x="457200" y="1600200"/>
+            <a:ext cx="2560320" cy="2880360"/>
           </a:xfrm>
           <a:prstGeom prst="roundRect">
             <a:avLst>
-              <a:gd name="adj" fmla="val 4000"/>
+              <a:gd name="adj" fmla="val 2857"/>
             </a:avLst>
           </a:prstGeom>
           <a:solidFill>
-            <a:schemeClr val="accent1"/>
+            <a:srgbClr val="2A3448"/>
           </a:solidFill>
           <a:ln w="12700">
             <a:solidFill>
-              <a:schemeClr val="accent1"/>
+              <a:srgbClr val="2A3448"/>
             </a:solidFill>
             <a:prstDash val="solid"/>
           </a:ln>
@@ -15969,14 +15711,14 @@
       </p:sp>
       <p:sp>
         <p:nvSpPr>
-          <p:cNvPr id="5" name="value 53 ms"/>
+          <p:cNvPr id="5" name="head Why"/>
           <p:cNvSpPr txBox="1"/>
           <p:nvPr/>
         </p:nvSpPr>
         <p:spPr>
           <a:xfrm>
-            <a:off x="640080" y="1234440"/>
-            <a:ext cx="1554480" cy="731520"/>
+            <a:off x="640080" y="1719072"/>
+            <a:ext cx="2194560" cy="411480"/>
           </a:xfrm>
           <a:prstGeom prst="rect">
             <a:avLst/>
@@ -15992,30 +15734,30 @@
               <a:buNone/>
             </a:pPr>
             <a:r>
-              <a:rPr lang="en-US" sz="3600" b="1" dirty="0">
-                <a:solidFill>
-                  <a:schemeClr val="bg1"/>
+              <a:rPr lang="en-US" sz="2000" b="1" dirty="0">
+                <a:solidFill>
+                  <a:schemeClr val="accent3"/>
                 </a:solidFill>
                 <a:latin typeface="Cambria" pitchFamily="34" charset="0"/>
                 <a:ea typeface="Cambria" pitchFamily="34" charset="-122"/>
                 <a:cs typeface="Cambria" pitchFamily="34" charset="-120"/>
               </a:rPr>
-              <a:t>53 ms</a:t>
-            </a:r>
-            <a:endParaRPr lang="en-US" sz="3600" dirty="0"/>
+              <a:t>Why</a:t>
+            </a:r>
+            <a:endParaRPr lang="en-US" sz="2000" dirty="0"/>
           </a:p>
         </p:txBody>
       </p:sp>
       <p:sp>
         <p:nvSpPr>
-          <p:cNvPr id="6" name="caption 53 ms"/>
+          <p:cNvPr id="6" name="items Why"/>
           <p:cNvSpPr txBox="1"/>
           <p:nvPr/>
         </p:nvSpPr>
         <p:spPr>
           <a:xfrm>
-            <a:off x="640080" y="2011680"/>
-            <a:ext cx="1554480" cy="777240"/>
+            <a:off x="640080" y="2212848"/>
+            <a:ext cx="2240280" cy="2194560"/>
           </a:xfrm>
           <a:prstGeom prst="rect">
             <a:avLst/>
@@ -16027,8 +15769,12 @@
           <a:bodyPr wrap="square" lIns="0" tIns="0" rIns="0" bIns="0" rtlCol="0" anchor="t"/>
           <a:lstStyle/>
           <a:p>
-            <a:pPr indent="0" marL="0">
-              <a:buNone/>
+            <a:pPr marL="342900" indent="-342900">
+              <a:spcAft>
+                <a:spcPts val="800"/>
+              </a:spcAft>
+              <a:buSzPct val="100000"/>
+              <a:buChar char="•"/>
             </a:pPr>
             <a:r>
               <a:rPr lang="en-US" sz="1400" dirty="0">
@@ -16036,34 +15782,70 @@
                   <a:schemeClr val="bg1"/>
                 </a:solidFill>
               </a:rPr>
-              <a:t>per photo on one CPU thread</a:t>
+              <a:t>1 visitor in 6 gets a wrong style, against 1 in 3 with the best classical model</a:t>
             </a:r>
             <a:endParaRPr lang="en-US" sz="1400" dirty="0"/>
           </a:p>
+          <a:p>
+            <a:pPr marL="342900" indent="-342900">
+              <a:spcAft>
+                <a:spcPts val="800"/>
+              </a:spcAft>
+              <a:buSzPct val="100000"/>
+              <a:buChar char="•"/>
+            </a:pPr>
+            <a:r>
+              <a:rPr lang="en-US" sz="1400" dirty="0">
+                <a:solidFill>
+                  <a:schemeClr val="bg1"/>
+                </a:solidFill>
+              </a:rPr>
+              <a:t>53 ms per photo on a modest CPU</a:t>
+            </a:r>
+            <a:endParaRPr lang="en-US" sz="1400" dirty="0"/>
+          </a:p>
+          <a:p>
+            <a:pPr marL="342900" indent="-342900">
+              <a:spcAft>
+                <a:spcPts val="800"/>
+              </a:spcAft>
+              <a:buSzPct val="100000"/>
+              <a:buChar char="•"/>
+            </a:pPr>
+            <a:r>
+              <a:rPr lang="en-US" sz="1400" dirty="0">
+                <a:solidFill>
+                  <a:schemeClr val="bg1"/>
+                </a:solidFill>
+              </a:rPr>
+              <a:t>Retrained in seconds when the collection changes</a:t>
+            </a:r>
+            <a:endParaRPr lang="en-US" sz="1400" dirty="0"/>
+          </a:p>
         </p:txBody>
       </p:sp>
       <p:sp>
         <p:nvSpPr>
-          <p:cNvPr id="7" name="card 26 ms"/>
+          <p:cNvPr id="7" name="column Not now"/>
           <p:cNvSpPr/>
           <p:nvPr/>
         </p:nvSpPr>
         <p:spPr>
           <a:xfrm>
-            <a:off x="2560320" y="1097280"/>
-            <a:ext cx="1920240" cy="1828800"/>
+            <a:off x="3291840" y="1600200"/>
+            <a:ext cx="2560320" cy="2880360"/>
           </a:xfrm>
           <a:prstGeom prst="roundRect">
             <a:avLst>
-              <a:gd name="adj" fmla="val 4000"/>
+              <a:gd name="adj" fmla="val 2857"/>
             </a:avLst>
           </a:prstGeom>
           <a:solidFill>
-            <a:schemeClr val="bg2"/>
+            <a:srgbClr val="2A3448"/>
           </a:solidFill>
           <a:ln w="12700">
             <a:solidFill>
-              <a:schemeClr val="bg2"/>
+              <a:srgbClr val="2A3448"/>
             </a:solidFill>
             <a:prstDash val="solid"/>
           </a:ln>
@@ -16071,14 +15853,14 @@
       </p:sp>
       <p:sp>
         <p:nvSpPr>
-          <p:cNvPr id="8" name="value 26 ms"/>
+          <p:cNvPr id="8" name="head Not now"/>
           <p:cNvSpPr txBox="1"/>
           <p:nvPr/>
         </p:nvSpPr>
         <p:spPr>
           <a:xfrm>
-            <a:off x="2743200" y="1234440"/>
-            <a:ext cx="1554480" cy="731520"/>
+            <a:off x="3474720" y="1719072"/>
+            <a:ext cx="2194560" cy="411480"/>
           </a:xfrm>
           <a:prstGeom prst="rect">
             <a:avLst/>
@@ -16094,30 +15876,30 @@
               <a:buNone/>
             </a:pPr>
             <a:r>
-              <a:rPr lang="en-US" sz="3600" b="1" dirty="0">
-                <a:solidFill>
-                  <a:schemeClr val="tx2"/>
+              <a:rPr lang="en-US" sz="2000" b="1" dirty="0">
+                <a:solidFill>
+                  <a:schemeClr val="accent2"/>
                 </a:solidFill>
                 <a:latin typeface="Cambria" pitchFamily="34" charset="0"/>
                 <a:ea typeface="Cambria" pitchFamily="34" charset="-122"/>
                 <a:cs typeface="Cambria" pitchFamily="34" charset="-120"/>
               </a:rPr>
-              <a:t>26 ms</a:t>
-            </a:r>
-            <a:endParaRPr lang="en-US" sz="3600" dirty="0"/>
+              <a:t>Not now</a:t>
+            </a:r>
+            <a:endParaRPr lang="en-US" sz="2000" dirty="0"/>
           </a:p>
         </p:txBody>
       </p:sp>
       <p:sp>
         <p:nvSpPr>
-          <p:cNvPr id="9" name="caption 26 ms"/>
+          <p:cNvPr id="9" name="items Not now"/>
           <p:cNvSpPr txBox="1"/>
           <p:nvPr/>
         </p:nvSpPr>
         <p:spPr>
           <a:xfrm>
-            <a:off x="2743200" y="2011680"/>
-            <a:ext cx="1554480" cy="777240"/>
+            <a:off x="3474720" y="2212848"/>
+            <a:ext cx="2240280" cy="2194560"/>
           </a:xfrm>
           <a:prstGeom prst="rect">
             <a:avLst/>
@@ -16129,43 +15911,83 @@
           <a:bodyPr wrap="square" lIns="0" tIns="0" rIns="0" bIns="0" rtlCol="0" anchor="t"/>
           <a:lstStyle/>
           <a:p>
-            <a:pPr indent="0" marL="0">
-              <a:buNone/>
+            <a:pPr marL="342900" indent="-342900">
+              <a:spcAft>
+                <a:spcPts val="800"/>
+              </a:spcAft>
+              <a:buSzPct val="100000"/>
+              <a:buChar char="•"/>
             </a:pPr>
             <a:r>
               <a:rPr lang="en-US" sz="1400" dirty="0">
                 <a:solidFill>
-                  <a:schemeClr val="tx1"/>
+                  <a:schemeClr val="bg1"/>
                 </a:solidFill>
               </a:rPr>
-              <a:t>per photo with 4 threads</a:t>
+              <a:t>Our MLP on pixels: 41 %</a:t>
             </a:r>
             <a:endParaRPr lang="en-US" sz="1400" dirty="0"/>
           </a:p>
+          <a:p>
+            <a:pPr marL="342900" indent="-342900">
+              <a:spcAft>
+                <a:spcPts val="800"/>
+              </a:spcAft>
+              <a:buSzPct val="100000"/>
+              <a:buChar char="•"/>
+            </a:pPr>
+            <a:r>
+              <a:rPr lang="en-US" sz="1400" dirty="0">
+                <a:solidFill>
+                  <a:schemeClr val="bg1"/>
+                </a:solidFill>
+              </a:rPr>
+              <a:t>The random forest alone: 67.3 %</a:t>
+            </a:r>
+            <a:endParaRPr lang="en-US" sz="1400" dirty="0"/>
+          </a:p>
+          <a:p>
+            <a:pPr marL="342900" indent="-342900">
+              <a:spcAft>
+                <a:spcPts val="800"/>
+              </a:spcAft>
+              <a:buSzPct val="100000"/>
+              <a:buChar char="•"/>
+            </a:pPr>
+            <a:r>
+              <a:rPr lang="en-US" sz="1400" dirty="0">
+                <a:solidFill>
+                  <a:schemeClr val="bg1"/>
+                </a:solidFill>
+              </a:rPr>
+              <a:t>Fine-tuning: slower, not proven better</a:t>
+            </a:r>
+            <a:endParaRPr lang="en-US" sz="1400" dirty="0"/>
+          </a:p>
         </p:txBody>
       </p:sp>
       <p:sp>
         <p:nvSpPr>
-          <p:cNvPr id="10" name="card 45 MB"/>
+          <p:cNvPr id="10" name="column Before launch"/>
           <p:cNvSpPr/>
           <p:nvPr/>
         </p:nvSpPr>
         <p:spPr>
           <a:xfrm>
-            <a:off x="4663440" y="1097280"/>
-            <a:ext cx="1920240" cy="1828800"/>
+            <a:off x="6126480" y="1600200"/>
+            <a:ext cx="2560320" cy="2880360"/>
           </a:xfrm>
           <a:prstGeom prst="roundRect">
             <a:avLst>
-              <a:gd name="adj" fmla="val 4000"/>
+              <a:gd name="adj" fmla="val 2857"/>
             </a:avLst>
           </a:prstGeom>
           <a:solidFill>
-            <a:schemeClr val="bg2"/>
+            <a:srgbClr val="2A3448"/>
           </a:solidFill>
           <a:ln w="12700">
             <a:solidFill>
-              <a:schemeClr val="bg2"/>
+              <a:srgbClr val="2A3448"/>
             </a:solidFill>
             <a:prstDash val="solid"/>
           </a:ln>
@@ -16173,14 +15995,14 @@
       </p:sp>
       <p:sp>
         <p:nvSpPr>
-          <p:cNvPr id="11" name="value 45 MB"/>
+          <p:cNvPr id="11" name="head Before launch"/>
           <p:cNvSpPr txBox="1"/>
           <p:nvPr/>
         </p:nvSpPr>
         <p:spPr>
           <a:xfrm>
-            <a:off x="4846320" y="1234440"/>
-            <a:ext cx="1554480" cy="731520"/>
+            <a:off x="6309360" y="1719072"/>
+            <a:ext cx="2194560" cy="411480"/>
           </a:xfrm>
           <a:prstGeom prst="rect">
             <a:avLst/>
@@ -16196,30 +16018,30 @@
               <a:buNone/>
             </a:pPr>
             <a:r>
-              <a:rPr lang="en-US" sz="3600" b="1" dirty="0">
-                <a:solidFill>
-                  <a:schemeClr val="tx2"/>
+              <a:rPr lang="en-US" sz="2000" b="1" dirty="0">
+                <a:solidFill>
+                  <a:schemeClr val="accent4"/>
                 </a:solidFill>
                 <a:latin typeface="Cambria" pitchFamily="34" charset="0"/>
                 <a:ea typeface="Cambria" pitchFamily="34" charset="-122"/>
                 <a:cs typeface="Cambria" pitchFamily="34" charset="-120"/>
               </a:rPr>
-              <a:t>45 MB</a:t>
-            </a:r>
-            <a:endParaRPr lang="en-US" sz="3600" dirty="0"/>
+              <a:t>Before launch</a:t>
+            </a:r>
+            <a:endParaRPr lang="en-US" sz="2000" dirty="0"/>
           </a:p>
         </p:txBody>
       </p:sp>
       <p:sp>
         <p:nvSpPr>
-          <p:cNvPr id="12" name="caption 45 MB"/>
+          <p:cNvPr id="12" name="items Before launch"/>
           <p:cNvSpPr txBox="1"/>
           <p:nvPr/>
         </p:nvSpPr>
         <p:spPr>
           <a:xfrm>
-            <a:off x="4846320" y="2011680"/>
-            <a:ext cx="1554480" cy="777240"/>
+            <a:off x="6309360" y="2212848"/>
+            <a:ext cx="2240280" cy="2194560"/>
           </a:xfrm>
           <a:prstGeom prst="rect">
             <a:avLst/>
@@ -16231,203 +16053,58 @@
           <a:bodyPr wrap="square" lIns="0" tIns="0" rIns="0" bIns="0" rtlCol="0" anchor="t"/>
           <a:lstStyle/>
           <a:p>
-            <a:pPr indent="0" marL="0">
-              <a:buNone/>
+            <a:pPr marL="342900" indent="-342900">
+              <a:spcAft>
+                <a:spcPts val="800"/>
+              </a:spcAft>
+              <a:buSzPct val="100000"/>
+              <a:buChar char="•"/>
             </a:pPr>
             <a:r>
               <a:rPr lang="en-US" sz="1400" dirty="0">
                 <a:solidFill>
-                  <a:schemeClr val="tx1"/>
+                  <a:schemeClr val="bg1"/>
                 </a:solidFill>
               </a:rPr>
-              <a:t>model file (11 M numbers)</a:t>
+              <a:t>Test a few hundred real kiosk photos</a:t>
             </a:r>
             <a:endParaRPr lang="en-US" sz="1400" dirty="0"/>
           </a:p>
-        </p:txBody>
-      </p:sp>
-      <p:sp>
-        <p:nvSpPr>
-          <p:cNvPr id="13" name="card 17 s"/>
-          <p:cNvSpPr/>
-          <p:nvPr/>
-        </p:nvSpPr>
-        <p:spPr>
-          <a:xfrm>
-            <a:off x="6766560" y="1097280"/>
-            <a:ext cx="1920240" cy="1828800"/>
-          </a:xfrm>
-          <a:prstGeom prst="roundRect">
-            <a:avLst>
-              <a:gd name="adj" fmla="val 4000"/>
-            </a:avLst>
-          </a:prstGeom>
-          <a:solidFill>
-            <a:schemeClr val="bg2"/>
-          </a:solidFill>
-          <a:ln w="12700">
-            <a:solidFill>
-              <a:schemeClr val="bg2"/>
-            </a:solidFill>
-            <a:prstDash val="solid"/>
-          </a:ln>
-        </p:spPr>
-      </p:sp>
-      <p:sp>
-        <p:nvSpPr>
-          <p:cNvPr id="14" name="value 17 s"/>
-          <p:cNvSpPr txBox="1"/>
-          <p:nvPr/>
-        </p:nvSpPr>
-        <p:spPr>
-          <a:xfrm>
-            <a:off x="6949440" y="1234440"/>
-            <a:ext cx="1554480" cy="731520"/>
-          </a:xfrm>
-          <a:prstGeom prst="rect">
-            <a:avLst/>
-          </a:prstGeom>
-          <a:noFill/>
-          <a:ln/>
-        </p:spPr>
-        <p:txBody>
-          <a:bodyPr wrap="square" lIns="0" tIns="0" rIns="0" bIns="0" rtlCol="0" anchor="ctr"/>
-          <a:lstStyle/>
-          <a:p>
-            <a:pPr indent="0" marL="0">
-              <a:buNone/>
-            </a:pPr>
-            <a:r>
-              <a:rPr lang="en-US" sz="3600" b="1" dirty="0">
-                <a:solidFill>
-                  <a:schemeClr val="tx2"/>
-                </a:solidFill>
-                <a:latin typeface="Cambria" pitchFamily="34" charset="0"/>
-                <a:ea typeface="Cambria" pitchFamily="34" charset="-122"/>
-                <a:cs typeface="Cambria" pitchFamily="34" charset="-120"/>
+          <a:p>
+            <a:pPr marL="342900" indent="-342900">
+              <a:spcAft>
+                <a:spcPts val="800"/>
+              </a:spcAft>
+              <a:buSzPct val="100000"/>
+              <a:buChar char="•"/>
+            </a:pPr>
+            <a:r>
+              <a:rPr lang="en-US" sz="1400" dirty="0">
+                <a:solidFill>
+                  <a:schemeClr val="bg1"/>
+                </a:solidFill>
               </a:rPr>
-              <a:t>17 s</a:t>
-            </a:r>
-            <a:endParaRPr lang="en-US" sz="3600" dirty="0"/>
-          </a:p>
-        </p:txBody>
-      </p:sp>
-      <p:sp>
-        <p:nvSpPr>
-          <p:cNvPr id="15" name="caption 17 s"/>
-          <p:cNvSpPr txBox="1"/>
-          <p:nvPr/>
-        </p:nvSpPr>
-        <p:spPr>
-          <a:xfrm>
-            <a:off x="6949440" y="2011680"/>
-            <a:ext cx="1554480" cy="777240"/>
-          </a:xfrm>
-          <a:prstGeom prst="rect">
-            <a:avLst/>
-          </a:prstGeom>
-          <a:noFill/>
-          <a:ln/>
-        </p:spPr>
-        <p:txBody>
-          <a:bodyPr wrap="square" lIns="0" tIns="0" rIns="0" bIns="0" rtlCol="0" anchor="t"/>
-          <a:lstStyle/>
-          <a:p>
-            <a:pPr indent="0" marL="0">
-              <a:buNone/>
+              <a:t>Add more styles and paintings</a:t>
+            </a:r>
+            <a:endParaRPr lang="en-US" sz="1400" dirty="0"/>
+          </a:p>
+          <a:p>
+            <a:pPr marL="342900" indent="-342900">
+              <a:spcAft>
+                <a:spcPts val="800"/>
+              </a:spcAft>
+              <a:buSzPct val="100000"/>
+              <a:buChar char="•"/>
             </a:pPr>
             <a:r>
               <a:rPr lang="en-US" sz="1400" dirty="0">
                 <a:solidFill>
-                  <a:schemeClr val="tx1"/>
+                  <a:schemeClr val="bg1"/>
                 </a:solidFill>
               </a:rPr>
-              <a:t>training on a laptop, no GPU</a:t>
+              <a:t>Measure the real kiosk hardware</a:t>
             </a:r>
             <a:endParaRPr lang="en-US" sz="1400" dirty="0"/>
-          </a:p>
-        </p:txBody>
-      </p:sp>
-      <p:sp>
-        <p:nvSpPr>
-          <p:cNvPr id="16" name="note In practice"/>
-          <p:cNvSpPr/>
-          <p:nvPr/>
-        </p:nvSpPr>
-        <p:spPr>
-          <a:xfrm>
-            <a:off x="457200" y="3154680"/>
-            <a:ext cx="8229600" cy="1143000"/>
-          </a:xfrm>
-          <a:prstGeom prst="roundRect">
-            <a:avLst>
-              <a:gd name="adj" fmla="val 6400"/>
-            </a:avLst>
-          </a:prstGeom>
-          <a:solidFill>
-            <a:schemeClr val="bg2"/>
-          </a:solidFill>
-          <a:ln w="12700">
-            <a:solidFill>
-              <a:schemeClr val="bg2"/>
-            </a:solidFill>
-            <a:prstDash val="solid"/>
-          </a:ln>
-        </p:spPr>
-      </p:sp>
-      <p:sp>
-        <p:nvSpPr>
-          <p:cNvPr id="17" name="text In practice"/>
-          <p:cNvSpPr txBox="1"/>
-          <p:nvPr/>
-        </p:nvSpPr>
-        <p:spPr>
-          <a:xfrm>
-            <a:off x="621792" y="3264408"/>
-            <a:ext cx="7900416" cy="923544"/>
-          </a:xfrm>
-          <a:prstGeom prst="rect">
-            <a:avLst/>
-          </a:prstGeom>
-          <a:noFill/>
-          <a:ln/>
-        </p:spPr>
-        <p:txBody>
-          <a:bodyPr wrap="square" lIns="0" tIns="0" rIns="0" bIns="0" rtlCol="0" anchor="t"/>
-          <a:lstStyle/>
-          <a:p>
-            <a:pPr indent="0" marL="0">
-              <a:spcAft>
-                <a:spcPts val="400"/>
-              </a:spcAft>
-              <a:buNone/>
-            </a:pPr>
-            <a:r>
-              <a:rPr lang="en-US" sz="1500" b="1" dirty="0">
-                <a:solidFill>
-                  <a:schemeClr val="tx2"/>
-                </a:solidFill>
-              </a:rPr>
-              <a:t>In practice</a:t>
-            </a:r>
-            <a:endParaRPr lang="en-US" sz="1500" dirty="0"/>
-          </a:p>
-          <a:p>
-            <a:pPr indent="0" marL="0">
-              <a:spcAft>
-                <a:spcPts val="400"/>
-              </a:spcAft>
-              <a:buNone/>
-            </a:pPr>
-            <a:r>
-              <a:rPr lang="en-US" sz="1400" dirty="0">
-                <a:solidFill>
-                  <a:schemeClr val="tx1"/>
-                </a:solidFill>
-              </a:rPr>
-              <a:t>A kiosk 4 times slower still answers in about 0.2 s. Random forest: 24 ms and 26 MB, but 67.3 %. When the collection changes: compute the new features, retrain one layer, in seconds.</a:t>
-            </a:r>
-            <a:endParaRPr lang="en-US" sz="1500" dirty="0"/>
           </a:p>
         </p:txBody>
       </p:sp>
@@ -16461,7 +16138,7 @@
             <a:lvl1pPr>
               <a:defRPr sz="1000">
                 <a:solidFill>
-                  <a:srgbClr val="5F6473"/>
+                  <a:srgbClr val="C9CED8"/>
                 </a:solidFill>
               </a:defRPr>
             </a:lvl1pPr>

</xml_diff>

<commit_message>
Explain fine-tuning and the new last layer of ResNet18 in the talk
</commit_message>
<xml_diff>
--- a/docs/museum_guide_presentation.pptx
+++ b/docs/museum_guide_presentation.pptx
@@ -125,26 +125,26 @@
   <p:extLst>
     <p:ext uri="{521415D9-36F7-43E2-AB2F-B90AF26B5E84}">
       <p14:sectionLst xmlns:p14="http://schemas.microsoft.com/office/powerpoint/2010/main">
-        <p14:section name="The question" id="{9f5630a8-eee5-e941-99a6-01aec248509c}">
+        <p14:section name="The question" id="{a45440c9-4287-6f7b-953d-94c9a6f03c1e}">
           <p14:sldIdLst>
             <p14:sldId id="256"/>
             <p14:sldId id="257"/>
             <p14:sldId id="258"/>
           </p14:sldIdLst>
         </p14:section>
-        <p14:section name="Our MLP" id="{be62296f-469d-49c9-eb0e-cf19aaa438fc}">
+        <p14:section name="Our MLP" id="{a30b9349-52fb-f842-befd-a221b2013c3c}">
           <p14:sldIdLst>
             <p14:sldId id="259"/>
             <p14:sldId id="260"/>
           </p14:sldIdLst>
         </p14:section>
-        <p14:section name="Pretrained ResNet" id="{65061b7d-3608-94c1-54f8-78407fcaf667}">
+        <p14:section name="Pretrained ResNet" id="{b3ab7417-6ab0-0b05-90f5-c5eb4af26608}">
           <p14:sldIdLst>
             <p14:sldId id="261"/>
             <p14:sldId id="262"/>
           </p14:sldIdLst>
         </p14:section>
-        <p14:section name="The answer" id="{3b0ed52e-c82a-3779-134d-b3e44453f027}">
+        <p14:section name="The answer" id="{0036de71-22bb-39c9-b1ee-e8be649e8741}">
           <p14:sldIdLst>
             <p14:sldId id="263"/>
             <p14:sldId id="264"/>
@@ -152,7 +152,7 @@
             <p14:sldId id="266"/>
           </p14:sldIdLst>
         </p14:section>
-        <p14:section name="Backup" id="{fd7b9a15-fdab-3496-9b3a-aaff0728a223}">
+        <p14:section name="Backup" id="{6c491d10-e6a0-1dee-847e-bf870c53c821}">
           <p14:sldIdLst>
             <p14:sldId id="267"/>
             <p14:sldId id="268"/>
@@ -2474,7 +2474,7 @@
           <a:p>
             <a:r>
               <a:rPr lang="en-US" dirty="0"/>
-              <a:t>On the test, our own MLP reached 41 percent, the best classical model 67, and the frozen ResNet18 83. So, our answer to the director: yes, a neural network is worth it, but a pretrained one that we reuse. We recommend a frozen ResNet18 with a linear head. Why? It is accurate: one visitor in six gets a wrong style, against one in three. It is fast enough for a modest CPU, and cheap for a small team: one small layer, retrained in seconds. We do not recommend our MLP, a classical model alone, or fine-tuning for now. Before the launch, we must test real photos taken at the kiosks, add more styles, and measure the real hardware. Thank you. We are happy to take your questions.</a:t>
+              <a:t>On the test, our own MLP reached 41 percent, the best classical model 67, and the frozen ResNet18 83. So, our answer to the director: yes, a neural network is worth it, but a pretrained one that we reuse. We recommend a frozen ResNet18 with a linear head. Why? It is accurate: one visitor in six gets a wrong style, against one in three. It is fast enough for a modest CPU, and cheap for a small team: one small layer, retrained in seconds. Before the launch, we must test real photos taken at the kiosks, add more styles, and measure the real hardware. Thank you. We are happy to take your questions.</a:t>
             </a:r>
             <a:endParaRPr lang="en-US" dirty="0"/>
           </a:p>
@@ -3662,7 +3662,7 @@
           <a:p>
             <a:r>
               <a:rPr lang="en-US" dirty="0"/>
-              <a:t>There is a type of network made for images, which recognises shapes: the convolutional network. We used ResNet18, the smallest ResNet. Its 18 layers slide small filters over the picture: the first layers find edges and colours, the next ones textures, the last ones shapes. Our MLP saw 12 288 separate pixels. ResNet18 already learned all this on 1.2 million ImageNet photos. We only have 1 061 paintings, so we keep it as it is: it is frozen. It turns each painting into 512 numbers. We train only the last layer, which turns these 512 numbers into our 5 styles: 2 565 weights. Like hiring an experienced art expert, and only teaching them our five style names.</a:t>
+              <a:t>There is a type of network made for images, which recognises shapes: the convolutional network. We used ResNet18, the smallest ResNet. Its 18 layers slide small filters over the picture: the first layers find edges and colours, the next ones textures, the last ones shapes. Our MLP saw 12 288 separate pixels. ResNet18 already learned all this on 1.2 million ImageNet photos. We only have 1 061 paintings, so we keep it as it is: it is frozen. It turns each painting into 512 numbers. We remove its last layer, made for ImageNet, and add our own: from these 512 numbers to our 5 styles, 2 565 weights, the only ones we train. Like hiring an experienced art expert, and only teaching them our five style names.</a:t>
             </a:r>
           </a:p>
           <a:p>
@@ -3761,7 +3761,7 @@
           <a:p>
             <a:r>
               <a:rPr lang="en-US" dirty="0"/>
-              <a:t>Training this last layer takes less than a second, and gives 88.1 percent on validation, almost twice our best MLP. And it does see shapes: it finds 71 percent of the Cubist paintings, against 7 for our MLP. We also tried fine-tuning, letting its last block learn too: 8.4 million weights for 1 061 paintings. It overfits: 85.4 percent. We monitored it like the MLP: the gap between train and validation is only 0.09, against 0.61 for our first MLP.</a:t>
+              <a:t>Training this last layer takes less than a second, and gives 88.1 percent on validation, almost twice our best MLP. And it does see shapes: it finds 71 percent of the Cubist paintings, against 7 for our MLP. We also tried fine-tuning: we unfreeze the last block of ResNet18, so that it also learns from our paintings, 8.4 million weights instead of 2 565. It was less convincing than keeping it frozen: 85.4 percent instead of 88.1. With only 1 061 paintings, it starts to learn them by heart. We monitored it like the MLP: the gap between train and validation is only 0.09, against 0.61 for our first MLP.</a:t>
             </a:r>
           </a:p>
           <a:p>
@@ -16270,7 +16270,7 @@
       </p:sp>
       <p:sp>
         <p:nvSpPr>
-          <p:cNvPr id="20" name="box 1 linear layer"/>
+          <p:cNvPr id="20" name="box Our new last layer"/>
           <p:cNvSpPr/>
           <p:nvPr/>
         </p:nvSpPr>
@@ -16297,7 +16297,7 @@
       </p:sp>
       <p:sp>
         <p:nvSpPr>
-          <p:cNvPr id="21" name="box text 1 linear layer"/>
+          <p:cNvPr id="21" name="box text Our new last layer"/>
           <p:cNvSpPr txBox="1"/>
           <p:nvPr/>
         </p:nvSpPr>
@@ -16328,7 +16328,7 @@
                   <a:schemeClr val="bg1"/>
                 </a:solidFill>
               </a:rPr>
-              <a:t>1 linear layer</a:t>
+              <a:t>Our new last layer</a:t>
             </a:r>
             <a:endParaRPr lang="en-US" sz="1400" dirty="0"/>
           </a:p>
@@ -16345,7 +16345,7 @@
                   <a:schemeClr val="bg1"/>
                 </a:solidFill>
               </a:rPr>
-              <a:t>512 → 5 styles: 2 565 weights, the only part we train</a:t>
+              <a:t>replaces ResNet's own: 512 → 5 styles, 2 565 weights, the only part we train</a:t>
             </a:r>
             <a:endParaRPr lang="en-US" sz="1400" dirty="0"/>
           </a:p>
@@ -16594,7 +16594,7 @@
                   <a:schemeClr val="tx1"/>
                 </a:solidFill>
               </a:rPr>
-              <a:t>Only 1 061 paintings: too few for 11 million weights. We reuse what it learned and train only the last layer, in 0.4 s.</a:t>
+              <a:t>Only 1 061 paintings: too few for 11 million weights. We reuse what it learned and train only our new last layer, in 0.4 s.</a:t>
             </a:r>
             <a:endParaRPr lang="en-US" sz="1400" dirty="0"/>
           </a:p>
@@ -16845,7 +16845,7 @@
       </p:sp>
       <p:sp>
         <p:nvSpPr>
-          <p:cNvPr id="7" name="note Fine-tuning layer4"/>
+          <p:cNvPr id="7" name="note Fine-tuning: less convincing"/>
           <p:cNvSpPr/>
           <p:nvPr/>
         </p:nvSpPr>
@@ -16872,7 +16872,7 @@
       </p:sp>
       <p:sp>
         <p:nvSpPr>
-          <p:cNvPr id="8" name="text Fine-tuning layer4"/>
+          <p:cNvPr id="8" name="text Fine-tuning: less convincing"/>
           <p:cNvSpPr txBox="1"/>
           <p:nvPr/>
         </p:nvSpPr>
@@ -16903,7 +16903,7 @@
                   <a:schemeClr val="tx2"/>
                 </a:solidFill>
               </a:rPr>
-              <a:t>Fine-tuning layer4</a:t>
+              <a:t>Fine-tuning: less convincing</a:t>
             </a:r>
             <a:endParaRPr lang="en-US" sz="1500" dirty="0"/>
           </a:p>
@@ -16920,7 +16920,7 @@
                   <a:schemeClr val="tx1"/>
                 </a:solidFill>
               </a:rPr>
-              <a:t>Its last block learns too: 8.4 M weights for 1 061 images, 99.9 % on train, 85.4 % on validation. It overfits.</a:t>
+              <a:t>We also unfreeze its last block (8.4 M weights) to learn from our paintings: 85.4 % on validation, below the frozen version.</a:t>
             </a:r>
             <a:endParaRPr lang="en-US" sz="1500" dirty="0"/>
           </a:p>

</xml_diff>

<commit_message>
Explain fine-tuning in the talk and keep two columns on the recommendation slide
</commit_message>
<xml_diff>
--- a/docs/museum_guide_presentation.pptx
+++ b/docs/museum_guide_presentation.pptx
@@ -125,26 +125,26 @@
   <p:extLst>
     <p:ext uri="{521415D9-36F7-43E2-AB2F-B90AF26B5E84}">
       <p14:sectionLst xmlns:p14="http://schemas.microsoft.com/office/powerpoint/2010/main">
-        <p14:section name="The question" id="{a45440c9-4287-6f7b-953d-94c9a6f03c1e}">
+        <p14:section name="The question" id="{2b1f7bbd-f83b-2092-8d78-94d699bf1835}">
           <p14:sldIdLst>
             <p14:sldId id="256"/>
             <p14:sldId id="257"/>
             <p14:sldId id="258"/>
           </p14:sldIdLst>
         </p14:section>
-        <p14:section name="Our MLP" id="{a30b9349-52fb-f842-befd-a221b2013c3c}">
+        <p14:section name="Our MLP" id="{ecb29beb-5014-8232-be95-2d1d1e2c8be2}">
           <p14:sldIdLst>
             <p14:sldId id="259"/>
             <p14:sldId id="260"/>
           </p14:sldIdLst>
         </p14:section>
-        <p14:section name="Pretrained ResNet" id="{b3ab7417-6ab0-0b05-90f5-c5eb4af26608}">
+        <p14:section name="Pretrained ResNet" id="{12aa952f-1d01-c7dd-70b0-8fb98e086ba3}">
           <p14:sldIdLst>
             <p14:sldId id="261"/>
             <p14:sldId id="262"/>
           </p14:sldIdLst>
         </p14:section>
-        <p14:section name="The answer" id="{0036de71-22bb-39c9-b1ee-e8be649e8741}">
+        <p14:section name="The answer" id="{e58da664-e8fb-debc-e941-8e80493e368e}">
           <p14:sldIdLst>
             <p14:sldId id="263"/>
             <p14:sldId id="264"/>
@@ -152,7 +152,7 @@
             <p14:sldId id="266"/>
           </p14:sldIdLst>
         </p14:section>
-        <p14:section name="Backup" id="{6c491d10-e6a0-1dee-847e-bf870c53c821}">
+        <p14:section name="Backup" id="{1a5b1e8e-e0fd-abca-294a-14c630917218}">
           <p14:sldIdLst>
             <p14:sldId id="267"/>
             <p14:sldId id="268"/>
@@ -6083,11 +6083,11 @@
         <p:spPr>
           <a:xfrm>
             <a:off x="457200" y="1600200"/>
-            <a:ext cx="2560320" cy="2880360"/>
+            <a:ext cx="3977640" cy="2880360"/>
           </a:xfrm>
           <a:prstGeom prst="roundRect">
             <a:avLst>
-              <a:gd name="adj" fmla="val 2857"/>
+              <a:gd name="adj" fmla="val 2540"/>
             </a:avLst>
           </a:prstGeom>
           <a:solidFill>
@@ -6109,8 +6109,8 @@
         </p:nvSpPr>
         <p:spPr>
           <a:xfrm>
-            <a:off x="640080" y="1719072"/>
-            <a:ext cx="2194560" cy="411480"/>
+            <a:off x="685800" y="1737360"/>
+            <a:ext cx="3520440" cy="411480"/>
           </a:xfrm>
           <a:prstGeom prst="rect">
             <a:avLst/>
@@ -6126,7 +6126,7 @@
               <a:buNone/>
             </a:pPr>
             <a:r>
-              <a:rPr lang="en-US" sz="2000" b="1" dirty="0">
+              <a:rPr lang="en-US" sz="2200" b="1" dirty="0">
                 <a:solidFill>
                   <a:schemeClr val="accent3"/>
                 </a:solidFill>
@@ -6136,7 +6136,7 @@
               </a:rPr>
               <a:t>Why</a:t>
             </a:r>
-            <a:endParaRPr lang="en-US" sz="2000" dirty="0"/>
+            <a:endParaRPr lang="en-US" sz="2200" dirty="0"/>
           </a:p>
         </p:txBody>
       </p:sp>
@@ -6148,8 +6148,8 @@
         </p:nvSpPr>
         <p:spPr>
           <a:xfrm>
-            <a:off x="640080" y="2212848"/>
-            <a:ext cx="2240280" cy="2194560"/>
+            <a:off x="685800" y="2286000"/>
+            <a:ext cx="3520440" cy="2103120"/>
           </a:xfrm>
           <a:prstGeom prst="rect">
             <a:avLst/>
@@ -6169,14 +6169,14 @@
               <a:buChar char="•"/>
             </a:pPr>
             <a:r>
-              <a:rPr lang="en-US" sz="1400" dirty="0">
+              <a:rPr lang="en-US" sz="1600" dirty="0">
                 <a:solidFill>
                   <a:schemeClr val="bg1"/>
                 </a:solidFill>
               </a:rPr>
               <a:t>1 visitor in 6 gets a wrong style, against 1 in 3 with the best classical model</a:t>
             </a:r>
-            <a:endParaRPr lang="en-US" sz="1400" dirty="0"/>
+            <a:endParaRPr lang="en-US" sz="1600" dirty="0"/>
           </a:p>
           <a:p>
             <a:pPr marL="342900" indent="-342900">
@@ -6187,14 +6187,14 @@
               <a:buChar char="•"/>
             </a:pPr>
             <a:r>
-              <a:rPr lang="en-US" sz="1400" dirty="0">
+              <a:rPr lang="en-US" sz="1600" dirty="0">
                 <a:solidFill>
                   <a:schemeClr val="bg1"/>
                 </a:solidFill>
               </a:rPr>
               <a:t>53 ms per photo on a modest CPU</a:t>
             </a:r>
-            <a:endParaRPr lang="en-US" sz="1400" dirty="0"/>
+            <a:endParaRPr lang="en-US" sz="1600" dirty="0"/>
           </a:p>
           <a:p>
             <a:pPr marL="342900" indent="-342900">
@@ -6205,31 +6205,31 @@
               <a:buChar char="•"/>
             </a:pPr>
             <a:r>
-              <a:rPr lang="en-US" sz="1400" dirty="0">
+              <a:rPr lang="en-US" sz="1600" dirty="0">
                 <a:solidFill>
                   <a:schemeClr val="bg1"/>
                 </a:solidFill>
               </a:rPr>
               <a:t>Retrained in seconds when the collection changes</a:t>
             </a:r>
-            <a:endParaRPr lang="en-US" sz="1400" dirty="0"/>
-          </a:p>
-        </p:txBody>
-      </p:sp>
-      <p:sp>
-        <p:nvSpPr>
-          <p:cNvPr id="7" name="column Not now"/>
+            <a:endParaRPr lang="en-US" sz="1600" dirty="0"/>
+          </a:p>
+        </p:txBody>
+      </p:sp>
+      <p:sp>
+        <p:nvSpPr>
+          <p:cNvPr id="7" name="column Before launch"/>
           <p:cNvSpPr/>
           <p:nvPr/>
         </p:nvSpPr>
         <p:spPr>
           <a:xfrm>
-            <a:off x="3291840" y="1600200"/>
-            <a:ext cx="2560320" cy="2880360"/>
+            <a:off x="4709160" y="1600200"/>
+            <a:ext cx="3977640" cy="2880360"/>
           </a:xfrm>
           <a:prstGeom prst="roundRect">
             <a:avLst>
-              <a:gd name="adj" fmla="val 2857"/>
+              <a:gd name="adj" fmla="val 2540"/>
             </a:avLst>
           </a:prstGeom>
           <a:solidFill>
@@ -6245,14 +6245,14 @@
       </p:sp>
       <p:sp>
         <p:nvSpPr>
-          <p:cNvPr id="8" name="head Not now"/>
+          <p:cNvPr id="8" name="head Before launch"/>
           <p:cNvSpPr txBox="1"/>
           <p:nvPr/>
         </p:nvSpPr>
         <p:spPr>
           <a:xfrm>
-            <a:off x="3474720" y="1719072"/>
-            <a:ext cx="2194560" cy="411480"/>
+            <a:off x="4937760" y="1737360"/>
+            <a:ext cx="3520440" cy="411480"/>
           </a:xfrm>
           <a:prstGeom prst="rect">
             <a:avLst/>
@@ -6268,30 +6268,30 @@
               <a:buNone/>
             </a:pPr>
             <a:r>
-              <a:rPr lang="en-US" sz="2000" b="1" dirty="0">
-                <a:solidFill>
-                  <a:schemeClr val="accent2"/>
+              <a:rPr lang="en-US" sz="2200" b="1" dirty="0">
+                <a:solidFill>
+                  <a:schemeClr val="accent4"/>
                 </a:solidFill>
                 <a:latin typeface="Cambria" pitchFamily="34" charset="0"/>
                 <a:ea typeface="Cambria" pitchFamily="34" charset="-122"/>
                 <a:cs typeface="Cambria" pitchFamily="34" charset="-120"/>
               </a:rPr>
-              <a:t>Not now</a:t>
-            </a:r>
-            <a:endParaRPr lang="en-US" sz="2000" dirty="0"/>
-          </a:p>
-        </p:txBody>
-      </p:sp>
-      <p:sp>
-        <p:nvSpPr>
-          <p:cNvPr id="9" name="items Not now"/>
+              <a:t>Before launch</a:t>
+            </a:r>
+            <a:endParaRPr lang="en-US" sz="2200" dirty="0"/>
+          </a:p>
+        </p:txBody>
+      </p:sp>
+      <p:sp>
+        <p:nvSpPr>
+          <p:cNvPr id="9" name="items Before launch"/>
           <p:cNvSpPr txBox="1"/>
           <p:nvPr/>
         </p:nvSpPr>
         <p:spPr>
           <a:xfrm>
-            <a:off x="3474720" y="2212848"/>
-            <a:ext cx="2240280" cy="2194560"/>
+            <a:off x="4937760" y="2286000"/>
+            <a:ext cx="3520440" cy="2103120"/>
           </a:xfrm>
           <a:prstGeom prst="rect">
             <a:avLst/>
@@ -6311,14 +6311,14 @@
               <a:buChar char="•"/>
             </a:pPr>
             <a:r>
-              <a:rPr lang="en-US" sz="1400" dirty="0">
+              <a:rPr lang="en-US" sz="1600" dirty="0">
                 <a:solidFill>
                   <a:schemeClr val="bg1"/>
                 </a:solidFill>
               </a:rPr>
-              <a:t>Our MLP on pixels: 41 %</a:t>
-            </a:r>
-            <a:endParaRPr lang="en-US" sz="1400" dirty="0"/>
+              <a:t>Test a few hundred real kiosk photos</a:t>
+            </a:r>
+            <a:endParaRPr lang="en-US" sz="1600" dirty="0"/>
           </a:p>
           <a:p>
             <a:pPr marL="342900" indent="-342900">
@@ -6329,14 +6329,14 @@
               <a:buChar char="•"/>
             </a:pPr>
             <a:r>
-              <a:rPr lang="en-US" sz="1400" dirty="0">
+              <a:rPr lang="en-US" sz="1600" dirty="0">
                 <a:solidFill>
                   <a:schemeClr val="bg1"/>
                 </a:solidFill>
               </a:rPr>
-              <a:t>The random forest alone: 67.3 %</a:t>
-            </a:r>
-            <a:endParaRPr lang="en-US" sz="1400" dirty="0"/>
+              <a:t>Add more styles and paintings</a:t>
+            </a:r>
+            <a:endParaRPr lang="en-US" sz="1600" dirty="0"/>
           </a:p>
           <a:p>
             <a:pPr marL="342900" indent="-342900">
@@ -6347,156 +6347,14 @@
               <a:buChar char="•"/>
             </a:pPr>
             <a:r>
-              <a:rPr lang="en-US" sz="1400" dirty="0">
+              <a:rPr lang="en-US" sz="1600" dirty="0">
                 <a:solidFill>
                   <a:schemeClr val="bg1"/>
                 </a:solidFill>
               </a:rPr>
-              <a:t>Fine-tuning: slower, not proven better</a:t>
-            </a:r>
-            <a:endParaRPr lang="en-US" sz="1400" dirty="0"/>
-          </a:p>
-        </p:txBody>
-      </p:sp>
-      <p:sp>
-        <p:nvSpPr>
-          <p:cNvPr id="10" name="column Before launch"/>
-          <p:cNvSpPr/>
-          <p:nvPr/>
-        </p:nvSpPr>
-        <p:spPr>
-          <a:xfrm>
-            <a:off x="6126480" y="1600200"/>
-            <a:ext cx="2560320" cy="2880360"/>
-          </a:xfrm>
-          <a:prstGeom prst="roundRect">
-            <a:avLst>
-              <a:gd name="adj" fmla="val 2857"/>
-            </a:avLst>
-          </a:prstGeom>
-          <a:solidFill>
-            <a:srgbClr val="2A3448"/>
-          </a:solidFill>
-          <a:ln w="12700">
-            <a:solidFill>
-              <a:srgbClr val="2A3448"/>
-            </a:solidFill>
-            <a:prstDash val="solid"/>
-          </a:ln>
-        </p:spPr>
-      </p:sp>
-      <p:sp>
-        <p:nvSpPr>
-          <p:cNvPr id="11" name="head Before launch"/>
-          <p:cNvSpPr txBox="1"/>
-          <p:nvPr/>
-        </p:nvSpPr>
-        <p:spPr>
-          <a:xfrm>
-            <a:off x="6309360" y="1719072"/>
-            <a:ext cx="2194560" cy="411480"/>
-          </a:xfrm>
-          <a:prstGeom prst="rect">
-            <a:avLst/>
-          </a:prstGeom>
-          <a:noFill/>
-          <a:ln/>
-        </p:spPr>
-        <p:txBody>
-          <a:bodyPr wrap="square" lIns="0" tIns="0" rIns="0" bIns="0" rtlCol="0" anchor="ctr"/>
-          <a:lstStyle/>
-          <a:p>
-            <a:pPr indent="0" marL="0">
-              <a:buNone/>
-            </a:pPr>
-            <a:r>
-              <a:rPr lang="en-US" sz="2000" b="1" dirty="0">
-                <a:solidFill>
-                  <a:schemeClr val="accent4"/>
-                </a:solidFill>
-                <a:latin typeface="Cambria" pitchFamily="34" charset="0"/>
-                <a:ea typeface="Cambria" pitchFamily="34" charset="-122"/>
-                <a:cs typeface="Cambria" pitchFamily="34" charset="-120"/>
-              </a:rPr>
-              <a:t>Before launch</a:t>
-            </a:r>
-            <a:endParaRPr lang="en-US" sz="2000" dirty="0"/>
-          </a:p>
-        </p:txBody>
-      </p:sp>
-      <p:sp>
-        <p:nvSpPr>
-          <p:cNvPr id="12" name="items Before launch"/>
-          <p:cNvSpPr txBox="1"/>
-          <p:nvPr/>
-        </p:nvSpPr>
-        <p:spPr>
-          <a:xfrm>
-            <a:off x="6309360" y="2212848"/>
-            <a:ext cx="2240280" cy="2194560"/>
-          </a:xfrm>
-          <a:prstGeom prst="rect">
-            <a:avLst/>
-          </a:prstGeom>
-          <a:noFill/>
-          <a:ln/>
-        </p:spPr>
-        <p:txBody>
-          <a:bodyPr wrap="square" lIns="0" tIns="0" rIns="0" bIns="0" rtlCol="0" anchor="t"/>
-          <a:lstStyle/>
-          <a:p>
-            <a:pPr marL="342900" indent="-342900">
-              <a:spcAft>
-                <a:spcPts val="800"/>
-              </a:spcAft>
-              <a:buSzPct val="100000"/>
-              <a:buChar char="•"/>
-            </a:pPr>
-            <a:r>
-              <a:rPr lang="en-US" sz="1400" dirty="0">
-                <a:solidFill>
-                  <a:schemeClr val="bg1"/>
-                </a:solidFill>
-              </a:rPr>
-              <a:t>Test a few hundred real kiosk photos</a:t>
-            </a:r>
-            <a:endParaRPr lang="en-US" sz="1400" dirty="0"/>
-          </a:p>
-          <a:p>
-            <a:pPr marL="342900" indent="-342900">
-              <a:spcAft>
-                <a:spcPts val="800"/>
-              </a:spcAft>
-              <a:buSzPct val="100000"/>
-              <a:buChar char="•"/>
-            </a:pPr>
-            <a:r>
-              <a:rPr lang="en-US" sz="1400" dirty="0">
-                <a:solidFill>
-                  <a:schemeClr val="bg1"/>
-                </a:solidFill>
-              </a:rPr>
-              <a:t>Add more styles and paintings</a:t>
-            </a:r>
-            <a:endParaRPr lang="en-US" sz="1400" dirty="0"/>
-          </a:p>
-          <a:p>
-            <a:pPr marL="342900" indent="-342900">
-              <a:spcAft>
-                <a:spcPts val="800"/>
-              </a:spcAft>
-              <a:buSzPct val="100000"/>
-              <a:buChar char="•"/>
-            </a:pPr>
-            <a:r>
-              <a:rPr lang="en-US" sz="1400" dirty="0">
-                <a:solidFill>
-                  <a:schemeClr val="bg1"/>
-                </a:solidFill>
-              </a:rPr>
               <a:t>Measure the real kiosk hardware</a:t>
             </a:r>
-            <a:endParaRPr lang="en-US" sz="1400" dirty="0"/>
+            <a:endParaRPr lang="en-US" sz="1600" dirty="0"/>
           </a:p>
         </p:txBody>
       </p:sp>

</xml_diff>

<commit_message>
Add a backup slide that shows the inside of ResNet18 and its linear head
</commit_message>
<xml_diff>
--- a/docs/museum_guide_presentation.pptx
+++ b/docs/museum_guide_presentation.pptx
@@ -24,9 +24,10 @@
     <p:sldId id="272" r:id="rId18"/>
     <p:sldId id="273" r:id="rId19"/>
     <p:sldId id="274" r:id="rId20"/>
+    <p:sldId id="275" r:id="rId21"/>
   </p:sldIdLst>
   <p:notesMasterIdLst>
-    <p:notesMasterId r:id="rId21"/>
+    <p:notesMasterId r:id="rId22"/>
   </p:notesMasterIdLst>
   <p:sldSz cx="9144000" cy="5143500"/>
   <p:notesSz cx="5143500" cy="9144000"/>
@@ -125,26 +126,26 @@
   <p:extLst>
     <p:ext uri="{521415D9-36F7-43E2-AB2F-B90AF26B5E84}">
       <p14:sectionLst xmlns:p14="http://schemas.microsoft.com/office/powerpoint/2010/main">
-        <p14:section name="The question" id="{2b1f7bbd-f83b-2092-8d78-94d699bf1835}">
+        <p14:section name="The question" id="{58dd4e7b-83ea-3470-e926-2c21dcb2a8e3}">
           <p14:sldIdLst>
             <p14:sldId id="256"/>
             <p14:sldId id="257"/>
             <p14:sldId id="258"/>
           </p14:sldIdLst>
         </p14:section>
-        <p14:section name="Our MLP" id="{ecb29beb-5014-8232-be95-2d1d1e2c8be2}">
+        <p14:section name="Our MLP" id="{e0d5256e-f470-8fb8-0b66-670c872c8233}">
           <p14:sldIdLst>
             <p14:sldId id="259"/>
             <p14:sldId id="260"/>
           </p14:sldIdLst>
         </p14:section>
-        <p14:section name="Pretrained ResNet" id="{12aa952f-1d01-c7dd-70b0-8fb98e086ba3}">
+        <p14:section name="Pretrained ResNet" id="{7089e9a1-3197-81ea-2d1f-0f5aed3c1c71}">
           <p14:sldIdLst>
             <p14:sldId id="261"/>
             <p14:sldId id="262"/>
           </p14:sldIdLst>
         </p14:section>
-        <p14:section name="The answer" id="{e58da664-e8fb-debc-e941-8e80493e368e}">
+        <p14:section name="The answer" id="{570237ec-11b4-f7ce-669d-b8eb6ca962fd}">
           <p14:sldIdLst>
             <p14:sldId id="263"/>
             <p14:sldId id="264"/>
@@ -152,7 +153,7 @@
             <p14:sldId id="266"/>
           </p14:sldIdLst>
         </p14:section>
-        <p14:section name="Backup" id="{1a5b1e8e-e0fd-abca-294a-14c630917218}">
+        <p14:section name="Backup" id="{f395000c-73c4-74fc-d50e-222894e442df}">
           <p14:sldIdLst>
             <p14:sldId id="267"/>
             <p14:sldId id="268"/>
@@ -162,6 +163,7 @@
             <p14:sldId id="272"/>
             <p14:sldId id="273"/>
             <p14:sldId id="274"/>
+            <p14:sldId id="275"/>
           </p14:sldIdLst>
         </p14:section>
       </p14:sectionLst>
@@ -3319,6 +3321,94 @@
 </p:notes>
 </file>
 
+<file path=ppt/notesSlides/notesSlide20.xml><?xml version="1.0" encoding="utf-8"?>
+<p:notes xmlns:a="http://schemas.openxmlformats.org/drawingml/2006/main" xmlns:r="http://schemas.openxmlformats.org/officeDocument/2006/relationships" xmlns:p="http://schemas.openxmlformats.org/presentationml/2006/main">
+  <p:cSld>
+    <p:spTree>
+      <p:nvGrpSpPr>
+        <p:cNvPr id="1" name=""/>
+        <p:cNvGrpSpPr/>
+        <p:nvPr/>
+      </p:nvGrpSpPr>
+      <p:grpSpPr>
+        <a:xfrm>
+          <a:off x="0" y="0"/>
+          <a:ext cx="0" cy="0"/>
+          <a:chOff x="0" y="0"/>
+          <a:chExt cx="0" cy="0"/>
+        </a:xfrm>
+      </p:grpSpPr>
+      <p:sp>
+        <p:nvSpPr>
+          <p:cNvPr id="2" name="Slide Image Placeholder 1"/>
+          <p:cNvSpPr>
+            <a:spLocks noGrp="1" noRot="1" noChangeAspect="1"/>
+          </p:cNvSpPr>
+          <p:nvPr>
+            <p:ph type="sldImg"/>
+          </p:nvPr>
+        </p:nvSpPr>
+        <p:spPr/>
+      </p:sp>
+      <p:sp>
+        <p:nvSpPr>
+          <p:cNvPr id="3" name="Notes Placeholder 2"/>
+          <p:cNvSpPr>
+            <a:spLocks noGrp="1"/>
+          </p:cNvSpPr>
+          <p:nvPr>
+            <p:ph type="body" idx="1"/>
+          </p:nvPr>
+        </p:nvSpPr>
+        <p:spPr/>
+        <p:txBody>
+          <a:bodyPr/>
+          <a:lstStyle/>
+          <a:p>
+            <a:r>
+              <a:rPr lang="en-US" dirty="0"/>
+              <a:t>If asked how ResNet18 is built: the painting (224 by 224 pixels, 3 colours) goes through a first convolution and four layers of residual blocks. At each layer the picture gets smaller (56, 28, 14, 7 pixels) but the number of channels grows (64 to 512): from edges and colours to textures, patterns and shapes. The average of the last 512 maps gives 512 numbers. All of this is frozen: 11.2 million weights learned on ImageNet. Our linear head turns the 512 numbers into 5 scores, one per style: 2 565 weights, the only ones we train. Residual means each block adds its input back through a shortcut, so the gradient reaches every layer.</a:t>
+            </a:r>
+            <a:endParaRPr lang="en-US" dirty="0"/>
+          </a:p>
+        </p:txBody>
+      </p:sp>
+      <p:sp>
+        <p:nvSpPr>
+          <p:cNvPr id="4" name="Slide Number Placeholder 3"/>
+          <p:cNvSpPr>
+            <a:spLocks noGrp="1"/>
+          </p:cNvSpPr>
+          <p:nvPr>
+            <p:ph type="sldNum" sz="quarter" idx="10"/>
+          </p:nvPr>
+        </p:nvSpPr>
+        <p:spPr/>
+        <p:txBody>
+          <a:bodyPr/>
+          <a:lstStyle/>
+          <a:p>
+            <a:fld id="{F7021451-1387-4CA6-816F-3879F97B5CBC}" type="slidenum">
+              <a:rPr lang="en-US"/>
+              <a:t>20</a:t>
+            </a:fld>
+            <a:endParaRPr lang="en-US"/>
+          </a:p>
+        </p:txBody>
+      </p:sp>
+    </p:spTree>
+    <p:extLst>
+      <p:ext uri="{BB962C8B-B14F-4D97-AF65-F5344CB8AC3E}">
+        <p14:creationId xmlns:p14="http://schemas.microsoft.com/office/powerpoint/2010/main" val="1024086991"/>
+      </p:ext>
+    </p:extLst>
+  </p:cSld>
+  <p:clrMapOvr>
+    <a:masterClrMapping/>
+  </p:clrMapOvr>
+</p:notes>
+</file>
+
 <file path=ppt/notesSlides/notesSlide3.xml><?xml version="1.0" encoding="utf-8"?>
 <p:notes xmlns:a="http://schemas.openxmlformats.org/drawingml/2006/main" xmlns:r="http://schemas.openxmlformats.org/officeDocument/2006/relationships" xmlns:p="http://schemas.openxmlformats.org/presentationml/2006/main">
   <p:cSld>
@@ -14132,6 +14222,2366 @@
             <a:fld id="{F7021451-1387-4CA6-816F-3879F97B5CBC}" type="slidenum">
               <a:rPr b="0" lang="en-US"/>
               <a:t>2</a:t>
+            </a:fld>
+            <a:endParaRPr lang="en-US"/>
+          </a:p>
+        </p:txBody>
+      </p:sp>
+    </p:spTree>
+  </p:cSld>
+  <p:clrMapOvr>
+    <a:masterClrMapping/>
+  </p:clrMapOvr>
+</p:sld>
+</file>
+
+<file path=ppt/slides/slide20.xml><?xml version="1.0" encoding="utf-8"?>
+<p:sld xmlns:a="http://schemas.openxmlformats.org/drawingml/2006/main" xmlns:r="http://schemas.openxmlformats.org/officeDocument/2006/relationships" xmlns:p="http://schemas.openxmlformats.org/presentationml/2006/main">
+  <p:cSld name="Slide 20">
+    <p:spTree>
+      <p:nvGrpSpPr>
+        <p:cNvPr id="1" name=""/>
+        <p:cNvGrpSpPr/>
+        <p:nvPr/>
+      </p:nvGrpSpPr>
+      <p:grpSpPr>
+        <a:xfrm>
+          <a:off x="0" y="0"/>
+          <a:ext cx="0" cy="0"/>
+          <a:chOff x="0" y="0"/>
+          <a:chExt cx="0" cy="0"/>
+        </a:xfrm>
+      </p:grpSpPr>
+      <p:sp>
+        <p:nvSpPr>
+          <p:cNvPr id="2" name="Text 0"/>
+          <p:cNvSpPr/>
+          <p:nvPr>
+            <p:ph idx="100" type="title" hasCustomPrompt="1"/>
+          </p:nvPr>
+        </p:nvSpPr>
+        <p:spPr>
+          <a:xfrm>
+            <a:off x="457200" y="274320"/>
+            <a:ext cx="8229600" cy="640080"/>
+          </a:xfrm>
+          <a:prstGeom prst="rect">
+            <a:avLst/>
+          </a:prstGeom>
+          <a:noFill/>
+          <a:ln/>
+        </p:spPr>
+        <p:txBody>
+          <a:bodyPr wrap="square" lIns="0" tIns="0" rIns="0" bIns="0" rtlCol="0" anchor="ctr"/>
+          <a:lstStyle/>
+          <a:p>
+            <a:pPr indent="0" marL="0">
+              <a:buNone/>
+            </a:pPr>
+            <a:r>
+              <a:rPr lang="en-US" sz="3000" b="1" dirty="0">
+                <a:solidFill>
+                  <a:schemeClr val="tx2"/>
+                </a:solidFill>
+              </a:rPr>
+              <a:t>Backup: inside ResNet18 + our linear head</a:t>
+            </a:r>
+            <a:endParaRPr lang="en-US" sz="3000" dirty="0"/>
+          </a:p>
+        </p:txBody>
+      </p:sp>
+      <p:sp>
+        <p:nvSpPr>
+          <p:cNvPr id="3" name="stage 1 painting"/>
+          <p:cNvSpPr/>
+          <p:nvPr/>
+        </p:nvSpPr>
+        <p:spPr>
+          <a:xfrm>
+            <a:off x="466344" y="1051560"/>
+            <a:ext cx="749808" cy="1645920"/>
+          </a:xfrm>
+          <a:prstGeom prst="roundRect">
+            <a:avLst>
+              <a:gd name="adj" fmla="val 7317"/>
+            </a:avLst>
+          </a:prstGeom>
+          <a:solidFill>
+            <a:schemeClr val="bg2"/>
+          </a:solidFill>
+          <a:ln w="12700">
+            <a:solidFill>
+              <a:schemeClr val="bg2"/>
+            </a:solidFill>
+            <a:prstDash val="solid"/>
+          </a:ln>
+        </p:spPr>
+      </p:sp>
+      <p:sp>
+        <p:nvSpPr>
+          <p:cNvPr id="4" name="stage name 1 painting"/>
+          <p:cNvSpPr txBox="1"/>
+          <p:nvPr/>
+        </p:nvSpPr>
+        <p:spPr>
+          <a:xfrm>
+            <a:off x="466344" y="1051560"/>
+            <a:ext cx="749808" cy="1645920"/>
+          </a:xfrm>
+          <a:prstGeom prst="rect">
+            <a:avLst/>
+          </a:prstGeom>
+          <a:noFill/>
+          <a:ln/>
+        </p:spPr>
+        <p:txBody>
+          <a:bodyPr wrap="square" lIns="254" tIns="254" rIns="254" bIns="254" rtlCol="0" anchor="ctr"/>
+          <a:lstStyle/>
+          <a:p>
+            <a:pPr algn="ctr" indent="0" marL="0">
+              <a:buNone/>
+            </a:pPr>
+            <a:r>
+              <a:rPr lang="en-US" sz="1000" b="1" dirty="0">
+                <a:solidFill>
+                  <a:schemeClr val="tx2"/>
+                </a:solidFill>
+              </a:rPr>
+              <a:t>1 painting</a:t>
+            </a:r>
+            <a:endParaRPr lang="en-US" sz="1000" dirty="0"/>
+          </a:p>
+        </p:txBody>
+      </p:sp>
+      <p:sp>
+        <p:nvSpPr>
+          <p:cNvPr id="5" name="stage caption 1 painting"/>
+          <p:cNvSpPr txBox="1"/>
+          <p:nvPr/>
+        </p:nvSpPr>
+        <p:spPr>
+          <a:xfrm>
+            <a:off x="393192" y="2770632"/>
+            <a:ext cx="896112" cy="384048"/>
+          </a:xfrm>
+          <a:prstGeom prst="rect">
+            <a:avLst/>
+          </a:prstGeom>
+          <a:noFill/>
+          <a:ln/>
+        </p:spPr>
+        <p:txBody>
+          <a:bodyPr wrap="square" lIns="0" tIns="0" rIns="0" bIns="0" rtlCol="0" anchor="t"/>
+          <a:lstStyle/>
+          <a:p>
+            <a:pPr algn="ctr" indent="0" marL="0">
+              <a:buNone/>
+            </a:pPr>
+            <a:r>
+              <a:rPr lang="en-US" sz="900" dirty="0">
+                <a:solidFill>
+                  <a:schemeClr val="tx1"/>
+                </a:solidFill>
+              </a:rPr>
+              <a:t>224 x 224 x 3</a:t>
+            </a:r>
+            <a:endParaRPr lang="en-US" sz="900" dirty="0"/>
+          </a:p>
+        </p:txBody>
+      </p:sp>
+      <p:sp>
+        <p:nvSpPr>
+          <p:cNvPr id="6" name="stage arrow 1"/>
+          <p:cNvSpPr/>
+          <p:nvPr/>
+        </p:nvSpPr>
+        <p:spPr>
+          <a:xfrm>
+            <a:off x="1243584" y="1874520"/>
+            <a:ext cx="128016" cy="0"/>
+          </a:xfrm>
+          <a:prstGeom prst="line">
+            <a:avLst/>
+          </a:prstGeom>
+          <a:noFill/>
+          <a:ln w="19050">
+            <a:solidFill>
+              <a:srgbClr val="3A3F4B"/>
+            </a:solidFill>
+            <a:prstDash val="solid"/>
+            <a:tailEnd type="triangle"/>
+          </a:ln>
+        </p:spPr>
+      </p:sp>
+      <p:sp>
+        <p:nvSpPr>
+          <p:cNvPr id="7" name="stage conv1 + pool"/>
+          <p:cNvSpPr/>
+          <p:nvPr/>
+        </p:nvSpPr>
+        <p:spPr>
+          <a:xfrm>
+            <a:off x="1399032" y="1209672"/>
+            <a:ext cx="749808" cy="1329695"/>
+          </a:xfrm>
+          <a:prstGeom prst="roundRect">
+            <a:avLst>
+              <a:gd name="adj" fmla="val 7317"/>
+            </a:avLst>
+          </a:prstGeom>
+          <a:solidFill>
+            <a:schemeClr val="tx2"/>
+          </a:solidFill>
+          <a:ln w="12700">
+            <a:solidFill>
+              <a:schemeClr val="tx2"/>
+            </a:solidFill>
+            <a:prstDash val="solid"/>
+          </a:ln>
+        </p:spPr>
+      </p:sp>
+      <p:sp>
+        <p:nvSpPr>
+          <p:cNvPr id="8" name="stage name conv1 + pool"/>
+          <p:cNvSpPr txBox="1"/>
+          <p:nvPr/>
+        </p:nvSpPr>
+        <p:spPr>
+          <a:xfrm>
+            <a:off x="1399032" y="1209672"/>
+            <a:ext cx="749808" cy="1329695"/>
+          </a:xfrm>
+          <a:prstGeom prst="rect">
+            <a:avLst/>
+          </a:prstGeom>
+          <a:noFill/>
+          <a:ln/>
+        </p:spPr>
+        <p:txBody>
+          <a:bodyPr wrap="square" lIns="254" tIns="254" rIns="254" bIns="254" rtlCol="0" anchor="ctr"/>
+          <a:lstStyle/>
+          <a:p>
+            <a:pPr algn="ctr" indent="0" marL="0">
+              <a:buNone/>
+            </a:pPr>
+            <a:r>
+              <a:rPr lang="en-US" sz="1000" b="1" dirty="0">
+                <a:solidFill>
+                  <a:schemeClr val="bg1"/>
+                </a:solidFill>
+              </a:rPr>
+              <a:t>conv1 + pool</a:t>
+            </a:r>
+            <a:endParaRPr lang="en-US" sz="1000" dirty="0"/>
+          </a:p>
+        </p:txBody>
+      </p:sp>
+      <p:sp>
+        <p:nvSpPr>
+          <p:cNvPr id="9" name="stage caption conv1 + pool"/>
+          <p:cNvSpPr txBox="1"/>
+          <p:nvPr/>
+        </p:nvSpPr>
+        <p:spPr>
+          <a:xfrm>
+            <a:off x="1325880" y="2770632"/>
+            <a:ext cx="896112" cy="384048"/>
+          </a:xfrm>
+          <a:prstGeom prst="rect">
+            <a:avLst/>
+          </a:prstGeom>
+          <a:noFill/>
+          <a:ln/>
+        </p:spPr>
+        <p:txBody>
+          <a:bodyPr wrap="square" lIns="0" tIns="0" rIns="0" bIns="0" rtlCol="0" anchor="t"/>
+          <a:lstStyle/>
+          <a:p>
+            <a:pPr algn="ctr" indent="0" marL="0">
+              <a:buNone/>
+            </a:pPr>
+            <a:r>
+              <a:rPr lang="en-US" sz="900" dirty="0">
+                <a:solidFill>
+                  <a:schemeClr val="tx1"/>
+                </a:solidFill>
+              </a:rPr>
+              <a:t>56 x 56 x 64</a:t>
+            </a:r>
+            <a:endParaRPr lang="en-US" sz="900" dirty="0"/>
+          </a:p>
+          <a:p>
+            <a:pPr algn="ctr" indent="0" marL="0">
+              <a:buNone/>
+            </a:pPr>
+            <a:r>
+              <a:rPr lang="en-US" sz="900" dirty="0">
+                <a:solidFill>
+                  <a:schemeClr val="tx1"/>
+                </a:solidFill>
+              </a:rPr>
+              <a:t>9.5 k weights</a:t>
+            </a:r>
+            <a:endParaRPr lang="en-US" sz="900" dirty="0"/>
+          </a:p>
+        </p:txBody>
+      </p:sp>
+      <p:sp>
+        <p:nvSpPr>
+          <p:cNvPr id="10" name="stage arrow 2"/>
+          <p:cNvSpPr/>
+          <p:nvPr/>
+        </p:nvSpPr>
+        <p:spPr>
+          <a:xfrm>
+            <a:off x="2176272" y="1874520"/>
+            <a:ext cx="128016" cy="0"/>
+          </a:xfrm>
+          <a:prstGeom prst="line">
+            <a:avLst/>
+          </a:prstGeom>
+          <a:noFill/>
+          <a:ln w="19050">
+            <a:solidFill>
+              <a:srgbClr val="3A3F4B"/>
+            </a:solidFill>
+            <a:prstDash val="solid"/>
+            <a:tailEnd type="triangle"/>
+          </a:ln>
+        </p:spPr>
+      </p:sp>
+      <p:sp>
+        <p:nvSpPr>
+          <p:cNvPr id="11" name="stage layer1"/>
+          <p:cNvSpPr/>
+          <p:nvPr/>
+        </p:nvSpPr>
+        <p:spPr>
+          <a:xfrm>
+            <a:off x="2331720" y="1209672"/>
+            <a:ext cx="749808" cy="1329695"/>
+          </a:xfrm>
+          <a:prstGeom prst="roundRect">
+            <a:avLst>
+              <a:gd name="adj" fmla="val 7317"/>
+            </a:avLst>
+          </a:prstGeom>
+          <a:solidFill>
+            <a:schemeClr val="tx2"/>
+          </a:solidFill>
+          <a:ln w="12700">
+            <a:solidFill>
+              <a:schemeClr val="tx2"/>
+            </a:solidFill>
+            <a:prstDash val="solid"/>
+          </a:ln>
+        </p:spPr>
+      </p:sp>
+      <p:sp>
+        <p:nvSpPr>
+          <p:cNvPr id="12" name="stage name layer1"/>
+          <p:cNvSpPr txBox="1"/>
+          <p:nvPr/>
+        </p:nvSpPr>
+        <p:spPr>
+          <a:xfrm>
+            <a:off x="2331720" y="1209672"/>
+            <a:ext cx="749808" cy="1329695"/>
+          </a:xfrm>
+          <a:prstGeom prst="rect">
+            <a:avLst/>
+          </a:prstGeom>
+          <a:noFill/>
+          <a:ln/>
+        </p:spPr>
+        <p:txBody>
+          <a:bodyPr wrap="square" lIns="254" tIns="254" rIns="254" bIns="254" rtlCol="0" anchor="ctr"/>
+          <a:lstStyle/>
+          <a:p>
+            <a:pPr algn="ctr" indent="0" marL="0">
+              <a:buNone/>
+            </a:pPr>
+            <a:r>
+              <a:rPr lang="en-US" sz="1000" b="1" dirty="0">
+                <a:solidFill>
+                  <a:schemeClr val="bg1"/>
+                </a:solidFill>
+              </a:rPr>
+              <a:t>layer1</a:t>
+            </a:r>
+            <a:endParaRPr lang="en-US" sz="1000" dirty="0"/>
+          </a:p>
+        </p:txBody>
+      </p:sp>
+      <p:sp>
+        <p:nvSpPr>
+          <p:cNvPr id="13" name="stage caption layer1"/>
+          <p:cNvSpPr txBox="1"/>
+          <p:nvPr/>
+        </p:nvSpPr>
+        <p:spPr>
+          <a:xfrm>
+            <a:off x="2258568" y="2770632"/>
+            <a:ext cx="896112" cy="384048"/>
+          </a:xfrm>
+          <a:prstGeom prst="rect">
+            <a:avLst/>
+          </a:prstGeom>
+          <a:noFill/>
+          <a:ln/>
+        </p:spPr>
+        <p:txBody>
+          <a:bodyPr wrap="square" lIns="0" tIns="0" rIns="0" bIns="0" rtlCol="0" anchor="t"/>
+          <a:lstStyle/>
+          <a:p>
+            <a:pPr algn="ctr" indent="0" marL="0">
+              <a:buNone/>
+            </a:pPr>
+            <a:r>
+              <a:rPr lang="en-US" sz="900" dirty="0">
+                <a:solidFill>
+                  <a:schemeClr val="tx1"/>
+                </a:solidFill>
+              </a:rPr>
+              <a:t>56 x 56 x 64</a:t>
+            </a:r>
+            <a:endParaRPr lang="en-US" sz="900" dirty="0"/>
+          </a:p>
+          <a:p>
+            <a:pPr algn="ctr" indent="0" marL="0">
+              <a:buNone/>
+            </a:pPr>
+            <a:r>
+              <a:rPr lang="en-US" sz="900" dirty="0">
+                <a:solidFill>
+                  <a:schemeClr val="tx1"/>
+                </a:solidFill>
+              </a:rPr>
+              <a:t>148 k weights</a:t>
+            </a:r>
+            <a:endParaRPr lang="en-US" sz="900" dirty="0"/>
+          </a:p>
+        </p:txBody>
+      </p:sp>
+      <p:sp>
+        <p:nvSpPr>
+          <p:cNvPr id="14" name="stage arrow 3"/>
+          <p:cNvSpPr/>
+          <p:nvPr/>
+        </p:nvSpPr>
+        <p:spPr>
+          <a:xfrm>
+            <a:off x="3108960" y="1874520"/>
+            <a:ext cx="128016" cy="0"/>
+          </a:xfrm>
+          <a:prstGeom prst="line">
+            <a:avLst/>
+          </a:prstGeom>
+          <a:noFill/>
+          <a:ln w="19050">
+            <a:solidFill>
+              <a:srgbClr val="3A3F4B"/>
+            </a:solidFill>
+            <a:prstDash val="solid"/>
+            <a:tailEnd type="triangle"/>
+          </a:ln>
+        </p:spPr>
+      </p:sp>
+      <p:sp>
+        <p:nvSpPr>
+          <p:cNvPr id="15" name="stage layer2"/>
+          <p:cNvSpPr/>
+          <p:nvPr/>
+        </p:nvSpPr>
+        <p:spPr>
+          <a:xfrm>
+            <a:off x="3264408" y="1288729"/>
+            <a:ext cx="749808" cy="1171583"/>
+          </a:xfrm>
+          <a:prstGeom prst="roundRect">
+            <a:avLst>
+              <a:gd name="adj" fmla="val 7317"/>
+            </a:avLst>
+          </a:prstGeom>
+          <a:solidFill>
+            <a:schemeClr val="tx2"/>
+          </a:solidFill>
+          <a:ln w="12700">
+            <a:solidFill>
+              <a:schemeClr val="tx2"/>
+            </a:solidFill>
+            <a:prstDash val="solid"/>
+          </a:ln>
+        </p:spPr>
+      </p:sp>
+      <p:sp>
+        <p:nvSpPr>
+          <p:cNvPr id="16" name="stage name layer2"/>
+          <p:cNvSpPr txBox="1"/>
+          <p:nvPr/>
+        </p:nvSpPr>
+        <p:spPr>
+          <a:xfrm>
+            <a:off x="3264408" y="1288729"/>
+            <a:ext cx="749808" cy="1171583"/>
+          </a:xfrm>
+          <a:prstGeom prst="rect">
+            <a:avLst/>
+          </a:prstGeom>
+          <a:noFill/>
+          <a:ln/>
+        </p:spPr>
+        <p:txBody>
+          <a:bodyPr wrap="square" lIns="254" tIns="254" rIns="254" bIns="254" rtlCol="0" anchor="ctr"/>
+          <a:lstStyle/>
+          <a:p>
+            <a:pPr algn="ctr" indent="0" marL="0">
+              <a:buNone/>
+            </a:pPr>
+            <a:r>
+              <a:rPr lang="en-US" sz="1000" b="1" dirty="0">
+                <a:solidFill>
+                  <a:schemeClr val="bg1"/>
+                </a:solidFill>
+              </a:rPr>
+              <a:t>layer2</a:t>
+            </a:r>
+            <a:endParaRPr lang="en-US" sz="1000" dirty="0"/>
+          </a:p>
+        </p:txBody>
+      </p:sp>
+      <p:sp>
+        <p:nvSpPr>
+          <p:cNvPr id="17" name="stage caption layer2"/>
+          <p:cNvSpPr txBox="1"/>
+          <p:nvPr/>
+        </p:nvSpPr>
+        <p:spPr>
+          <a:xfrm>
+            <a:off x="3191256" y="2770632"/>
+            <a:ext cx="896112" cy="384048"/>
+          </a:xfrm>
+          <a:prstGeom prst="rect">
+            <a:avLst/>
+          </a:prstGeom>
+          <a:noFill/>
+          <a:ln/>
+        </p:spPr>
+        <p:txBody>
+          <a:bodyPr wrap="square" lIns="0" tIns="0" rIns="0" bIns="0" rtlCol="0" anchor="t"/>
+          <a:lstStyle/>
+          <a:p>
+            <a:pPr algn="ctr" indent="0" marL="0">
+              <a:buNone/>
+            </a:pPr>
+            <a:r>
+              <a:rPr lang="en-US" sz="900" dirty="0">
+                <a:solidFill>
+                  <a:schemeClr val="tx1"/>
+                </a:solidFill>
+              </a:rPr>
+              <a:t>28 x 28 x 128</a:t>
+            </a:r>
+            <a:endParaRPr lang="en-US" sz="900" dirty="0"/>
+          </a:p>
+          <a:p>
+            <a:pPr algn="ctr" indent="0" marL="0">
+              <a:buNone/>
+            </a:pPr>
+            <a:r>
+              <a:rPr lang="en-US" sz="900" dirty="0">
+                <a:solidFill>
+                  <a:schemeClr val="tx1"/>
+                </a:solidFill>
+              </a:rPr>
+              <a:t>526 k weights</a:t>
+            </a:r>
+            <a:endParaRPr lang="en-US" sz="900" dirty="0"/>
+          </a:p>
+        </p:txBody>
+      </p:sp>
+      <p:sp>
+        <p:nvSpPr>
+          <p:cNvPr id="18" name="stage arrow 4"/>
+          <p:cNvSpPr/>
+          <p:nvPr/>
+        </p:nvSpPr>
+        <p:spPr>
+          <a:xfrm>
+            <a:off x="4041648" y="1874520"/>
+            <a:ext cx="128016" cy="0"/>
+          </a:xfrm>
+          <a:prstGeom prst="line">
+            <a:avLst/>
+          </a:prstGeom>
+          <a:noFill/>
+          <a:ln w="19050">
+            <a:solidFill>
+              <a:srgbClr val="3A3F4B"/>
+            </a:solidFill>
+            <a:prstDash val="solid"/>
+            <a:tailEnd type="triangle"/>
+          </a:ln>
+        </p:spPr>
+      </p:sp>
+      <p:sp>
+        <p:nvSpPr>
+          <p:cNvPr id="19" name="stage layer3"/>
+          <p:cNvSpPr/>
+          <p:nvPr/>
+        </p:nvSpPr>
+        <p:spPr>
+          <a:xfrm>
+            <a:off x="4197096" y="1367785"/>
+            <a:ext cx="749808" cy="1013470"/>
+          </a:xfrm>
+          <a:prstGeom prst="roundRect">
+            <a:avLst>
+              <a:gd name="adj" fmla="val 7317"/>
+            </a:avLst>
+          </a:prstGeom>
+          <a:solidFill>
+            <a:schemeClr val="tx2"/>
+          </a:solidFill>
+          <a:ln w="12700">
+            <a:solidFill>
+              <a:schemeClr val="tx2"/>
+            </a:solidFill>
+            <a:prstDash val="solid"/>
+          </a:ln>
+        </p:spPr>
+      </p:sp>
+      <p:sp>
+        <p:nvSpPr>
+          <p:cNvPr id="20" name="stage name layer3"/>
+          <p:cNvSpPr txBox="1"/>
+          <p:nvPr/>
+        </p:nvSpPr>
+        <p:spPr>
+          <a:xfrm>
+            <a:off x="4197096" y="1367785"/>
+            <a:ext cx="749808" cy="1013470"/>
+          </a:xfrm>
+          <a:prstGeom prst="rect">
+            <a:avLst/>
+          </a:prstGeom>
+          <a:noFill/>
+          <a:ln/>
+        </p:spPr>
+        <p:txBody>
+          <a:bodyPr wrap="square" lIns="254" tIns="254" rIns="254" bIns="254" rtlCol="0" anchor="ctr"/>
+          <a:lstStyle/>
+          <a:p>
+            <a:pPr algn="ctr" indent="0" marL="0">
+              <a:buNone/>
+            </a:pPr>
+            <a:r>
+              <a:rPr lang="en-US" sz="1000" b="1" dirty="0">
+                <a:solidFill>
+                  <a:schemeClr val="bg1"/>
+                </a:solidFill>
+              </a:rPr>
+              <a:t>layer3</a:t>
+            </a:r>
+            <a:endParaRPr lang="en-US" sz="1000" dirty="0"/>
+          </a:p>
+        </p:txBody>
+      </p:sp>
+      <p:sp>
+        <p:nvSpPr>
+          <p:cNvPr id="21" name="stage caption layer3"/>
+          <p:cNvSpPr txBox="1"/>
+          <p:nvPr/>
+        </p:nvSpPr>
+        <p:spPr>
+          <a:xfrm>
+            <a:off x="4123944" y="2770632"/>
+            <a:ext cx="896112" cy="384048"/>
+          </a:xfrm>
+          <a:prstGeom prst="rect">
+            <a:avLst/>
+          </a:prstGeom>
+          <a:noFill/>
+          <a:ln/>
+        </p:spPr>
+        <p:txBody>
+          <a:bodyPr wrap="square" lIns="0" tIns="0" rIns="0" bIns="0" rtlCol="0" anchor="t"/>
+          <a:lstStyle/>
+          <a:p>
+            <a:pPr algn="ctr" indent="0" marL="0">
+              <a:buNone/>
+            </a:pPr>
+            <a:r>
+              <a:rPr lang="en-US" sz="900" dirty="0">
+                <a:solidFill>
+                  <a:schemeClr val="tx1"/>
+                </a:solidFill>
+              </a:rPr>
+              <a:t>14 x 14 x 256</a:t>
+            </a:r>
+            <a:endParaRPr lang="en-US" sz="900" dirty="0"/>
+          </a:p>
+          <a:p>
+            <a:pPr algn="ctr" indent="0" marL="0">
+              <a:buNone/>
+            </a:pPr>
+            <a:r>
+              <a:rPr lang="en-US" sz="900" dirty="0">
+                <a:solidFill>
+                  <a:schemeClr val="tx1"/>
+                </a:solidFill>
+              </a:rPr>
+              <a:t>2.1 M weights</a:t>
+            </a:r>
+            <a:endParaRPr lang="en-US" sz="900" dirty="0"/>
+          </a:p>
+        </p:txBody>
+      </p:sp>
+      <p:sp>
+        <p:nvSpPr>
+          <p:cNvPr id="22" name="stage arrow 5"/>
+          <p:cNvSpPr/>
+          <p:nvPr/>
+        </p:nvSpPr>
+        <p:spPr>
+          <a:xfrm>
+            <a:off x="4974336" y="1874520"/>
+            <a:ext cx="128016" cy="0"/>
+          </a:xfrm>
+          <a:prstGeom prst="line">
+            <a:avLst/>
+          </a:prstGeom>
+          <a:noFill/>
+          <a:ln w="19050">
+            <a:solidFill>
+              <a:srgbClr val="3A3F4B"/>
+            </a:solidFill>
+            <a:prstDash val="solid"/>
+            <a:tailEnd type="triangle"/>
+          </a:ln>
+        </p:spPr>
+      </p:sp>
+      <p:sp>
+        <p:nvSpPr>
+          <p:cNvPr id="23" name="stage layer4"/>
+          <p:cNvSpPr/>
+          <p:nvPr/>
+        </p:nvSpPr>
+        <p:spPr>
+          <a:xfrm>
+            <a:off x="5129784" y="1446841"/>
+            <a:ext cx="749808" cy="855358"/>
+          </a:xfrm>
+          <a:prstGeom prst="roundRect">
+            <a:avLst>
+              <a:gd name="adj" fmla="val 7317"/>
+            </a:avLst>
+          </a:prstGeom>
+          <a:solidFill>
+            <a:schemeClr val="tx2"/>
+          </a:solidFill>
+          <a:ln w="12700">
+            <a:solidFill>
+              <a:schemeClr val="tx2"/>
+            </a:solidFill>
+            <a:prstDash val="solid"/>
+          </a:ln>
+        </p:spPr>
+      </p:sp>
+      <p:sp>
+        <p:nvSpPr>
+          <p:cNvPr id="24" name="stage name layer4"/>
+          <p:cNvSpPr txBox="1"/>
+          <p:nvPr/>
+        </p:nvSpPr>
+        <p:spPr>
+          <a:xfrm>
+            <a:off x="5129784" y="1446841"/>
+            <a:ext cx="749808" cy="855358"/>
+          </a:xfrm>
+          <a:prstGeom prst="rect">
+            <a:avLst/>
+          </a:prstGeom>
+          <a:noFill/>
+          <a:ln/>
+        </p:spPr>
+        <p:txBody>
+          <a:bodyPr wrap="square" lIns="254" tIns="254" rIns="254" bIns="254" rtlCol="0" anchor="ctr"/>
+          <a:lstStyle/>
+          <a:p>
+            <a:pPr algn="ctr" indent="0" marL="0">
+              <a:buNone/>
+            </a:pPr>
+            <a:r>
+              <a:rPr lang="en-US" sz="1000" b="1" dirty="0">
+                <a:solidFill>
+                  <a:schemeClr val="bg1"/>
+                </a:solidFill>
+              </a:rPr>
+              <a:t>layer4</a:t>
+            </a:r>
+            <a:endParaRPr lang="en-US" sz="1000" dirty="0"/>
+          </a:p>
+        </p:txBody>
+      </p:sp>
+      <p:sp>
+        <p:nvSpPr>
+          <p:cNvPr id="25" name="stage caption layer4"/>
+          <p:cNvSpPr txBox="1"/>
+          <p:nvPr/>
+        </p:nvSpPr>
+        <p:spPr>
+          <a:xfrm>
+            <a:off x="5056632" y="2770632"/>
+            <a:ext cx="896112" cy="384048"/>
+          </a:xfrm>
+          <a:prstGeom prst="rect">
+            <a:avLst/>
+          </a:prstGeom>
+          <a:noFill/>
+          <a:ln/>
+        </p:spPr>
+        <p:txBody>
+          <a:bodyPr wrap="square" lIns="0" tIns="0" rIns="0" bIns="0" rtlCol="0" anchor="t"/>
+          <a:lstStyle/>
+          <a:p>
+            <a:pPr algn="ctr" indent="0" marL="0">
+              <a:buNone/>
+            </a:pPr>
+            <a:r>
+              <a:rPr lang="en-US" sz="900" dirty="0">
+                <a:solidFill>
+                  <a:schemeClr val="tx1"/>
+                </a:solidFill>
+              </a:rPr>
+              <a:t>7 x 7 x 512</a:t>
+            </a:r>
+            <a:endParaRPr lang="en-US" sz="900" dirty="0"/>
+          </a:p>
+          <a:p>
+            <a:pPr algn="ctr" indent="0" marL="0">
+              <a:buNone/>
+            </a:pPr>
+            <a:r>
+              <a:rPr lang="en-US" sz="900" dirty="0">
+                <a:solidFill>
+                  <a:schemeClr val="tx1"/>
+                </a:solidFill>
+              </a:rPr>
+              <a:t>8.4 M weights</a:t>
+            </a:r>
+            <a:endParaRPr lang="en-US" sz="900" dirty="0"/>
+          </a:p>
+        </p:txBody>
+      </p:sp>
+      <p:sp>
+        <p:nvSpPr>
+          <p:cNvPr id="26" name="stage arrow 6"/>
+          <p:cNvSpPr/>
+          <p:nvPr/>
+        </p:nvSpPr>
+        <p:spPr>
+          <a:xfrm>
+            <a:off x="5907024" y="1874520"/>
+            <a:ext cx="128016" cy="0"/>
+          </a:xfrm>
+          <a:prstGeom prst="line">
+            <a:avLst/>
+          </a:prstGeom>
+          <a:noFill/>
+          <a:ln w="19050">
+            <a:solidFill>
+              <a:srgbClr val="3A3F4B"/>
+            </a:solidFill>
+            <a:prstDash val="solid"/>
+            <a:tailEnd type="triangle"/>
+          </a:ln>
+        </p:spPr>
+      </p:sp>
+      <p:sp>
+        <p:nvSpPr>
+          <p:cNvPr id="27" name="stage average"/>
+          <p:cNvSpPr/>
+          <p:nvPr/>
+        </p:nvSpPr>
+        <p:spPr>
+          <a:xfrm>
+            <a:off x="6062472" y="1668780"/>
+            <a:ext cx="749808" cy="411480"/>
+          </a:xfrm>
+          <a:prstGeom prst="roundRect">
+            <a:avLst>
+              <a:gd name="adj" fmla="val 13333"/>
+            </a:avLst>
+          </a:prstGeom>
+          <a:solidFill>
+            <a:schemeClr val="tx2"/>
+          </a:solidFill>
+          <a:ln w="12700">
+            <a:solidFill>
+              <a:schemeClr val="tx2"/>
+            </a:solidFill>
+            <a:prstDash val="solid"/>
+          </a:ln>
+        </p:spPr>
+      </p:sp>
+      <p:sp>
+        <p:nvSpPr>
+          <p:cNvPr id="28" name="stage name average"/>
+          <p:cNvSpPr txBox="1"/>
+          <p:nvPr/>
+        </p:nvSpPr>
+        <p:spPr>
+          <a:xfrm>
+            <a:off x="6062472" y="1668780"/>
+            <a:ext cx="749808" cy="411480"/>
+          </a:xfrm>
+          <a:prstGeom prst="rect">
+            <a:avLst/>
+          </a:prstGeom>
+          <a:noFill/>
+          <a:ln/>
+        </p:spPr>
+        <p:txBody>
+          <a:bodyPr wrap="square" lIns="254" tIns="254" rIns="254" bIns="254" rtlCol="0" anchor="ctr"/>
+          <a:lstStyle/>
+          <a:p>
+            <a:pPr algn="ctr" indent="0" marL="0">
+              <a:buNone/>
+            </a:pPr>
+            <a:r>
+              <a:rPr lang="en-US" sz="1000" b="1" dirty="0">
+                <a:solidFill>
+                  <a:schemeClr val="bg1"/>
+                </a:solidFill>
+              </a:rPr>
+              <a:t>average</a:t>
+            </a:r>
+            <a:endParaRPr lang="en-US" sz="1000" dirty="0"/>
+          </a:p>
+        </p:txBody>
+      </p:sp>
+      <p:sp>
+        <p:nvSpPr>
+          <p:cNvPr id="29" name="stage caption average"/>
+          <p:cNvSpPr txBox="1"/>
+          <p:nvPr/>
+        </p:nvSpPr>
+        <p:spPr>
+          <a:xfrm>
+            <a:off x="5989320" y="2770632"/>
+            <a:ext cx="896112" cy="384048"/>
+          </a:xfrm>
+          <a:prstGeom prst="rect">
+            <a:avLst/>
+          </a:prstGeom>
+          <a:noFill/>
+          <a:ln/>
+        </p:spPr>
+        <p:txBody>
+          <a:bodyPr wrap="square" lIns="0" tIns="0" rIns="0" bIns="0" rtlCol="0" anchor="t"/>
+          <a:lstStyle/>
+          <a:p>
+            <a:pPr algn="ctr" indent="0" marL="0">
+              <a:buNone/>
+            </a:pPr>
+            <a:r>
+              <a:rPr lang="en-US" sz="900" dirty="0">
+                <a:solidFill>
+                  <a:schemeClr val="tx1"/>
+                </a:solidFill>
+              </a:rPr>
+              <a:t>512 numbers</a:t>
+            </a:r>
+            <a:endParaRPr lang="en-US" sz="900" dirty="0"/>
+          </a:p>
+          <a:p>
+            <a:pPr algn="ctr" indent="0" marL="0">
+              <a:buNone/>
+            </a:pPr>
+            <a:r>
+              <a:rPr lang="en-US" sz="900" dirty="0">
+                <a:solidFill>
+                  <a:schemeClr val="tx1"/>
+                </a:solidFill>
+              </a:rPr>
+              <a:t>no weights</a:t>
+            </a:r>
+            <a:endParaRPr lang="en-US" sz="900" dirty="0"/>
+          </a:p>
+        </p:txBody>
+      </p:sp>
+      <p:sp>
+        <p:nvSpPr>
+          <p:cNvPr id="30" name="stage arrow 7"/>
+          <p:cNvSpPr/>
+          <p:nvPr/>
+        </p:nvSpPr>
+        <p:spPr>
+          <a:xfrm>
+            <a:off x="6839712" y="1874520"/>
+            <a:ext cx="128016" cy="0"/>
+          </a:xfrm>
+          <a:prstGeom prst="line">
+            <a:avLst/>
+          </a:prstGeom>
+          <a:noFill/>
+          <a:ln w="19050">
+            <a:solidFill>
+              <a:srgbClr val="3A3F4B"/>
+            </a:solidFill>
+            <a:prstDash val="solid"/>
+            <a:tailEnd type="triangle"/>
+          </a:ln>
+        </p:spPr>
+      </p:sp>
+      <p:sp>
+        <p:nvSpPr>
+          <p:cNvPr id="31" name="stage linear head"/>
+          <p:cNvSpPr/>
+          <p:nvPr/>
+        </p:nvSpPr>
+        <p:spPr>
+          <a:xfrm>
+            <a:off x="6995160" y="1668780"/>
+            <a:ext cx="749808" cy="411480"/>
+          </a:xfrm>
+          <a:prstGeom prst="roundRect">
+            <a:avLst>
+              <a:gd name="adj" fmla="val 13333"/>
+            </a:avLst>
+          </a:prstGeom>
+          <a:solidFill>
+            <a:schemeClr val="accent1"/>
+          </a:solidFill>
+          <a:ln w="12700">
+            <a:solidFill>
+              <a:schemeClr val="accent1"/>
+            </a:solidFill>
+            <a:prstDash val="solid"/>
+          </a:ln>
+        </p:spPr>
+      </p:sp>
+      <p:sp>
+        <p:nvSpPr>
+          <p:cNvPr id="32" name="stage name linear head"/>
+          <p:cNvSpPr txBox="1"/>
+          <p:nvPr/>
+        </p:nvSpPr>
+        <p:spPr>
+          <a:xfrm>
+            <a:off x="6995160" y="1668780"/>
+            <a:ext cx="749808" cy="411480"/>
+          </a:xfrm>
+          <a:prstGeom prst="rect">
+            <a:avLst/>
+          </a:prstGeom>
+          <a:noFill/>
+          <a:ln/>
+        </p:spPr>
+        <p:txBody>
+          <a:bodyPr wrap="square" lIns="254" tIns="254" rIns="254" bIns="254" rtlCol="0" anchor="ctr"/>
+          <a:lstStyle/>
+          <a:p>
+            <a:pPr algn="ctr" indent="0" marL="0">
+              <a:buNone/>
+            </a:pPr>
+            <a:r>
+              <a:rPr lang="en-US" sz="1000" b="1" dirty="0">
+                <a:solidFill>
+                  <a:schemeClr val="bg1"/>
+                </a:solidFill>
+              </a:rPr>
+              <a:t>linear head</a:t>
+            </a:r>
+            <a:endParaRPr lang="en-US" sz="1000" dirty="0"/>
+          </a:p>
+        </p:txBody>
+      </p:sp>
+      <p:sp>
+        <p:nvSpPr>
+          <p:cNvPr id="33" name="stage caption linear head"/>
+          <p:cNvSpPr txBox="1"/>
+          <p:nvPr/>
+        </p:nvSpPr>
+        <p:spPr>
+          <a:xfrm>
+            <a:off x="6922008" y="2770632"/>
+            <a:ext cx="896112" cy="384048"/>
+          </a:xfrm>
+          <a:prstGeom prst="rect">
+            <a:avLst/>
+          </a:prstGeom>
+          <a:noFill/>
+          <a:ln/>
+        </p:spPr>
+        <p:txBody>
+          <a:bodyPr wrap="square" lIns="0" tIns="0" rIns="0" bIns="0" rtlCol="0" anchor="t"/>
+          <a:lstStyle/>
+          <a:p>
+            <a:pPr algn="ctr" indent="0" marL="0">
+              <a:buNone/>
+            </a:pPr>
+            <a:r>
+              <a:rPr lang="en-US" sz="900" dirty="0">
+                <a:solidFill>
+                  <a:schemeClr val="tx1"/>
+                </a:solidFill>
+              </a:rPr>
+              <a:t>512 → 5</a:t>
+            </a:r>
+            <a:endParaRPr lang="en-US" sz="900" dirty="0"/>
+          </a:p>
+          <a:p>
+            <a:pPr algn="ctr" indent="0" marL="0">
+              <a:buNone/>
+            </a:pPr>
+            <a:r>
+              <a:rPr lang="en-US" sz="900" dirty="0">
+                <a:solidFill>
+                  <a:schemeClr val="tx1"/>
+                </a:solidFill>
+              </a:rPr>
+              <a:t>2 565 weights</a:t>
+            </a:r>
+            <a:endParaRPr lang="en-US" sz="900" dirty="0"/>
+          </a:p>
+        </p:txBody>
+      </p:sp>
+      <p:sp>
+        <p:nvSpPr>
+          <p:cNvPr id="34" name="stage arrow 8"/>
+          <p:cNvSpPr/>
+          <p:nvPr/>
+        </p:nvSpPr>
+        <p:spPr>
+          <a:xfrm>
+            <a:off x="7772400" y="1874520"/>
+            <a:ext cx="128016" cy="0"/>
+          </a:xfrm>
+          <a:prstGeom prst="line">
+            <a:avLst/>
+          </a:prstGeom>
+          <a:noFill/>
+          <a:ln w="19050">
+            <a:solidFill>
+              <a:srgbClr val="3A3F4B"/>
+            </a:solidFill>
+            <a:prstDash val="solid"/>
+            <a:tailEnd type="triangle"/>
+          </a:ln>
+        </p:spPr>
+      </p:sp>
+      <p:sp>
+        <p:nvSpPr>
+          <p:cNvPr id="35" name="stage 5 styles"/>
+          <p:cNvSpPr/>
+          <p:nvPr/>
+        </p:nvSpPr>
+        <p:spPr>
+          <a:xfrm>
+            <a:off x="7927848" y="1668780"/>
+            <a:ext cx="749808" cy="411480"/>
+          </a:xfrm>
+          <a:prstGeom prst="roundRect">
+            <a:avLst>
+              <a:gd name="adj" fmla="val 13333"/>
+            </a:avLst>
+          </a:prstGeom>
+          <a:solidFill>
+            <a:schemeClr val="bg2"/>
+          </a:solidFill>
+          <a:ln w="12700">
+            <a:solidFill>
+              <a:schemeClr val="bg2"/>
+            </a:solidFill>
+            <a:prstDash val="solid"/>
+          </a:ln>
+        </p:spPr>
+      </p:sp>
+      <p:sp>
+        <p:nvSpPr>
+          <p:cNvPr id="36" name="stage name 5 styles"/>
+          <p:cNvSpPr txBox="1"/>
+          <p:nvPr/>
+        </p:nvSpPr>
+        <p:spPr>
+          <a:xfrm>
+            <a:off x="7927848" y="1668780"/>
+            <a:ext cx="749808" cy="411480"/>
+          </a:xfrm>
+          <a:prstGeom prst="rect">
+            <a:avLst/>
+          </a:prstGeom>
+          <a:noFill/>
+          <a:ln/>
+        </p:spPr>
+        <p:txBody>
+          <a:bodyPr wrap="square" lIns="254" tIns="254" rIns="254" bIns="254" rtlCol="0" anchor="ctr"/>
+          <a:lstStyle/>
+          <a:p>
+            <a:pPr algn="ctr" indent="0" marL="0">
+              <a:buNone/>
+            </a:pPr>
+            <a:r>
+              <a:rPr lang="en-US" sz="1000" b="1" dirty="0">
+                <a:solidFill>
+                  <a:schemeClr val="tx2"/>
+                </a:solidFill>
+              </a:rPr>
+              <a:t>5 styles</a:t>
+            </a:r>
+            <a:endParaRPr lang="en-US" sz="1000" dirty="0"/>
+          </a:p>
+        </p:txBody>
+      </p:sp>
+      <p:sp>
+        <p:nvSpPr>
+          <p:cNvPr id="37" name="stage caption 5 styles"/>
+          <p:cNvSpPr txBox="1"/>
+          <p:nvPr/>
+        </p:nvSpPr>
+        <p:spPr>
+          <a:xfrm>
+            <a:off x="7854696" y="2770632"/>
+            <a:ext cx="896112" cy="384048"/>
+          </a:xfrm>
+          <a:prstGeom prst="rect">
+            <a:avLst/>
+          </a:prstGeom>
+          <a:noFill/>
+          <a:ln/>
+        </p:spPr>
+        <p:txBody>
+          <a:bodyPr wrap="square" lIns="0" tIns="0" rIns="0" bIns="0" rtlCol="0" anchor="t"/>
+          <a:lstStyle/>
+          <a:p>
+            <a:pPr algn="ctr" indent="0" marL="0">
+              <a:buNone/>
+            </a:pPr>
+            <a:r>
+              <a:rPr lang="en-US" sz="900" dirty="0">
+                <a:solidFill>
+                  <a:schemeClr val="tx1"/>
+                </a:solidFill>
+              </a:rPr>
+              <a:t>highest score wins</a:t>
+            </a:r>
+            <a:endParaRPr lang="en-US" sz="900" dirty="0"/>
+          </a:p>
+        </p:txBody>
+      </p:sp>
+      <p:sp>
+        <p:nvSpPr>
+          <p:cNvPr id="38" name="sees edges, colours"/>
+          <p:cNvSpPr txBox="1"/>
+          <p:nvPr/>
+        </p:nvSpPr>
+        <p:spPr>
+          <a:xfrm>
+            <a:off x="1353312" y="987552"/>
+            <a:ext cx="1773936" cy="182880"/>
+          </a:xfrm>
+          <a:prstGeom prst="rect">
+            <a:avLst/>
+          </a:prstGeom>
+          <a:noFill/>
+          <a:ln/>
+        </p:spPr>
+        <p:txBody>
+          <a:bodyPr wrap="square" lIns="0" tIns="0" rIns="0" bIns="0" rtlCol="0" anchor="ctr"/>
+          <a:lstStyle/>
+          <a:p>
+            <a:pPr algn="ctr" indent="0" marL="0">
+              <a:buNone/>
+            </a:pPr>
+            <a:r>
+              <a:rPr lang="en-US" sz="900" i="1" dirty="0">
+                <a:solidFill>
+                  <a:schemeClr val="accent1"/>
+                </a:solidFill>
+              </a:rPr>
+              <a:t>edges, colours</a:t>
+            </a:r>
+            <a:endParaRPr lang="en-US" sz="900" dirty="0"/>
+          </a:p>
+        </p:txBody>
+      </p:sp>
+      <p:sp>
+        <p:nvSpPr>
+          <p:cNvPr id="39" name="sees textures"/>
+          <p:cNvSpPr txBox="1"/>
+          <p:nvPr/>
+        </p:nvSpPr>
+        <p:spPr>
+          <a:xfrm>
+            <a:off x="3218688" y="987552"/>
+            <a:ext cx="841248" cy="182880"/>
+          </a:xfrm>
+          <a:prstGeom prst="rect">
+            <a:avLst/>
+          </a:prstGeom>
+          <a:noFill/>
+          <a:ln/>
+        </p:spPr>
+        <p:txBody>
+          <a:bodyPr wrap="square" lIns="0" tIns="0" rIns="0" bIns="0" rtlCol="0" anchor="ctr"/>
+          <a:lstStyle/>
+          <a:p>
+            <a:pPr algn="ctr" indent="0" marL="0">
+              <a:buNone/>
+            </a:pPr>
+            <a:r>
+              <a:rPr lang="en-US" sz="900" i="1" dirty="0">
+                <a:solidFill>
+                  <a:schemeClr val="accent1"/>
+                </a:solidFill>
+              </a:rPr>
+              <a:t>textures</a:t>
+            </a:r>
+            <a:endParaRPr lang="en-US" sz="900" dirty="0"/>
+          </a:p>
+        </p:txBody>
+      </p:sp>
+      <p:sp>
+        <p:nvSpPr>
+          <p:cNvPr id="40" name="sees patterns"/>
+          <p:cNvSpPr txBox="1"/>
+          <p:nvPr/>
+        </p:nvSpPr>
+        <p:spPr>
+          <a:xfrm>
+            <a:off x="4151376" y="987552"/>
+            <a:ext cx="841248" cy="182880"/>
+          </a:xfrm>
+          <a:prstGeom prst="rect">
+            <a:avLst/>
+          </a:prstGeom>
+          <a:noFill/>
+          <a:ln/>
+        </p:spPr>
+        <p:txBody>
+          <a:bodyPr wrap="square" lIns="0" tIns="0" rIns="0" bIns="0" rtlCol="0" anchor="ctr"/>
+          <a:lstStyle/>
+          <a:p>
+            <a:pPr algn="ctr" indent="0" marL="0">
+              <a:buNone/>
+            </a:pPr>
+            <a:r>
+              <a:rPr lang="en-US" sz="900" i="1" dirty="0">
+                <a:solidFill>
+                  <a:schemeClr val="accent1"/>
+                </a:solidFill>
+              </a:rPr>
+              <a:t>patterns</a:t>
+            </a:r>
+            <a:endParaRPr lang="en-US" sz="900" dirty="0"/>
+          </a:p>
+        </p:txBody>
+      </p:sp>
+      <p:sp>
+        <p:nvSpPr>
+          <p:cNvPr id="41" name="sees shapes"/>
+          <p:cNvSpPr txBox="1"/>
+          <p:nvPr/>
+        </p:nvSpPr>
+        <p:spPr>
+          <a:xfrm>
+            <a:off x="5084064" y="987552"/>
+            <a:ext cx="841248" cy="182880"/>
+          </a:xfrm>
+          <a:prstGeom prst="rect">
+            <a:avLst/>
+          </a:prstGeom>
+          <a:noFill/>
+          <a:ln/>
+        </p:spPr>
+        <p:txBody>
+          <a:bodyPr wrap="square" lIns="0" tIns="0" rIns="0" bIns="0" rtlCol="0" anchor="ctr"/>
+          <a:lstStyle/>
+          <a:p>
+            <a:pPr algn="ctr" indent="0" marL="0">
+              <a:buNone/>
+            </a:pPr>
+            <a:r>
+              <a:rPr lang="en-US" sz="900" i="1" dirty="0">
+                <a:solidFill>
+                  <a:schemeClr val="accent1"/>
+                </a:solidFill>
+              </a:rPr>
+              <a:t>shapes</a:t>
+            </a:r>
+            <a:endParaRPr lang="en-US" sz="900" dirty="0"/>
+          </a:p>
+        </p:txBody>
+      </p:sp>
+      <p:sp>
+        <p:nvSpPr>
+          <p:cNvPr id="42" name="frozen bar"/>
+          <p:cNvSpPr/>
+          <p:nvPr/>
+        </p:nvSpPr>
+        <p:spPr>
+          <a:xfrm>
+            <a:off x="1399032" y="3218688"/>
+            <a:ext cx="5413248" cy="45720"/>
+          </a:xfrm>
+          <a:prstGeom prst="rect">
+            <a:avLst/>
+          </a:prstGeom>
+          <a:solidFill>
+            <a:schemeClr val="tx2"/>
+          </a:solidFill>
+          <a:ln w="12700">
+            <a:solidFill>
+              <a:schemeClr val="tx2"/>
+            </a:solidFill>
+            <a:prstDash val="solid"/>
+          </a:ln>
+        </p:spPr>
+      </p:sp>
+      <p:sp>
+        <p:nvSpPr>
+          <p:cNvPr id="43" name="frozen label"/>
+          <p:cNvSpPr txBox="1"/>
+          <p:nvPr/>
+        </p:nvSpPr>
+        <p:spPr>
+          <a:xfrm>
+            <a:off x="1399032" y="3291840"/>
+            <a:ext cx="5413248" cy="201168"/>
+          </a:xfrm>
+          <a:prstGeom prst="rect">
+            <a:avLst/>
+          </a:prstGeom>
+          <a:noFill/>
+          <a:ln/>
+        </p:spPr>
+        <p:txBody>
+          <a:bodyPr wrap="square" lIns="0" tIns="0" rIns="0" bIns="0" rtlCol="0" anchor="ctr"/>
+          <a:lstStyle/>
+          <a:p>
+            <a:pPr algn="ctr" indent="0" marL="0">
+              <a:buNone/>
+            </a:pPr>
+            <a:r>
+              <a:rPr lang="en-US" sz="1000" b="1" dirty="0">
+                <a:solidFill>
+                  <a:schemeClr val="tx2"/>
+                </a:solidFill>
+              </a:rPr>
+              <a:t>Frozen body: 11.2 million weights learned on ImageNet, never changed</a:t>
+            </a:r>
+            <a:endParaRPr lang="en-US" sz="1000" dirty="0"/>
+          </a:p>
+        </p:txBody>
+      </p:sp>
+      <p:sp>
+        <p:nvSpPr>
+          <p:cNvPr id="44" name="trained bar"/>
+          <p:cNvSpPr/>
+          <p:nvPr/>
+        </p:nvSpPr>
+        <p:spPr>
+          <a:xfrm>
+            <a:off x="6995160" y="3218688"/>
+            <a:ext cx="749808" cy="45720"/>
+          </a:xfrm>
+          <a:prstGeom prst="rect">
+            <a:avLst/>
+          </a:prstGeom>
+          <a:solidFill>
+            <a:schemeClr val="accent1"/>
+          </a:solidFill>
+          <a:ln w="12700">
+            <a:solidFill>
+              <a:schemeClr val="accent1"/>
+            </a:solidFill>
+            <a:prstDash val="solid"/>
+          </a:ln>
+        </p:spPr>
+      </p:sp>
+      <p:sp>
+        <p:nvSpPr>
+          <p:cNvPr id="45" name="trained label"/>
+          <p:cNvSpPr txBox="1"/>
+          <p:nvPr/>
+        </p:nvSpPr>
+        <p:spPr>
+          <a:xfrm>
+            <a:off x="6995160" y="3291840"/>
+            <a:ext cx="749808" cy="201168"/>
+          </a:xfrm>
+          <a:prstGeom prst="rect">
+            <a:avLst/>
+          </a:prstGeom>
+          <a:noFill/>
+          <a:ln/>
+        </p:spPr>
+        <p:txBody>
+          <a:bodyPr wrap="square" lIns="0" tIns="0" rIns="0" bIns="0" rtlCol="0" anchor="ctr"/>
+          <a:lstStyle/>
+          <a:p>
+            <a:pPr algn="ctr" indent="0" marL="0">
+              <a:buNone/>
+            </a:pPr>
+            <a:r>
+              <a:rPr lang="en-US" sz="1000" b="1" dirty="0">
+                <a:solidFill>
+                  <a:schemeClr val="accent1"/>
+                </a:solidFill>
+              </a:rPr>
+              <a:t>Trained by us</a:t>
+            </a:r>
+            <a:endParaRPr lang="en-US" sz="1000" dirty="0"/>
+          </a:p>
+        </p:txBody>
+      </p:sp>
+      <p:sp>
+        <p:nvSpPr>
+          <p:cNvPr id="46" name="block title"/>
+          <p:cNvSpPr txBox="1"/>
+          <p:nvPr/>
+        </p:nvSpPr>
+        <p:spPr>
+          <a:xfrm>
+            <a:off x="457200" y="3593592"/>
+            <a:ext cx="3291840" cy="182880"/>
+          </a:xfrm>
+          <a:prstGeom prst="rect">
+            <a:avLst/>
+          </a:prstGeom>
+          <a:noFill/>
+          <a:ln/>
+        </p:spPr>
+        <p:txBody>
+          <a:bodyPr wrap="square" lIns="0" tIns="0" rIns="0" bIns="0" rtlCol="0" anchor="ctr"/>
+          <a:lstStyle/>
+          <a:p>
+            <a:pPr indent="0" marL="0">
+              <a:buNone/>
+            </a:pPr>
+            <a:r>
+              <a:rPr lang="en-US" sz="1100" b="1" dirty="0">
+                <a:solidFill>
+                  <a:schemeClr val="tx2"/>
+                </a:solidFill>
+              </a:rPr>
+              <a:t>One residual block (2 per layer, 8 in all)</a:t>
+            </a:r>
+            <a:endParaRPr lang="en-US" sz="1100" dirty="0"/>
+          </a:p>
+        </p:txBody>
+      </p:sp>
+      <p:sp>
+        <p:nvSpPr>
+          <p:cNvPr id="47" name="block text 0 x"/>
+          <p:cNvSpPr txBox="1"/>
+          <p:nvPr/>
+        </p:nvSpPr>
+        <p:spPr>
+          <a:xfrm>
+            <a:off x="457200" y="4224528"/>
+            <a:ext cx="274320" cy="310896"/>
+          </a:xfrm>
+          <a:prstGeom prst="rect">
+            <a:avLst/>
+          </a:prstGeom>
+          <a:noFill/>
+          <a:ln/>
+        </p:spPr>
+        <p:txBody>
+          <a:bodyPr wrap="square" lIns="0" tIns="0" rIns="0" bIns="0" rtlCol="0" anchor="ctr"/>
+          <a:lstStyle/>
+          <a:p>
+            <a:pPr algn="ctr" indent="0" marL="0">
+              <a:buNone/>
+            </a:pPr>
+            <a:r>
+              <a:rPr lang="en-US" sz="1000" b="1" dirty="0">
+                <a:solidFill>
+                  <a:schemeClr val="tx2"/>
+                </a:solidFill>
+              </a:rPr>
+              <a:t>x</a:t>
+            </a:r>
+            <a:endParaRPr lang="en-US" sz="1000" dirty="0"/>
+          </a:p>
+        </p:txBody>
+      </p:sp>
+      <p:sp>
+        <p:nvSpPr>
+          <p:cNvPr id="48" name="block arrow 1"/>
+          <p:cNvSpPr/>
+          <p:nvPr/>
+        </p:nvSpPr>
+        <p:spPr>
+          <a:xfrm>
+            <a:off x="749808" y="4379976"/>
+            <a:ext cx="118872" cy="0"/>
+          </a:xfrm>
+          <a:prstGeom prst="line">
+            <a:avLst/>
+          </a:prstGeom>
+          <a:noFill/>
+          <a:ln w="15875">
+            <a:solidFill>
+              <a:srgbClr val="3A3F4B"/>
+            </a:solidFill>
+            <a:prstDash val="solid"/>
+            <a:tailEnd type="triangle"/>
+          </a:ln>
+        </p:spPr>
+      </p:sp>
+      <p:sp>
+        <p:nvSpPr>
+          <p:cNvPr id="49" name="block 1 conv 3x3"/>
+          <p:cNvSpPr/>
+          <p:nvPr/>
+        </p:nvSpPr>
+        <p:spPr>
+          <a:xfrm>
+            <a:off x="886968" y="4224528"/>
+            <a:ext cx="731520" cy="310896"/>
+          </a:xfrm>
+          <a:prstGeom prst="roundRect">
+            <a:avLst>
+              <a:gd name="adj" fmla="val 14706"/>
+            </a:avLst>
+          </a:prstGeom>
+          <a:solidFill>
+            <a:schemeClr val="tx2"/>
+          </a:solidFill>
+          <a:ln w="12700">
+            <a:solidFill>
+              <a:schemeClr val="tx2"/>
+            </a:solidFill>
+            <a:prstDash val="solid"/>
+          </a:ln>
+        </p:spPr>
+      </p:sp>
+      <p:sp>
+        <p:nvSpPr>
+          <p:cNvPr id="50" name="block text 1 conv 3x3"/>
+          <p:cNvSpPr txBox="1"/>
+          <p:nvPr/>
+        </p:nvSpPr>
+        <p:spPr>
+          <a:xfrm>
+            <a:off x="886968" y="4224528"/>
+            <a:ext cx="731520" cy="310896"/>
+          </a:xfrm>
+          <a:prstGeom prst="rect">
+            <a:avLst/>
+          </a:prstGeom>
+          <a:noFill/>
+          <a:ln/>
+        </p:spPr>
+        <p:txBody>
+          <a:bodyPr wrap="square" lIns="0" tIns="0" rIns="0" bIns="0" rtlCol="0" anchor="ctr"/>
+          <a:lstStyle/>
+          <a:p>
+            <a:pPr algn="ctr" indent="0" marL="0">
+              <a:buNone/>
+            </a:pPr>
+            <a:r>
+              <a:rPr lang="en-US" sz="1000" b="1" dirty="0">
+                <a:solidFill>
+                  <a:schemeClr val="bg1"/>
+                </a:solidFill>
+              </a:rPr>
+              <a:t>conv 3x3</a:t>
+            </a:r>
+            <a:endParaRPr lang="en-US" sz="1000" dirty="0"/>
+          </a:p>
+        </p:txBody>
+      </p:sp>
+      <p:sp>
+        <p:nvSpPr>
+          <p:cNvPr id="51" name="block arrow 2"/>
+          <p:cNvSpPr/>
+          <p:nvPr/>
+        </p:nvSpPr>
+        <p:spPr>
+          <a:xfrm>
+            <a:off x="1636776" y="4379976"/>
+            <a:ext cx="118872" cy="0"/>
+          </a:xfrm>
+          <a:prstGeom prst="line">
+            <a:avLst/>
+          </a:prstGeom>
+          <a:noFill/>
+          <a:ln w="15875">
+            <a:solidFill>
+              <a:srgbClr val="3A3F4B"/>
+            </a:solidFill>
+            <a:prstDash val="solid"/>
+            <a:tailEnd type="triangle"/>
+          </a:ln>
+        </p:spPr>
+      </p:sp>
+      <p:sp>
+        <p:nvSpPr>
+          <p:cNvPr id="52" name="block 2 BN + ReLU"/>
+          <p:cNvSpPr/>
+          <p:nvPr/>
+        </p:nvSpPr>
+        <p:spPr>
+          <a:xfrm>
+            <a:off x="1773936" y="4224528"/>
+            <a:ext cx="822960" cy="310896"/>
+          </a:xfrm>
+          <a:prstGeom prst="roundRect">
+            <a:avLst>
+              <a:gd name="adj" fmla="val 14706"/>
+            </a:avLst>
+          </a:prstGeom>
+          <a:solidFill>
+            <a:schemeClr val="tx2"/>
+          </a:solidFill>
+          <a:ln w="12700">
+            <a:solidFill>
+              <a:schemeClr val="tx2"/>
+            </a:solidFill>
+            <a:prstDash val="solid"/>
+          </a:ln>
+        </p:spPr>
+      </p:sp>
+      <p:sp>
+        <p:nvSpPr>
+          <p:cNvPr id="53" name="block text 2 BN + ReLU"/>
+          <p:cNvSpPr txBox="1"/>
+          <p:nvPr/>
+        </p:nvSpPr>
+        <p:spPr>
+          <a:xfrm>
+            <a:off x="1773936" y="4224528"/>
+            <a:ext cx="822960" cy="310896"/>
+          </a:xfrm>
+          <a:prstGeom prst="rect">
+            <a:avLst/>
+          </a:prstGeom>
+          <a:noFill/>
+          <a:ln/>
+        </p:spPr>
+        <p:txBody>
+          <a:bodyPr wrap="square" lIns="0" tIns="0" rIns="0" bIns="0" rtlCol="0" anchor="ctr"/>
+          <a:lstStyle/>
+          <a:p>
+            <a:pPr algn="ctr" indent="0" marL="0">
+              <a:buNone/>
+            </a:pPr>
+            <a:r>
+              <a:rPr lang="en-US" sz="1000" b="1" dirty="0">
+                <a:solidFill>
+                  <a:schemeClr val="bg1"/>
+                </a:solidFill>
+              </a:rPr>
+              <a:t>BN + ReLU</a:t>
+            </a:r>
+            <a:endParaRPr lang="en-US" sz="1000" dirty="0"/>
+          </a:p>
+        </p:txBody>
+      </p:sp>
+      <p:sp>
+        <p:nvSpPr>
+          <p:cNvPr id="54" name="block arrow 3"/>
+          <p:cNvSpPr/>
+          <p:nvPr/>
+        </p:nvSpPr>
+        <p:spPr>
+          <a:xfrm>
+            <a:off x="2615184" y="4379976"/>
+            <a:ext cx="118872" cy="0"/>
+          </a:xfrm>
+          <a:prstGeom prst="line">
+            <a:avLst/>
+          </a:prstGeom>
+          <a:noFill/>
+          <a:ln w="15875">
+            <a:solidFill>
+              <a:srgbClr val="3A3F4B"/>
+            </a:solidFill>
+            <a:prstDash val="solid"/>
+            <a:tailEnd type="triangle"/>
+          </a:ln>
+        </p:spPr>
+      </p:sp>
+      <p:sp>
+        <p:nvSpPr>
+          <p:cNvPr id="55" name="block 3 conv 3x3"/>
+          <p:cNvSpPr/>
+          <p:nvPr/>
+        </p:nvSpPr>
+        <p:spPr>
+          <a:xfrm>
+            <a:off x="2752344" y="4224528"/>
+            <a:ext cx="731520" cy="310896"/>
+          </a:xfrm>
+          <a:prstGeom prst="roundRect">
+            <a:avLst>
+              <a:gd name="adj" fmla="val 14706"/>
+            </a:avLst>
+          </a:prstGeom>
+          <a:solidFill>
+            <a:schemeClr val="tx2"/>
+          </a:solidFill>
+          <a:ln w="12700">
+            <a:solidFill>
+              <a:schemeClr val="tx2"/>
+            </a:solidFill>
+            <a:prstDash val="solid"/>
+          </a:ln>
+        </p:spPr>
+      </p:sp>
+      <p:sp>
+        <p:nvSpPr>
+          <p:cNvPr id="56" name="block text 3 conv 3x3"/>
+          <p:cNvSpPr txBox="1"/>
+          <p:nvPr/>
+        </p:nvSpPr>
+        <p:spPr>
+          <a:xfrm>
+            <a:off x="2752344" y="4224528"/>
+            <a:ext cx="731520" cy="310896"/>
+          </a:xfrm>
+          <a:prstGeom prst="rect">
+            <a:avLst/>
+          </a:prstGeom>
+          <a:noFill/>
+          <a:ln/>
+        </p:spPr>
+        <p:txBody>
+          <a:bodyPr wrap="square" lIns="0" tIns="0" rIns="0" bIns="0" rtlCol="0" anchor="ctr"/>
+          <a:lstStyle/>
+          <a:p>
+            <a:pPr algn="ctr" indent="0" marL="0">
+              <a:buNone/>
+            </a:pPr>
+            <a:r>
+              <a:rPr lang="en-US" sz="1000" b="1" dirty="0">
+                <a:solidFill>
+                  <a:schemeClr val="bg1"/>
+                </a:solidFill>
+              </a:rPr>
+              <a:t>conv 3x3</a:t>
+            </a:r>
+            <a:endParaRPr lang="en-US" sz="1000" dirty="0"/>
+          </a:p>
+        </p:txBody>
+      </p:sp>
+      <p:sp>
+        <p:nvSpPr>
+          <p:cNvPr id="57" name="block arrow 4"/>
+          <p:cNvSpPr/>
+          <p:nvPr/>
+        </p:nvSpPr>
+        <p:spPr>
+          <a:xfrm>
+            <a:off x="3502152" y="4379976"/>
+            <a:ext cx="118872" cy="0"/>
+          </a:xfrm>
+          <a:prstGeom prst="line">
+            <a:avLst/>
+          </a:prstGeom>
+          <a:noFill/>
+          <a:ln w="15875">
+            <a:solidFill>
+              <a:srgbClr val="3A3F4B"/>
+            </a:solidFill>
+            <a:prstDash val="solid"/>
+            <a:tailEnd type="triangle"/>
+          </a:ln>
+        </p:spPr>
+      </p:sp>
+      <p:sp>
+        <p:nvSpPr>
+          <p:cNvPr id="58" name="block 4 BN"/>
+          <p:cNvSpPr/>
+          <p:nvPr/>
+        </p:nvSpPr>
+        <p:spPr>
+          <a:xfrm>
+            <a:off x="3639312" y="4224528"/>
+            <a:ext cx="457200" cy="310896"/>
+          </a:xfrm>
+          <a:prstGeom prst="roundRect">
+            <a:avLst>
+              <a:gd name="adj" fmla="val 14706"/>
+            </a:avLst>
+          </a:prstGeom>
+          <a:solidFill>
+            <a:schemeClr val="tx2"/>
+          </a:solidFill>
+          <a:ln w="12700">
+            <a:solidFill>
+              <a:schemeClr val="tx2"/>
+            </a:solidFill>
+            <a:prstDash val="solid"/>
+          </a:ln>
+        </p:spPr>
+      </p:sp>
+      <p:sp>
+        <p:nvSpPr>
+          <p:cNvPr id="59" name="block text 4 BN"/>
+          <p:cNvSpPr txBox="1"/>
+          <p:nvPr/>
+        </p:nvSpPr>
+        <p:spPr>
+          <a:xfrm>
+            <a:off x="3639312" y="4224528"/>
+            <a:ext cx="457200" cy="310896"/>
+          </a:xfrm>
+          <a:prstGeom prst="rect">
+            <a:avLst/>
+          </a:prstGeom>
+          <a:noFill/>
+          <a:ln/>
+        </p:spPr>
+        <p:txBody>
+          <a:bodyPr wrap="square" lIns="0" tIns="0" rIns="0" bIns="0" rtlCol="0" anchor="ctr"/>
+          <a:lstStyle/>
+          <a:p>
+            <a:pPr algn="ctr" indent="0" marL="0">
+              <a:buNone/>
+            </a:pPr>
+            <a:r>
+              <a:rPr lang="en-US" sz="1000" b="1" dirty="0">
+                <a:solidFill>
+                  <a:schemeClr val="bg1"/>
+                </a:solidFill>
+              </a:rPr>
+              <a:t>BN</a:t>
+            </a:r>
+            <a:endParaRPr lang="en-US" sz="1000" dirty="0"/>
+          </a:p>
+        </p:txBody>
+      </p:sp>
+      <p:sp>
+        <p:nvSpPr>
+          <p:cNvPr id="60" name="block arrow 5"/>
+          <p:cNvSpPr/>
+          <p:nvPr/>
+        </p:nvSpPr>
+        <p:spPr>
+          <a:xfrm>
+            <a:off x="4114800" y="4379976"/>
+            <a:ext cx="118872" cy="0"/>
+          </a:xfrm>
+          <a:prstGeom prst="line">
+            <a:avLst/>
+          </a:prstGeom>
+          <a:noFill/>
+          <a:ln w="15875">
+            <a:solidFill>
+              <a:srgbClr val="3A3F4B"/>
+            </a:solidFill>
+            <a:prstDash val="solid"/>
+            <a:tailEnd type="triangle"/>
+          </a:ln>
+        </p:spPr>
+      </p:sp>
+      <p:sp>
+        <p:nvSpPr>
+          <p:cNvPr id="61" name="block add"/>
+          <p:cNvSpPr/>
+          <p:nvPr/>
+        </p:nvSpPr>
+        <p:spPr>
+          <a:xfrm>
+            <a:off x="4251960" y="4224528"/>
+            <a:ext cx="310896" cy="310896"/>
+          </a:xfrm>
+          <a:prstGeom prst="ellipse">
+            <a:avLst/>
+          </a:prstGeom>
+          <a:solidFill>
+            <a:schemeClr val="accent1"/>
+          </a:solidFill>
+          <a:ln w="12700">
+            <a:solidFill>
+              <a:schemeClr val="accent1"/>
+            </a:solidFill>
+            <a:prstDash val="solid"/>
+          </a:ln>
+        </p:spPr>
+      </p:sp>
+      <p:sp>
+        <p:nvSpPr>
+          <p:cNvPr id="62" name="block text 5 +"/>
+          <p:cNvSpPr txBox="1"/>
+          <p:nvPr/>
+        </p:nvSpPr>
+        <p:spPr>
+          <a:xfrm>
+            <a:off x="4251960" y="4224528"/>
+            <a:ext cx="310896" cy="310896"/>
+          </a:xfrm>
+          <a:prstGeom prst="rect">
+            <a:avLst/>
+          </a:prstGeom>
+          <a:noFill/>
+          <a:ln/>
+        </p:spPr>
+        <p:txBody>
+          <a:bodyPr wrap="square" lIns="0" tIns="0" rIns="0" bIns="0" rtlCol="0" anchor="ctr"/>
+          <a:lstStyle/>
+          <a:p>
+            <a:pPr algn="ctr" indent="0" marL="0">
+              <a:buNone/>
+            </a:pPr>
+            <a:r>
+              <a:rPr lang="en-US" sz="1400" b="1" dirty="0">
+                <a:solidFill>
+                  <a:schemeClr val="bg1"/>
+                </a:solidFill>
+              </a:rPr>
+              <a:t>+</a:t>
+            </a:r>
+            <a:endParaRPr lang="en-US" sz="1400" dirty="0"/>
+          </a:p>
+        </p:txBody>
+      </p:sp>
+      <p:sp>
+        <p:nvSpPr>
+          <p:cNvPr id="63" name="block arrow 6"/>
+          <p:cNvSpPr/>
+          <p:nvPr/>
+        </p:nvSpPr>
+        <p:spPr>
+          <a:xfrm>
+            <a:off x="4581144" y="4379976"/>
+            <a:ext cx="118872" cy="0"/>
+          </a:xfrm>
+          <a:prstGeom prst="line">
+            <a:avLst/>
+          </a:prstGeom>
+          <a:noFill/>
+          <a:ln w="15875">
+            <a:solidFill>
+              <a:srgbClr val="3A3F4B"/>
+            </a:solidFill>
+            <a:prstDash val="solid"/>
+            <a:tailEnd type="triangle"/>
+          </a:ln>
+        </p:spPr>
+      </p:sp>
+      <p:sp>
+        <p:nvSpPr>
+          <p:cNvPr id="64" name="block 6 ReLU"/>
+          <p:cNvSpPr/>
+          <p:nvPr/>
+        </p:nvSpPr>
+        <p:spPr>
+          <a:xfrm>
+            <a:off x="4718304" y="4224528"/>
+            <a:ext cx="548640" cy="310896"/>
+          </a:xfrm>
+          <a:prstGeom prst="roundRect">
+            <a:avLst>
+              <a:gd name="adj" fmla="val 14706"/>
+            </a:avLst>
+          </a:prstGeom>
+          <a:solidFill>
+            <a:schemeClr val="tx2"/>
+          </a:solidFill>
+          <a:ln w="12700">
+            <a:solidFill>
+              <a:schemeClr val="tx2"/>
+            </a:solidFill>
+            <a:prstDash val="solid"/>
+          </a:ln>
+        </p:spPr>
+      </p:sp>
+      <p:sp>
+        <p:nvSpPr>
+          <p:cNvPr id="65" name="block text 6 ReLU"/>
+          <p:cNvSpPr txBox="1"/>
+          <p:nvPr/>
+        </p:nvSpPr>
+        <p:spPr>
+          <a:xfrm>
+            <a:off x="4718304" y="4224528"/>
+            <a:ext cx="548640" cy="310896"/>
+          </a:xfrm>
+          <a:prstGeom prst="rect">
+            <a:avLst/>
+          </a:prstGeom>
+          <a:noFill/>
+          <a:ln/>
+        </p:spPr>
+        <p:txBody>
+          <a:bodyPr wrap="square" lIns="0" tIns="0" rIns="0" bIns="0" rtlCol="0" anchor="ctr"/>
+          <a:lstStyle/>
+          <a:p>
+            <a:pPr algn="ctr" indent="0" marL="0">
+              <a:buNone/>
+            </a:pPr>
+            <a:r>
+              <a:rPr lang="en-US" sz="1000" b="1" dirty="0">
+                <a:solidFill>
+                  <a:schemeClr val="bg1"/>
+                </a:solidFill>
+              </a:rPr>
+              <a:t>ReLU</a:t>
+            </a:r>
+            <a:endParaRPr lang="en-US" sz="1000" dirty="0"/>
+          </a:p>
+        </p:txBody>
+      </p:sp>
+      <p:sp>
+        <p:nvSpPr>
+          <p:cNvPr id="66" name="block arrow 7"/>
+          <p:cNvSpPr/>
+          <p:nvPr/>
+        </p:nvSpPr>
+        <p:spPr>
+          <a:xfrm>
+            <a:off x="5285232" y="4379976"/>
+            <a:ext cx="118872" cy="0"/>
+          </a:xfrm>
+          <a:prstGeom prst="line">
+            <a:avLst/>
+          </a:prstGeom>
+          <a:noFill/>
+          <a:ln w="15875">
+            <a:solidFill>
+              <a:srgbClr val="3A3F4B"/>
+            </a:solidFill>
+            <a:prstDash val="solid"/>
+            <a:tailEnd type="triangle"/>
+          </a:ln>
+        </p:spPr>
+      </p:sp>
+      <p:sp>
+        <p:nvSpPr>
+          <p:cNvPr id="67" name="block text 7 out"/>
+          <p:cNvSpPr txBox="1"/>
+          <p:nvPr/>
+        </p:nvSpPr>
+        <p:spPr>
+          <a:xfrm>
+            <a:off x="5422392" y="4224528"/>
+            <a:ext cx="320040" cy="310896"/>
+          </a:xfrm>
+          <a:prstGeom prst="rect">
+            <a:avLst/>
+          </a:prstGeom>
+          <a:noFill/>
+          <a:ln/>
+        </p:spPr>
+        <p:txBody>
+          <a:bodyPr wrap="square" lIns="0" tIns="0" rIns="0" bIns="0" rtlCol="0" anchor="ctr"/>
+          <a:lstStyle/>
+          <a:p>
+            <a:pPr algn="ctr" indent="0" marL="0">
+              <a:buNone/>
+            </a:pPr>
+            <a:r>
+              <a:rPr lang="en-US" sz="1000" b="1" dirty="0">
+                <a:solidFill>
+                  <a:schemeClr val="tx2"/>
+                </a:solidFill>
+              </a:rPr>
+              <a:t>out</a:t>
+            </a:r>
+            <a:endParaRPr lang="en-US" sz="1000" dirty="0"/>
+          </a:p>
+        </p:txBody>
+      </p:sp>
+      <p:sp>
+        <p:nvSpPr>
+          <p:cNvPr id="68" name="shortcut up"/>
+          <p:cNvSpPr/>
+          <p:nvPr/>
+        </p:nvSpPr>
+        <p:spPr>
+          <a:xfrm>
+            <a:off x="594360" y="3959352"/>
+            <a:ext cx="0" cy="265176"/>
+          </a:xfrm>
+          <a:prstGeom prst="line">
+            <a:avLst/>
+          </a:prstGeom>
+          <a:noFill/>
+          <a:ln w="19050">
+            <a:solidFill>
+              <a:schemeClr val="accent1"/>
+            </a:solidFill>
+            <a:prstDash val="solid"/>
+          </a:ln>
+        </p:spPr>
+      </p:sp>
+      <p:sp>
+        <p:nvSpPr>
+          <p:cNvPr id="69" name="shortcut across"/>
+          <p:cNvSpPr/>
+          <p:nvPr/>
+        </p:nvSpPr>
+        <p:spPr>
+          <a:xfrm>
+            <a:off x="594360" y="3959352"/>
+            <a:ext cx="3813048" cy="0"/>
+          </a:xfrm>
+          <a:prstGeom prst="line">
+            <a:avLst/>
+          </a:prstGeom>
+          <a:noFill/>
+          <a:ln w="19050">
+            <a:solidFill>
+              <a:schemeClr val="accent1"/>
+            </a:solidFill>
+            <a:prstDash val="solid"/>
+          </a:ln>
+        </p:spPr>
+      </p:sp>
+      <p:sp>
+        <p:nvSpPr>
+          <p:cNvPr id="70" name="shortcut down"/>
+          <p:cNvSpPr/>
+          <p:nvPr/>
+        </p:nvSpPr>
+        <p:spPr>
+          <a:xfrm>
+            <a:off x="4407408" y="3959352"/>
+            <a:ext cx="0" cy="265176"/>
+          </a:xfrm>
+          <a:prstGeom prst="line">
+            <a:avLst/>
+          </a:prstGeom>
+          <a:noFill/>
+          <a:ln w="19050">
+            <a:solidFill>
+              <a:schemeClr val="accent1"/>
+            </a:solidFill>
+            <a:prstDash val="solid"/>
+            <a:tailEnd type="triangle"/>
+          </a:ln>
+        </p:spPr>
+      </p:sp>
+      <p:sp>
+        <p:nvSpPr>
+          <p:cNvPr id="71" name="shortcut label"/>
+          <p:cNvSpPr txBox="1"/>
+          <p:nvPr/>
+        </p:nvSpPr>
+        <p:spPr>
+          <a:xfrm>
+            <a:off x="594360" y="3758184"/>
+            <a:ext cx="3813048" cy="182880"/>
+          </a:xfrm>
+          <a:prstGeom prst="rect">
+            <a:avLst/>
+          </a:prstGeom>
+          <a:noFill/>
+          <a:ln/>
+        </p:spPr>
+        <p:txBody>
+          <a:bodyPr wrap="square" lIns="0" tIns="0" rIns="0" bIns="0" rtlCol="0" anchor="ctr"/>
+          <a:lstStyle/>
+          <a:p>
+            <a:pPr algn="ctr" indent="0" marL="0">
+              <a:buNone/>
+            </a:pPr>
+            <a:r>
+              <a:rPr lang="en-US" sz="900" i="1" dirty="0">
+                <a:solidFill>
+                  <a:schemeClr val="accent1"/>
+                </a:solidFill>
+              </a:rPr>
+              <a:t>shortcut: the input x is added back</a:t>
+            </a:r>
+            <a:endParaRPr lang="en-US" sz="900" dirty="0"/>
+          </a:p>
+        </p:txBody>
+      </p:sp>
+      <p:sp>
+        <p:nvSpPr>
+          <p:cNvPr id="72" name="residual text"/>
+          <p:cNvSpPr txBox="1"/>
+          <p:nvPr/>
+        </p:nvSpPr>
+        <p:spPr>
+          <a:xfrm>
+            <a:off x="5897880" y="3593592"/>
+            <a:ext cx="2788920" cy="1051560"/>
+          </a:xfrm>
+          <a:prstGeom prst="rect">
+            <a:avLst/>
+          </a:prstGeom>
+          <a:noFill/>
+          <a:ln/>
+        </p:spPr>
+        <p:txBody>
+          <a:bodyPr wrap="square" lIns="0" tIns="0" rIns="0" bIns="0" rtlCol="0" anchor="t"/>
+          <a:lstStyle/>
+          <a:p>
+            <a:pPr indent="0" marL="0">
+              <a:buNone/>
+            </a:pPr>
+            <a:r>
+              <a:rPr lang="en-US" sz="1100" b="1" dirty="0">
+                <a:solidFill>
+                  <a:schemeClr val="tx2"/>
+                </a:solidFill>
+              </a:rPr>
+              <a:t>Why "Res" (residual): </a:t>
+            </a:r>
+            <a:pPr indent="0" marL="0">
+              <a:buNone/>
+            </a:pPr>
+            <a:r>
+              <a:rPr lang="en-US" sz="1100" dirty="0">
+                <a:solidFill>
+                  <a:schemeClr val="tx1"/>
+                </a:solidFill>
+              </a:rPr>
+              <a:t>each block only learns a correction added to its input. The gradient flows back through the shortcuts, so all the layers learn. 18 layers = conv1 + 16 convolutions in the blocks + the last layer.</a:t>
+            </a:r>
+            <a:endParaRPr lang="en-US" sz="1100" dirty="0"/>
+          </a:p>
+        </p:txBody>
+      </p:sp>
+      <p:sp>
+        <p:nvSpPr>
+          <p:cNvPr id="25" name="Slide Number Placeholder 0"/>
+          <p:cNvSpPr>
+            <a:spLocks noGrp="1"/>
+          </p:cNvSpPr>
+          <p:nvPr>
+            <p:ph type="sldNum" sz="quarter" idx="4294967295"/>
+          </p:nvPr>
+        </p:nvSpPr>
+        <p:spPr>
+          <a:xfrm>
+            <a:off x="8229600" y="4754880"/>
+            <a:ext cx="457200" cy="274320"/>
+          </a:xfrm>
+          <a:prstGeom prst="rect">
+            <a:avLst/>
+          </a:prstGeom>
+          <a:extLst>
+            <a:ext uri="{C572A759-6A51-4108-AA02-DFA0A04FC94B}">
+              <ma14:wrappingTextBoxFlag xmlns:ma14="http://schemas.microsoft.com/office/mac/drawingml/2011/main" val="0"/>
+            </a:ext>
+          </a:extLst>
+        </p:spPr>
+        <p:txBody>
+          <a:bodyPr/>
+          <a:lstStyle>
+            <a:lvl1pPr>
+              <a:defRPr sz="1000">
+                <a:solidFill>
+                  <a:srgbClr val="5F6473"/>
+                </a:solidFill>
+              </a:defRPr>
+            </a:lvl1pPr>
+          </a:lstStyle>
+          <a:p>
+            <a:pPr algn="r"/>
+            <a:fld id="{F7021451-1387-4CA6-816F-3879F97B5CBC}" type="slidenum">
+              <a:rPr b="0" lang="en-US"/>
+              <a:t>20</a:t>
             </a:fld>
             <a:endParaRPr lang="en-US"/>
           </a:p>

</xml_diff>

<commit_message>
Add the from-zero result to a backup slide, the guide and the README
</commit_message>
<xml_diff>
--- a/docs/museum_guide_presentation.pptx
+++ b/docs/museum_guide_presentation.pptx
@@ -25,9 +25,10 @@
     <p:sldId id="273" r:id="rId19"/>
     <p:sldId id="274" r:id="rId20"/>
     <p:sldId id="275" r:id="rId21"/>
+    <p:sldId id="276" r:id="rId22"/>
   </p:sldIdLst>
   <p:notesMasterIdLst>
-    <p:notesMasterId r:id="rId22"/>
+    <p:notesMasterId r:id="rId23"/>
   </p:notesMasterIdLst>
   <p:sldSz cx="9144000" cy="5143500"/>
   <p:notesSz cx="5143500" cy="9144000"/>
@@ -126,26 +127,26 @@
   <p:extLst>
     <p:ext uri="{521415D9-36F7-43E2-AB2F-B90AF26B5E84}">
       <p14:sectionLst xmlns:p14="http://schemas.microsoft.com/office/powerpoint/2010/main">
-        <p14:section name="The question" id="{58dd4e7b-83ea-3470-e926-2c21dcb2a8e3}">
+        <p14:section name="The question" id="{62f554b6-d8e5-3c46-3fdb-09919cafaa8a}">
           <p14:sldIdLst>
             <p14:sldId id="256"/>
             <p14:sldId id="257"/>
             <p14:sldId id="258"/>
           </p14:sldIdLst>
         </p14:section>
-        <p14:section name="Our MLP" id="{e0d5256e-f470-8fb8-0b66-670c872c8233}">
+        <p14:section name="Our MLP" id="{ecac1086-34cb-8507-671c-4beac8d0a44c}">
           <p14:sldIdLst>
             <p14:sldId id="259"/>
             <p14:sldId id="260"/>
           </p14:sldIdLst>
         </p14:section>
-        <p14:section name="Pretrained ResNet" id="{7089e9a1-3197-81ea-2d1f-0f5aed3c1c71}">
+        <p14:section name="Pretrained ResNet" id="{66bfdf40-3ed5-7fb0-0af4-1959a18ab581}">
           <p14:sldIdLst>
             <p14:sldId id="261"/>
             <p14:sldId id="262"/>
           </p14:sldIdLst>
         </p14:section>
-        <p14:section name="The answer" id="{570237ec-11b4-f7ce-669d-b8eb6ca962fd}">
+        <p14:section name="The answer" id="{1b938b10-f466-8728-a5b7-2a8fef8c22a0}">
           <p14:sldIdLst>
             <p14:sldId id="263"/>
             <p14:sldId id="264"/>
@@ -153,7 +154,7 @@
             <p14:sldId id="266"/>
           </p14:sldIdLst>
         </p14:section>
-        <p14:section name="Backup" id="{f395000c-73c4-74fc-d50e-222894e442df}">
+        <p14:section name="Backup" id="{9d43feac-6ef5-f78e-1f0e-a28137b2a419}">
           <p14:sldIdLst>
             <p14:sldId id="267"/>
             <p14:sldId id="268"/>
@@ -164,6 +165,7 @@
             <p14:sldId id="273"/>
             <p14:sldId id="274"/>
             <p14:sldId id="275"/>
+            <p14:sldId id="276"/>
           </p14:sldIdLst>
         </p14:section>
       </p14:sectionLst>
@@ -1883,6 +1885,472 @@
 </c:chartSpace>
 </file>
 
+<file path=ppt/charts/chart6.xml><?xml version="1.0" encoding="utf-8"?>
+<c:chartSpace xmlns:c="http://schemas.openxmlformats.org/drawingml/2006/chart" xmlns:a="http://schemas.openxmlformats.org/drawingml/2006/main" xmlns:r="http://schemas.openxmlformats.org/officeDocument/2006/relationships">
+  <c:date1904 val="0"/>
+  <c:roundedCorners val="1"/>
+  <c:chart>
+    <c:title>
+      <c:tx>
+        <c:rich>
+          <a:bodyPr/>
+          <a:lstStyle/>
+          <a:p>
+            <a:pPr>
+              <a:defRPr sz="1400" b="0" i="0" u="none" strike="noStrike">
+                <a:solidFill>
+                  <a:srgbClr val="3A3F4B"/>
+                </a:solidFill>
+                <a:latin typeface="+mn-lt"/>
+              </a:defRPr>
+            </a:pPr>
+            <a:r>
+              <a:rPr sz="1400" b="0" i="0" u="none" strike="noStrike">
+                <a:solidFill>
+                  <a:srgbClr val="3A3F4B"/>
+                </a:solidFill>
+                <a:latin typeface="+mn-lt"/>
+              </a:rPr>
+              <a:t>Validation accuracy (219 paintings)</a:t>
+            </a:r>
+          </a:p>
+        </c:rich>
+      </c:tx>
+      <c:layout/>
+      <c:overlay val="0"/>
+    </c:title>
+    <c:autoTitleDeleted val="0"/>
+    <c:plotArea>
+      <c:layout/>
+      <c:barChart>
+        <c:barDir val="bar"/>
+        <c:grouping val="stacked"/>
+        <c:varyColors val="0"/>
+        <c:ser>
+          <c:idx val="0"/>
+          <c:order val="0"/>
+          <c:tx>
+            <c:strRef>
+              <c:f>Sheet1!$B$1</c:f>
+              <c:strCache>
+                <c:ptCount val="1"/>
+                <c:pt idx="0">
+                  <c:v>other</c:v>
+                </c:pt>
+              </c:strCache>
+            </c:strRef>
+          </c:tx>
+          <c:spPr>
+            <a:solidFill>
+              <a:srgbClr val="A9AEB8"/>
+            </a:solidFill>
+            <a:effectLst/>
+          </c:spPr>
+          <c:invertIfNegative val="0"/>
+          <c:dLbls>
+            <c:numFmt formatCode="0&quot;.&quot;0&quot; %&quot;;;" sourceLinked="0"/>
+            <c:txPr>
+              <a:bodyPr/>
+              <a:lstStyle/>
+              <a:p>
+                <a:pPr>
+                  <a:defRPr b="0" i="0" strike="noStrike" sz="1200" u="none">
+                    <a:solidFill>
+                      <a:srgbClr val="FFFFFF"/>
+                    </a:solidFill>
+                    <a:latin typeface="+mn-lt"/>
+                  </a:defRPr>
+                </a:pPr>
+              </a:p>
+            </c:txPr>
+            <c:dLblPos val="inEnd"/>
+            <c:showLegendKey val="0"/>
+            <c:showVal val="1"/>
+            <c:showCatName val="0"/>
+            <c:showSerName val="0"/>
+            <c:showPercent val="0"/>
+            <c:showBubbleSize val="0"/>
+            <c:showLeaderLines val="0"/>
+          </c:dLbls>
+          <c:cat>
+            <c:multiLvlStrRef>
+              <c:f>Sheet1!$A$2:$A$6</c:f>
+              <c:multiLvlStrCache>
+                <c:ptCount val="5"/>
+                <c:lvl>
+                  <c:pt idx="0">
+                    <c:v>Our best MLP (pixels)</c:v>
+                  </c:pt>
+                  <c:pt idx="1">
+                    <c:v>ResNet18 from zero</c:v>
+                  </c:pt>
+                  <c:pt idx="2">
+                    <c:v>Random forest, 102 numbers</c:v>
+                  </c:pt>
+                  <c:pt idx="3">
+                    <c:v>ResNet18, layer4 fine-tuned</c:v>
+                  </c:pt>
+                  <c:pt idx="4">
+                    <c:v>ResNet18 frozen + linear head</c:v>
+                  </c:pt>
+                </c:lvl>
+              </c:multiLvlStrCache>
+            </c:multiLvlStrRef>
+          </c:cat>
+          <c:val>
+            <c:numRef>
+              <c:f>Sheet1!$B$2:$B$6</c:f>
+              <c:numCache>
+                <c:formatCode>General</c:formatCode>
+                <c:ptCount val="5"/>
+                <c:pt idx="0">
+                  <c:v>455</c:v>
+                </c:pt>
+                <c:pt idx="1">
+                  <c:v>0</c:v>
+                </c:pt>
+                <c:pt idx="2">
+                  <c:v>635</c:v>
+                </c:pt>
+                <c:pt idx="3">
+                  <c:v>854</c:v>
+                </c:pt>
+                <c:pt idx="4">
+                  <c:v>0</c:v>
+                </c:pt>
+              </c:numCache>
+            </c:numRef>
+          </c:val>
+        </c:ser>
+        <c:ser>
+          <c:idx val="1"/>
+          <c:order val="1"/>
+          <c:tx>
+            <c:strRef>
+              <c:f>Sheet1!$C$1</c:f>
+              <c:strCache>
+                <c:ptCount val="1"/>
+                <c:pt idx="0">
+                  <c:v>from zero</c:v>
+                </c:pt>
+              </c:strCache>
+            </c:strRef>
+          </c:tx>
+          <c:spPr>
+            <a:solidFill>
+              <a:srgbClr val="EDA100"/>
+            </a:solidFill>
+            <a:effectLst/>
+          </c:spPr>
+          <c:invertIfNegative val="0"/>
+          <c:dLbls>
+            <c:numFmt formatCode="0&quot;.&quot;0&quot; %&quot;;;" sourceLinked="0"/>
+            <c:txPr>
+              <a:bodyPr/>
+              <a:lstStyle/>
+              <a:p>
+                <a:pPr>
+                  <a:defRPr b="0" i="0" strike="noStrike" sz="1200" u="none">
+                    <a:solidFill>
+                      <a:srgbClr val="FFFFFF"/>
+                    </a:solidFill>
+                    <a:latin typeface="+mn-lt"/>
+                  </a:defRPr>
+                </a:pPr>
+              </a:p>
+            </c:txPr>
+            <c:dLblPos val="inEnd"/>
+            <c:showLegendKey val="0"/>
+            <c:showVal val="1"/>
+            <c:showCatName val="0"/>
+            <c:showSerName val="0"/>
+            <c:showPercent val="0"/>
+            <c:showBubbleSize val="0"/>
+            <c:showLeaderLines val="0"/>
+          </c:dLbls>
+          <c:cat>
+            <c:multiLvlStrRef>
+              <c:f>Sheet1!$A$2:$A$6</c:f>
+              <c:multiLvlStrCache>
+                <c:ptCount val="5"/>
+                <c:lvl>
+                  <c:pt idx="0">
+                    <c:v>Our best MLP (pixels)</c:v>
+                  </c:pt>
+                  <c:pt idx="1">
+                    <c:v>ResNet18 from zero</c:v>
+                  </c:pt>
+                  <c:pt idx="2">
+                    <c:v>Random forest, 102 numbers</c:v>
+                  </c:pt>
+                  <c:pt idx="3">
+                    <c:v>ResNet18, layer4 fine-tuned</c:v>
+                  </c:pt>
+                  <c:pt idx="4">
+                    <c:v>ResNet18 frozen + linear head</c:v>
+                  </c:pt>
+                </c:lvl>
+              </c:multiLvlStrCache>
+            </c:multiLvlStrRef>
+          </c:cat>
+          <c:val>
+            <c:numRef>
+              <c:f>Sheet1!$C$2:$C$6</c:f>
+              <c:numCache>
+                <c:formatCode>General</c:formatCode>
+                <c:ptCount val="5"/>
+                <c:pt idx="0">
+                  <c:v>0</c:v>
+                </c:pt>
+                <c:pt idx="1">
+                  <c:v>616</c:v>
+                </c:pt>
+                <c:pt idx="2">
+                  <c:v>0</c:v>
+                </c:pt>
+                <c:pt idx="3">
+                  <c:v>0</c:v>
+                </c:pt>
+                <c:pt idx="4">
+                  <c:v>0</c:v>
+                </c:pt>
+              </c:numCache>
+            </c:numRef>
+          </c:val>
+        </c:ser>
+        <c:ser>
+          <c:idx val="2"/>
+          <c:order val="2"/>
+          <c:tx>
+            <c:strRef>
+              <c:f>Sheet1!$D$1</c:f>
+              <c:strCache>
+                <c:ptCount val="1"/>
+                <c:pt idx="0">
+                  <c:v>chosen</c:v>
+                </c:pt>
+              </c:strCache>
+            </c:strRef>
+          </c:tx>
+          <c:spPr>
+            <a:solidFill>
+              <a:srgbClr val="2A78D6"/>
+            </a:solidFill>
+            <a:effectLst/>
+          </c:spPr>
+          <c:invertIfNegative val="0"/>
+          <c:dLbls>
+            <c:numFmt formatCode="0&quot;.&quot;0&quot; %&quot;;;" sourceLinked="0"/>
+            <c:txPr>
+              <a:bodyPr/>
+              <a:lstStyle/>
+              <a:p>
+                <a:pPr>
+                  <a:defRPr b="0" i="0" strike="noStrike" sz="1200" u="none">
+                    <a:solidFill>
+                      <a:srgbClr val="FFFFFF"/>
+                    </a:solidFill>
+                    <a:latin typeface="+mn-lt"/>
+                  </a:defRPr>
+                </a:pPr>
+              </a:p>
+            </c:txPr>
+            <c:dLblPos val="inEnd"/>
+            <c:showLegendKey val="0"/>
+            <c:showVal val="1"/>
+            <c:showCatName val="0"/>
+            <c:showSerName val="0"/>
+            <c:showPercent val="0"/>
+            <c:showBubbleSize val="0"/>
+            <c:showLeaderLines val="0"/>
+          </c:dLbls>
+          <c:cat>
+            <c:multiLvlStrRef>
+              <c:f>Sheet1!$A$2:$A$6</c:f>
+              <c:multiLvlStrCache>
+                <c:ptCount val="5"/>
+                <c:lvl>
+                  <c:pt idx="0">
+                    <c:v>Our best MLP (pixels)</c:v>
+                  </c:pt>
+                  <c:pt idx="1">
+                    <c:v>ResNet18 from zero</c:v>
+                  </c:pt>
+                  <c:pt idx="2">
+                    <c:v>Random forest, 102 numbers</c:v>
+                  </c:pt>
+                  <c:pt idx="3">
+                    <c:v>ResNet18, layer4 fine-tuned</c:v>
+                  </c:pt>
+                  <c:pt idx="4">
+                    <c:v>ResNet18 frozen + linear head</c:v>
+                  </c:pt>
+                </c:lvl>
+              </c:multiLvlStrCache>
+            </c:multiLvlStrRef>
+          </c:cat>
+          <c:val>
+            <c:numRef>
+              <c:f>Sheet1!$D$2:$D$6</c:f>
+              <c:numCache>
+                <c:formatCode>General</c:formatCode>
+                <c:ptCount val="5"/>
+                <c:pt idx="0">
+                  <c:v>0</c:v>
+                </c:pt>
+                <c:pt idx="1">
+                  <c:v>0</c:v>
+                </c:pt>
+                <c:pt idx="2">
+                  <c:v>0</c:v>
+                </c:pt>
+                <c:pt idx="3">
+                  <c:v>0</c:v>
+                </c:pt>
+                <c:pt idx="4">
+                  <c:v>881</c:v>
+                </c:pt>
+              </c:numCache>
+            </c:numRef>
+          </c:val>
+        </c:ser>
+        <c:dLbls>
+          <c:numFmt formatCode="0&quot;.&quot;0&quot; %&quot;;;" sourceLinked="0"/>
+          <c:txPr>
+            <a:bodyPr/>
+            <a:lstStyle/>
+            <a:p>
+              <a:pPr>
+                <a:defRPr b="0" i="0" strike="noStrike" sz="1200" u="none">
+                  <a:solidFill>
+                    <a:srgbClr val="FFFFFF"/>
+                  </a:solidFill>
+                  <a:latin typeface="+mn-lt"/>
+                </a:defRPr>
+              </a:pPr>
+            </a:p>
+          </c:txPr>
+          <c:dLblPos val="inEnd"/>
+          <c:showLegendKey val="0"/>
+          <c:showVal val="1"/>
+          <c:showCatName val="0"/>
+          <c:showSerName val="0"/>
+          <c:showPercent val="0"/>
+          <c:showBubbleSize val="0"/>
+          <c:showLeaderLines val="0"/>
+        </c:dLbls>
+        <c:gapWidth val="45"/>
+        <c:overlap val="100"/>
+        <c:axId val="2094734554"/>
+        <c:axId val="2094734552"/>
+        <c:axId val="2094734556"/>
+      </c:barChart>
+      <c:catAx>
+        <c:axId val="2094734554"/>
+        <c:scaling>
+          <c:orientation val="minMax"/>
+        </c:scaling>
+        <c:delete val="0"/>
+        <c:axPos val="l"/>
+        <c:numFmt formatCode="General" sourceLinked="1"/>
+        <c:majorTickMark val="out"/>
+        <c:minorTickMark val="none"/>
+        <c:tickLblPos val="nextTo"/>
+        <c:spPr>
+          <a:ln w="12700" cap="flat">
+            <a:solidFill>
+              <a:srgbClr val="888888"/>
+            </a:solidFill>
+            <a:prstDash val="solid"/>
+            <a:round/>
+          </a:ln>
+        </c:spPr>
+        <c:txPr>
+          <a:bodyPr/>
+          <a:lstStyle/>
+          <a:p>
+            <a:pPr>
+              <a:defRPr sz="1200" b="0" i="0" u="none" strike="noStrike">
+                <a:solidFill>
+                  <a:srgbClr val="3A3F4B"/>
+                </a:solidFill>
+                <a:latin typeface="+mn-lt"/>
+              </a:defRPr>
+            </a:pPr>
+            <a:endParaRPr lang="en-US"/>
+          </a:p>
+        </c:txPr>
+        <c:crossAx val="2094734552"/>
+        <c:crosses val="autoZero"/>
+        <c:auto val="1"/>
+        <c:lblAlgn val="ctr"/>
+        <c:noMultiLvlLbl val="1"/>
+      </c:catAx>
+      <c:valAx>
+        <c:axId val="2094734552"/>
+        <c:scaling>
+          <c:orientation val="minMax"/>
+          <c:max val="1000"/>
+          <c:min val="0"/>
+        </c:scaling>
+        <c:delete val="1"/>
+        <c:axPos val="b"/>
+        <c:numFmt formatCode="General" sourceLinked="0"/>
+        <c:majorTickMark val="out"/>
+        <c:minorTickMark val="none"/>
+        <c:tickLblPos val="low"/>
+        <c:spPr>
+          <a:ln w="12700" cap="flat">
+            <a:solidFill>
+              <a:srgbClr val="888888"/>
+            </a:solidFill>
+            <a:prstDash val="solid"/>
+            <a:round/>
+          </a:ln>
+        </c:spPr>
+        <c:txPr>
+          <a:bodyPr/>
+          <a:lstStyle/>
+          <a:p>
+            <a:pPr>
+              <a:defRPr sz="1200" b="0" i="0" u="none" strike="noStrike">
+                <a:solidFill>
+                  <a:srgbClr val="000000"/>
+                </a:solidFill>
+                <a:latin typeface="+mn-lt"/>
+              </a:defRPr>
+            </a:pPr>
+            <a:endParaRPr lang="en-US"/>
+          </a:p>
+        </c:txPr>
+        <c:crossAx val="2094734554"/>
+        <c:crosses val="autoZero"/>
+        <c:crossBetween val="between"/>
+      </c:valAx>
+      <c:spPr>
+        <a:noFill/>
+        <a:ln>
+          <a:noFill/>
+        </a:ln>
+        <a:effectLst/>
+      </c:spPr>
+    </c:plotArea>
+    <c:plotVisOnly val="1"/>
+    <c:dispBlanksAs val="span"/>
+  </c:chart>
+  <c:spPr>
+    <a:noFill/>
+    <a:ln>
+      <a:noFill/>
+    </a:ln>
+    <a:effectLst/>
+  </c:spPr>
+  <c:externalData r:id="rId1">
+    <c:autoUpdate val="0"/>
+  </c:externalData>
+</c:chartSpace>
+</file>
+
 <file path=ppt/notesMasters/notesMaster1.xml><?xml version="1.0" encoding="utf-8"?>
 <p:notesMaster xmlns:a="http://schemas.openxmlformats.org/drawingml/2006/main" xmlns:r="http://schemas.openxmlformats.org/officeDocument/2006/relationships" xmlns:p="http://schemas.openxmlformats.org/presentationml/2006/main">
   <p:cSld>
@@ -3391,6 +3859,94 @@
             <a:fld id="{F7021451-1387-4CA6-816F-3879F97B5CBC}" type="slidenum">
               <a:rPr lang="en-US"/>
               <a:t>20</a:t>
+            </a:fld>
+            <a:endParaRPr lang="en-US"/>
+          </a:p>
+        </p:txBody>
+      </p:sp>
+    </p:spTree>
+    <p:extLst>
+      <p:ext uri="{BB962C8B-B14F-4D97-AF65-F5344CB8AC3E}">
+        <p14:creationId xmlns:p14="http://schemas.microsoft.com/office/powerpoint/2010/main" val="1024086991"/>
+      </p:ext>
+    </p:extLst>
+  </p:cSld>
+  <p:clrMapOvr>
+    <a:masterClrMapping/>
+  </p:clrMapOvr>
+</p:notes>
+</file>
+
+<file path=ppt/notesSlides/notesSlide21.xml><?xml version="1.0" encoding="utf-8"?>
+<p:notes xmlns:a="http://schemas.openxmlformats.org/drawingml/2006/main" xmlns:r="http://schemas.openxmlformats.org/officeDocument/2006/relationships" xmlns:p="http://schemas.openxmlformats.org/presentationml/2006/main">
+  <p:cSld>
+    <p:spTree>
+      <p:nvGrpSpPr>
+        <p:cNvPr id="1" name=""/>
+        <p:cNvGrpSpPr/>
+        <p:nvPr/>
+      </p:nvGrpSpPr>
+      <p:grpSpPr>
+        <a:xfrm>
+          <a:off x="0" y="0"/>
+          <a:ext cx="0" cy="0"/>
+          <a:chOff x="0" y="0"/>
+          <a:chExt cx="0" cy="0"/>
+        </a:xfrm>
+      </p:grpSpPr>
+      <p:sp>
+        <p:nvSpPr>
+          <p:cNvPr id="2" name="Slide Image Placeholder 1"/>
+          <p:cNvSpPr>
+            <a:spLocks noGrp="1" noRot="1" noChangeAspect="1"/>
+          </p:cNvSpPr>
+          <p:nvPr>
+            <p:ph type="sldImg"/>
+          </p:nvPr>
+        </p:nvSpPr>
+        <p:spPr/>
+      </p:sp>
+      <p:sp>
+        <p:nvSpPr>
+          <p:cNvPr id="3" name="Notes Placeholder 2"/>
+          <p:cNvSpPr>
+            <a:spLocks noGrp="1"/>
+          </p:cNvSpPr>
+          <p:nvPr>
+            <p:ph type="body" idx="1"/>
+          </p:nvPr>
+        </p:nvSpPr>
+        <p:spPr/>
+        <p:txBody>
+          <a:bodyPr/>
+          <a:lstStyle/>
+          <a:p>
+            <a:r>
+              <a:rPr lang="en-US" dirty="0"/>
+              <a:t>If asked why we did not train ResNet18 from zero: we measured it. With random weights and every layer learning, the same network reaches only 61.6 % on validation at best, against 88.1 % for the frozen pretrained one: about the level of the random forest. It is better than our MLP, because convolutions see shapes, but 1 061 paintings are far too few to learn 11 million weights. It also took 24 minutes of CPU, against less than a second for our linear head. One seed, validation only.</a:t>
+            </a:r>
+            <a:endParaRPr lang="en-US" dirty="0"/>
+          </a:p>
+        </p:txBody>
+      </p:sp>
+      <p:sp>
+        <p:nvSpPr>
+          <p:cNvPr id="4" name="Slide Number Placeholder 3"/>
+          <p:cNvSpPr>
+            <a:spLocks noGrp="1"/>
+          </p:cNvSpPr>
+          <p:nvPr>
+            <p:ph type="sldNum" sz="quarter" idx="10"/>
+          </p:nvPr>
+        </p:nvSpPr>
+        <p:spPr/>
+        <p:txBody>
+          <a:bodyPr/>
+          <a:lstStyle/>
+          <a:p>
+            <a:fld id="{F7021451-1387-4CA6-816F-3879F97B5CBC}" type="slidenum">
+              <a:rPr lang="en-US"/>
+              <a:t>21</a:t>
             </a:fld>
             <a:endParaRPr lang="en-US"/>
           </a:p>
@@ -16582,6 +17138,398 @@
             <a:fld id="{F7021451-1387-4CA6-816F-3879F97B5CBC}" type="slidenum">
               <a:rPr b="0" lang="en-US"/>
               <a:t>20</a:t>
+            </a:fld>
+            <a:endParaRPr lang="en-US"/>
+          </a:p>
+        </p:txBody>
+      </p:sp>
+    </p:spTree>
+  </p:cSld>
+  <p:clrMapOvr>
+    <a:masterClrMapping/>
+  </p:clrMapOvr>
+</p:sld>
+</file>
+
+<file path=ppt/slides/slide21.xml><?xml version="1.0" encoding="utf-8"?>
+<p:sld xmlns:a="http://schemas.openxmlformats.org/drawingml/2006/main" xmlns:r="http://schemas.openxmlformats.org/officeDocument/2006/relationships" xmlns:p="http://schemas.openxmlformats.org/presentationml/2006/main">
+  <p:cSld name="Slide 21">
+    <p:spTree>
+      <p:nvGrpSpPr>
+        <p:cNvPr id="1" name=""/>
+        <p:cNvGrpSpPr/>
+        <p:nvPr/>
+      </p:nvGrpSpPr>
+      <p:grpSpPr>
+        <a:xfrm>
+          <a:off x="0" y="0"/>
+          <a:ext cx="0" cy="0"/>
+          <a:chOff x="0" y="0"/>
+          <a:chExt cx="0" cy="0"/>
+        </a:xfrm>
+      </p:grpSpPr>
+      <p:sp>
+        <p:nvSpPr>
+          <p:cNvPr id="2" name="Text 0"/>
+          <p:cNvSpPr/>
+          <p:nvPr>
+            <p:ph idx="100" type="title" hasCustomPrompt="1"/>
+          </p:nvPr>
+        </p:nvSpPr>
+        <p:spPr>
+          <a:xfrm>
+            <a:off x="457200" y="274320"/>
+            <a:ext cx="8229600" cy="640080"/>
+          </a:xfrm>
+          <a:prstGeom prst="rect">
+            <a:avLst/>
+          </a:prstGeom>
+          <a:noFill/>
+          <a:ln/>
+        </p:spPr>
+        <p:txBody>
+          <a:bodyPr wrap="square" lIns="0" tIns="0" rIns="0" bIns="0" rtlCol="0" anchor="ctr"/>
+          <a:lstStyle/>
+          <a:p>
+            <a:pPr indent="0" marL="0">
+              <a:buNone/>
+            </a:pPr>
+            <a:r>
+              <a:rPr lang="en-US" sz="3000" b="1" dirty="0">
+                <a:solidFill>
+                  <a:schemeClr val="tx2"/>
+                </a:solidFill>
+              </a:rPr>
+              <a:t>Backup: why pretrained? ResNet18 from zero</a:t>
+            </a:r>
+            <a:endParaRPr lang="en-US" sz="3000" dirty="0"/>
+          </a:p>
+        </p:txBody>
+      </p:sp>
+      <p:graphicFrame>
+        <p:nvGraphicFramePr>
+          <p:cNvPr id="3" name="chart from zero" descr=""/>
+          <p:cNvGraphicFramePr/>
+          <p:nvPr/>
+        </p:nvGraphicFramePr>
+        <p:xfrm>
+          <a:off x="365760" y="1005840"/>
+          <a:ext cx="4937760" cy="3611880"/>
+        </p:xfrm>
+        <a:graphic xmlns:a="http://schemas.openxmlformats.org/drawingml/2006/main">
+          <a:graphicData uri="http://schemas.openxmlformats.org/drawingml/2006/chart">
+            <c:chart xmlns:c="http://schemas.openxmlformats.org/drawingml/2006/chart" r:id="rId1"/>
+          </a:graphicData>
+        </a:graphic>
+      </p:graphicFrame>
+      <p:sp>
+        <p:nvSpPr>
+          <p:cNvPr id="4" name="card -26.5"/>
+          <p:cNvSpPr/>
+          <p:nvPr/>
+        </p:nvSpPr>
+        <p:spPr>
+          <a:xfrm>
+            <a:off x="5532120" y="1051560"/>
+            <a:ext cx="3154680" cy="1417320"/>
+          </a:xfrm>
+          <a:prstGeom prst="roundRect">
+            <a:avLst>
+              <a:gd name="adj" fmla="val 5161"/>
+            </a:avLst>
+          </a:prstGeom>
+          <a:solidFill>
+            <a:schemeClr val="accent1"/>
+          </a:solidFill>
+          <a:ln w="12700">
+            <a:solidFill>
+              <a:schemeClr val="accent1"/>
+            </a:solidFill>
+            <a:prstDash val="solid"/>
+          </a:ln>
+        </p:spPr>
+      </p:sp>
+      <p:sp>
+        <p:nvSpPr>
+          <p:cNvPr id="5" name="value -26.5"/>
+          <p:cNvSpPr txBox="1"/>
+          <p:nvPr/>
+        </p:nvSpPr>
+        <p:spPr>
+          <a:xfrm>
+            <a:off x="5715000" y="1188720"/>
+            <a:ext cx="2788920" cy="731520"/>
+          </a:xfrm>
+          <a:prstGeom prst="rect">
+            <a:avLst/>
+          </a:prstGeom>
+          <a:noFill/>
+          <a:ln/>
+        </p:spPr>
+        <p:txBody>
+          <a:bodyPr wrap="square" lIns="0" tIns="0" rIns="0" bIns="0" rtlCol="0" anchor="ctr"/>
+          <a:lstStyle/>
+          <a:p>
+            <a:pPr indent="0" marL="0">
+              <a:buNone/>
+            </a:pPr>
+            <a:r>
+              <a:rPr lang="en-US" sz="3600" b="1" dirty="0">
+                <a:solidFill>
+                  <a:schemeClr val="bg1"/>
+                </a:solidFill>
+                <a:latin typeface="Cambria" pitchFamily="34" charset="0"/>
+                <a:ea typeface="Cambria" pitchFamily="34" charset="-122"/>
+                <a:cs typeface="Cambria" pitchFamily="34" charset="-120"/>
+              </a:rPr>
+              <a:t>-26.5</a:t>
+            </a:r>
+            <a:endParaRPr lang="en-US" sz="3600" dirty="0"/>
+          </a:p>
+        </p:txBody>
+      </p:sp>
+      <p:sp>
+        <p:nvSpPr>
+          <p:cNvPr id="6" name="caption -26.5"/>
+          <p:cNvSpPr txBox="1"/>
+          <p:nvPr/>
+        </p:nvSpPr>
+        <p:spPr>
+          <a:xfrm>
+            <a:off x="5715000" y="1965960"/>
+            <a:ext cx="2788920" cy="365760"/>
+          </a:xfrm>
+          <a:prstGeom prst="rect">
+            <a:avLst/>
+          </a:prstGeom>
+          <a:noFill/>
+          <a:ln/>
+        </p:spPr>
+        <p:txBody>
+          <a:bodyPr wrap="square" lIns="0" tIns="0" rIns="0" bIns="0" rtlCol="0" anchor="t"/>
+          <a:lstStyle/>
+          <a:p>
+            <a:pPr indent="0" marL="0">
+              <a:buNone/>
+            </a:pPr>
+            <a:r>
+              <a:rPr lang="en-US" sz="1200" dirty="0">
+                <a:solidFill>
+                  <a:schemeClr val="bg1"/>
+                </a:solidFill>
+              </a:rPr>
+              <a:t>points without the pretraining: same network, same paintings</a:t>
+            </a:r>
+            <a:endParaRPr lang="en-US" sz="1200" dirty="0"/>
+          </a:p>
+        </p:txBody>
+      </p:sp>
+      <p:sp>
+        <p:nvSpPr>
+          <p:cNvPr id="7" name="note How we trained it"/>
+          <p:cNvSpPr/>
+          <p:nvPr/>
+        </p:nvSpPr>
+        <p:spPr>
+          <a:xfrm>
+            <a:off x="5532120" y="2606040"/>
+            <a:ext cx="3154680" cy="960120"/>
+          </a:xfrm>
+          <a:prstGeom prst="roundRect">
+            <a:avLst>
+              <a:gd name="adj" fmla="val 7619"/>
+            </a:avLst>
+          </a:prstGeom>
+          <a:solidFill>
+            <a:schemeClr val="bg2"/>
+          </a:solidFill>
+          <a:ln w="12700">
+            <a:solidFill>
+              <a:schemeClr val="bg2"/>
+            </a:solidFill>
+            <a:prstDash val="solid"/>
+          </a:ln>
+        </p:spPr>
+      </p:sp>
+      <p:sp>
+        <p:nvSpPr>
+          <p:cNvPr id="8" name="text How we trained it"/>
+          <p:cNvSpPr txBox="1"/>
+          <p:nvPr/>
+        </p:nvSpPr>
+        <p:spPr>
+          <a:xfrm>
+            <a:off x="5696712" y="2715768"/>
+            <a:ext cx="2825496" cy="740664"/>
+          </a:xfrm>
+          <a:prstGeom prst="rect">
+            <a:avLst/>
+          </a:prstGeom>
+          <a:noFill/>
+          <a:ln/>
+        </p:spPr>
+        <p:txBody>
+          <a:bodyPr wrap="square" lIns="0" tIns="0" rIns="0" bIns="0" rtlCol="0" anchor="t"/>
+          <a:lstStyle/>
+          <a:p>
+            <a:pPr indent="0" marL="0">
+              <a:spcAft>
+                <a:spcPts val="400"/>
+              </a:spcAft>
+              <a:buNone/>
+            </a:pPr>
+            <a:r>
+              <a:rPr lang="en-US" sz="1300" b="1" dirty="0">
+                <a:solidFill>
+                  <a:schemeClr val="tx2"/>
+                </a:solidFill>
+              </a:rPr>
+              <a:t>How we trained it</a:t>
+            </a:r>
+            <a:endParaRPr lang="en-US" sz="1300" dirty="0"/>
+          </a:p>
+          <a:p>
+            <a:pPr indent="0" marL="0">
+              <a:spcAft>
+                <a:spcPts val="400"/>
+              </a:spcAft>
+              <a:buNone/>
+            </a:pPr>
+            <a:r>
+              <a:rPr lang="en-US" sz="1100" dirty="0">
+                <a:solidFill>
+                  <a:schemeClr val="tx1"/>
+                </a:solidFill>
+              </a:rPr>
+              <a:t>Random weights, every layer learns (11.2 M). Crop + flip, AdamW, 30 epochs, 24 min. One seed.</a:t>
+            </a:r>
+            <a:endParaRPr lang="en-US" sz="1300" dirty="0"/>
+          </a:p>
+        </p:txBody>
+      </p:sp>
+      <p:sp>
+        <p:nvSpPr>
+          <p:cNvPr id="9" name="note What it shows"/>
+          <p:cNvSpPr/>
+          <p:nvPr/>
+        </p:nvSpPr>
+        <p:spPr>
+          <a:xfrm>
+            <a:off x="5532120" y="3657600"/>
+            <a:ext cx="3154680" cy="960120"/>
+          </a:xfrm>
+          <a:prstGeom prst="roundRect">
+            <a:avLst>
+              <a:gd name="adj" fmla="val 7619"/>
+            </a:avLst>
+          </a:prstGeom>
+          <a:solidFill>
+            <a:schemeClr val="bg2"/>
+          </a:solidFill>
+          <a:ln w="12700">
+            <a:solidFill>
+              <a:schemeClr val="bg2"/>
+            </a:solidFill>
+            <a:prstDash val="solid"/>
+          </a:ln>
+        </p:spPr>
+      </p:sp>
+      <p:sp>
+        <p:nvSpPr>
+          <p:cNvPr id="10" name="text What it shows"/>
+          <p:cNvSpPr txBox="1"/>
+          <p:nvPr/>
+        </p:nvSpPr>
+        <p:spPr>
+          <a:xfrm>
+            <a:off x="5696712" y="3767328"/>
+            <a:ext cx="2825496" cy="740664"/>
+          </a:xfrm>
+          <a:prstGeom prst="rect">
+            <a:avLst/>
+          </a:prstGeom>
+          <a:noFill/>
+          <a:ln/>
+        </p:spPr>
+        <p:txBody>
+          <a:bodyPr wrap="square" lIns="0" tIns="0" rIns="0" bIns="0" rtlCol="0" anchor="t"/>
+          <a:lstStyle/>
+          <a:p>
+            <a:pPr indent="0" marL="0">
+              <a:spcAft>
+                <a:spcPts val="400"/>
+              </a:spcAft>
+              <a:buNone/>
+            </a:pPr>
+            <a:r>
+              <a:rPr lang="en-US" sz="1300" b="1" dirty="0">
+                <a:solidFill>
+                  <a:schemeClr val="tx2"/>
+                </a:solidFill>
+              </a:rPr>
+              <a:t>What it shows</a:t>
+            </a:r>
+            <a:endParaRPr lang="en-US" sz="1300" dirty="0"/>
+          </a:p>
+          <a:p>
+            <a:pPr indent="0" marL="0">
+              <a:spcAft>
+                <a:spcPts val="400"/>
+              </a:spcAft>
+              <a:buNone/>
+            </a:pPr>
+            <a:r>
+              <a:rPr lang="en-US" sz="1100" dirty="0">
+                <a:solidFill>
+                  <a:schemeClr val="tx1"/>
+                </a:solidFill>
+              </a:rPr>
+              <a:t>Better than our MLP, but only like the random forest: the 1.2 million ImageNet photos make the difference.</a:t>
+            </a:r>
+            <a:endParaRPr lang="en-US" sz="1300" dirty="0"/>
+          </a:p>
+        </p:txBody>
+      </p:sp>
+      <p:sp>
+        <p:nvSpPr>
+          <p:cNvPr id="25" name="Slide Number Placeholder 0"/>
+          <p:cNvSpPr>
+            <a:spLocks noGrp="1"/>
+          </p:cNvSpPr>
+          <p:nvPr>
+            <p:ph type="sldNum" sz="quarter" idx="4294967295"/>
+          </p:nvPr>
+        </p:nvSpPr>
+        <p:spPr>
+          <a:xfrm>
+            <a:off x="8229600" y="4754880"/>
+            <a:ext cx="457200" cy="274320"/>
+          </a:xfrm>
+          <a:prstGeom prst="rect">
+            <a:avLst/>
+          </a:prstGeom>
+          <a:extLst>
+            <a:ext uri="{C572A759-6A51-4108-AA02-DFA0A04FC94B}">
+              <ma14:wrappingTextBoxFlag xmlns:ma14="http://schemas.microsoft.com/office/mac/drawingml/2011/main" val="0"/>
+            </a:ext>
+          </a:extLst>
+        </p:spPr>
+        <p:txBody>
+          <a:bodyPr/>
+          <a:lstStyle>
+            <a:lvl1pPr>
+              <a:defRPr sz="1000">
+                <a:solidFill>
+                  <a:srgbClr val="5F6473"/>
+                </a:solidFill>
+              </a:defRPr>
+            </a:lvl1pPr>
+          </a:lstStyle>
+          <a:p>
+            <a:pPr algn="r"/>
+            <a:fld id="{F7021451-1387-4CA6-816F-3879F97B5CBC}" type="slidenum">
+              <a:rPr b="0" lang="en-US"/>
+              <a:t>21</a:t>
             </a:fld>
             <a:endParaRPr lang="en-US"/>
           </a:p>

</xml_diff>

<commit_message>
Say that ResNet18 is frozen first and fine-tuned later on slide 6
</commit_message>
<xml_diff>
--- a/docs/museum_guide_presentation.pptx
+++ b/docs/museum_guide_presentation.pptx
@@ -128,26 +128,26 @@
   <p:extLst>
     <p:ext uri="{521415D9-36F7-43E2-AB2F-B90AF26B5E84}">
       <p14:sectionLst xmlns:p14="http://schemas.microsoft.com/office/powerpoint/2010/main">
-        <p14:section name="The question" id="{0e764249-c4a2-7c5e-58c6-8b5b303dea06}">
+        <p14:section name="The question" id="{4d5effb1-7fdb-319d-7c29-bb11bba8365a}">
           <p14:sldIdLst>
             <p14:sldId id="256"/>
             <p14:sldId id="257"/>
             <p14:sldId id="258"/>
           </p14:sldIdLst>
         </p14:section>
-        <p14:section name="Our MLP" id="{e503cfdf-7b20-dbf0-f4fe-b42b6211847e}">
+        <p14:section name="Our MLP" id="{7393dc7e-96b3-114f-4f52-34aa9e4bd10c}">
           <p14:sldIdLst>
             <p14:sldId id="259"/>
             <p14:sldId id="260"/>
           </p14:sldIdLst>
         </p14:section>
-        <p14:section name="Pretrained ResNet" id="{ae8c777f-05e4-9318-3412-89db81906245}">
+        <p14:section name="Pretrained ResNet" id="{2152acd8-4a2c-f2f3-908f-829c76c9f019}">
           <p14:sldIdLst>
             <p14:sldId id="261"/>
             <p14:sldId id="262"/>
           </p14:sldIdLst>
         </p14:section>
-        <p14:section name="The answer" id="{ffc4b98b-c872-eb59-63fc-1ba48d798600}">
+        <p14:section name="The answer" id="{4fd5af23-5373-c5a9-36e3-0af30fecabf5}">
           <p14:sldIdLst>
             <p14:sldId id="263"/>
             <p14:sldId id="264"/>
@@ -156,7 +156,7 @@
             <p14:sldId id="267"/>
           </p14:sldIdLst>
         </p14:section>
-        <p14:section name="Backup" id="{31e2f479-e148-8b7b-93f2-d73a1ab4db3d}">
+        <p14:section name="Backup" id="{be07f03d-ab52-9b4c-98ce-8471985eb315}">
           <p14:sldIdLst>
             <p14:sldId id="268"/>
             <p14:sldId id="269"/>
@@ -4784,7 +4784,7 @@
           <a:p>
             <a:r>
               <a:rPr lang="en-US" dirty="0"/>
-              <a:t>There is a type of network made for images, which recognises shapes: the convolutional network. We used ResNet18, the smallest ResNet. Its 18 layers slide small filters over the picture: the first layers find edges and colours, the next ones textures, the last ones shapes. Our MLP saw 12 288 separate pixels. ResNet18 already learned this on 1.2 million ImageNet photos, so we keep it frozen. It turns each painting into 512 numbers. We replace its last layer, made for ImageNet, by our own: from these 512 numbers to our 5 styles, 2 565 weights, the only ones we train. Like hiring an experienced art expert, and only teaching them our five style names.</a:t>
+              <a:t>There is a type of network made for images, which recognises shapes: the convolutional network. We used ResNet18, the smallest ResNet. Its 18 layers slide small filters over the picture: the first layers find edges and colours, the next ones textures, the last ones shapes. Our MLP saw 12 288 separate pixels. ResNet18 already learned this on 1.2 million ImageNet photos, so first, we keep it frozen. It turns each painting into 512 numbers. We replace its last layer, made for ImageNet, by our own: from these 512 numbers to our 5 styles, 2 565 weights, the only ones we train in this first version. Like hiring an experienced art expert, and only teaching them our five style names.</a:t>
             </a:r>
           </a:p>
           <a:p>
@@ -20200,7 +20200,7 @@
                   <a:schemeClr val="bg1"/>
                 </a:solidFill>
               </a:rPr>
-              <a:t>ResNet18, pretrained and frozen</a:t>
+              <a:t>ResNet18, pretrained, frozen first</a:t>
             </a:r>
             <a:endParaRPr lang="en-US" sz="1400" dirty="0"/>
           </a:p>
@@ -20214,7 +20214,7 @@
                   <a:srgbClr val="C9CED8"/>
                 </a:solidFill>
               </a:rPr>
-              <a:t>18 layers, 11 million weights learned on 1.2 million ImageNet photos. We do not change them.</a:t>
+              <a:t>18 layers, 11 million weights learned on 1.2 million ImageNet photos. Fine-tuning will unfreeze the last block.</a:t>
             </a:r>
             <a:endParaRPr lang="en-US" sz="1400" dirty="0"/>
           </a:p>
@@ -20661,7 +20661,7 @@
                   <a:schemeClr val="bg1"/>
                 </a:solidFill>
               </a:rPr>
-              <a:t>replaces ResNet's own: 512 → 5 styles, 2 565 weights, the only part we train</a:t>
+              <a:t>replaces ResNet's own: 512 → 5 styles, 2 565 weights, always trained</a:t>
             </a:r>
             <a:endParaRPr lang="en-US" sz="1400" dirty="0"/>
           </a:p>
@@ -20835,7 +20835,7 @@
       </p:sp>
       <p:sp>
         <p:nvSpPr>
-          <p:cNvPr id="26" name="note Why frozen"/>
+          <p:cNvPr id="26" name="note Why frozen first"/>
           <p:cNvSpPr/>
           <p:nvPr/>
         </p:nvSpPr>
@@ -20862,7 +20862,7 @@
       </p:sp>
       <p:sp>
         <p:nvSpPr>
-          <p:cNvPr id="27" name="text Why frozen"/>
+          <p:cNvPr id="27" name="text Why frozen first"/>
           <p:cNvSpPr txBox="1"/>
           <p:nvPr/>
         </p:nvSpPr>
@@ -20893,7 +20893,7 @@
                   <a:schemeClr val="tx2"/>
                 </a:solidFill>
               </a:rPr>
-              <a:t>Why frozen</a:t>
+              <a:t>Why frozen first</a:t>
             </a:r>
             <a:endParaRPr lang="en-US" sz="1400" dirty="0"/>
           </a:p>
@@ -20910,7 +20910,7 @@
                   <a:schemeClr val="tx1"/>
                 </a:solidFill>
               </a:rPr>
-              <a:t>Only 1 061 paintings: too few for 11 million weights. We reuse what it learned and train only our new last layer, in 0.4 s.</a:t>
+              <a:t>Only 1 061 paintings: too few for 11 million weights. We reuse what it learned and first train only our new last layer, in 0.4 s.</a:t>
             </a:r>
             <a:endParaRPr lang="en-US" sz="1400" dirty="0"/>
           </a:p>

</xml_diff>

<commit_message>
Present the two ways to reuse ResNet18, with the first layers frozen in both
</commit_message>
<xml_diff>
--- a/docs/museum_guide_presentation.pptx
+++ b/docs/museum_guide_presentation.pptx
@@ -127,26 +127,26 @@
   <p:extLst>
     <p:ext uri="{521415D9-36F7-43E2-AB2F-B90AF26B5E84}">
       <p14:sectionLst xmlns:p14="http://schemas.microsoft.com/office/powerpoint/2010/main">
-        <p14:section name="The question" id="{76db2735-e78e-aec8-12f8-db163638c4c3}">
+        <p14:section name="The question" id="{f5dd5c36-b928-0153-5d19-6bd22879d9d8}">
           <p14:sldIdLst>
             <p14:sldId id="256"/>
             <p14:sldId id="257"/>
             <p14:sldId id="258"/>
           </p14:sldIdLst>
         </p14:section>
-        <p14:section name="Our MLP" id="{283b523b-d3a3-3574-94a5-154dbc625aea}">
+        <p14:section name="Our MLP" id="{5eaa6aa4-b703-5372-b3b9-b70845fc54c3}">
           <p14:sldIdLst>
             <p14:sldId id="259"/>
             <p14:sldId id="260"/>
           </p14:sldIdLst>
         </p14:section>
-        <p14:section name="Pretrained ResNet" id="{e913a311-60d2-d84e-6708-d6026b106d43}">
+        <p14:section name="Pretrained ResNet" id="{77baa77e-9374-5208-a11c-a4a6a8817e05}">
           <p14:sldIdLst>
             <p14:sldId id="261"/>
             <p14:sldId id="262"/>
           </p14:sldIdLst>
         </p14:section>
-        <p14:section name="The answer" id="{b9b32b65-4cf5-1621-d5fb-ee205fe3cf68}">
+        <p14:section name="The answer" id="{35cf45d9-9c63-9062-9a6c-50f0c614b5cb}">
           <p14:sldIdLst>
             <p14:sldId id="263"/>
             <p14:sldId id="264"/>
@@ -154,7 +154,7 @@
             <p14:sldId id="266"/>
           </p14:sldIdLst>
         </p14:section>
-        <p14:section name="Backup" id="{04c9c729-aa00-271b-297d-5a79454dc72e}">
+        <p14:section name="Backup" id="{93d96cc0-3f12-25e9-3edd-ffe266c6551a}">
           <p14:sldIdLst>
             <p14:sldId id="267"/>
             <p14:sldId id="268"/>
@@ -2944,7 +2944,7 @@
           <a:p>
             <a:r>
               <a:rPr lang="en-US" dirty="0"/>
-              <a:t>On the 440 test paintings, our own MLP reached 42 percent, the random forest 65, and the fine-tuned ResNet18 88. So, our answer to the director: yes, a neural network is worth it, but a pretrained one that we reuse. We recommend ResNet18, pretrained on ImageNet, with its last block fine-tuned on our paintings. Why? It is accurate: one visitor in eight gets a wrong style, against one in three. It is fast enough for a modest CPU, and cheap for a small team: retrained in a few minutes. Before the launch, we must test real photos taken at the kiosks, add more styles, and measure the real hardware. Thank you. We are happy to take your questions.</a:t>
+              <a:t>On the 440 test paintings, our own MLP reached 42 percent, the random forest 65, and the fine-tuned ResNet18 88. So, our answer to the director: yes, a neural network is worth it, but a pretrained one that we reuse. We recommend ResNet18, pretrained on ImageNet, with its first layers frozen and its last block fine-tuned on our paintings. Why? It is accurate: one visitor in eight gets a wrong style, against one in three. It is fast enough for a modest CPU, and cheap for a small team: retrained in a few minutes. Before the launch, we must test real photos taken at the kiosks, add more styles, and measure the real hardware. Thank you. We are happy to take your questions.</a:t>
             </a:r>
             <a:endParaRPr lang="en-US" dirty="0"/>
           </a:p>
@@ -4308,7 +4308,7 @@
           <a:p>
             <a:r>
               <a:rPr lang="en-US" dirty="0"/>
-              <a:t>There is a type of network made for images, which recognises shapes: the convolutional network. We used ResNet18, the smallest ResNet. Its 18 layers slide small filters over the picture: the first layers find edges and colours, the next ones textures, the last ones shapes. Our MLP saw 12 288 separate pixels. ResNet18 already learned this on 1.2 million ImageNet photos, so first, we keep it frozen. It turns each painting into 512 numbers. We replace its last layer, made for ImageNet, by our own: from these 512 numbers to our 5 styles, 2 565 weights, the only ones we train in this first version. Like hiring an experienced art expert, and only teaching them our five style names.</a:t>
+              <a:t>There is a type of network made for images, which recognises shapes: the convolutional network. We used ResNet18, the smallest ResNet. Its 18 layers slide small filters over the picture: the first layers find edges and colours, the next ones textures, the last ones shapes. Our MLP saw 12 288 separate pixels. ResNet18 already learned this on 1.2 million ImageNet photos, and we only have 1 061 paintings, so we never retrain all of it. It turns each painting into 512 numbers. We replace its last layer, made for ImageNet, by our own: from these 512 numbers to our 5 styles. We tried two ways. Frozen: only our new layer learns, 2 565 weights. Fine-tuned: the first layers stay frozen, but the last block learns again on our paintings, 8.4 million weights. Like hiring an experienced art expert: frozen, we only teach them our five style names; fine-tuned, we also retrain their eye for shapes.</a:t>
             </a:r>
           </a:p>
           <a:p>
@@ -4407,7 +4407,7 @@
           <a:p>
             <a:r>
               <a:rPr lang="en-US" dirty="0"/>
-              <a:t>Training this last layer takes less than a second, and gives 88.1 percent on validation, almost twice our best MLP. And it does see shapes: it finds 71 percent of the Cubist paintings, against 7 for our MLP. We also tried fine-tuning: we unfreeze its last block, 8.4 million weights instead of 2 565, so that it also learns from our paintings. On validation it looked less convincing, 85.4 percent, so we chose the frozen version. Keep this in mind. We monitored it like the MLP: the gap between train and validation is only 0.09, against 0.61 for our first MLP.</a:t>
+              <a:t>The frozen version trains in less than a second and gives 88.1 percent on validation, almost twice our best MLP. And it does see shapes: it finds 71 percent of the Cubist paintings, against 7 for our MLP. The fine-tuned version looked less convincing on validation, 85.4 percent, so we first chose the frozen one. Keep this in mind. We monitored it like the MLP: the gap between train and validation is only 0.09, against 0.61 for our first MLP.</a:t>
             </a:r>
           </a:p>
           <a:p>
@@ -19379,7 +19379,7 @@
                   <a:schemeClr val="bg1"/>
                 </a:solidFill>
               </a:rPr>
-              <a:t>ResNet18, pretrained, frozen first</a:t>
+              <a:t>ResNet18, pretrained on ImageNet</a:t>
             </a:r>
             <a:endParaRPr lang="en-US" sz="1400" dirty="0"/>
           </a:p>
@@ -19393,7 +19393,7 @@
                   <a:srgbClr val="C9CED8"/>
                 </a:solidFill>
               </a:rPr>
-              <a:t>18 layers, 11 million weights learned on 1.2 million ImageNet photos. Fine-tuning will unfreeze the last block.</a:t>
+              <a:t>18 layers, 11 million weights learned on 1.2 million photos. We never retrain all of them.</a:t>
             </a:r>
             <a:endParaRPr lang="en-US" sz="1400" dirty="0"/>
           </a:p>
@@ -19407,12 +19407,12 @@
         </p:nvSpPr>
         <p:spPr>
           <a:xfrm>
-            <a:off x="2057400" y="2011680"/>
-            <a:ext cx="896112" cy="548640"/>
+            <a:off x="2057400" y="1920240"/>
+            <a:ext cx="896112" cy="685800"/>
           </a:xfrm>
           <a:prstGeom prst="roundRect">
             <a:avLst>
-              <a:gd name="adj" fmla="val 10000"/>
+              <a:gd name="adj" fmla="val 8000"/>
             </a:avLst>
           </a:prstGeom>
           <a:solidFill>
@@ -19434,8 +19434,8 @@
         </p:nvSpPr>
         <p:spPr>
           <a:xfrm>
-            <a:off x="2057400" y="2011680"/>
-            <a:ext cx="896112" cy="548640"/>
+            <a:off x="2057400" y="1920240"/>
+            <a:ext cx="896112" cy="685800"/>
           </a:xfrm>
           <a:prstGeom prst="rect">
             <a:avLst/>
@@ -19474,6 +19474,20 @@
             </a:r>
             <a:endParaRPr lang="en-US" sz="900" dirty="0"/>
           </a:p>
+          <a:p>
+            <a:pPr algn="ctr" indent="0" marL="0">
+              <a:buNone/>
+            </a:pPr>
+            <a:r>
+              <a:rPr lang="en-US" sz="900" dirty="0">
+                <a:solidFill>
+                  <a:srgbClr val="C9CED8"/>
+                </a:solidFill>
+              </a:rPr>
+              <a:t>always frozen</a:t>
+            </a:r>
+            <a:endParaRPr lang="en-US" sz="900" dirty="0"/>
+          </a:p>
         </p:txBody>
       </p:sp>
       <p:sp>
@@ -19484,12 +19498,12 @@
         </p:nvSpPr>
         <p:spPr>
           <a:xfrm>
-            <a:off x="3063240" y="2011680"/>
-            <a:ext cx="896112" cy="548640"/>
+            <a:off x="3063240" y="1920240"/>
+            <a:ext cx="896112" cy="685800"/>
           </a:xfrm>
           <a:prstGeom prst="roundRect">
             <a:avLst>
-              <a:gd name="adj" fmla="val 10000"/>
+              <a:gd name="adj" fmla="val 8000"/>
             </a:avLst>
           </a:prstGeom>
           <a:solidFill>
@@ -19511,8 +19525,8 @@
         </p:nvSpPr>
         <p:spPr>
           <a:xfrm>
-            <a:off x="3063240" y="2011680"/>
-            <a:ext cx="896112" cy="548640"/>
+            <a:off x="3063240" y="1920240"/>
+            <a:ext cx="896112" cy="685800"/>
           </a:xfrm>
           <a:prstGeom prst="rect">
             <a:avLst/>
@@ -19551,6 +19565,20 @@
             </a:r>
             <a:endParaRPr lang="en-US" sz="900" dirty="0"/>
           </a:p>
+          <a:p>
+            <a:pPr algn="ctr" indent="0" marL="0">
+              <a:buNone/>
+            </a:pPr>
+            <a:r>
+              <a:rPr lang="en-US" sz="900" dirty="0">
+                <a:solidFill>
+                  <a:srgbClr val="C9CED8"/>
+                </a:solidFill>
+              </a:rPr>
+              <a:t>always frozen</a:t>
+            </a:r>
+            <a:endParaRPr lang="en-US" sz="900" dirty="0"/>
+          </a:p>
         </p:txBody>
       </p:sp>
       <p:sp>
@@ -19561,20 +19589,20 @@
         </p:nvSpPr>
         <p:spPr>
           <a:xfrm>
-            <a:off x="4069080" y="2011680"/>
-            <a:ext cx="896112" cy="548640"/>
+            <a:off x="4069080" y="1920240"/>
+            <a:ext cx="896112" cy="685800"/>
           </a:xfrm>
           <a:prstGeom prst="roundRect">
             <a:avLst>
-              <a:gd name="adj" fmla="val 10000"/>
+              <a:gd name="adj" fmla="val 8000"/>
             </a:avLst>
           </a:prstGeom>
           <a:solidFill>
             <a:srgbClr val="2A3448"/>
           </a:solidFill>
-          <a:ln w="12700">
+          <a:ln w="19050">
             <a:solidFill>
-              <a:srgbClr val="2A3448"/>
+              <a:schemeClr val="accent4"/>
             </a:solidFill>
             <a:prstDash val="solid"/>
           </a:ln>
@@ -19588,8 +19616,8 @@
         </p:nvSpPr>
         <p:spPr>
           <a:xfrm>
-            <a:off x="4069080" y="2011680"/>
-            <a:ext cx="896112" cy="548640"/>
+            <a:off x="4069080" y="1920240"/>
+            <a:ext cx="896112" cy="685800"/>
           </a:xfrm>
           <a:prstGeom prst="rect">
             <a:avLst/>
@@ -19610,7 +19638,7 @@
                   <a:srgbClr val="C9CED8"/>
                 </a:solidFill>
               </a:rPr>
-              <a:t>last layers</a:t>
+              <a:t>last block</a:t>
             </a:r>
             <a:endParaRPr lang="en-US" sz="900" dirty="0"/>
           </a:p>
@@ -19625,6 +19653,20 @@
                 </a:solidFill>
               </a:rPr>
               <a:t>shapes</a:t>
+            </a:r>
+            <a:endParaRPr lang="en-US" sz="900" dirty="0"/>
+          </a:p>
+          <a:p>
+            <a:pPr algn="ctr" indent="0" marL="0">
+              <a:buNone/>
+            </a:pPr>
+            <a:r>
+              <a:rPr lang="en-US" sz="900" dirty="0">
+                <a:solidFill>
+                  <a:schemeClr val="accent4"/>
+                </a:solidFill>
+              </a:rPr>
+              <a:t>fine-tuned: learns</a:t>
             </a:r>
             <a:endParaRPr lang="en-US" sz="900" dirty="0"/>
           </a:p>
@@ -19840,7 +19882,7 @@
                   <a:schemeClr val="bg1"/>
                 </a:solidFill>
               </a:rPr>
-              <a:t>replaces ResNet's own: 512 → 5 styles, 2 565 weights, always trained</a:t>
+              <a:t>replaces ResNet's own: 512 → 5 styles, 2 565 weights, trained in both ways</a:t>
             </a:r>
             <a:endParaRPr lang="en-US" sz="1400" dirty="0"/>
           </a:p>
@@ -20014,7 +20056,7 @@
       </p:sp>
       <p:sp>
         <p:nvSpPr>
-          <p:cNvPr id="26" name="note Why frozen first"/>
+          <p:cNvPr id="26" name="note Two ways to reuse it"/>
           <p:cNvSpPr/>
           <p:nvPr/>
         </p:nvSpPr>
@@ -20041,7 +20083,7 @@
       </p:sp>
       <p:sp>
         <p:nvSpPr>
-          <p:cNvPr id="27" name="text Why frozen first"/>
+          <p:cNvPr id="27" name="text Two ways to reuse it"/>
           <p:cNvSpPr txBox="1"/>
           <p:nvPr/>
         </p:nvSpPr>
@@ -20072,7 +20114,7 @@
                   <a:schemeClr val="tx2"/>
                 </a:solidFill>
               </a:rPr>
-              <a:t>Why frozen first</a:t>
+              <a:t>Two ways to reuse it</a:t>
             </a:r>
             <a:endParaRPr lang="en-US" sz="1400" dirty="0"/>
           </a:p>
@@ -20089,7 +20131,7 @@
                   <a:schemeClr val="tx1"/>
                 </a:solidFill>
               </a:rPr>
-              <a:t>Only 1 061 paintings: too few for 11 million weights. We reuse what it learned and first train only our new last layer, in 0.4 s.</a:t>
+              <a:t>Frozen: only our new layer learns (2 565 weights, 0.4 s). Fine-tuned: the last block learns too (8.4 M weights, minutes), the first layers stay frozen.</a:t>
             </a:r>
             <a:endParaRPr lang="en-US" sz="1400" dirty="0"/>
           </a:p>
@@ -20340,7 +20382,7 @@
       </p:sp>
       <p:sp>
         <p:nvSpPr>
-          <p:cNvPr id="7" name="note Fine-tuning: lower on validation"/>
+          <p:cNvPr id="7" name="note Fine-tuned: lower on validation"/>
           <p:cNvSpPr/>
           <p:nvPr/>
         </p:nvSpPr>
@@ -20367,7 +20409,7 @@
       </p:sp>
       <p:sp>
         <p:nvSpPr>
-          <p:cNvPr id="8" name="text Fine-tuning: lower on validation"/>
+          <p:cNvPr id="8" name="text Fine-tuned: lower on validation"/>
           <p:cNvSpPr txBox="1"/>
           <p:nvPr/>
         </p:nvSpPr>
@@ -20398,7 +20440,7 @@
                   <a:schemeClr val="tx2"/>
                 </a:solidFill>
               </a:rPr>
-              <a:t>Fine-tuning: lower on validation</a:t>
+              <a:t>Fine-tuned: lower on validation</a:t>
             </a:r>
             <a:endParaRPr lang="en-US" sz="1500" dirty="0"/>
           </a:p>
@@ -20415,7 +20457,7 @@
                   <a:schemeClr val="tx1"/>
                 </a:solidFill>
               </a:rPr>
-              <a:t>We also unfreeze its last block (8.4 M weights) to learn from our paintings: 85.4 % on validation. The tests will say otherwise.</a:t>
+              <a:t>Last block learning again (8.4 M weights), first layers still frozen: 85.4 % on validation. The tests will say otherwise.</a:t>
             </a:r>
             <a:endParaRPr lang="en-US" sz="1500" dirty="0"/>
           </a:p>

</xml_diff>

<commit_message>
Introduce ResNet18 better: where it comes from and why the smallest one
</commit_message>
<xml_diff>
--- a/docs/museum_guide_presentation.pptx
+++ b/docs/museum_guide_presentation.pptx
@@ -127,26 +127,26 @@
   <p:extLst>
     <p:ext uri="{521415D9-36F7-43E2-AB2F-B90AF26B5E84}">
       <p14:sectionLst xmlns:p14="http://schemas.microsoft.com/office/powerpoint/2010/main">
-        <p14:section name="The question" id="{f5dd5c36-b928-0153-5d19-6bd22879d9d8}">
+        <p14:section name="The question" id="{c503b9dc-c7db-933c-64b5-a6e5c2a875a9}">
           <p14:sldIdLst>
             <p14:sldId id="256"/>
             <p14:sldId id="257"/>
             <p14:sldId id="258"/>
           </p14:sldIdLst>
         </p14:section>
-        <p14:section name="Our MLP" id="{5eaa6aa4-b703-5372-b3b9-b70845fc54c3}">
+        <p14:section name="Our MLP" id="{982f17fe-fc6a-eb00-c4af-854ad71b40f4}">
           <p14:sldIdLst>
             <p14:sldId id="259"/>
             <p14:sldId id="260"/>
           </p14:sldIdLst>
         </p14:section>
-        <p14:section name="Pretrained ResNet" id="{77baa77e-9374-5208-a11c-a4a6a8817e05}">
+        <p14:section name="Pretrained ResNet" id="{81e2cee5-6bae-cddf-0fb1-843f04839793}">
           <p14:sldIdLst>
             <p14:sldId id="261"/>
             <p14:sldId id="262"/>
           </p14:sldIdLst>
         </p14:section>
-        <p14:section name="The answer" id="{35cf45d9-9c63-9062-9a6c-50f0c614b5cb}">
+        <p14:section name="The answer" id="{69ce220a-9807-1f9d-17db-483dab30e66d}">
           <p14:sldIdLst>
             <p14:sldId id="263"/>
             <p14:sldId id="264"/>
@@ -154,7 +154,7 @@
             <p14:sldId id="266"/>
           </p14:sldIdLst>
         </p14:section>
-        <p14:section name="Backup" id="{93d96cc0-3f12-25e9-3edd-ffe266c6551a}">
+        <p14:section name="Backup" id="{acb32d7a-4fed-2ecf-e272-ef7cdb46d047}">
           <p14:sldIdLst>
             <p14:sldId id="267"/>
             <p14:sldId id="268"/>
@@ -4308,7 +4308,7 @@
           <a:p>
             <a:r>
               <a:rPr lang="en-US" dirty="0"/>
-              <a:t>There is a type of network made for images, which recognises shapes: the convolutional network. We used ResNet18, the smallest ResNet. Its 18 layers slide small filters over the picture: the first layers find edges and colours, the next ones textures, the last ones shapes. Our MLP saw 12 288 separate pixels. ResNet18 already learned this on 1.2 million ImageNet photos, and we only have 1 061 paintings, so we never retrain all of it. It turns each painting into 512 numbers. We replace its last layer, made for ImageNet, by our own: from these 512 numbers to our 5 styles. We tried two ways. Frozen: only our new layer learns, 2 565 weights. Fine-tuned: the first layers stay frozen, but the last block learns again on our paintings, 8.4 million weights. Like hiring an experienced art expert: frozen, we only teach them our five style names; fine-tuned, we also retrain their eye for shapes.</a:t>
+              <a:t>To see shapes, we need a network made for images: a convolutional network, or CNN. The brief asks for a ResNet, a famous family of CNNs from Microsoft Research, which won the big ImageNet competition in 2015. ResNet18 is its smallest member, with 18 layers: light enough for a kiosk, and PyTorch gives it already trained. "Res" means residual: shortcuts between its layers let a deep network learn well. Its 18 layers slide small filters over the picture: the first layers find edges and colours, the next ones textures, the last ones shapes. Our MLP saw 12 288 separate pixels. ResNet18 already learned this on 1.2 million ImageNet photos, and we only have 1 061 paintings, so we never retrain all of it. It turns each painting into 512 numbers. We replace its last layer, made for ImageNet, by our own: from these 512 numbers to our 5 styles. We tried two ways. Frozen: only our new layer learns, 2 565 weights. Fine-tuned: the first layers stay frozen, but the last block learns again on our paintings, 8.4 million weights. Like hiring an experienced art expert: frozen, we only teach them our five style names; fine-tuned, we also retrain their eye for shapes.</a:t>
             </a:r>
           </a:p>
           <a:p>
@@ -20048,7 +20048,7 @@
                   <a:schemeClr val="tx1"/>
                 </a:solidFill>
               </a:rPr>
-              <a:t>The brief asks for a pretrained ResNet; ResNet18 is the smallest (45 MB), light enough for a kiosk CPU. Shortcuts between layers let its 18 layers learn well.</a:t>
+              <a:t>ResNet, a famous CNN family (ImageNet winner in 2015), is asked by the brief. ResNet18 is its smallest member: 45 MB, light enough for a kiosk CPU.</a:t>
             </a:r>
             <a:endParaRPr lang="en-US" sz="1400" dirty="0"/>
           </a:p>

</xml_diff>